<commit_message>
Add a beginner explanation of the KV cache to the deck and guides
New slide 2 (Background: the KV cache) with speaker notes, showing
generation with and without a cache and what query, key and value mean.
The same figure, in English and Spanish, opens a new section 1.1 in both
technical guides; later subsections in section 1 are renumbered.
</commit_message>
<xml_diff>
--- a/docs/TurboQuant.pptx
+++ b/docs/TurboQuant.pptx
@@ -6,6 +6,7 @@
   </p:sldMasterIdLst>
   <p:sldIdLst>
     <p:sldId id="256" r:id="rId2"/>
+    <p:sldId id="274" r:id="rId25"/>
     <p:sldId id="257" r:id="rId3"/>
     <p:sldId id="258" r:id="rId4"/>
     <p:sldId id="259" r:id="rId5"/>
@@ -1346,6 +1347,76 @@
         <p14:creationId xmlns:p14="http://schemas.microsoft.com/office/powerpoint/2010/main" val="1024086991"/>
       </p:ext>
     </p:extLst>
+  </p:cSld>
+  <p:clrMapOvr>
+    <a:masterClrMapping/>
+  </p:clrMapOvr>
+</p:notes>
+</file>
+
+<file path=ppt/notesSlides/notesSlide19.xml><?xml version="1.0" encoding="utf-8"?>
+<p:notes xmlns:a="http://schemas.openxmlformats.org/drawingml/2006/main" xmlns:p="http://schemas.openxmlformats.org/presentationml/2006/main" xmlns:r="http://schemas.openxmlformats.org/officeDocument/2006/relationships">
+  <p:cSld>
+    <p:spTree>
+      <p:nvGrpSpPr>
+        <p:cNvPr id="1" name=""/>
+        <p:cNvGrpSpPr/>
+        <p:nvPr/>
+      </p:nvGrpSpPr>
+      <p:grpSpPr>
+        <a:xfrm>
+          <a:off x="0" y="0"/>
+          <a:ext cx="0" cy="0"/>
+          <a:chOff x="0" y="0"/>
+          <a:chExt cx="0" cy="0"/>
+        </a:xfrm>
+      </p:grpSpPr>
+      <p:sp>
+        <p:nvSpPr>
+          <p:cNvPr id="2" name="Slide Image Placeholder 1"/>
+          <p:cNvSpPr>
+            <a:spLocks noGrp="1"/>
+          </p:cNvSpPr>
+          <p:nvPr>
+            <p:ph type="sldImg" idx="2"/>
+          </p:nvPr>
+        </p:nvSpPr>
+        <p:spPr/>
+      </p:sp>
+      <p:sp>
+        <p:nvSpPr>
+          <p:cNvPr id="3" name="Notes Placeholder 2"/>
+          <p:cNvSpPr>
+            <a:spLocks noGrp="1"/>
+          </p:cNvSpPr>
+          <p:nvPr>
+            <p:ph type="body" idx="3" sz="quarter"/>
+          </p:nvPr>
+        </p:nvSpPr>
+        <p:spPr/>
+        <p:txBody>
+          <a:bodyPr/>
+          <a:lstStyle/>
+          <a:p>
+            <a:r>
+              <a:t>Before the problem, a quick picture of what the KV cache is, for anyone who has not met it. A language model writes one word, strictly one token, at a time. To choose the next word, every layer runs attention: the newest word makes a query, which says what it is looking for. Every earlier word has a key, a label saying what it is about, and a value, the information it hands over. The query is compared with all the keys, and the values of the best matches are mixed together. Left side: without a cache, the model would recompute the keys and values of the whole sentence at every step, so the work keeps growing. Right side: those keys and values never change once computed, so the model stores them and computes only the newest word's pair. That store is the KV cache. It makes generation fast, but it costs memory: one key and one value per token, in every layer and every head, for every user. The next slide puts a number on it, and the rest of the talk is about making those vectors 4 to 6 times smaller.</a:t>
+            </a:r>
+          </a:p>
+        </p:txBody>
+      </p:sp>
+      <p:sp>
+        <p:nvSpPr>
+          <p:cNvPr id="4" name="Slide Number Placeholder 3"/>
+          <p:cNvSpPr>
+            <a:spLocks noGrp="1"/>
+          </p:cNvSpPr>
+          <p:nvPr>
+            <p:ph type="sldNum" idx="5" sz="quarter"/>
+          </p:nvPr>
+        </p:nvSpPr>
+        <p:spPr/>
+      </p:sp>
+    </p:spTree>
   </p:cSld>
   <p:clrMapOvr>
     <a:masterClrMapping/>
@@ -15850,6 +15921,189 @@
           </a:p>
         </p:txBody>
       </p:sp>
+    </p:spTree>
+  </p:cSld>
+  <p:clrMapOvr>
+    <a:masterClrMapping/>
+  </p:clrMapOvr>
+</p:sld>
+</file>
+
+<file path=ppt/slides/slide19.xml><?xml version="1.0" encoding="utf-8"?>
+<p:sld xmlns:a="http://schemas.openxmlformats.org/drawingml/2006/main" xmlns:p="http://schemas.openxmlformats.org/presentationml/2006/main" xmlns:r="http://schemas.openxmlformats.org/officeDocument/2006/relationships">
+  <p:cSld>
+    <p:bg>
+      <p:bgPr>
+        <a:solidFill>
+          <a:srgbClr val="F6F5F0"/>
+        </a:solidFill>
+      </p:bgPr>
+    </p:bg>
+    <p:spTree>
+      <p:nvGrpSpPr>
+        <p:cNvPr id="1" name=""/>
+        <p:cNvGrpSpPr/>
+        <p:nvPr/>
+      </p:nvGrpSpPr>
+      <p:grpSpPr/>
+      <p:sp>
+        <p:nvSpPr>
+          <p:cNvPr id="2" name="Text 0"/>
+          <p:cNvSpPr/>
+          <p:nvPr/>
+        </p:nvSpPr>
+        <p:spPr>
+          <a:xfrm>
+            <a:off x="812800" y="812800"/>
+            <a:ext cx="10883392" cy="238720"/>
+          </a:xfrm>
+          <a:prstGeom prst="rect">
+            <a:avLst/>
+          </a:prstGeom>
+          <a:noFill/>
+          <a:ln/>
+        </p:spPr>
+        <p:txBody>
+          <a:bodyPr wrap="square" lIns="0" tIns="0" rIns="0" bIns="0" rtlCol="0" anchor="t">
+            <a:normAutofit/>
+          </a:bodyPr>
+          <a:lstStyle/>
+          <a:p>
+            <a:pPr algn="l" indent="0" marL="0">
+              <a:lnSpc>
+                <a:spcPts val="1680"/>
+              </a:lnSpc>
+              <a:buNone/>
+            </a:pPr>
+            <a:r>
+              <a:rPr lang="en-US" sz="1200" spc="100" kern="0" dirty="0">
+                <a:solidFill>
+                  <a:srgbClr val="B4521A"/>
+                </a:solidFill>
+                <a:latin typeface="JetBrains Mono" pitchFamily="49" charset="0"/>
+                <a:ea typeface="JetBrains Mono" pitchFamily="49" charset="-122"/>
+                <a:cs typeface="JetBrains Mono" pitchFamily="49" charset="-120"/>
+              </a:rPr>
+              <a:t>BACKGROUND · THE KV CACHE</a:t>
+            </a:r>
+            <a:endParaRPr lang="en-US" sz="1200" dirty="0"/>
+          </a:p>
+        </p:txBody>
+      </p:sp>
+      <p:sp>
+        <p:nvSpPr>
+          <p:cNvPr id="3" name="Text 1"/>
+          <p:cNvSpPr/>
+          <p:nvPr>
+            <p:ph type="title"/>
+          </p:nvPr>
+        </p:nvSpPr>
+        <p:spPr>
+          <a:xfrm>
+            <a:off x="812800" y="1330920"/>
+            <a:ext cx="10883392" cy="560000"/>
+          </a:xfrm>
+          <a:prstGeom prst="rect">
+            <a:avLst/>
+          </a:prstGeom>
+          <a:noFill/>
+          <a:ln/>
+        </p:spPr>
+        <p:txBody>
+          <a:bodyPr wrap="square" lIns="0" tIns="0" rIns="0" bIns="0" rtlCol="0" anchor="t">
+            <a:normAutofit/>
+          </a:bodyPr>
+          <a:lstStyle/>
+          <a:p>
+            <a:pPr algn="l" indent="0" marL="0">
+              <a:lnSpc>
+                <a:spcPts val="3520"/>
+              </a:lnSpc>
+              <a:buNone/>
+            </a:pPr>
+            <a:r>
+              <a:rPr lang="en-US" sz="3200" b="1" i="0" dirty="0">
+                <a:solidFill>
+                  <a:srgbClr val="0F1B2D"/>
+                </a:solidFill>
+                <a:latin typeface="IBM Plex Sans" pitchFamily="34" charset="0"/>
+                <a:ea typeface="IBM Plex Sans" pitchFamily="34" charset="-122"/>
+                <a:cs typeface="IBM Plex Sans" pitchFamily="34" charset="-120"/>
+              </a:rPr>
+              <a:t>The KV cache: compute once, reuse at every step</a:t>
+            </a:r>
+            <a:endParaRPr lang="en-US" sz="3200" dirty="0"/>
+          </a:p>
+        </p:txBody>
+      </p:sp>
+      <p:sp>
+        <p:nvSpPr>
+          <p:cNvPr id="12" name="Text 10"/>
+          <p:cNvSpPr/>
+          <p:nvPr/>
+        </p:nvSpPr>
+        <p:spPr>
+          <a:xfrm>
+            <a:off x="812800" y="6500000"/>
+            <a:ext cx="10883392" cy="238720"/>
+          </a:xfrm>
+          <a:prstGeom prst="rect">
+            <a:avLst/>
+          </a:prstGeom>
+          <a:noFill/>
+          <a:ln/>
+        </p:spPr>
+        <p:txBody>
+          <a:bodyPr wrap="square" lIns="0" tIns="0" rIns="0" bIns="0" rtlCol="0" anchor="t">
+            <a:normAutofit/>
+          </a:bodyPr>
+          <a:lstStyle/>
+          <a:p>
+            <a:pPr algn="l" indent="0" marL="0">
+              <a:lnSpc>
+                <a:spcPts val="1680"/>
+              </a:lnSpc>
+              <a:buNone/>
+            </a:pPr>
+            <a:r>
+              <a:rPr lang="en-US" sz="1200" dirty="0">
+                <a:solidFill>
+                  <a:srgbClr val="5F6979"/>
+                </a:solidFill>
+                <a:latin typeface="IBM Plex Sans" pitchFamily="34" charset="0"/>
+                <a:ea typeface="IBM Plex Sans" pitchFamily="34" charset="-122"/>
+                <a:cs typeface="IBM Plex Sans" pitchFamily="34" charset="-120"/>
+              </a:rPr>
+              <a:t>The price: one K and one V per token, in every layer and head. That is what TurboQuant compresses.</a:t>
+            </a:r>
+            <a:endParaRPr lang="en-US" sz="1200" dirty="0"/>
+          </a:p>
+        </p:txBody>
+      </p:sp>
+      <p:pic>
+        <p:nvPicPr>
+          <p:cNvPr id="13" name="Picture 12" descr="fig15_kvcache_basics_deck_en.png"/>
+          <p:cNvPicPr>
+            <a:picLocks noChangeAspect="1"/>
+          </p:cNvPicPr>
+          <p:nvPr/>
+        </p:nvPicPr>
+        <p:blipFill>
+          <a:blip r:embed="rId2"/>
+          <a:stretch>
+            <a:fillRect/>
+          </a:stretch>
+        </p:blipFill>
+        <p:spPr>
+          <a:xfrm>
+            <a:off x="486299" y="1900000"/>
+            <a:ext cx="10883392" cy="4527491"/>
+          </a:xfrm>
+          <a:prstGeom prst="rect">
+            <a:avLst/>
+          </a:prstGeom>
+        </p:spPr>
+      </p:pic>
     </p:spTree>
   </p:cSld>
   <p:clrMapOvr>

</xml_diff>

<commit_message>
Explain the quantization process and product quantization
New slide 4 (Background: quantization) with speaker notes, following eight
numbers through classic min-max quantization at 2 bits: find the range, lay
out the allowed values, round to codes, store and read back. The same figure,
in English and Spanish, is a new section 1.4 in both technical guides, which
also explains what TurboQuant changes; Results at a glance becomes 1.5.

New section 5.4 in both guides explains product quantization (PQ), with a
figure, its bit budget in the demo, and how it compares with TurboQuant. Guide
only, no slide.
</commit_message>
<xml_diff>
--- a/docs/TurboQuant.pptx
+++ b/docs/TurboQuant.pptx
@@ -8,6 +8,7 @@
     <p:sldId id="256" r:id="rId2"/>
     <p:sldId id="278" r:id="rId29"/>
     <p:sldId id="257" r:id="rId3"/>
+    <p:sldId id="279" r:id="rId30"/>
     <p:sldId id="258" r:id="rId4"/>
     <p:sldId id="259" r:id="rId5"/>
     <p:sldId id="260" r:id="rId6"/>
@@ -1796,6 +1797,76 @@
 </p:notes>
 </file>
 
+<file path=ppt/notesSlides/notesSlide24.xml><?xml version="1.0" encoding="utf-8"?>
+<p:notes xmlns:a="http://schemas.openxmlformats.org/drawingml/2006/main" xmlns:p="http://schemas.openxmlformats.org/presentationml/2006/main" xmlns:r="http://schemas.openxmlformats.org/officeDocument/2006/relationships">
+  <p:cSld>
+    <p:spTree>
+      <p:nvGrpSpPr>
+        <p:cNvPr id="1" name=""/>
+        <p:cNvGrpSpPr/>
+        <p:nvPr/>
+      </p:nvGrpSpPr>
+      <p:grpSpPr>
+        <a:xfrm>
+          <a:off x="0" y="0"/>
+          <a:ext cx="0" cy="0"/>
+          <a:chOff x="0" y="0"/>
+          <a:chExt cx="0" cy="0"/>
+        </a:xfrm>
+      </p:grpSpPr>
+      <p:sp>
+        <p:nvSpPr>
+          <p:cNvPr id="2" name="Slide Image Placeholder 1"/>
+          <p:cNvSpPr>
+            <a:spLocks noGrp="1"/>
+          </p:cNvSpPr>
+          <p:nvPr>
+            <p:ph type="sldImg" idx="2"/>
+          </p:nvPr>
+        </p:nvSpPr>
+        <p:spPr/>
+      </p:sp>
+      <p:sp>
+        <p:nvSpPr>
+          <p:cNvPr id="3" name="Notes Placeholder 2"/>
+          <p:cNvSpPr>
+            <a:spLocks noGrp="1"/>
+          </p:cNvSpPr>
+          <p:nvPr>
+            <p:ph type="body" idx="3" sz="quarter"/>
+          </p:nvPr>
+        </p:nvSpPr>
+        <p:spPr/>
+        <p:txBody>
+          <a:bodyPr/>
+          <a:lstStyle/>
+          <a:p>
+            <a:r>
+              <a:t>Before we look at what goes wrong with classic quantization, here is how it works, on eight numbers. Step one: find the range of the block, the smallest and the largest number. Step two: with 2 bits we can name four allowed values, so we spread four values evenly over that range. Step three: every number is replaced by the 2-bit code of the nearest allowed value; that rounding is the only place we lose information. Step four: we store the codes, plus the minimum and the step so we can decode. Reading back is just minimum plus code times step, and the bottom row shows the error each number picks up. Two things to notice. First, the range has to be stored for every block, and that is the hidden tax on the next slide. Second, the two extreme numbers set the range, so five of the eight numbers share only two values. TurboQuant keeps the rounding and the storing, but replaces the first two steps: it rotates the vector first so nothing sticks out, and uses one fixed set of values for every vector, so there is no range to store.</a:t>
+            </a:r>
+          </a:p>
+        </p:txBody>
+      </p:sp>
+      <p:sp>
+        <p:nvSpPr>
+          <p:cNvPr id="4" name="Slide Number Placeholder 3"/>
+          <p:cNvSpPr>
+            <a:spLocks noGrp="1"/>
+          </p:cNvSpPr>
+          <p:nvPr>
+            <p:ph type="sldNum" idx="5" sz="quarter"/>
+          </p:nvPr>
+        </p:nvSpPr>
+        <p:spPr/>
+      </p:sp>
+    </p:spTree>
+  </p:cSld>
+  <p:clrMapOvr>
+    <a:masterClrMapping/>
+  </p:clrMapOvr>
+</p:notes>
+</file>
+
 <file path=ppt/notesSlides/notesSlide3.xml><?xml version="1.0" encoding="utf-8"?>
 <p:notes xmlns:a="http://schemas.openxmlformats.org/drawingml/2006/main" xmlns:r="http://schemas.openxmlformats.org/officeDocument/2006/relationships" xmlns:p="http://schemas.openxmlformats.org/presentationml/2006/main">
   <p:cSld>
@@ -3327,6 +3398,538 @@
 
 <file path=ppt/slides/slide10.xml><?xml version="1.0" encoding="utf-8"?>
 <p:sld xmlns:a="http://schemas.openxmlformats.org/drawingml/2006/main" xmlns:r="http://schemas.openxmlformats.org/officeDocument/2006/relationships" xmlns:p="http://schemas.openxmlformats.org/presentationml/2006/main">
+  <p:cSld name="Slide 9">
+    <p:bg>
+      <p:bgPr>
+        <a:solidFill>
+          <a:srgbClr val="F6F5F0"/>
+        </a:solidFill>
+      </p:bgPr>
+    </p:bg>
+    <p:spTree>
+      <p:nvGrpSpPr>
+        <p:cNvPr id="1" name=""/>
+        <p:cNvGrpSpPr/>
+        <p:nvPr/>
+      </p:nvGrpSpPr>
+      <p:grpSpPr>
+        <a:xfrm>
+          <a:off x="0" y="0"/>
+          <a:ext cx="0" cy="0"/>
+          <a:chOff x="0" y="0"/>
+          <a:chExt cx="0" cy="0"/>
+        </a:xfrm>
+      </p:grpSpPr>
+      <p:sp>
+        <p:nvSpPr>
+          <p:cNvPr id="2" name="Text 0"/>
+          <p:cNvSpPr/>
+          <p:nvPr/>
+        </p:nvSpPr>
+        <p:spPr>
+          <a:xfrm>
+            <a:off x="812800" y="812800"/>
+            <a:ext cx="10883392" cy="235248"/>
+          </a:xfrm>
+          <a:prstGeom prst="rect">
+            <a:avLst/>
+          </a:prstGeom>
+          <a:noFill/>
+          <a:ln/>
+        </p:spPr>
+        <p:txBody>
+          <a:bodyPr wrap="square" lIns="0" tIns="0" rIns="0" bIns="0" rtlCol="0" anchor="t">
+            <a:normAutofit/>
+          </a:bodyPr>
+          <a:lstStyle/>
+          <a:p>
+            <a:pPr algn="l" indent="0" marL="0">
+              <a:lnSpc>
+                <a:spcPts val="1675"/>
+              </a:lnSpc>
+              <a:buNone/>
+            </a:pPr>
+            <a:r>
+              <a:rPr lang="en-US" sz="1196" spc="100" kern="0" dirty="0">
+                <a:solidFill>
+                  <a:srgbClr val="B4521A"/>
+                </a:solidFill>
+                <a:latin typeface="JetBrains Mono" pitchFamily="49" charset="0"/>
+                <a:ea typeface="JetBrains Mono" pitchFamily="49" charset="-122"/>
+                <a:cs typeface="JetBrains Mono" pitchFamily="49" charset="-120"/>
+              </a:rPr>
+              <a:t>IN PRODUCTION</a:t>
+            </a:r>
+            <a:endParaRPr lang="en-US" sz="1196" dirty="0"/>
+          </a:p>
+        </p:txBody>
+      </p:sp>
+      <p:sp>
+        <p:nvSpPr>
+          <p:cNvPr id="3" name="Text 1"/>
+          <p:cNvSpPr/>
+          <p:nvPr>
+            <p:ph type="title"/>
+          </p:nvPr>
+        </p:nvSpPr>
+        <p:spPr>
+          <a:xfrm>
+            <a:off x="812800" y="1327448"/>
+            <a:ext cx="10883392" cy="465138"/>
+          </a:xfrm>
+          <a:prstGeom prst="rect">
+            <a:avLst/>
+          </a:prstGeom>
+          <a:noFill/>
+          <a:ln/>
+        </p:spPr>
+        <p:txBody>
+          <a:bodyPr wrap="square" lIns="0" tIns="0" rIns="0" bIns="0" rtlCol="0" anchor="t">
+            <a:normAutofit/>
+          </a:bodyPr>
+          <a:lstStyle/>
+          <a:p>
+            <a:pPr algn="l" indent="0" marL="0">
+              <a:lnSpc>
+                <a:spcPts val="3465"/>
+              </a:lnSpc>
+              <a:buNone/>
+            </a:pPr>
+            <a:r>
+              <a:rPr lang="en-US" sz="3150" b="1" i="0" dirty="0">
+                <a:solidFill>
+                  <a:srgbClr val="0F1B2D"/>
+                </a:solidFill>
+                <a:latin typeface="IBM Plex Sans" pitchFamily="34" charset="0"/>
+                <a:ea typeface="IBM Plex Sans" pitchFamily="34" charset="-122"/>
+                <a:cs typeface="IBM Plex Sans" pitchFamily="34" charset="-120"/>
+              </a:rPr>
+              <a:t>The big win is capacity; speed depends on the kernel</a:t>
+            </a:r>
+            <a:endParaRPr lang="en-US" sz="3150" dirty="0"/>
+          </a:p>
+        </p:txBody>
+      </p:sp>
+      <p:sp>
+        <p:nvSpPr>
+          <p:cNvPr id="4" name="Shape 2"/>
+          <p:cNvSpPr/>
+          <p:nvPr/>
+        </p:nvSpPr>
+        <p:spPr>
+          <a:xfrm>
+            <a:off x="815975" y="2075160"/>
+            <a:ext cx="5175250" cy="2715220"/>
+          </a:xfrm>
+          <a:prstGeom prst="roundRect">
+            <a:avLst>
+              <a:gd name="adj" fmla="val 3625"/>
+            </a:avLst>
+          </a:prstGeom>
+          <a:solidFill>
+            <a:srgbClr val="FDFCF9"/>
+          </a:solidFill>
+          <a:ln w="6350">
+            <a:solidFill>
+              <a:srgbClr val="E2DFD6"/>
+            </a:solidFill>
+            <a:prstDash val="solid"/>
+          </a:ln>
+        </p:spPr>
+      </p:sp>
+      <p:sp>
+        <p:nvSpPr>
+          <p:cNvPr id="5" name="Text 3"/>
+          <p:cNvSpPr/>
+          <p:nvPr/>
+        </p:nvSpPr>
+        <p:spPr>
+          <a:xfrm>
+            <a:off x="1123950" y="2383135"/>
+            <a:ext cx="4696079" cy="233660"/>
+          </a:xfrm>
+          <a:prstGeom prst="rect">
+            <a:avLst/>
+          </a:prstGeom>
+          <a:noFill/>
+          <a:ln/>
+        </p:spPr>
+        <p:txBody>
+          <a:bodyPr wrap="square" lIns="0" tIns="0" rIns="0" bIns="0" rtlCol="0" anchor="t">
+            <a:normAutofit/>
+          </a:bodyPr>
+          <a:lstStyle/>
+          <a:p>
+            <a:pPr algn="l" indent="0" marL="0">
+              <a:lnSpc>
+                <a:spcPts val="1675"/>
+              </a:lnSpc>
+              <a:buNone/>
+            </a:pPr>
+            <a:r>
+              <a:rPr lang="en-US" sz="1196" dirty="0">
+                <a:solidFill>
+                  <a:srgbClr val="5F6979"/>
+                </a:solidFill>
+                <a:latin typeface="JetBrains Mono" pitchFamily="49" charset="0"/>
+                <a:ea typeface="JetBrains Mono" pitchFamily="49" charset="-122"/>
+                <a:cs typeface="JetBrains Mono" pitchFamily="49" charset="-120"/>
+              </a:rPr>
+              <a:t>GOOGLE RESEARCH BLOG</a:t>
+            </a:r>
+            <a:endParaRPr lang="en-US" sz="1196" dirty="0"/>
+          </a:p>
+        </p:txBody>
+      </p:sp>
+      <p:sp>
+        <p:nvSpPr>
+          <p:cNvPr id="6" name="Text 4"/>
+          <p:cNvSpPr/>
+          <p:nvPr/>
+        </p:nvSpPr>
+        <p:spPr>
+          <a:xfrm>
+            <a:off x="1123950" y="2718395"/>
+            <a:ext cx="4696079" cy="620713"/>
+          </a:xfrm>
+          <a:prstGeom prst="rect">
+            <a:avLst/>
+          </a:prstGeom>
+          <a:noFill/>
+          <a:ln/>
+        </p:spPr>
+        <p:txBody>
+          <a:bodyPr wrap="square" lIns="0" tIns="0" rIns="0" bIns="0" rtlCol="0" anchor="t">
+            <a:normAutofit/>
+          </a:bodyPr>
+          <a:lstStyle/>
+          <a:p>
+            <a:pPr algn="l" indent="0" marL="0">
+              <a:lnSpc>
+                <a:spcPts val="4710"/>
+              </a:lnSpc>
+              <a:buNone/>
+            </a:pPr>
+            <a:r>
+              <a:rPr lang="en-US" sz="4710" b="1" dirty="0">
+                <a:solidFill>
+                  <a:srgbClr val="0F1B2D"/>
+                </a:solidFill>
+                <a:latin typeface="IBM Plex Sans" pitchFamily="34" charset="0"/>
+                <a:ea typeface="IBM Plex Sans" pitchFamily="34" charset="-122"/>
+                <a:cs typeface="IBM Plex Sans" pitchFamily="34" charset="-120"/>
+              </a:rPr>
+              <a:t>up to 8x</a:t>
+            </a:r>
+            <a:endParaRPr lang="en-US" sz="4710" dirty="0"/>
+          </a:p>
+        </p:txBody>
+      </p:sp>
+      <p:sp>
+        <p:nvSpPr>
+          <p:cNvPr id="7" name="Text 5"/>
+          <p:cNvSpPr/>
+          <p:nvPr/>
+        </p:nvSpPr>
+        <p:spPr>
+          <a:xfrm>
+            <a:off x="1123950" y="3440708"/>
+            <a:ext cx="4696079" cy="1067098"/>
+          </a:xfrm>
+          <a:prstGeom prst="rect">
+            <a:avLst/>
+          </a:prstGeom>
+          <a:noFill/>
+          <a:ln/>
+        </p:spPr>
+        <p:txBody>
+          <a:bodyPr wrap="square" lIns="0" tIns="0" rIns="0" bIns="0" rtlCol="0" anchor="t">
+            <a:normAutofit/>
+          </a:bodyPr>
+          <a:lstStyle/>
+          <a:p>
+            <a:pPr algn="l" indent="0" marL="0">
+              <a:lnSpc>
+                <a:spcPts val="2054"/>
+              </a:lnSpc>
+              <a:buNone/>
+            </a:pPr>
+            <a:r>
+              <a:rPr lang="en-US" sz="1467" dirty="0">
+                <a:solidFill>
+                  <a:srgbClr val="3A4556"/>
+                </a:solidFill>
+                <a:latin typeface="IBM Plex Sans" pitchFamily="34" charset="0"/>
+                <a:ea typeface="IBM Plex Sans" pitchFamily="34" charset="-122"/>
+                <a:cs typeface="IBM Plex Sans" pitchFamily="34" charset="-120"/>
+              </a:rPr>
+              <a:t>faster attention-logit computation with 4-bit TurboQuant versus 32-bit keys on H100. At least 6x smaller KV memory on needle tasks, with 3-bit keys and no training.</a:t>
+            </a:r>
+            <a:endParaRPr lang="en-US" sz="1467" dirty="0"/>
+          </a:p>
+        </p:txBody>
+      </p:sp>
+      <p:sp>
+        <p:nvSpPr>
+          <p:cNvPr id="8" name="Shape 6"/>
+          <p:cNvSpPr/>
+          <p:nvPr/>
+        </p:nvSpPr>
+        <p:spPr>
+          <a:xfrm>
+            <a:off x="6200775" y="2075160"/>
+            <a:ext cx="5175250" cy="2715220"/>
+          </a:xfrm>
+          <a:prstGeom prst="roundRect">
+            <a:avLst>
+              <a:gd name="adj" fmla="val 3625"/>
+            </a:avLst>
+          </a:prstGeom>
+          <a:solidFill>
+            <a:srgbClr val="FDFCF9"/>
+          </a:solidFill>
+          <a:ln w="6350">
+            <a:solidFill>
+              <a:srgbClr val="E2DFD6"/>
+            </a:solidFill>
+            <a:prstDash val="solid"/>
+          </a:ln>
+        </p:spPr>
+      </p:sp>
+      <p:sp>
+        <p:nvSpPr>
+          <p:cNvPr id="9" name="Text 7"/>
+          <p:cNvSpPr/>
+          <p:nvPr/>
+        </p:nvSpPr>
+        <p:spPr>
+          <a:xfrm>
+            <a:off x="6508750" y="2383135"/>
+            <a:ext cx="4696079" cy="233660"/>
+          </a:xfrm>
+          <a:prstGeom prst="rect">
+            <a:avLst/>
+          </a:prstGeom>
+          <a:noFill/>
+          <a:ln/>
+        </p:spPr>
+        <p:txBody>
+          <a:bodyPr wrap="square" lIns="0" tIns="0" rIns="0" bIns="0" rtlCol="0" anchor="t">
+            <a:normAutofit/>
+          </a:bodyPr>
+          <a:lstStyle/>
+          <a:p>
+            <a:pPr algn="l" indent="0" marL="0">
+              <a:lnSpc>
+                <a:spcPts val="1675"/>
+              </a:lnSpc>
+              <a:buNone/>
+            </a:pPr>
+            <a:r>
+              <a:rPr lang="en-US" sz="1196" dirty="0">
+                <a:solidFill>
+                  <a:srgbClr val="5F6979"/>
+                </a:solidFill>
+                <a:latin typeface="JetBrains Mono" pitchFamily="49" charset="0"/>
+                <a:ea typeface="JetBrains Mono" pitchFamily="49" charset="-122"/>
+                <a:cs typeface="JetBrains Mono" pitchFamily="49" charset="-120"/>
+              </a:rPr>
+              <a:t>VLLM 0.20.2+ · H100</a:t>
+            </a:r>
+            <a:endParaRPr lang="en-US" sz="1196" dirty="0"/>
+          </a:p>
+        </p:txBody>
+      </p:sp>
+      <p:sp>
+        <p:nvSpPr>
+          <p:cNvPr id="10" name="Text 8"/>
+          <p:cNvSpPr/>
+          <p:nvPr/>
+        </p:nvSpPr>
+        <p:spPr>
+          <a:xfrm>
+            <a:off x="6508750" y="2718395"/>
+            <a:ext cx="4696079" cy="620713"/>
+          </a:xfrm>
+          <a:prstGeom prst="rect">
+            <a:avLst/>
+          </a:prstGeom>
+          <a:noFill/>
+          <a:ln/>
+        </p:spPr>
+        <p:txBody>
+          <a:bodyPr wrap="square" lIns="0" tIns="0" rIns="0" bIns="0" rtlCol="0" anchor="t">
+            <a:normAutofit/>
+          </a:bodyPr>
+          <a:lstStyle/>
+          <a:p>
+            <a:pPr algn="l" indent="0" marL="0">
+              <a:lnSpc>
+                <a:spcPts val="4710"/>
+              </a:lnSpc>
+              <a:buNone/>
+            </a:pPr>
+            <a:r>
+              <a:rPr lang="en-US" sz="4710" b="1" dirty="0">
+                <a:solidFill>
+                  <a:srgbClr val="0F1B2D"/>
+                </a:solidFill>
+                <a:latin typeface="IBM Plex Sans" pitchFamily="34" charset="0"/>
+                <a:ea typeface="IBM Plex Sans" pitchFamily="34" charset="-122"/>
+                <a:cs typeface="IBM Plex Sans" pitchFamily="34" charset="-120"/>
+              </a:rPr>
+              <a:t>2.3–3.7x</a:t>
+            </a:r>
+            <a:endParaRPr lang="en-US" sz="4710" dirty="0"/>
+          </a:p>
+        </p:txBody>
+      </p:sp>
+      <p:sp>
+        <p:nvSpPr>
+          <p:cNvPr id="11" name="Text 9"/>
+          <p:cNvSpPr/>
+          <p:nvPr/>
+        </p:nvSpPr>
+        <p:spPr>
+          <a:xfrm>
+            <a:off x="6508750" y="3440708"/>
+            <a:ext cx="4696079" cy="1067098"/>
+          </a:xfrm>
+          <a:prstGeom prst="rect">
+            <a:avLst/>
+          </a:prstGeom>
+          <a:noFill/>
+          <a:ln/>
+        </p:spPr>
+        <p:txBody>
+          <a:bodyPr wrap="square" lIns="0" tIns="0" rIns="0" bIns="0" rtlCol="0" anchor="t">
+            <a:normAutofit/>
+          </a:bodyPr>
+          <a:lstStyle/>
+          <a:p>
+            <a:pPr algn="l" indent="0" marL="0">
+              <a:lnSpc>
+                <a:spcPts val="2054"/>
+              </a:lnSpc>
+              <a:buNone/>
+            </a:pPr>
+            <a:r>
+              <a:rPr lang="en-US" sz="1467" dirty="0">
+                <a:solidFill>
+                  <a:srgbClr val="3A4556"/>
+                </a:solidFill>
+                <a:latin typeface="IBM Plex Sans" pitchFamily="34" charset="0"/>
+                <a:ea typeface="IBM Plex Sans" pitchFamily="34" charset="-122"/>
+                <a:cs typeface="IBM Plex Sans" pitchFamily="34" charset="-120"/>
+              </a:rPr>
+              <a:t>more KV-cache capacity, at 66–80% of BF16 throughput. The aggressive 3-bit variants drop up to ~20 points on hard math and coding; FP8 stays throughput-neutral.</a:t>
+            </a:r>
+            <a:endParaRPr lang="en-US" sz="1467" dirty="0"/>
+          </a:p>
+        </p:txBody>
+      </p:sp>
+      <p:sp>
+        <p:nvSpPr>
+          <p:cNvPr id="12" name="Text 10"/>
+          <p:cNvSpPr/>
+          <p:nvPr/>
+        </p:nvSpPr>
+        <p:spPr>
+          <a:xfrm>
+            <a:off x="812800" y="5098355"/>
+            <a:ext cx="10566400" cy="743645"/>
+          </a:xfrm>
+          <a:prstGeom prst="roundRect">
+            <a:avLst>
+              <a:gd name="adj" fmla="val 10247"/>
+            </a:avLst>
+          </a:prstGeom>
+          <a:solidFill>
+            <a:srgbClr val="E9E6DD"/>
+          </a:solidFill>
+          <a:ln/>
+        </p:spPr>
+        <p:txBody>
+          <a:bodyPr wrap="square" lIns="155482" tIns="104682" rIns="0" bIns="79282" rtlCol="0" anchor="t">
+            <a:normAutofit/>
+          </a:bodyPr>
+          <a:lstStyle/>
+          <a:p>
+            <a:pPr algn="l" indent="0" marL="0">
+              <a:lnSpc>
+                <a:spcPts val="1936"/>
+              </a:lnSpc>
+              <a:buNone/>
+            </a:pPr>
+            <a:r>
+              <a:rPr lang="en-US" sz="1383" dirty="0">
+                <a:solidFill>
+                  <a:srgbClr val="0F1B2D"/>
+                </a:solidFill>
+                <a:latin typeface="JetBrains Mono" pitchFamily="49" charset="0"/>
+                <a:ea typeface="JetBrains Mono" pitchFamily="49" charset="-122"/>
+                <a:cs typeface="JetBrains Mono" pitchFamily="49" charset="-120"/>
+              </a:rPr>
+              <a:t>vllm serve &lt;model&gt; --kv-cache-dtype turboquant_4bit_nc # or turboquant_k8v4, turboquant_k3v4_nc, turboquant_3bit_nc</a:t>
+            </a:r>
+            <a:endParaRPr lang="en-US" sz="1383" dirty="0"/>
+          </a:p>
+        </p:txBody>
+      </p:sp>
+      <p:sp>
+        <p:nvSpPr>
+          <p:cNvPr id="13" name="Text 11"/>
+          <p:cNvSpPr/>
+          <p:nvPr/>
+        </p:nvSpPr>
+        <p:spPr>
+          <a:xfrm>
+            <a:off x="812800" y="6238280"/>
+            <a:ext cx="10883392" cy="238720"/>
+          </a:xfrm>
+          <a:prstGeom prst="rect">
+            <a:avLst/>
+          </a:prstGeom>
+          <a:noFill/>
+          <a:ln/>
+        </p:spPr>
+        <p:txBody>
+          <a:bodyPr wrap="square" lIns="0" tIns="0" rIns="0" bIns="0" rtlCol="0" anchor="t">
+            <a:normAutofit/>
+          </a:bodyPr>
+          <a:lstStyle/>
+          <a:p>
+            <a:pPr algn="l" indent="0" marL="0">
+              <a:lnSpc>
+                <a:spcPts val="1680"/>
+              </a:lnSpc>
+              <a:buNone/>
+            </a:pPr>
+            <a:r>
+              <a:rPr lang="en-US" sz="1200" dirty="0">
+                <a:solidFill>
+                  <a:srgbClr val="5F6979"/>
+                </a:solidFill>
+                <a:latin typeface="IBM Plex Sans" pitchFamily="34" charset="0"/>
+                <a:ea typeface="IBM Plex Sans" pitchFamily="34" charset="-122"/>
+                <a:cs typeface="IBM Plex Sans" pitchFamily="34" charset="-120"/>
+              </a:rPr>
+              <a:t>Sources: research.google/blog/turboquant-redefining-ai-efficiency-with-extreme-compression · vllm.ai/blog/2026-05-11-turboquant</a:t>
+            </a:r>
+            <a:endParaRPr lang="en-US" sz="1200" dirty="0"/>
+          </a:p>
+        </p:txBody>
+      </p:sp>
+    </p:spTree>
+  </p:cSld>
+  <p:clrMapOvr>
+    <a:masterClrMapping/>
+  </p:clrMapOvr>
+</p:sld>
+</file>
+
+<file path=ppt/slides/slide11.xml><?xml version="1.0" encoding="utf-8"?>
+<p:sld xmlns:a="http://schemas.openxmlformats.org/drawingml/2006/main" xmlns:r="http://schemas.openxmlformats.org/officeDocument/2006/relationships" xmlns:p="http://schemas.openxmlformats.org/presentationml/2006/main">
   <p:cSld name="Slide 10">
     <p:bg>
       <p:bgPr>
@@ -4797,7 +5400,7 @@
 </p:sld>
 </file>
 
-<file path=ppt/slides/slide11.xml><?xml version="1.0" encoding="utf-8"?>
+<file path=ppt/slides/slide12.xml><?xml version="1.0" encoding="utf-8"?>
 <p:sld xmlns:a="http://schemas.openxmlformats.org/drawingml/2006/main" xmlns:r="http://schemas.openxmlformats.org/officeDocument/2006/relationships" xmlns:p="http://schemas.openxmlformats.org/presentationml/2006/main">
   <p:cSld name="Slide 11">
     <p:bg>
@@ -5271,7 +5874,7 @@
 </p:sld>
 </file>
 
-<file path=ppt/slides/slide12.xml><?xml version="1.0" encoding="utf-8"?>
+<file path=ppt/slides/slide13.xml><?xml version="1.0" encoding="utf-8"?>
 <p:sld xmlns:a="http://schemas.openxmlformats.org/drawingml/2006/main" xmlns:r="http://schemas.openxmlformats.org/officeDocument/2006/relationships" xmlns:p="http://schemas.openxmlformats.org/presentationml/2006/main">
   <p:cSld name="Slide 12">
     <p:bg>
@@ -5819,7 +6422,7 @@
 </p:sld>
 </file>
 
-<file path=ppt/slides/slide13.xml><?xml version="1.0" encoding="utf-8"?>
+<file path=ppt/slides/slide14.xml><?xml version="1.0" encoding="utf-8"?>
 <p:sld xmlns:a="http://schemas.openxmlformats.org/drawingml/2006/main" xmlns:r="http://schemas.openxmlformats.org/officeDocument/2006/relationships" xmlns:p="http://schemas.openxmlformats.org/presentationml/2006/main">
   <p:cSld name="Slide 13">
     <p:bg>
@@ -8015,7 +8618,7 @@
 </p:sld>
 </file>
 
-<file path=ppt/slides/slide14.xml><?xml version="1.0" encoding="utf-8"?>
+<file path=ppt/slides/slide15.xml><?xml version="1.0" encoding="utf-8"?>
 <p:sld xmlns:a="http://schemas.openxmlformats.org/drawingml/2006/main" xmlns:r="http://schemas.openxmlformats.org/officeDocument/2006/relationships" xmlns:p="http://schemas.openxmlformats.org/presentationml/2006/main">
   <p:cSld name="Slide 14">
     <p:bg>
@@ -13101,7 +13704,7 @@
 </p:sld>
 </file>
 
-<file path=ppt/slides/slide15.xml><?xml version="1.0" encoding="utf-8"?>
+<file path=ppt/slides/slide16.xml><?xml version="1.0" encoding="utf-8"?>
 <p:sld xmlns:a="http://schemas.openxmlformats.org/drawingml/2006/main" xmlns:r="http://schemas.openxmlformats.org/officeDocument/2006/relationships" xmlns:p="http://schemas.openxmlformats.org/presentationml/2006/main">
   <p:cSld name="Slide 15">
     <p:bg>
@@ -14240,7 +14843,7 @@
 </p:sld>
 </file>
 
-<file path=ppt/slides/slide16.xml><?xml version="1.0" encoding="utf-8"?>
+<file path=ppt/slides/slide17.xml><?xml version="1.0" encoding="utf-8"?>
 <p:sld xmlns:a="http://schemas.openxmlformats.org/drawingml/2006/main" xmlns:p="http://schemas.openxmlformats.org/presentationml/2006/main" xmlns:r="http://schemas.openxmlformats.org/officeDocument/2006/relationships">
   <p:cSld>
     <p:spTree>
@@ -14736,7 +15339,7 @@
 </p:sld>
 </file>
 
-<file path=ppt/slides/slide17.xml><?xml version="1.0" encoding="utf-8"?>
+<file path=ppt/slides/slide18.xml><?xml version="1.0" encoding="utf-8"?>
 <p:sld xmlns:a="http://schemas.openxmlformats.org/drawingml/2006/main" xmlns:p="http://schemas.openxmlformats.org/presentationml/2006/main" xmlns:r="http://schemas.openxmlformats.org/officeDocument/2006/relationships">
   <p:cSld>
     <p:spTree>
@@ -17016,7 +17619,7 @@
 </p:sld>
 </file>
 
-<file path=ppt/slides/slide18.xml><?xml version="1.0" encoding="utf-8"?>
+<file path=ppt/slides/slide19.xml><?xml version="1.0" encoding="utf-8"?>
 <p:sld xmlns:a="http://schemas.openxmlformats.org/drawingml/2006/main" xmlns:p="http://schemas.openxmlformats.org/presentationml/2006/main" xmlns:r="http://schemas.openxmlformats.org/officeDocument/2006/relationships">
   <p:cSld>
     <p:spTree>
@@ -18848,7 +19451,190 @@
 </p:sld>
 </file>
 
-<file path=ppt/slides/slide19.xml><?xml version="1.0" encoding="utf-8"?>
+<file path=ppt/slides/slide2.xml><?xml version="1.0" encoding="utf-8"?>
+<p:sld xmlns:a="http://schemas.openxmlformats.org/drawingml/2006/main" xmlns:p="http://schemas.openxmlformats.org/presentationml/2006/main" xmlns:r="http://schemas.openxmlformats.org/officeDocument/2006/relationships">
+  <p:cSld>
+    <p:bg>
+      <p:bgPr>
+        <a:solidFill>
+          <a:srgbClr val="F6F5F0"/>
+        </a:solidFill>
+      </p:bgPr>
+    </p:bg>
+    <p:spTree>
+      <p:nvGrpSpPr>
+        <p:cNvPr id="1" name=""/>
+        <p:cNvGrpSpPr/>
+        <p:nvPr/>
+      </p:nvGrpSpPr>
+      <p:grpSpPr/>
+      <p:sp>
+        <p:nvSpPr>
+          <p:cNvPr id="2" name="Text 0"/>
+          <p:cNvSpPr/>
+          <p:nvPr/>
+        </p:nvSpPr>
+        <p:spPr>
+          <a:xfrm>
+            <a:off x="812800" y="812800"/>
+            <a:ext cx="10883392" cy="238720"/>
+          </a:xfrm>
+          <a:prstGeom prst="rect">
+            <a:avLst/>
+          </a:prstGeom>
+          <a:noFill/>
+          <a:ln/>
+        </p:spPr>
+        <p:txBody>
+          <a:bodyPr wrap="square" lIns="0" tIns="0" rIns="0" bIns="0" rtlCol="0" anchor="t">
+            <a:normAutofit/>
+          </a:bodyPr>
+          <a:lstStyle/>
+          <a:p>
+            <a:pPr algn="l" indent="0" marL="0">
+              <a:lnSpc>
+                <a:spcPts val="1680"/>
+              </a:lnSpc>
+              <a:buNone/>
+            </a:pPr>
+            <a:r>
+              <a:rPr lang="en-US" sz="1200" spc="100" kern="0" dirty="0">
+                <a:solidFill>
+                  <a:srgbClr val="B4521A"/>
+                </a:solidFill>
+                <a:latin typeface="JetBrains Mono" pitchFamily="49" charset="0"/>
+                <a:ea typeface="JetBrains Mono" pitchFamily="49" charset="-122"/>
+                <a:cs typeface="JetBrains Mono" pitchFamily="49" charset="-120"/>
+              </a:rPr>
+              <a:t>BACKGROUND · THE KV CACHE</a:t>
+            </a:r>
+            <a:endParaRPr lang="en-US" sz="1200" dirty="0"/>
+          </a:p>
+        </p:txBody>
+      </p:sp>
+      <p:sp>
+        <p:nvSpPr>
+          <p:cNvPr id="3" name="Text 1"/>
+          <p:cNvSpPr/>
+          <p:nvPr>
+            <p:ph type="title"/>
+          </p:nvPr>
+        </p:nvSpPr>
+        <p:spPr>
+          <a:xfrm>
+            <a:off x="812800" y="1330920"/>
+            <a:ext cx="10883392" cy="560000"/>
+          </a:xfrm>
+          <a:prstGeom prst="rect">
+            <a:avLst/>
+          </a:prstGeom>
+          <a:noFill/>
+          <a:ln/>
+        </p:spPr>
+        <p:txBody>
+          <a:bodyPr wrap="square" lIns="0" tIns="0" rIns="0" bIns="0" rtlCol="0" anchor="t">
+            <a:normAutofit/>
+          </a:bodyPr>
+          <a:lstStyle/>
+          <a:p>
+            <a:pPr algn="l" indent="0" marL="0">
+              <a:lnSpc>
+                <a:spcPts val="3520"/>
+              </a:lnSpc>
+              <a:buNone/>
+            </a:pPr>
+            <a:r>
+              <a:rPr lang="en-US" sz="3200" b="1" i="0" dirty="0">
+                <a:solidFill>
+                  <a:srgbClr val="0F1B2D"/>
+                </a:solidFill>
+                <a:latin typeface="IBM Plex Sans" pitchFamily="34" charset="0"/>
+                <a:ea typeface="IBM Plex Sans" pitchFamily="34" charset="-122"/>
+                <a:cs typeface="IBM Plex Sans" pitchFamily="34" charset="-120"/>
+              </a:rPr>
+              <a:t>The KV cache: compute once, reuse at every step</a:t>
+            </a:r>
+            <a:endParaRPr lang="en-US" sz="3200" dirty="0"/>
+          </a:p>
+        </p:txBody>
+      </p:sp>
+      <p:sp>
+        <p:nvSpPr>
+          <p:cNvPr id="12" name="Text 10"/>
+          <p:cNvSpPr/>
+          <p:nvPr/>
+        </p:nvSpPr>
+        <p:spPr>
+          <a:xfrm>
+            <a:off x="812800" y="6500000"/>
+            <a:ext cx="10883392" cy="238720"/>
+          </a:xfrm>
+          <a:prstGeom prst="rect">
+            <a:avLst/>
+          </a:prstGeom>
+          <a:noFill/>
+          <a:ln/>
+        </p:spPr>
+        <p:txBody>
+          <a:bodyPr wrap="square" lIns="0" tIns="0" rIns="0" bIns="0" rtlCol="0" anchor="t">
+            <a:normAutofit/>
+          </a:bodyPr>
+          <a:lstStyle/>
+          <a:p>
+            <a:pPr algn="l" indent="0" marL="0">
+              <a:lnSpc>
+                <a:spcPts val="1680"/>
+              </a:lnSpc>
+              <a:buNone/>
+            </a:pPr>
+            <a:r>
+              <a:rPr lang="en-US" sz="1200" dirty="0">
+                <a:solidFill>
+                  <a:srgbClr val="5F6979"/>
+                </a:solidFill>
+                <a:latin typeface="IBM Plex Sans" pitchFamily="34" charset="0"/>
+                <a:ea typeface="IBM Plex Sans" pitchFamily="34" charset="-122"/>
+                <a:cs typeface="IBM Plex Sans" pitchFamily="34" charset="-120"/>
+              </a:rPr>
+              <a:t>The price: one K and one V per token, in every layer and head. That is what TurboQuant compresses.</a:t>
+            </a:r>
+            <a:endParaRPr lang="en-US" sz="1200" dirty="0"/>
+          </a:p>
+        </p:txBody>
+      </p:sp>
+      <p:pic>
+        <p:nvPicPr>
+          <p:cNvPr id="13" name="Picture 12" descr="fig15_kvcache_basics_deck_en.png"/>
+          <p:cNvPicPr>
+            <a:picLocks noChangeAspect="1"/>
+          </p:cNvPicPr>
+          <p:nvPr/>
+        </p:nvPicPr>
+        <p:blipFill>
+          <a:blip r:embed="rId2"/>
+          <a:stretch>
+            <a:fillRect/>
+          </a:stretch>
+        </p:blipFill>
+        <p:spPr>
+          <a:xfrm>
+            <a:off x="486299" y="1900000"/>
+            <a:ext cx="10883392" cy="4527491"/>
+          </a:xfrm>
+          <a:prstGeom prst="rect">
+            <a:avLst/>
+          </a:prstGeom>
+        </p:spPr>
+      </p:pic>
+    </p:spTree>
+  </p:cSld>
+  <p:clrMapOvr>
+    <a:masterClrMapping/>
+  </p:clrMapOvr>
+</p:sld>
+</file>
+
+<file path=ppt/slides/slide20.xml><?xml version="1.0" encoding="utf-8"?>
 <p:sld xmlns:a="http://schemas.openxmlformats.org/drawingml/2006/main" xmlns:p="http://schemas.openxmlformats.org/presentationml/2006/main" xmlns:r="http://schemas.openxmlformats.org/officeDocument/2006/relationships">
   <p:cSld>
     <p:spTree>
@@ -19344,513 +20130,7 @@
 </p:sld>
 </file>
 
-<file path=ppt/slides/slide2.xml><?xml version="1.0" encoding="utf-8"?>
-<p:sld xmlns:a="http://schemas.openxmlformats.org/drawingml/2006/main" xmlns:r="http://schemas.openxmlformats.org/officeDocument/2006/relationships" xmlns:p="http://schemas.openxmlformats.org/presentationml/2006/main">
-  <p:cSld name="Slide 2">
-    <p:bg>
-      <p:bgPr>
-        <a:solidFill>
-          <a:srgbClr val="F6F5F0"/>
-        </a:solidFill>
-      </p:bgPr>
-    </p:bg>
-    <p:spTree>
-      <p:nvGrpSpPr>
-        <p:cNvPr id="1" name=""/>
-        <p:cNvGrpSpPr/>
-        <p:nvPr/>
-      </p:nvGrpSpPr>
-      <p:grpSpPr>
-        <a:xfrm>
-          <a:off x="0" y="0"/>
-          <a:ext cx="0" cy="0"/>
-          <a:chOff x="0" y="0"/>
-          <a:chExt cx="0" cy="0"/>
-        </a:xfrm>
-      </p:grpSpPr>
-      <p:sp>
-        <p:nvSpPr>
-          <p:cNvPr id="2" name="Text 0"/>
-          <p:cNvSpPr/>
-          <p:nvPr/>
-        </p:nvSpPr>
-        <p:spPr>
-          <a:xfrm>
-            <a:off x="812800" y="812800"/>
-            <a:ext cx="10883392" cy="238720"/>
-          </a:xfrm>
-          <a:prstGeom prst="rect">
-            <a:avLst/>
-          </a:prstGeom>
-          <a:noFill/>
-          <a:ln/>
-        </p:spPr>
-        <p:txBody>
-          <a:bodyPr wrap="square" lIns="0" tIns="0" rIns="0" bIns="0" rtlCol="0" anchor="t">
-            <a:normAutofit/>
-          </a:bodyPr>
-          <a:lstStyle/>
-          <a:p>
-            <a:pPr algn="l" indent="0" marL="0">
-              <a:lnSpc>
-                <a:spcPts val="1680"/>
-              </a:lnSpc>
-              <a:buNone/>
-            </a:pPr>
-            <a:r>
-              <a:rPr lang="en-US" sz="1200" spc="100" kern="0" dirty="0">
-                <a:solidFill>
-                  <a:srgbClr val="B4521A"/>
-                </a:solidFill>
-                <a:latin typeface="JetBrains Mono" pitchFamily="49" charset="0"/>
-                <a:ea typeface="JetBrains Mono" pitchFamily="49" charset="-122"/>
-                <a:cs typeface="JetBrains Mono" pitchFamily="49" charset="-120"/>
-              </a:rPr>
-              <a:t>THE PROBLEM</a:t>
-            </a:r>
-            <a:endParaRPr lang="en-US" sz="1200" dirty="0"/>
-          </a:p>
-        </p:txBody>
-      </p:sp>
-      <p:sp>
-        <p:nvSpPr>
-          <p:cNvPr id="3" name="Text 1"/>
-          <p:cNvSpPr/>
-          <p:nvPr>
-            <p:ph type="title"/>
-          </p:nvPr>
-        </p:nvSpPr>
-        <p:spPr>
-          <a:xfrm>
-            <a:off x="812800" y="1330920"/>
-            <a:ext cx="10883392" cy="919361"/>
-          </a:xfrm>
-          <a:prstGeom prst="rect">
-            <a:avLst/>
-          </a:prstGeom>
-          <a:noFill/>
-          <a:ln/>
-        </p:spPr>
-        <p:txBody>
-          <a:bodyPr wrap="square" lIns="0" tIns="0" rIns="0" bIns="0" rtlCol="0" anchor="t">
-            <a:normAutofit/>
-          </a:bodyPr>
-          <a:lstStyle/>
-          <a:p>
-            <a:pPr algn="l" indent="0" marL="0">
-              <a:lnSpc>
-                <a:spcPts val="3520"/>
-              </a:lnSpc>
-              <a:buNone/>
-            </a:pPr>
-            <a:r>
-              <a:rPr lang="en-US" sz="3200" b="1" i="0" dirty="0">
-                <a:solidFill>
-                  <a:srgbClr val="0F1B2D"/>
-                </a:solidFill>
-                <a:latin typeface="IBM Plex Sans" pitchFamily="34" charset="0"/>
-                <a:ea typeface="IBM Plex Sans" pitchFamily="34" charset="-122"/>
-                <a:cs typeface="IBM Plex Sans" pitchFamily="34" charset="-120"/>
-              </a:rPr>
-              <a:t>Memory, not compute, limits long context and large indexes</a:t>
-            </a:r>
-            <a:endParaRPr lang="en-US" sz="3200" dirty="0"/>
-          </a:p>
-        </p:txBody>
-      </p:sp>
-      <p:sp>
-        <p:nvSpPr>
-          <p:cNvPr id="4" name="Shape 2"/>
-          <p:cNvSpPr/>
-          <p:nvPr/>
-        </p:nvSpPr>
-        <p:spPr>
-          <a:xfrm>
-            <a:off x="815975" y="2532856"/>
-            <a:ext cx="5175250" cy="3305969"/>
-          </a:xfrm>
-          <a:prstGeom prst="roundRect">
-            <a:avLst>
-              <a:gd name="adj" fmla="val 2977"/>
-            </a:avLst>
-          </a:prstGeom>
-          <a:solidFill>
-            <a:srgbClr val="FDFCF9"/>
-          </a:solidFill>
-          <a:ln w="6350">
-            <a:solidFill>
-              <a:srgbClr val="E2DFD6"/>
-            </a:solidFill>
-            <a:prstDash val="solid"/>
-          </a:ln>
-        </p:spPr>
-      </p:sp>
-      <p:sp>
-        <p:nvSpPr>
-          <p:cNvPr id="5" name="Text 3"/>
-          <p:cNvSpPr/>
-          <p:nvPr/>
-        </p:nvSpPr>
-        <p:spPr>
-          <a:xfrm>
-            <a:off x="1123950" y="2840831"/>
-            <a:ext cx="4696079" cy="238720"/>
-          </a:xfrm>
-          <a:prstGeom prst="rect">
-            <a:avLst/>
-          </a:prstGeom>
-          <a:noFill/>
-          <a:ln/>
-        </p:spPr>
-        <p:txBody>
-          <a:bodyPr wrap="square" lIns="0" tIns="0" rIns="0" bIns="0" rtlCol="0" anchor="t">
-            <a:normAutofit/>
-          </a:bodyPr>
-          <a:lstStyle/>
-          <a:p>
-            <a:pPr algn="l" indent="0" marL="0">
-              <a:lnSpc>
-                <a:spcPts val="1680"/>
-              </a:lnSpc>
-              <a:buNone/>
-            </a:pPr>
-            <a:r>
-              <a:rPr lang="en-US" sz="1200" dirty="0">
-                <a:solidFill>
-                  <a:srgbClr val="5F6979"/>
-                </a:solidFill>
-                <a:latin typeface="JetBrains Mono" pitchFamily="49" charset="0"/>
-                <a:ea typeface="JetBrains Mono" pitchFamily="49" charset="-122"/>
-                <a:cs typeface="JetBrains Mono" pitchFamily="49" charset="-120"/>
-              </a:rPr>
-              <a:t>LLM KV CACHE · LLAMA-3.1-8B, FP16</a:t>
-            </a:r>
-            <a:endParaRPr lang="en-US" sz="1200" dirty="0"/>
-          </a:p>
-        </p:txBody>
-      </p:sp>
-      <p:sp>
-        <p:nvSpPr>
-          <p:cNvPr id="6" name="Text 4"/>
-          <p:cNvSpPr/>
-          <p:nvPr/>
-        </p:nvSpPr>
-        <p:spPr>
-          <a:xfrm>
-            <a:off x="1123950" y="3181152"/>
-            <a:ext cx="4696079" cy="635000"/>
-          </a:xfrm>
-          <a:prstGeom prst="rect">
-            <a:avLst/>
-          </a:prstGeom>
-          <a:noFill/>
-          <a:ln/>
-        </p:spPr>
-        <p:txBody>
-          <a:bodyPr wrap="square" lIns="0" tIns="0" rIns="0" bIns="0" rtlCol="0" anchor="t">
-            <a:normAutofit/>
-          </a:bodyPr>
-          <a:lstStyle/>
-          <a:p>
-            <a:pPr algn="l" indent="0" marL="0">
-              <a:lnSpc>
-                <a:spcPts val="4800"/>
-              </a:lnSpc>
-              <a:buNone/>
-            </a:pPr>
-            <a:r>
-              <a:rPr lang="en-US" sz="4800" b="1" dirty="0">
-                <a:solidFill>
-                  <a:srgbClr val="0F1B2D"/>
-                </a:solidFill>
-                <a:latin typeface="IBM Plex Sans" pitchFamily="34" charset="0"/>
-                <a:ea typeface="IBM Plex Sans" pitchFamily="34" charset="-122"/>
-                <a:cs typeface="IBM Plex Sans" pitchFamily="34" charset="-120"/>
-              </a:rPr>
-              <a:t>128 KB</a:t>
-            </a:r>
-            <a:endParaRPr lang="en-US" sz="4800" dirty="0"/>
-          </a:p>
-        </p:txBody>
-      </p:sp>
-      <p:sp>
-        <p:nvSpPr>
-          <p:cNvPr id="7" name="Text 5"/>
-          <p:cNvSpPr/>
-          <p:nvPr/>
-        </p:nvSpPr>
-        <p:spPr>
-          <a:xfrm>
-            <a:off x="1123950" y="3917752"/>
-            <a:ext cx="4696079" cy="1163241"/>
-          </a:xfrm>
-          <a:prstGeom prst="rect">
-            <a:avLst/>
-          </a:prstGeom>
-          <a:noFill/>
-          <a:ln/>
-        </p:spPr>
-        <p:txBody>
-          <a:bodyPr wrap="square" lIns="0" tIns="0" rIns="0" bIns="0" rtlCol="0" anchor="t">
-            <a:normAutofit/>
-          </a:bodyPr>
-          <a:lstStyle/>
-          <a:p>
-            <a:pPr algn="l" indent="0" marL="0">
-              <a:lnSpc>
-                <a:spcPts val="2240"/>
-              </a:lnSpc>
-              <a:buNone/>
-            </a:pPr>
-            <a:r>
-              <a:rPr lang="en-US" sz="1600" dirty="0">
-                <a:solidFill>
-                  <a:srgbClr val="3A4556"/>
-                </a:solidFill>
-                <a:latin typeface="IBM Plex Sans" pitchFamily="34" charset="0"/>
-                <a:ea typeface="IBM Plex Sans" pitchFamily="34" charset="-122"/>
-                <a:cs typeface="IBM Plex Sans" pitchFamily="34" charset="-120"/>
-              </a:rPr>
-              <a:t>per token (32 layers × 8 KV heads × 128 dims × K and V × 2 bytes). A 128k-token context needs </a:t>
-            </a:r>
-            <a:r>
-              <a:rPr lang="en-US" sz="1600" b="1" dirty="0">
-                <a:solidFill>
-                  <a:srgbClr val="3A4556"/>
-                </a:solidFill>
-                <a:latin typeface="IBM Plex Sans" pitchFamily="34" charset="0"/>
-                <a:ea typeface="IBM Plex Sans" pitchFamily="34" charset="-122"/>
-                <a:cs typeface="IBM Plex Sans" pitchFamily="34" charset="-120"/>
-              </a:rPr>
-              <a:t>16 GB</a:t>
-            </a:r>
-            <a:r>
-              <a:rPr lang="en-US" sz="1600" dirty="0">
-                <a:solidFill>
-                  <a:srgbClr val="3A4556"/>
-                </a:solidFill>
-                <a:latin typeface="IBM Plex Sans" pitchFamily="34" charset="0"/>
-                <a:ea typeface="IBM Plex Sans" pitchFamily="34" charset="-122"/>
-                <a:cs typeface="IBM Plex Sans" pitchFamily="34" charset="-120"/>
-              </a:rPr>
-              <a:t>, as much as the weights, and every generated token re-reads all of it.</a:t>
-            </a:r>
-            <a:endParaRPr lang="en-US" sz="1600" dirty="0"/>
-          </a:p>
-        </p:txBody>
-      </p:sp>
-      <p:sp>
-        <p:nvSpPr>
-          <p:cNvPr id="8" name="Shape 6"/>
-          <p:cNvSpPr/>
-          <p:nvPr/>
-        </p:nvSpPr>
-        <p:spPr>
-          <a:xfrm>
-            <a:off x="6200775" y="2532856"/>
-            <a:ext cx="5175250" cy="3305969"/>
-          </a:xfrm>
-          <a:prstGeom prst="roundRect">
-            <a:avLst>
-              <a:gd name="adj" fmla="val 2977"/>
-            </a:avLst>
-          </a:prstGeom>
-          <a:solidFill>
-            <a:srgbClr val="FDFCF9"/>
-          </a:solidFill>
-          <a:ln w="6350">
-            <a:solidFill>
-              <a:srgbClr val="E2DFD6"/>
-            </a:solidFill>
-            <a:prstDash val="solid"/>
-          </a:ln>
-        </p:spPr>
-      </p:sp>
-      <p:sp>
-        <p:nvSpPr>
-          <p:cNvPr id="9" name="Text 7"/>
-          <p:cNvSpPr/>
-          <p:nvPr/>
-        </p:nvSpPr>
-        <p:spPr>
-          <a:xfrm>
-            <a:off x="6508750" y="2840831"/>
-            <a:ext cx="4696079" cy="238720"/>
-          </a:xfrm>
-          <a:prstGeom prst="rect">
-            <a:avLst/>
-          </a:prstGeom>
-          <a:noFill/>
-          <a:ln/>
-        </p:spPr>
-        <p:txBody>
-          <a:bodyPr wrap="square" lIns="0" tIns="0" rIns="0" bIns="0" rtlCol="0" anchor="t">
-            <a:normAutofit/>
-          </a:bodyPr>
-          <a:lstStyle/>
-          <a:p>
-            <a:pPr algn="l" indent="0" marL="0">
-              <a:lnSpc>
-                <a:spcPts val="1680"/>
-              </a:lnSpc>
-              <a:buNone/>
-            </a:pPr>
-            <a:r>
-              <a:rPr lang="en-US" sz="1200" dirty="0">
-                <a:solidFill>
-                  <a:srgbClr val="5F6979"/>
-                </a:solidFill>
-                <a:latin typeface="JetBrains Mono" pitchFamily="49" charset="0"/>
-                <a:ea typeface="JetBrains Mono" pitchFamily="49" charset="-122"/>
-                <a:cs typeface="JetBrains Mono" pitchFamily="49" charset="-120"/>
-              </a:rPr>
-              <a:t>VECTOR INDEX · 1M × 1536-D FLOAT32</a:t>
-            </a:r>
-            <a:endParaRPr lang="en-US" sz="1200" dirty="0"/>
-          </a:p>
-        </p:txBody>
-      </p:sp>
-      <p:sp>
-        <p:nvSpPr>
-          <p:cNvPr id="10" name="Text 8"/>
-          <p:cNvSpPr/>
-          <p:nvPr/>
-        </p:nvSpPr>
-        <p:spPr>
-          <a:xfrm>
-            <a:off x="6508750" y="3181152"/>
-            <a:ext cx="4696079" cy="635000"/>
-          </a:xfrm>
-          <a:prstGeom prst="rect">
-            <a:avLst/>
-          </a:prstGeom>
-          <a:noFill/>
-          <a:ln/>
-        </p:spPr>
-        <p:txBody>
-          <a:bodyPr wrap="square" lIns="0" tIns="0" rIns="0" bIns="0" rtlCol="0" anchor="t">
-            <a:normAutofit/>
-          </a:bodyPr>
-          <a:lstStyle/>
-          <a:p>
-            <a:pPr algn="l" indent="0" marL="0">
-              <a:lnSpc>
-                <a:spcPts val="4800"/>
-              </a:lnSpc>
-              <a:buNone/>
-            </a:pPr>
-            <a:r>
-              <a:rPr lang="en-US" sz="4800" b="1" dirty="0">
-                <a:solidFill>
-                  <a:srgbClr val="0F1B2D"/>
-                </a:solidFill>
-                <a:latin typeface="IBM Plex Sans" pitchFamily="34" charset="0"/>
-                <a:ea typeface="IBM Plex Sans" pitchFamily="34" charset="-122"/>
-                <a:cs typeface="IBM Plex Sans" pitchFamily="34" charset="-120"/>
-              </a:rPr>
-              <a:t>6.1 GB</a:t>
-            </a:r>
-            <a:endParaRPr lang="en-US" sz="4800" dirty="0"/>
-          </a:p>
-        </p:txBody>
-      </p:sp>
-      <p:sp>
-        <p:nvSpPr>
-          <p:cNvPr id="11" name="Text 9"/>
-          <p:cNvSpPr/>
-          <p:nvPr/>
-        </p:nvSpPr>
-        <p:spPr>
-          <a:xfrm>
-            <a:off x="6508750" y="3917752"/>
-            <a:ext cx="4696079" cy="878780"/>
-          </a:xfrm>
-          <a:prstGeom prst="rect">
-            <a:avLst/>
-          </a:prstGeom>
-          <a:noFill/>
-          <a:ln/>
-        </p:spPr>
-        <p:txBody>
-          <a:bodyPr wrap="square" lIns="0" tIns="0" rIns="0" bIns="0" rtlCol="0" anchor="t">
-            <a:normAutofit/>
-          </a:bodyPr>
-          <a:lstStyle/>
-          <a:p>
-            <a:pPr algn="l" indent="0" marL="0">
-              <a:lnSpc>
-                <a:spcPts val="2240"/>
-              </a:lnSpc>
-              <a:buNone/>
-            </a:pPr>
-            <a:r>
-              <a:rPr lang="en-US" sz="1600" dirty="0">
-                <a:solidFill>
-                  <a:srgbClr val="3A4556"/>
-                </a:solidFill>
-                <a:latin typeface="IBM Plex Sans" pitchFamily="34" charset="0"/>
-                <a:ea typeface="IBM Plex Sans" pitchFamily="34" charset="-122"/>
-                <a:cs typeface="IBM Plex Sans" pitchFamily="34" charset="-120"/>
-              </a:rPr>
-              <a:t>for one million OpenAI-size embeddings. Product quantization shrinks it, but must train codebooks first and re-train when the data drifts.</a:t>
-            </a:r>
-            <a:endParaRPr lang="en-US" sz="1600" dirty="0"/>
-          </a:p>
-        </p:txBody>
-      </p:sp>
-      <p:sp>
-        <p:nvSpPr>
-          <p:cNvPr id="12" name="Text 10"/>
-          <p:cNvSpPr/>
-          <p:nvPr/>
-        </p:nvSpPr>
-        <p:spPr>
-          <a:xfrm>
-            <a:off x="812800" y="6238280"/>
-            <a:ext cx="10883392" cy="238720"/>
-          </a:xfrm>
-          <a:prstGeom prst="rect">
-            <a:avLst/>
-          </a:prstGeom>
-          <a:noFill/>
-          <a:ln/>
-        </p:spPr>
-        <p:txBody>
-          <a:bodyPr wrap="square" lIns="0" tIns="0" rIns="0" bIns="0" rtlCol="0" anchor="t">
-            <a:normAutofit/>
-          </a:bodyPr>
-          <a:lstStyle/>
-          <a:p>
-            <a:pPr algn="l" indent="0" marL="0">
-              <a:lnSpc>
-                <a:spcPts val="1680"/>
-              </a:lnSpc>
-              <a:buNone/>
-            </a:pPr>
-            <a:r>
-              <a:rPr lang="en-US" sz="1200" dirty="0">
-                <a:solidFill>
-                  <a:srgbClr val="5F6979"/>
-                </a:solidFill>
-                <a:latin typeface="IBM Plex Sans" pitchFamily="34" charset="0"/>
-                <a:ea typeface="IBM Plex Sans" pitchFamily="34" charset="-122"/>
-                <a:cs typeface="IBM Plex Sans" pitchFamily="34" charset="-120"/>
-              </a:rPr>
-              <a:t>Decode attention is memory-bandwidth bound: fewer bytes per token means more context, more concurrent users, and faster attention.</a:t>
-            </a:r>
-            <a:endParaRPr lang="en-US" sz="1200" dirty="0"/>
-          </a:p>
-        </p:txBody>
-      </p:sp>
-    </p:spTree>
-  </p:cSld>
-  <p:clrMapOvr>
-    <a:masterClrMapping/>
-  </p:clrMapOvr>
-</p:sld>
-</file>
-
-<file path=ppt/slides/slide20.xml><?xml version="1.0" encoding="utf-8"?>
+<file path=ppt/slides/slide21.xml><?xml version="1.0" encoding="utf-8"?>
 <p:sld xmlns:a="http://schemas.openxmlformats.org/drawingml/2006/main" xmlns:r="http://schemas.openxmlformats.org/officeDocument/2006/relationships" xmlns:p="http://schemas.openxmlformats.org/presentationml/2006/main">
   <p:cSld name="Slide 16">
     <p:bg>
@@ -20374,7 +20654,7 @@
 </p:sld>
 </file>
 
-<file path=ppt/slides/slide21.xml><?xml version="1.0" encoding="utf-8"?>
+<file path=ppt/slides/slide22.xml><?xml version="1.0" encoding="utf-8"?>
 <p:sld xmlns:a="http://schemas.openxmlformats.org/drawingml/2006/main" xmlns:r="http://schemas.openxmlformats.org/officeDocument/2006/relationships" xmlns:p="http://schemas.openxmlformats.org/presentationml/2006/main">
   <p:cSld name="Slide 17">
     <p:bg>
@@ -21473,7 +21753,7 @@
 </p:sld>
 </file>
 
-<file path=ppt/slides/slide22.xml><?xml version="1.0" encoding="utf-8"?>
+<file path=ppt/slides/slide23.xml><?xml version="1.0" encoding="utf-8"?>
 <p:sld xmlns:a="http://schemas.openxmlformats.org/drawingml/2006/main" xmlns:r="http://schemas.openxmlformats.org/officeDocument/2006/relationships" xmlns:p="http://schemas.openxmlformats.org/presentationml/2006/main">
   <p:cSld name="Slide 18">
     <p:bg>
@@ -21823,7 +22103,7 @@
 </p:sld>
 </file>
 
-<file path=ppt/slides/slide23.xml><?xml version="1.0" encoding="utf-8"?>
+<file path=ppt/slides/slide24.xml><?xml version="1.0" encoding="utf-8"?>
 <p:sld xmlns:a="http://schemas.openxmlformats.org/drawingml/2006/main" xmlns:p="http://schemas.openxmlformats.org/presentationml/2006/main" xmlns:r="http://schemas.openxmlformats.org/officeDocument/2006/relationships">
   <p:cSld>
     <p:bg>
@@ -21878,7 +22158,7 @@
                 <a:ea typeface="JetBrains Mono" pitchFamily="49" charset="-122"/>
                 <a:cs typeface="JetBrains Mono" pitchFamily="49" charset="-120"/>
               </a:rPr>
-              <a:t>BACKGROUND · THE KV CACHE</a:t>
+              <a:t>BACKGROUND · QUANTIZATION</a:t>
             </a:r>
             <a:endParaRPr lang="en-US" sz="1200" dirty="0"/>
           </a:p>
@@ -21924,7 +22204,7 @@
                 <a:ea typeface="IBM Plex Sans" pitchFamily="34" charset="-122"/>
                 <a:cs typeface="IBM Plex Sans" pitchFamily="34" charset="-120"/>
               </a:rPr>
-              <a:t>The KV cache: compute once, reuse at every step</a:t>
+              <a:t>Quantization: round, store a short code, read it back</a:t>
             </a:r>
             <a:endParaRPr lang="en-US" sz="3200" dirty="0"/>
           </a:p>
@@ -21968,7 +22248,7 @@
                 <a:ea typeface="IBM Plex Sans" pitchFamily="34" charset="-122"/>
                 <a:cs typeface="IBM Plex Sans" pitchFamily="34" charset="-120"/>
               </a:rPr>
-              <a:t>The price: one K and one V per token, in every layer and head. That is what TurboQuant compresses.</a:t>
+              <a:t>TurboQuant keeps steps 3 and 4 and replaces 1 and 2: rotate first, then use one fixed set of values, so no range is stored.</a:t>
             </a:r>
             <a:endParaRPr lang="en-US" sz="1200" dirty="0"/>
           </a:p>
@@ -21976,7 +22256,7 @@
       </p:sp>
       <p:pic>
         <p:nvPicPr>
-          <p:cNvPr id="13" name="Picture 12" descr="fig15_kvcache_basics_deck_en.png"/>
+          <p:cNvPr id="13" name="Picture 12" descr="slide_quant.png"/>
           <p:cNvPicPr>
             <a:picLocks noChangeAspect="1"/>
           </p:cNvPicPr>
@@ -21990,8 +22270,8 @@
         </p:blipFill>
         <p:spPr>
           <a:xfrm>
-            <a:off x="486299" y="1900000"/>
-            <a:ext cx="10883392" cy="4527491"/>
+            <a:off x="1330043" y="1900000"/>
+            <a:ext cx="9531914" cy="4480000"/>
           </a:xfrm>
           <a:prstGeom prst="rect">
             <a:avLst/>
@@ -22007,6 +22287,512 @@
 </file>
 
 <file path=ppt/slides/slide3.xml><?xml version="1.0" encoding="utf-8"?>
+<p:sld xmlns:a="http://schemas.openxmlformats.org/drawingml/2006/main" xmlns:r="http://schemas.openxmlformats.org/officeDocument/2006/relationships" xmlns:p="http://schemas.openxmlformats.org/presentationml/2006/main">
+  <p:cSld name="Slide 2">
+    <p:bg>
+      <p:bgPr>
+        <a:solidFill>
+          <a:srgbClr val="F6F5F0"/>
+        </a:solidFill>
+      </p:bgPr>
+    </p:bg>
+    <p:spTree>
+      <p:nvGrpSpPr>
+        <p:cNvPr id="1" name=""/>
+        <p:cNvGrpSpPr/>
+        <p:nvPr/>
+      </p:nvGrpSpPr>
+      <p:grpSpPr>
+        <a:xfrm>
+          <a:off x="0" y="0"/>
+          <a:ext cx="0" cy="0"/>
+          <a:chOff x="0" y="0"/>
+          <a:chExt cx="0" cy="0"/>
+        </a:xfrm>
+      </p:grpSpPr>
+      <p:sp>
+        <p:nvSpPr>
+          <p:cNvPr id="2" name="Text 0"/>
+          <p:cNvSpPr/>
+          <p:nvPr/>
+        </p:nvSpPr>
+        <p:spPr>
+          <a:xfrm>
+            <a:off x="812800" y="812800"/>
+            <a:ext cx="10883392" cy="238720"/>
+          </a:xfrm>
+          <a:prstGeom prst="rect">
+            <a:avLst/>
+          </a:prstGeom>
+          <a:noFill/>
+          <a:ln/>
+        </p:spPr>
+        <p:txBody>
+          <a:bodyPr wrap="square" lIns="0" tIns="0" rIns="0" bIns="0" rtlCol="0" anchor="t">
+            <a:normAutofit/>
+          </a:bodyPr>
+          <a:lstStyle/>
+          <a:p>
+            <a:pPr algn="l" indent="0" marL="0">
+              <a:lnSpc>
+                <a:spcPts val="1680"/>
+              </a:lnSpc>
+              <a:buNone/>
+            </a:pPr>
+            <a:r>
+              <a:rPr lang="en-US" sz="1200" spc="100" kern="0" dirty="0">
+                <a:solidFill>
+                  <a:srgbClr val="B4521A"/>
+                </a:solidFill>
+                <a:latin typeface="JetBrains Mono" pitchFamily="49" charset="0"/>
+                <a:ea typeface="JetBrains Mono" pitchFamily="49" charset="-122"/>
+                <a:cs typeface="JetBrains Mono" pitchFamily="49" charset="-120"/>
+              </a:rPr>
+              <a:t>THE PROBLEM</a:t>
+            </a:r>
+            <a:endParaRPr lang="en-US" sz="1200" dirty="0"/>
+          </a:p>
+        </p:txBody>
+      </p:sp>
+      <p:sp>
+        <p:nvSpPr>
+          <p:cNvPr id="3" name="Text 1"/>
+          <p:cNvSpPr/>
+          <p:nvPr>
+            <p:ph type="title"/>
+          </p:nvPr>
+        </p:nvSpPr>
+        <p:spPr>
+          <a:xfrm>
+            <a:off x="812800" y="1330920"/>
+            <a:ext cx="10883392" cy="919361"/>
+          </a:xfrm>
+          <a:prstGeom prst="rect">
+            <a:avLst/>
+          </a:prstGeom>
+          <a:noFill/>
+          <a:ln/>
+        </p:spPr>
+        <p:txBody>
+          <a:bodyPr wrap="square" lIns="0" tIns="0" rIns="0" bIns="0" rtlCol="0" anchor="t">
+            <a:normAutofit/>
+          </a:bodyPr>
+          <a:lstStyle/>
+          <a:p>
+            <a:pPr algn="l" indent="0" marL="0">
+              <a:lnSpc>
+                <a:spcPts val="3520"/>
+              </a:lnSpc>
+              <a:buNone/>
+            </a:pPr>
+            <a:r>
+              <a:rPr lang="en-US" sz="3200" b="1" i="0" dirty="0">
+                <a:solidFill>
+                  <a:srgbClr val="0F1B2D"/>
+                </a:solidFill>
+                <a:latin typeface="IBM Plex Sans" pitchFamily="34" charset="0"/>
+                <a:ea typeface="IBM Plex Sans" pitchFamily="34" charset="-122"/>
+                <a:cs typeface="IBM Plex Sans" pitchFamily="34" charset="-120"/>
+              </a:rPr>
+              <a:t>Memory, not compute, limits long context and large indexes</a:t>
+            </a:r>
+            <a:endParaRPr lang="en-US" sz="3200" dirty="0"/>
+          </a:p>
+        </p:txBody>
+      </p:sp>
+      <p:sp>
+        <p:nvSpPr>
+          <p:cNvPr id="4" name="Shape 2"/>
+          <p:cNvSpPr/>
+          <p:nvPr/>
+        </p:nvSpPr>
+        <p:spPr>
+          <a:xfrm>
+            <a:off x="815975" y="2532856"/>
+            <a:ext cx="5175250" cy="3305969"/>
+          </a:xfrm>
+          <a:prstGeom prst="roundRect">
+            <a:avLst>
+              <a:gd name="adj" fmla="val 2977"/>
+            </a:avLst>
+          </a:prstGeom>
+          <a:solidFill>
+            <a:srgbClr val="FDFCF9"/>
+          </a:solidFill>
+          <a:ln w="6350">
+            <a:solidFill>
+              <a:srgbClr val="E2DFD6"/>
+            </a:solidFill>
+            <a:prstDash val="solid"/>
+          </a:ln>
+        </p:spPr>
+      </p:sp>
+      <p:sp>
+        <p:nvSpPr>
+          <p:cNvPr id="5" name="Text 3"/>
+          <p:cNvSpPr/>
+          <p:nvPr/>
+        </p:nvSpPr>
+        <p:spPr>
+          <a:xfrm>
+            <a:off x="1123950" y="2840831"/>
+            <a:ext cx="4696079" cy="238720"/>
+          </a:xfrm>
+          <a:prstGeom prst="rect">
+            <a:avLst/>
+          </a:prstGeom>
+          <a:noFill/>
+          <a:ln/>
+        </p:spPr>
+        <p:txBody>
+          <a:bodyPr wrap="square" lIns="0" tIns="0" rIns="0" bIns="0" rtlCol="0" anchor="t">
+            <a:normAutofit/>
+          </a:bodyPr>
+          <a:lstStyle/>
+          <a:p>
+            <a:pPr algn="l" indent="0" marL="0">
+              <a:lnSpc>
+                <a:spcPts val="1680"/>
+              </a:lnSpc>
+              <a:buNone/>
+            </a:pPr>
+            <a:r>
+              <a:rPr lang="en-US" sz="1200" dirty="0">
+                <a:solidFill>
+                  <a:srgbClr val="5F6979"/>
+                </a:solidFill>
+                <a:latin typeface="JetBrains Mono" pitchFamily="49" charset="0"/>
+                <a:ea typeface="JetBrains Mono" pitchFamily="49" charset="-122"/>
+                <a:cs typeface="JetBrains Mono" pitchFamily="49" charset="-120"/>
+              </a:rPr>
+              <a:t>LLM KV CACHE · LLAMA-3.1-8B, FP16</a:t>
+            </a:r>
+            <a:endParaRPr lang="en-US" sz="1200" dirty="0"/>
+          </a:p>
+        </p:txBody>
+      </p:sp>
+      <p:sp>
+        <p:nvSpPr>
+          <p:cNvPr id="6" name="Text 4"/>
+          <p:cNvSpPr/>
+          <p:nvPr/>
+        </p:nvSpPr>
+        <p:spPr>
+          <a:xfrm>
+            <a:off x="1123950" y="3181152"/>
+            <a:ext cx="4696079" cy="635000"/>
+          </a:xfrm>
+          <a:prstGeom prst="rect">
+            <a:avLst/>
+          </a:prstGeom>
+          <a:noFill/>
+          <a:ln/>
+        </p:spPr>
+        <p:txBody>
+          <a:bodyPr wrap="square" lIns="0" tIns="0" rIns="0" bIns="0" rtlCol="0" anchor="t">
+            <a:normAutofit/>
+          </a:bodyPr>
+          <a:lstStyle/>
+          <a:p>
+            <a:pPr algn="l" indent="0" marL="0">
+              <a:lnSpc>
+                <a:spcPts val="4800"/>
+              </a:lnSpc>
+              <a:buNone/>
+            </a:pPr>
+            <a:r>
+              <a:rPr lang="en-US" sz="4800" b="1" dirty="0">
+                <a:solidFill>
+                  <a:srgbClr val="0F1B2D"/>
+                </a:solidFill>
+                <a:latin typeface="IBM Plex Sans" pitchFamily="34" charset="0"/>
+                <a:ea typeface="IBM Plex Sans" pitchFamily="34" charset="-122"/>
+                <a:cs typeface="IBM Plex Sans" pitchFamily="34" charset="-120"/>
+              </a:rPr>
+              <a:t>128 KB</a:t>
+            </a:r>
+            <a:endParaRPr lang="en-US" sz="4800" dirty="0"/>
+          </a:p>
+        </p:txBody>
+      </p:sp>
+      <p:sp>
+        <p:nvSpPr>
+          <p:cNvPr id="7" name="Text 5"/>
+          <p:cNvSpPr/>
+          <p:nvPr/>
+        </p:nvSpPr>
+        <p:spPr>
+          <a:xfrm>
+            <a:off x="1123950" y="3917752"/>
+            <a:ext cx="4696079" cy="1163241"/>
+          </a:xfrm>
+          <a:prstGeom prst="rect">
+            <a:avLst/>
+          </a:prstGeom>
+          <a:noFill/>
+          <a:ln/>
+        </p:spPr>
+        <p:txBody>
+          <a:bodyPr wrap="square" lIns="0" tIns="0" rIns="0" bIns="0" rtlCol="0" anchor="t">
+            <a:normAutofit/>
+          </a:bodyPr>
+          <a:lstStyle/>
+          <a:p>
+            <a:pPr algn="l" indent="0" marL="0">
+              <a:lnSpc>
+                <a:spcPts val="2240"/>
+              </a:lnSpc>
+              <a:buNone/>
+            </a:pPr>
+            <a:r>
+              <a:rPr lang="en-US" sz="1600" dirty="0">
+                <a:solidFill>
+                  <a:srgbClr val="3A4556"/>
+                </a:solidFill>
+                <a:latin typeface="IBM Plex Sans" pitchFamily="34" charset="0"/>
+                <a:ea typeface="IBM Plex Sans" pitchFamily="34" charset="-122"/>
+                <a:cs typeface="IBM Plex Sans" pitchFamily="34" charset="-120"/>
+              </a:rPr>
+              <a:t>per token (32 layers × 8 KV heads × 128 dims × K and V × 2 bytes). A 128k-token context needs </a:t>
+            </a:r>
+            <a:r>
+              <a:rPr lang="en-US" sz="1600" b="1" dirty="0">
+                <a:solidFill>
+                  <a:srgbClr val="3A4556"/>
+                </a:solidFill>
+                <a:latin typeface="IBM Plex Sans" pitchFamily="34" charset="0"/>
+                <a:ea typeface="IBM Plex Sans" pitchFamily="34" charset="-122"/>
+                <a:cs typeface="IBM Plex Sans" pitchFamily="34" charset="-120"/>
+              </a:rPr>
+              <a:t>16 GB</a:t>
+            </a:r>
+            <a:r>
+              <a:rPr lang="en-US" sz="1600" dirty="0">
+                <a:solidFill>
+                  <a:srgbClr val="3A4556"/>
+                </a:solidFill>
+                <a:latin typeface="IBM Plex Sans" pitchFamily="34" charset="0"/>
+                <a:ea typeface="IBM Plex Sans" pitchFamily="34" charset="-122"/>
+                <a:cs typeface="IBM Plex Sans" pitchFamily="34" charset="-120"/>
+              </a:rPr>
+              <a:t>, as much as the weights, and every generated token re-reads all of it.</a:t>
+            </a:r>
+            <a:endParaRPr lang="en-US" sz="1600" dirty="0"/>
+          </a:p>
+        </p:txBody>
+      </p:sp>
+      <p:sp>
+        <p:nvSpPr>
+          <p:cNvPr id="8" name="Shape 6"/>
+          <p:cNvSpPr/>
+          <p:nvPr/>
+        </p:nvSpPr>
+        <p:spPr>
+          <a:xfrm>
+            <a:off x="6200775" y="2532856"/>
+            <a:ext cx="5175250" cy="3305969"/>
+          </a:xfrm>
+          <a:prstGeom prst="roundRect">
+            <a:avLst>
+              <a:gd name="adj" fmla="val 2977"/>
+            </a:avLst>
+          </a:prstGeom>
+          <a:solidFill>
+            <a:srgbClr val="FDFCF9"/>
+          </a:solidFill>
+          <a:ln w="6350">
+            <a:solidFill>
+              <a:srgbClr val="E2DFD6"/>
+            </a:solidFill>
+            <a:prstDash val="solid"/>
+          </a:ln>
+        </p:spPr>
+      </p:sp>
+      <p:sp>
+        <p:nvSpPr>
+          <p:cNvPr id="9" name="Text 7"/>
+          <p:cNvSpPr/>
+          <p:nvPr/>
+        </p:nvSpPr>
+        <p:spPr>
+          <a:xfrm>
+            <a:off x="6508750" y="2840831"/>
+            <a:ext cx="4696079" cy="238720"/>
+          </a:xfrm>
+          <a:prstGeom prst="rect">
+            <a:avLst/>
+          </a:prstGeom>
+          <a:noFill/>
+          <a:ln/>
+        </p:spPr>
+        <p:txBody>
+          <a:bodyPr wrap="square" lIns="0" tIns="0" rIns="0" bIns="0" rtlCol="0" anchor="t">
+            <a:normAutofit/>
+          </a:bodyPr>
+          <a:lstStyle/>
+          <a:p>
+            <a:pPr algn="l" indent="0" marL="0">
+              <a:lnSpc>
+                <a:spcPts val="1680"/>
+              </a:lnSpc>
+              <a:buNone/>
+            </a:pPr>
+            <a:r>
+              <a:rPr lang="en-US" sz="1200" dirty="0">
+                <a:solidFill>
+                  <a:srgbClr val="5F6979"/>
+                </a:solidFill>
+                <a:latin typeface="JetBrains Mono" pitchFamily="49" charset="0"/>
+                <a:ea typeface="JetBrains Mono" pitchFamily="49" charset="-122"/>
+                <a:cs typeface="JetBrains Mono" pitchFamily="49" charset="-120"/>
+              </a:rPr>
+              <a:t>VECTOR INDEX · 1M × 1536-D FLOAT32</a:t>
+            </a:r>
+            <a:endParaRPr lang="en-US" sz="1200" dirty="0"/>
+          </a:p>
+        </p:txBody>
+      </p:sp>
+      <p:sp>
+        <p:nvSpPr>
+          <p:cNvPr id="10" name="Text 8"/>
+          <p:cNvSpPr/>
+          <p:nvPr/>
+        </p:nvSpPr>
+        <p:spPr>
+          <a:xfrm>
+            <a:off x="6508750" y="3181152"/>
+            <a:ext cx="4696079" cy="635000"/>
+          </a:xfrm>
+          <a:prstGeom prst="rect">
+            <a:avLst/>
+          </a:prstGeom>
+          <a:noFill/>
+          <a:ln/>
+        </p:spPr>
+        <p:txBody>
+          <a:bodyPr wrap="square" lIns="0" tIns="0" rIns="0" bIns="0" rtlCol="0" anchor="t">
+            <a:normAutofit/>
+          </a:bodyPr>
+          <a:lstStyle/>
+          <a:p>
+            <a:pPr algn="l" indent="0" marL="0">
+              <a:lnSpc>
+                <a:spcPts val="4800"/>
+              </a:lnSpc>
+              <a:buNone/>
+            </a:pPr>
+            <a:r>
+              <a:rPr lang="en-US" sz="4800" b="1" dirty="0">
+                <a:solidFill>
+                  <a:srgbClr val="0F1B2D"/>
+                </a:solidFill>
+                <a:latin typeface="IBM Plex Sans" pitchFamily="34" charset="0"/>
+                <a:ea typeface="IBM Plex Sans" pitchFamily="34" charset="-122"/>
+                <a:cs typeface="IBM Plex Sans" pitchFamily="34" charset="-120"/>
+              </a:rPr>
+              <a:t>6.1 GB</a:t>
+            </a:r>
+            <a:endParaRPr lang="en-US" sz="4800" dirty="0"/>
+          </a:p>
+        </p:txBody>
+      </p:sp>
+      <p:sp>
+        <p:nvSpPr>
+          <p:cNvPr id="11" name="Text 9"/>
+          <p:cNvSpPr/>
+          <p:nvPr/>
+        </p:nvSpPr>
+        <p:spPr>
+          <a:xfrm>
+            <a:off x="6508750" y="3917752"/>
+            <a:ext cx="4696079" cy="878780"/>
+          </a:xfrm>
+          <a:prstGeom prst="rect">
+            <a:avLst/>
+          </a:prstGeom>
+          <a:noFill/>
+          <a:ln/>
+        </p:spPr>
+        <p:txBody>
+          <a:bodyPr wrap="square" lIns="0" tIns="0" rIns="0" bIns="0" rtlCol="0" anchor="t">
+            <a:normAutofit/>
+          </a:bodyPr>
+          <a:lstStyle/>
+          <a:p>
+            <a:pPr algn="l" indent="0" marL="0">
+              <a:lnSpc>
+                <a:spcPts val="2240"/>
+              </a:lnSpc>
+              <a:buNone/>
+            </a:pPr>
+            <a:r>
+              <a:rPr lang="en-US" sz="1600" dirty="0">
+                <a:solidFill>
+                  <a:srgbClr val="3A4556"/>
+                </a:solidFill>
+                <a:latin typeface="IBM Plex Sans" pitchFamily="34" charset="0"/>
+                <a:ea typeface="IBM Plex Sans" pitchFamily="34" charset="-122"/>
+                <a:cs typeface="IBM Plex Sans" pitchFamily="34" charset="-120"/>
+              </a:rPr>
+              <a:t>for one million OpenAI-size embeddings. Product quantization shrinks it, but must train codebooks first and re-train when the data drifts.</a:t>
+            </a:r>
+            <a:endParaRPr lang="en-US" sz="1600" dirty="0"/>
+          </a:p>
+        </p:txBody>
+      </p:sp>
+      <p:sp>
+        <p:nvSpPr>
+          <p:cNvPr id="12" name="Text 10"/>
+          <p:cNvSpPr/>
+          <p:nvPr/>
+        </p:nvSpPr>
+        <p:spPr>
+          <a:xfrm>
+            <a:off x="812800" y="6238280"/>
+            <a:ext cx="10883392" cy="238720"/>
+          </a:xfrm>
+          <a:prstGeom prst="rect">
+            <a:avLst/>
+          </a:prstGeom>
+          <a:noFill/>
+          <a:ln/>
+        </p:spPr>
+        <p:txBody>
+          <a:bodyPr wrap="square" lIns="0" tIns="0" rIns="0" bIns="0" rtlCol="0" anchor="t">
+            <a:normAutofit/>
+          </a:bodyPr>
+          <a:lstStyle/>
+          <a:p>
+            <a:pPr algn="l" indent="0" marL="0">
+              <a:lnSpc>
+                <a:spcPts val="1680"/>
+              </a:lnSpc>
+              <a:buNone/>
+            </a:pPr>
+            <a:r>
+              <a:rPr lang="en-US" sz="1200" dirty="0">
+                <a:solidFill>
+                  <a:srgbClr val="5F6979"/>
+                </a:solidFill>
+                <a:latin typeface="IBM Plex Sans" pitchFamily="34" charset="0"/>
+                <a:ea typeface="IBM Plex Sans" pitchFamily="34" charset="-122"/>
+                <a:cs typeface="IBM Plex Sans" pitchFamily="34" charset="-120"/>
+              </a:rPr>
+              <a:t>Decode attention is memory-bandwidth bound: fewer bytes per token means more context, more concurrent users, and faster attention.</a:t>
+            </a:r>
+            <a:endParaRPr lang="en-US" sz="1200" dirty="0"/>
+          </a:p>
+        </p:txBody>
+      </p:sp>
+    </p:spTree>
+  </p:cSld>
+  <p:clrMapOvr>
+    <a:masterClrMapping/>
+  </p:clrMapOvr>
+</p:sld>
+</file>
+
+<file path=ppt/slides/slide4.xml><?xml version="1.0" encoding="utf-8"?>
 <p:sld xmlns:a="http://schemas.openxmlformats.org/drawingml/2006/main" xmlns:r="http://schemas.openxmlformats.org/officeDocument/2006/relationships" xmlns:p="http://schemas.openxmlformats.org/presentationml/2006/main">
   <p:cSld name="Slide 3">
     <p:bg>
@@ -24016,7 +24802,7 @@
 </p:sld>
 </file>
 
-<file path=ppt/slides/slide4.xml><?xml version="1.0" encoding="utf-8"?>
+<file path=ppt/slides/slide5.xml><?xml version="1.0" encoding="utf-8"?>
 <p:sld xmlns:a="http://schemas.openxmlformats.org/drawingml/2006/main" xmlns:r="http://schemas.openxmlformats.org/officeDocument/2006/relationships" xmlns:p="http://schemas.openxmlformats.org/presentationml/2006/main">
   <p:cSld name="Slide 4">
     <p:bg>
@@ -24654,7 +25440,7 @@
 </p:sld>
 </file>
 
-<file path=ppt/slides/slide5.xml><?xml version="1.0" encoding="utf-8"?>
+<file path=ppt/slides/slide6.xml><?xml version="1.0" encoding="utf-8"?>
 <p:sld xmlns:a="http://schemas.openxmlformats.org/drawingml/2006/main" xmlns:r="http://schemas.openxmlformats.org/officeDocument/2006/relationships" xmlns:p="http://schemas.openxmlformats.org/presentationml/2006/main">
   <p:cSld name="Slide 5">
     <p:bg>
@@ -25454,7 +26240,7 @@
 </p:sld>
 </file>
 
-<file path=ppt/slides/slide6.xml><?xml version="1.0" encoding="utf-8"?>
+<file path=ppt/slides/slide7.xml><?xml version="1.0" encoding="utf-8"?>
 <p:sld xmlns:a="http://schemas.openxmlformats.org/drawingml/2006/main" xmlns:r="http://schemas.openxmlformats.org/officeDocument/2006/relationships" xmlns:p="http://schemas.openxmlformats.org/presentationml/2006/main">
   <p:cSld name="Slide 6">
     <p:bg>
@@ -26198,7 +26984,7 @@
 </p:sld>
 </file>
 
-<file path=ppt/slides/slide7.xml><?xml version="1.0" encoding="utf-8"?>
+<file path=ppt/slides/slide8.xml><?xml version="1.0" encoding="utf-8"?>
 <p:sld xmlns:a="http://schemas.openxmlformats.org/drawingml/2006/main" xmlns:r="http://schemas.openxmlformats.org/officeDocument/2006/relationships" xmlns:p="http://schemas.openxmlformats.org/presentationml/2006/main">
   <p:cSld name="Slide 7">
     <p:bg>
@@ -28291,7 +29077,7 @@
 </p:sld>
 </file>
 
-<file path=ppt/slides/slide8.xml><?xml version="1.0" encoding="utf-8"?>
+<file path=ppt/slides/slide9.xml><?xml version="1.0" encoding="utf-8"?>
 <p:sld xmlns:a="http://schemas.openxmlformats.org/drawingml/2006/main" xmlns:r="http://schemas.openxmlformats.org/officeDocument/2006/relationships" xmlns:p="http://schemas.openxmlformats.org/presentationml/2006/main">
   <p:cSld name="Slide 8">
     <p:bg>
@@ -31040,538 +31826,6 @@
                 <a:cs typeface="IBM Plex Sans" pitchFamily="34" charset="-120"/>
               </a:rPr>
               <a:t>Source: 2504.19874, Table 1 and Figure 4. 2.5 and 3.5 bits use an outlier-channel split (e.g. 32 channels at 3 bits, 96 at 2 bits).</a:t>
-            </a:r>
-            <a:endParaRPr lang="en-US" sz="1200" dirty="0"/>
-          </a:p>
-        </p:txBody>
-      </p:sp>
-    </p:spTree>
-  </p:cSld>
-  <p:clrMapOvr>
-    <a:masterClrMapping/>
-  </p:clrMapOvr>
-</p:sld>
-</file>
-
-<file path=ppt/slides/slide9.xml><?xml version="1.0" encoding="utf-8"?>
-<p:sld xmlns:a="http://schemas.openxmlformats.org/drawingml/2006/main" xmlns:r="http://schemas.openxmlformats.org/officeDocument/2006/relationships" xmlns:p="http://schemas.openxmlformats.org/presentationml/2006/main">
-  <p:cSld name="Slide 9">
-    <p:bg>
-      <p:bgPr>
-        <a:solidFill>
-          <a:srgbClr val="F6F5F0"/>
-        </a:solidFill>
-      </p:bgPr>
-    </p:bg>
-    <p:spTree>
-      <p:nvGrpSpPr>
-        <p:cNvPr id="1" name=""/>
-        <p:cNvGrpSpPr/>
-        <p:nvPr/>
-      </p:nvGrpSpPr>
-      <p:grpSpPr>
-        <a:xfrm>
-          <a:off x="0" y="0"/>
-          <a:ext cx="0" cy="0"/>
-          <a:chOff x="0" y="0"/>
-          <a:chExt cx="0" cy="0"/>
-        </a:xfrm>
-      </p:grpSpPr>
-      <p:sp>
-        <p:nvSpPr>
-          <p:cNvPr id="2" name="Text 0"/>
-          <p:cNvSpPr/>
-          <p:nvPr/>
-        </p:nvSpPr>
-        <p:spPr>
-          <a:xfrm>
-            <a:off x="812800" y="812800"/>
-            <a:ext cx="10883392" cy="235248"/>
-          </a:xfrm>
-          <a:prstGeom prst="rect">
-            <a:avLst/>
-          </a:prstGeom>
-          <a:noFill/>
-          <a:ln/>
-        </p:spPr>
-        <p:txBody>
-          <a:bodyPr wrap="square" lIns="0" tIns="0" rIns="0" bIns="0" rtlCol="0" anchor="t">
-            <a:normAutofit/>
-          </a:bodyPr>
-          <a:lstStyle/>
-          <a:p>
-            <a:pPr algn="l" indent="0" marL="0">
-              <a:lnSpc>
-                <a:spcPts val="1675"/>
-              </a:lnSpc>
-              <a:buNone/>
-            </a:pPr>
-            <a:r>
-              <a:rPr lang="en-US" sz="1196" spc="100" kern="0" dirty="0">
-                <a:solidFill>
-                  <a:srgbClr val="B4521A"/>
-                </a:solidFill>
-                <a:latin typeface="JetBrains Mono" pitchFamily="49" charset="0"/>
-                <a:ea typeface="JetBrains Mono" pitchFamily="49" charset="-122"/>
-                <a:cs typeface="JetBrains Mono" pitchFamily="49" charset="-120"/>
-              </a:rPr>
-              <a:t>IN PRODUCTION</a:t>
-            </a:r>
-            <a:endParaRPr lang="en-US" sz="1196" dirty="0"/>
-          </a:p>
-        </p:txBody>
-      </p:sp>
-      <p:sp>
-        <p:nvSpPr>
-          <p:cNvPr id="3" name="Text 1"/>
-          <p:cNvSpPr/>
-          <p:nvPr>
-            <p:ph type="title"/>
-          </p:nvPr>
-        </p:nvSpPr>
-        <p:spPr>
-          <a:xfrm>
-            <a:off x="812800" y="1327448"/>
-            <a:ext cx="10883392" cy="465138"/>
-          </a:xfrm>
-          <a:prstGeom prst="rect">
-            <a:avLst/>
-          </a:prstGeom>
-          <a:noFill/>
-          <a:ln/>
-        </p:spPr>
-        <p:txBody>
-          <a:bodyPr wrap="square" lIns="0" tIns="0" rIns="0" bIns="0" rtlCol="0" anchor="t">
-            <a:normAutofit/>
-          </a:bodyPr>
-          <a:lstStyle/>
-          <a:p>
-            <a:pPr algn="l" indent="0" marL="0">
-              <a:lnSpc>
-                <a:spcPts val="3465"/>
-              </a:lnSpc>
-              <a:buNone/>
-            </a:pPr>
-            <a:r>
-              <a:rPr lang="en-US" sz="3150" b="1" i="0" dirty="0">
-                <a:solidFill>
-                  <a:srgbClr val="0F1B2D"/>
-                </a:solidFill>
-                <a:latin typeface="IBM Plex Sans" pitchFamily="34" charset="0"/>
-                <a:ea typeface="IBM Plex Sans" pitchFamily="34" charset="-122"/>
-                <a:cs typeface="IBM Plex Sans" pitchFamily="34" charset="-120"/>
-              </a:rPr>
-              <a:t>The big win is capacity; speed depends on the kernel</a:t>
-            </a:r>
-            <a:endParaRPr lang="en-US" sz="3150" dirty="0"/>
-          </a:p>
-        </p:txBody>
-      </p:sp>
-      <p:sp>
-        <p:nvSpPr>
-          <p:cNvPr id="4" name="Shape 2"/>
-          <p:cNvSpPr/>
-          <p:nvPr/>
-        </p:nvSpPr>
-        <p:spPr>
-          <a:xfrm>
-            <a:off x="815975" y="2075160"/>
-            <a:ext cx="5175250" cy="2715220"/>
-          </a:xfrm>
-          <a:prstGeom prst="roundRect">
-            <a:avLst>
-              <a:gd name="adj" fmla="val 3625"/>
-            </a:avLst>
-          </a:prstGeom>
-          <a:solidFill>
-            <a:srgbClr val="FDFCF9"/>
-          </a:solidFill>
-          <a:ln w="6350">
-            <a:solidFill>
-              <a:srgbClr val="E2DFD6"/>
-            </a:solidFill>
-            <a:prstDash val="solid"/>
-          </a:ln>
-        </p:spPr>
-      </p:sp>
-      <p:sp>
-        <p:nvSpPr>
-          <p:cNvPr id="5" name="Text 3"/>
-          <p:cNvSpPr/>
-          <p:nvPr/>
-        </p:nvSpPr>
-        <p:spPr>
-          <a:xfrm>
-            <a:off x="1123950" y="2383135"/>
-            <a:ext cx="4696079" cy="233660"/>
-          </a:xfrm>
-          <a:prstGeom prst="rect">
-            <a:avLst/>
-          </a:prstGeom>
-          <a:noFill/>
-          <a:ln/>
-        </p:spPr>
-        <p:txBody>
-          <a:bodyPr wrap="square" lIns="0" tIns="0" rIns="0" bIns="0" rtlCol="0" anchor="t">
-            <a:normAutofit/>
-          </a:bodyPr>
-          <a:lstStyle/>
-          <a:p>
-            <a:pPr algn="l" indent="0" marL="0">
-              <a:lnSpc>
-                <a:spcPts val="1675"/>
-              </a:lnSpc>
-              <a:buNone/>
-            </a:pPr>
-            <a:r>
-              <a:rPr lang="en-US" sz="1196" dirty="0">
-                <a:solidFill>
-                  <a:srgbClr val="5F6979"/>
-                </a:solidFill>
-                <a:latin typeface="JetBrains Mono" pitchFamily="49" charset="0"/>
-                <a:ea typeface="JetBrains Mono" pitchFamily="49" charset="-122"/>
-                <a:cs typeface="JetBrains Mono" pitchFamily="49" charset="-120"/>
-              </a:rPr>
-              <a:t>GOOGLE RESEARCH BLOG</a:t>
-            </a:r>
-            <a:endParaRPr lang="en-US" sz="1196" dirty="0"/>
-          </a:p>
-        </p:txBody>
-      </p:sp>
-      <p:sp>
-        <p:nvSpPr>
-          <p:cNvPr id="6" name="Text 4"/>
-          <p:cNvSpPr/>
-          <p:nvPr/>
-        </p:nvSpPr>
-        <p:spPr>
-          <a:xfrm>
-            <a:off x="1123950" y="2718395"/>
-            <a:ext cx="4696079" cy="620713"/>
-          </a:xfrm>
-          <a:prstGeom prst="rect">
-            <a:avLst/>
-          </a:prstGeom>
-          <a:noFill/>
-          <a:ln/>
-        </p:spPr>
-        <p:txBody>
-          <a:bodyPr wrap="square" lIns="0" tIns="0" rIns="0" bIns="0" rtlCol="0" anchor="t">
-            <a:normAutofit/>
-          </a:bodyPr>
-          <a:lstStyle/>
-          <a:p>
-            <a:pPr algn="l" indent="0" marL="0">
-              <a:lnSpc>
-                <a:spcPts val="4710"/>
-              </a:lnSpc>
-              <a:buNone/>
-            </a:pPr>
-            <a:r>
-              <a:rPr lang="en-US" sz="4710" b="1" dirty="0">
-                <a:solidFill>
-                  <a:srgbClr val="0F1B2D"/>
-                </a:solidFill>
-                <a:latin typeface="IBM Plex Sans" pitchFamily="34" charset="0"/>
-                <a:ea typeface="IBM Plex Sans" pitchFamily="34" charset="-122"/>
-                <a:cs typeface="IBM Plex Sans" pitchFamily="34" charset="-120"/>
-              </a:rPr>
-              <a:t>up to 8x</a:t>
-            </a:r>
-            <a:endParaRPr lang="en-US" sz="4710" dirty="0"/>
-          </a:p>
-        </p:txBody>
-      </p:sp>
-      <p:sp>
-        <p:nvSpPr>
-          <p:cNvPr id="7" name="Text 5"/>
-          <p:cNvSpPr/>
-          <p:nvPr/>
-        </p:nvSpPr>
-        <p:spPr>
-          <a:xfrm>
-            <a:off x="1123950" y="3440708"/>
-            <a:ext cx="4696079" cy="1067098"/>
-          </a:xfrm>
-          <a:prstGeom prst="rect">
-            <a:avLst/>
-          </a:prstGeom>
-          <a:noFill/>
-          <a:ln/>
-        </p:spPr>
-        <p:txBody>
-          <a:bodyPr wrap="square" lIns="0" tIns="0" rIns="0" bIns="0" rtlCol="0" anchor="t">
-            <a:normAutofit/>
-          </a:bodyPr>
-          <a:lstStyle/>
-          <a:p>
-            <a:pPr algn="l" indent="0" marL="0">
-              <a:lnSpc>
-                <a:spcPts val="2054"/>
-              </a:lnSpc>
-              <a:buNone/>
-            </a:pPr>
-            <a:r>
-              <a:rPr lang="en-US" sz="1467" dirty="0">
-                <a:solidFill>
-                  <a:srgbClr val="3A4556"/>
-                </a:solidFill>
-                <a:latin typeface="IBM Plex Sans" pitchFamily="34" charset="0"/>
-                <a:ea typeface="IBM Plex Sans" pitchFamily="34" charset="-122"/>
-                <a:cs typeface="IBM Plex Sans" pitchFamily="34" charset="-120"/>
-              </a:rPr>
-              <a:t>faster attention-logit computation with 4-bit TurboQuant versus 32-bit keys on H100. At least 6x smaller KV memory on needle tasks, with 3-bit keys and no training.</a:t>
-            </a:r>
-            <a:endParaRPr lang="en-US" sz="1467" dirty="0"/>
-          </a:p>
-        </p:txBody>
-      </p:sp>
-      <p:sp>
-        <p:nvSpPr>
-          <p:cNvPr id="8" name="Shape 6"/>
-          <p:cNvSpPr/>
-          <p:nvPr/>
-        </p:nvSpPr>
-        <p:spPr>
-          <a:xfrm>
-            <a:off x="6200775" y="2075160"/>
-            <a:ext cx="5175250" cy="2715220"/>
-          </a:xfrm>
-          <a:prstGeom prst="roundRect">
-            <a:avLst>
-              <a:gd name="adj" fmla="val 3625"/>
-            </a:avLst>
-          </a:prstGeom>
-          <a:solidFill>
-            <a:srgbClr val="FDFCF9"/>
-          </a:solidFill>
-          <a:ln w="6350">
-            <a:solidFill>
-              <a:srgbClr val="E2DFD6"/>
-            </a:solidFill>
-            <a:prstDash val="solid"/>
-          </a:ln>
-        </p:spPr>
-      </p:sp>
-      <p:sp>
-        <p:nvSpPr>
-          <p:cNvPr id="9" name="Text 7"/>
-          <p:cNvSpPr/>
-          <p:nvPr/>
-        </p:nvSpPr>
-        <p:spPr>
-          <a:xfrm>
-            <a:off x="6508750" y="2383135"/>
-            <a:ext cx="4696079" cy="233660"/>
-          </a:xfrm>
-          <a:prstGeom prst="rect">
-            <a:avLst/>
-          </a:prstGeom>
-          <a:noFill/>
-          <a:ln/>
-        </p:spPr>
-        <p:txBody>
-          <a:bodyPr wrap="square" lIns="0" tIns="0" rIns="0" bIns="0" rtlCol="0" anchor="t">
-            <a:normAutofit/>
-          </a:bodyPr>
-          <a:lstStyle/>
-          <a:p>
-            <a:pPr algn="l" indent="0" marL="0">
-              <a:lnSpc>
-                <a:spcPts val="1675"/>
-              </a:lnSpc>
-              <a:buNone/>
-            </a:pPr>
-            <a:r>
-              <a:rPr lang="en-US" sz="1196" dirty="0">
-                <a:solidFill>
-                  <a:srgbClr val="5F6979"/>
-                </a:solidFill>
-                <a:latin typeface="JetBrains Mono" pitchFamily="49" charset="0"/>
-                <a:ea typeface="JetBrains Mono" pitchFamily="49" charset="-122"/>
-                <a:cs typeface="JetBrains Mono" pitchFamily="49" charset="-120"/>
-              </a:rPr>
-              <a:t>VLLM 0.20.2+ · H100</a:t>
-            </a:r>
-            <a:endParaRPr lang="en-US" sz="1196" dirty="0"/>
-          </a:p>
-        </p:txBody>
-      </p:sp>
-      <p:sp>
-        <p:nvSpPr>
-          <p:cNvPr id="10" name="Text 8"/>
-          <p:cNvSpPr/>
-          <p:nvPr/>
-        </p:nvSpPr>
-        <p:spPr>
-          <a:xfrm>
-            <a:off x="6508750" y="2718395"/>
-            <a:ext cx="4696079" cy="620713"/>
-          </a:xfrm>
-          <a:prstGeom prst="rect">
-            <a:avLst/>
-          </a:prstGeom>
-          <a:noFill/>
-          <a:ln/>
-        </p:spPr>
-        <p:txBody>
-          <a:bodyPr wrap="square" lIns="0" tIns="0" rIns="0" bIns="0" rtlCol="0" anchor="t">
-            <a:normAutofit/>
-          </a:bodyPr>
-          <a:lstStyle/>
-          <a:p>
-            <a:pPr algn="l" indent="0" marL="0">
-              <a:lnSpc>
-                <a:spcPts val="4710"/>
-              </a:lnSpc>
-              <a:buNone/>
-            </a:pPr>
-            <a:r>
-              <a:rPr lang="en-US" sz="4710" b="1" dirty="0">
-                <a:solidFill>
-                  <a:srgbClr val="0F1B2D"/>
-                </a:solidFill>
-                <a:latin typeface="IBM Plex Sans" pitchFamily="34" charset="0"/>
-                <a:ea typeface="IBM Plex Sans" pitchFamily="34" charset="-122"/>
-                <a:cs typeface="IBM Plex Sans" pitchFamily="34" charset="-120"/>
-              </a:rPr>
-              <a:t>2.3–3.7x</a:t>
-            </a:r>
-            <a:endParaRPr lang="en-US" sz="4710" dirty="0"/>
-          </a:p>
-        </p:txBody>
-      </p:sp>
-      <p:sp>
-        <p:nvSpPr>
-          <p:cNvPr id="11" name="Text 9"/>
-          <p:cNvSpPr/>
-          <p:nvPr/>
-        </p:nvSpPr>
-        <p:spPr>
-          <a:xfrm>
-            <a:off x="6508750" y="3440708"/>
-            <a:ext cx="4696079" cy="1067098"/>
-          </a:xfrm>
-          <a:prstGeom prst="rect">
-            <a:avLst/>
-          </a:prstGeom>
-          <a:noFill/>
-          <a:ln/>
-        </p:spPr>
-        <p:txBody>
-          <a:bodyPr wrap="square" lIns="0" tIns="0" rIns="0" bIns="0" rtlCol="0" anchor="t">
-            <a:normAutofit/>
-          </a:bodyPr>
-          <a:lstStyle/>
-          <a:p>
-            <a:pPr algn="l" indent="0" marL="0">
-              <a:lnSpc>
-                <a:spcPts val="2054"/>
-              </a:lnSpc>
-              <a:buNone/>
-            </a:pPr>
-            <a:r>
-              <a:rPr lang="en-US" sz="1467" dirty="0">
-                <a:solidFill>
-                  <a:srgbClr val="3A4556"/>
-                </a:solidFill>
-                <a:latin typeface="IBM Plex Sans" pitchFamily="34" charset="0"/>
-                <a:ea typeface="IBM Plex Sans" pitchFamily="34" charset="-122"/>
-                <a:cs typeface="IBM Plex Sans" pitchFamily="34" charset="-120"/>
-              </a:rPr>
-              <a:t>more KV-cache capacity, at 66–80% of BF16 throughput. The aggressive 3-bit variants drop up to ~20 points on hard math and coding; FP8 stays throughput-neutral.</a:t>
-            </a:r>
-            <a:endParaRPr lang="en-US" sz="1467" dirty="0"/>
-          </a:p>
-        </p:txBody>
-      </p:sp>
-      <p:sp>
-        <p:nvSpPr>
-          <p:cNvPr id="12" name="Text 10"/>
-          <p:cNvSpPr/>
-          <p:nvPr/>
-        </p:nvSpPr>
-        <p:spPr>
-          <a:xfrm>
-            <a:off x="812800" y="5098355"/>
-            <a:ext cx="10566400" cy="743645"/>
-          </a:xfrm>
-          <a:prstGeom prst="roundRect">
-            <a:avLst>
-              <a:gd name="adj" fmla="val 10247"/>
-            </a:avLst>
-          </a:prstGeom>
-          <a:solidFill>
-            <a:srgbClr val="E9E6DD"/>
-          </a:solidFill>
-          <a:ln/>
-        </p:spPr>
-        <p:txBody>
-          <a:bodyPr wrap="square" lIns="155482" tIns="104682" rIns="0" bIns="79282" rtlCol="0" anchor="t">
-            <a:normAutofit/>
-          </a:bodyPr>
-          <a:lstStyle/>
-          <a:p>
-            <a:pPr algn="l" indent="0" marL="0">
-              <a:lnSpc>
-                <a:spcPts val="1936"/>
-              </a:lnSpc>
-              <a:buNone/>
-            </a:pPr>
-            <a:r>
-              <a:rPr lang="en-US" sz="1383" dirty="0">
-                <a:solidFill>
-                  <a:srgbClr val="0F1B2D"/>
-                </a:solidFill>
-                <a:latin typeface="JetBrains Mono" pitchFamily="49" charset="0"/>
-                <a:ea typeface="JetBrains Mono" pitchFamily="49" charset="-122"/>
-                <a:cs typeface="JetBrains Mono" pitchFamily="49" charset="-120"/>
-              </a:rPr>
-              <a:t>vllm serve &lt;model&gt; --kv-cache-dtype turboquant_4bit_nc # or turboquant_k8v4, turboquant_k3v4_nc, turboquant_3bit_nc</a:t>
-            </a:r>
-            <a:endParaRPr lang="en-US" sz="1383" dirty="0"/>
-          </a:p>
-        </p:txBody>
-      </p:sp>
-      <p:sp>
-        <p:nvSpPr>
-          <p:cNvPr id="13" name="Text 11"/>
-          <p:cNvSpPr/>
-          <p:nvPr/>
-        </p:nvSpPr>
-        <p:spPr>
-          <a:xfrm>
-            <a:off x="812800" y="6238280"/>
-            <a:ext cx="10883392" cy="238720"/>
-          </a:xfrm>
-          <a:prstGeom prst="rect">
-            <a:avLst/>
-          </a:prstGeom>
-          <a:noFill/>
-          <a:ln/>
-        </p:spPr>
-        <p:txBody>
-          <a:bodyPr wrap="square" lIns="0" tIns="0" rIns="0" bIns="0" rtlCol="0" anchor="t">
-            <a:normAutofit/>
-          </a:bodyPr>
-          <a:lstStyle/>
-          <a:p>
-            <a:pPr algn="l" indent="0" marL="0">
-              <a:lnSpc>
-                <a:spcPts val="1680"/>
-              </a:lnSpc>
-              <a:buNone/>
-            </a:pPr>
-            <a:r>
-              <a:rPr lang="en-US" sz="1200" dirty="0">
-                <a:solidFill>
-                  <a:srgbClr val="5F6979"/>
-                </a:solidFill>
-                <a:latin typeface="IBM Plex Sans" pitchFamily="34" charset="0"/>
-                <a:ea typeface="IBM Plex Sans" pitchFamily="34" charset="-122"/>
-                <a:cs typeface="IBM Plex Sans" pitchFamily="34" charset="-120"/>
-              </a:rPr>
-              <a:t>Sources: research.google/blog/turboquant-redefining-ai-efficiency-with-extreme-compression · vllm.ai/blog/2026-05-11-turboquant</a:t>
             </a:r>
             <a:endParaRPr lang="en-US" sz="1200" dirty="0"/>
           </a:p>

</xml_diff>

<commit_message>
Add worked QJL, PolarQuant and TurboQuant example slides and a TurboQuant example to both guides
Three new slides use v = [3, -4, 2, 0.5] and q = [1, -1, 1, 0]: QJL and
PolarQuant after 'Three papers, one idea', and an end-to-end TurboQuant_prod
example (rotation, 2-bit Lloyd-Max, residual, QJL sign bits, score) after
'Stage 2'. Section 2.3 of both guides gets the same TurboQuant example, and
docs/guide/worked_examples.py reproduces every number in the three examples.
</commit_message>
<xml_diff>
--- a/docs/TurboQuant.pptx
+++ b/docs/TurboQuant.pptx
@@ -11,8 +11,11 @@
     <p:sldId id="279" r:id="rId30"/>
     <p:sldId id="258" r:id="rId4"/>
     <p:sldId id="259" r:id="rId5"/>
+    <p:sldId id="280" r:id="rId31"/>
+    <p:sldId id="281" r:id="rId32"/>
     <p:sldId id="260" r:id="rId6"/>
     <p:sldId id="261" r:id="rId7"/>
+    <p:sldId id="282" r:id="rId33"/>
     <p:sldId id="262" r:id="rId8"/>
     <p:sldId id="263" r:id="rId9"/>
     <p:sldId id="264" r:id="rId10"/>
@@ -1843,6 +1846,216 @@
           <a:p>
             <a:r>
               <a:t>Before we look at what goes wrong with classic quantization, here is how it works, on eight numbers. Step one: find the range of the block, the smallest and the largest number. Step two: with 2 bits we can name four allowed values, so we spread four values evenly over that range. Step three: every number is replaced by the 2-bit code of the nearest allowed value; that rounding is the only place we lose information. Step four: we store the codes, plus the minimum and the step so we can decode. Reading back is just minimum plus code times step, and the bottom row shows the error each number picks up. Two things to notice. First, the range has to be stored for every block, and that is the hidden tax on the next slide. Second, the two extreme numbers set the range, so five of the eight numbers share only two values. TurboQuant keeps the rounding and the storing, but replaces the first two steps: it rotates the vector first so nothing sticks out, and uses one fixed set of values for every vector, so there is no range to store.</a:t>
+            </a:r>
+          </a:p>
+        </p:txBody>
+      </p:sp>
+      <p:sp>
+        <p:nvSpPr>
+          <p:cNvPr id="4" name="Slide Number Placeholder 3"/>
+          <p:cNvSpPr>
+            <a:spLocks noGrp="1"/>
+          </p:cNvSpPr>
+          <p:nvPr>
+            <p:ph type="sldNum" idx="5" sz="quarter"/>
+          </p:nvPr>
+        </p:nvSpPr>
+        <p:spPr/>
+      </p:sp>
+    </p:spTree>
+  </p:cSld>
+  <p:clrMapOvr>
+    <a:masterClrMapping/>
+  </p:clrMapOvr>
+</p:notes>
+</file>
+
+<file path=ppt/notesSlides/notesSlide25.xml><?xml version="1.0" encoding="utf-8"?>
+<p:notes xmlns:a="http://schemas.openxmlformats.org/drawingml/2006/main" xmlns:p="http://schemas.openxmlformats.org/presentationml/2006/main" xmlns:r="http://schemas.openxmlformats.org/officeDocument/2006/relationships">
+  <p:cSld>
+    <p:spTree>
+      <p:nvGrpSpPr>
+        <p:cNvPr id="1" name=""/>
+        <p:cNvGrpSpPr/>
+        <p:nvPr/>
+      </p:nvGrpSpPr>
+      <p:grpSpPr>
+        <a:xfrm>
+          <a:off x="0" y="0"/>
+          <a:ext cx="0" cy="0"/>
+          <a:chOff x="0" y="0"/>
+          <a:chExt cx="0" cy="0"/>
+        </a:xfrm>
+      </p:grpSpPr>
+      <p:sp>
+        <p:nvSpPr>
+          <p:cNvPr id="2" name="Slide Image Placeholder 1"/>
+          <p:cNvSpPr>
+            <a:spLocks noGrp="1"/>
+          </p:cNvSpPr>
+          <p:nvPr>
+            <p:ph type="sldImg" idx="2"/>
+          </p:nvPr>
+        </p:nvSpPr>
+        <p:spPr/>
+      </p:sp>
+      <p:sp>
+        <p:nvSpPr>
+          <p:cNvPr id="3" name="Notes Placeholder 2"/>
+          <p:cNvSpPr>
+            <a:spLocks noGrp="1"/>
+          </p:cNvSpPr>
+          <p:nvPr>
+            <p:ph type="body" idx="3" sz="quarter"/>
+          </p:nvPr>
+        </p:nvSpPr>
+        <p:spPr/>
+        <p:txBody>
+          <a:bodyPr/>
+          <a:lstStyle/>
+          <a:p>
+            <a:r>
+              <a:t>A worked QJL example on four numbers, the same key we will reuse for PolarQuant and TurboQuant. The key's norm is 5.41 and is stored as one float. We multiply the key by a random Gaussian matrix S, three rows here, which is never stored because it is regenerated from a seed. The projections are 3.85, minus 2.15 and minus 2.85, and we keep only their signs: three bits, 1 0 0. When the query 1, minus 1, 1, 0 arrives, its exact score with the key is 9. We project the query with the same S but do not quantize it, flip its projections by the stored signs and add them up: 3.0. Scaling by root pi over 2, divided by m, times the norm gives 6.78. That is one draw; the estimator is unbiased, so averaged over 2,000 draws of S it gives 9.07, and the spread falls like one over root m, from 4.4 at three bits to 0.24 at 1,024. Real heads use as many bits as the head dimension or more.</a:t>
+            </a:r>
+          </a:p>
+        </p:txBody>
+      </p:sp>
+      <p:sp>
+        <p:nvSpPr>
+          <p:cNvPr id="4" name="Slide Number Placeholder 3"/>
+          <p:cNvSpPr>
+            <a:spLocks noGrp="1"/>
+          </p:cNvSpPr>
+          <p:nvPr>
+            <p:ph type="sldNum" idx="5" sz="quarter"/>
+          </p:nvPr>
+        </p:nvSpPr>
+        <p:spPr/>
+      </p:sp>
+    </p:spTree>
+  </p:cSld>
+  <p:clrMapOvr>
+    <a:masterClrMapping/>
+  </p:clrMapOvr>
+</p:notes>
+</file>
+
+<file path=ppt/notesSlides/notesSlide26.xml><?xml version="1.0" encoding="utf-8"?>
+<p:notes xmlns:a="http://schemas.openxmlformats.org/drawingml/2006/main" xmlns:p="http://schemas.openxmlformats.org/presentationml/2006/main" xmlns:r="http://schemas.openxmlformats.org/officeDocument/2006/relationships">
+  <p:cSld>
+    <p:spTree>
+      <p:nvGrpSpPr>
+        <p:cNvPr id="1" name=""/>
+        <p:cNvGrpSpPr/>
+        <p:nvPr/>
+      </p:nvGrpSpPr>
+      <p:grpSpPr>
+        <a:xfrm>
+          <a:off x="0" y="0"/>
+          <a:ext cx="0" cy="0"/>
+          <a:chOff x="0" y="0"/>
+          <a:chExt cx="0" cy="0"/>
+        </a:xfrm>
+      </p:grpSpPr>
+      <p:sp>
+        <p:nvSpPr>
+          <p:cNvPr id="2" name="Slide Image Placeholder 1"/>
+          <p:cNvSpPr>
+            <a:spLocks noGrp="1"/>
+          </p:cNvSpPr>
+          <p:nvPr>
+            <p:ph type="sldImg" idx="2"/>
+          </p:nvPr>
+        </p:nvSpPr>
+        <p:spPr/>
+      </p:sp>
+      <p:sp>
+        <p:nvSpPr>
+          <p:cNvPr id="3" name="Notes Placeholder 2"/>
+          <p:cNvSpPr>
+            <a:spLocks noGrp="1"/>
+          </p:cNvSpPr>
+          <p:nvPr>
+            <p:ph type="body" idx="3" sz="quarter"/>
+          </p:nvPr>
+        </p:nvSpPr>
+        <p:spPr/>
+        <p:txBody>
+          <a:bodyPr/>
+          <a:lstStyle/>
+          <a:p>
+            <a:r>
+              <a:t>The same vector, now through PolarQuant. Assume it has already been randomly rotated. Level one pairs the coordinates: 3 and minus 4 become a radius of 5 and an angle of 306.9 degrees; 2 and 0.5 become a radius of 2.06 and an angle of 14 degrees. Level two pairs the two radii: the radius is 5.41, the norm of the whole vector, and the angle is 22.4 degrees, always between 0 and 90 because radii are non-negative. First-level angles are uniform, so they get 4 bits and 16 equal buckets. Higher-level angles concentrate around 45 degrees, so their 2-bit centroids come from k-means on the known density: 17.7, 36.3, 53.7 and 72.3 degrees. We store 10 bits of angles plus the norm. Decoding runs the tree top-down with cosines and sines and gives 2.86, minus 4.28, 1.62, 0.32: a 9.7 percent error, and a score of 8.76 against 9.</a:t>
+            </a:r>
+          </a:p>
+        </p:txBody>
+      </p:sp>
+      <p:sp>
+        <p:nvSpPr>
+          <p:cNvPr id="4" name="Slide Number Placeholder 3"/>
+          <p:cNvSpPr>
+            <a:spLocks noGrp="1"/>
+          </p:cNvSpPr>
+          <p:nvPr>
+            <p:ph type="sldNum" idx="5" sz="quarter"/>
+          </p:nvPr>
+        </p:nvSpPr>
+        <p:spPr/>
+      </p:sp>
+    </p:spTree>
+  </p:cSld>
+  <p:clrMapOvr>
+    <a:masterClrMapping/>
+  </p:clrMapOvr>
+</p:notes>
+</file>
+
+<file path=ppt/notesSlides/notesSlide27.xml><?xml version="1.0" encoding="utf-8"?>
+<p:notes xmlns:a="http://schemas.openxmlformats.org/drawingml/2006/main" xmlns:p="http://schemas.openxmlformats.org/presentationml/2006/main" xmlns:r="http://schemas.openxmlformats.org/officeDocument/2006/relationships">
+  <p:cSld>
+    <p:spTree>
+      <p:nvGrpSpPr>
+        <p:cNvPr id="1" name=""/>
+        <p:cNvGrpSpPr/>
+        <p:nvPr/>
+      </p:nvGrpSpPr>
+      <p:grpSpPr>
+        <a:xfrm>
+          <a:off x="0" y="0"/>
+          <a:ext cx="0" cy="0"/>
+          <a:chOff x="0" y="0"/>
+          <a:chExt cx="0" cy="0"/>
+        </a:xfrm>
+      </p:grpSpPr>
+      <p:sp>
+        <p:nvSpPr>
+          <p:cNvPr id="2" name="Slide Image Placeholder 1"/>
+          <p:cNvSpPr>
+            <a:spLocks noGrp="1"/>
+          </p:cNvSpPr>
+          <p:nvPr>
+            <p:ph type="sldImg" idx="2"/>
+          </p:nvPr>
+        </p:nvSpPr>
+        <p:spPr/>
+      </p:sp>
+      <p:sp>
+        <p:nvSpPr>
+          <p:cNvPr id="3" name="Notes Placeholder 2"/>
+          <p:cNvSpPr>
+            <a:spLocks noGrp="1"/>
+          </p:cNvSpPr>
+          <p:nvPr>
+            <p:ph type="body" idx="3" sz="quarter"/>
+          </p:nvPr>
+        </p:nvSpPr>
+        <p:spPr/>
+        <p:txBody>
+          <a:bodyPr/>
+          <a:lstStyle/>
+          <a:p>
+            <a:r>
+              <a:t>Now the whole of TurboQuant on the same four numbers, at 3 bits per coordinate: 2 bits for the MSE stage and 1 bit for QJL. Store the norm, 5.41, and work on the direction. Rotate: to keep the arithmetic on a slide we use a Hadamard matrix with random signs, a fast random rotation; the reference code uses a dense one. The coordinates change to 4.25, 0.75, 2.75 and minus 1.75, but the length does not. Divide by the norm and round each coordinate with the fixed Lloyd-Max codebook for d equals 4, plus or minus 0.219 and 0.674: 8 bits of codes. Decoding rotates the centroids back: 3.65, minus 3.65, 1.19, 1.19, and the score with our query drops to 8.48, the shrinkage bias. Stage two takes the residual, norm 1.29, and stores the signs of a 4 by 4 Gaussian projection of it: 1 1 0 0. At query time the correction is root pi over 2, over 4, times 1.29, times 0.8, which is 0.32, so the estimate is 8.81 against 9. Over 20,000 random rotations the MSE stage alone averages 8.32 and the full estimate 9.00: the QJL bit removes the bias.</a:t>
             </a:r>
           </a:p>
         </p:txBody>
@@ -24940,6 +25153,3850 @@
               <a:t>TurboQuant vs traditional quantization (Medium)</a:t>
             </a:r>
             <a:endParaRPr lang="en-US" sz="1400" dirty="0"/>
+          </a:p>
+        </p:txBody>
+      </p:sp>
+    </p:spTree>
+  </p:cSld>
+  <p:clrMapOvr>
+    <a:masterClrMapping/>
+  </p:clrMapOvr>
+</p:sld>
+</file>
+
+<file path=ppt/slides/slide25.xml><?xml version="1.0" encoding="utf-8"?>
+<p:sld xmlns:a="http://schemas.openxmlformats.org/drawingml/2006/main" xmlns:p="http://schemas.openxmlformats.org/presentationml/2006/main" xmlns:r="http://schemas.openxmlformats.org/officeDocument/2006/relationships">
+  <p:cSld>
+    <p:bg>
+      <p:bgPr>
+        <a:solidFill>
+          <a:srgbClr val="F6F5F0"/>
+        </a:solidFill>
+      </p:bgPr>
+    </p:bg>
+    <p:spTree>
+      <p:nvGrpSpPr>
+        <p:cNvPr id="1" name=""/>
+        <p:cNvGrpSpPr/>
+        <p:nvPr/>
+      </p:nvGrpSpPr>
+      <p:grpSpPr/>
+      <p:sp>
+        <p:nvSpPr>
+          <p:cNvPr id="3" name="Text 3"/>
+          <p:cNvSpPr/>
+          <p:nvPr/>
+        </p:nvSpPr>
+        <p:spPr>
+          <a:xfrm>
+            <a:off x="812800" y="812800"/>
+            <a:ext cx="10883392" cy="238720"/>
+          </a:xfrm>
+          <a:prstGeom prst="rect">
+            <a:avLst/>
+          </a:prstGeom>
+          <a:noFill/>
+          <a:ln/>
+        </p:spPr>
+        <p:txBody>
+          <a:bodyPr wrap="square" lIns="0" tIns="0" rIns="0" bIns="0" rtlCol="0" anchor="t">
+            <a:normAutofit/>
+          </a:bodyPr>
+          <a:lstStyle/>
+          <a:p>
+            <a:pPr algn="l" indent="0" marL="0">
+              <a:lnSpc>
+                <a:spcPts val="1680"/>
+              </a:lnSpc>
+              <a:buNone/>
+            </a:pPr>
+            <a:r>
+              <a:rPr lang="en-US" sz="1200" spc="100" dirty="0">
+                <a:solidFill>
+                  <a:srgbClr val="B4521A"/>
+                </a:solidFill>
+                <a:latin typeface="JetBrains Mono" pitchFamily="49" charset="0"/>
+                <a:ea typeface="JetBrains Mono" pitchFamily="49" charset="-122"/>
+                <a:cs typeface="JetBrains Mono" pitchFamily="49" charset="-120"/>
+              </a:rPr>
+              <a:t>QJL · WORKED EXAMPLE</a:t>
+            </a:r>
+            <a:endParaRPr lang="en-US" sz="1200" dirty="0"/>
+          </a:p>
+        </p:txBody>
+      </p:sp>
+      <p:sp>
+        <p:nvSpPr>
+          <p:cNvPr id="4" name="Text 4"/>
+          <p:cNvSpPr/>
+          <p:nvPr>
+            <p:ph type="title"/>
+          </p:nvPr>
+        </p:nvSpPr>
+        <p:spPr>
+          <a:xfrm>
+            <a:off x="812800" y="1381720"/>
+            <a:ext cx="11379200" cy="472380"/>
+          </a:xfrm>
+          <a:prstGeom prst="rect">
+            <a:avLst/>
+          </a:prstGeom>
+          <a:noFill/>
+          <a:ln/>
+        </p:spPr>
+        <p:txBody>
+          <a:bodyPr wrap="square" lIns="0" tIns="0" rIns="0" bIns="0" rtlCol="0" anchor="t">
+            <a:normAutofit/>
+          </a:bodyPr>
+          <a:lstStyle/>
+          <a:p>
+            <a:pPr algn="l" indent="0" marL="0">
+              <a:lnSpc>
+                <a:spcPts val="3520"/>
+              </a:lnSpc>
+              <a:buNone/>
+            </a:pPr>
+            <a:r>
+              <a:rPr lang="en-US" sz="3200" b="1" dirty="0">
+                <a:solidFill>
+                  <a:srgbClr val="0F1B2D"/>
+                </a:solidFill>
+                <a:latin typeface="IBM Plex Sans" pitchFamily="34" charset="0"/>
+                <a:ea typeface="IBM Plex Sans" pitchFamily="34" charset="-122"/>
+                <a:cs typeface="IBM Plex Sans" pitchFamily="34" charset="-120"/>
+              </a:rPr>
+              <a:t>QJL by hand: 4 numbers become 3 sign bits and a norm</a:t>
+            </a:r>
+            <a:endParaRPr lang="en-US" sz="3200" dirty="0"/>
+          </a:p>
+        </p:txBody>
+      </p:sp>
+      <p:sp>
+        <p:nvSpPr>
+          <p:cNvPr id="5" name="Shape 5"/>
+          <p:cNvSpPr/>
+          <p:nvPr/>
+        </p:nvSpPr>
+        <p:spPr>
+          <a:xfrm>
+            <a:off x="812800" y="2150000"/>
+            <a:ext cx="2585848" cy="2500000"/>
+          </a:xfrm>
+          <a:prstGeom prst="roundRect">
+            <a:avLst>
+              <a:gd name="adj" fmla="val 6060"/>
+            </a:avLst>
+          </a:prstGeom>
+          <a:solidFill>
+            <a:srgbClr val="FDFCF9"/>
+          </a:solidFill>
+          <a:ln w="6350">
+            <a:solidFill>
+              <a:srgbClr val="E2DFD6"/>
+            </a:solidFill>
+            <a:prstDash val="solid"/>
+          </a:ln>
+        </p:spPr>
+      </p:sp>
+      <p:sp>
+        <p:nvSpPr>
+          <p:cNvPr id="6" name="Text 6"/>
+          <p:cNvSpPr/>
+          <p:nvPr/>
+        </p:nvSpPr>
+        <p:spPr>
+          <a:xfrm>
+            <a:off x="1002800" y="2340000"/>
+            <a:ext cx="2205848" cy="2120000"/>
+          </a:xfrm>
+          <a:prstGeom prst="rect">
+            <a:avLst/>
+          </a:prstGeom>
+          <a:noFill/>
+          <a:ln/>
+        </p:spPr>
+        <p:txBody>
+          <a:bodyPr wrap="square" lIns="0" tIns="0" rIns="0" bIns="0" rtlCol="0" anchor="t">
+            <a:normAutofit/>
+          </a:bodyPr>
+          <a:lstStyle/>
+          <a:p>
+            <a:pPr algn="l" indent="0" marL="0">
+              <a:lnSpc>
+                <a:spcPts val="1875"/>
+              </a:lnSpc>
+              <a:spcAft>
+                <a:spcPts val="600"/>
+              </a:spcAft>
+              <a:buNone/>
+            </a:pPr>
+            <a:r>
+              <a:rPr lang="en-US" sz="1500" b="1" dirty="0">
+                <a:solidFill>
+                  <a:srgbClr val="0F1B2D"/>
+                </a:solidFill>
+                <a:latin typeface="IBM Plex Sans" pitchFamily="34" charset="0"/>
+                <a:ea typeface="IBM Plex Sans" pitchFamily="34" charset="-122"/>
+                <a:cs typeface="IBM Plex Sans" pitchFamily="34" charset="-120"/>
+              </a:rPr>
+              <a:t>1 · Key and norm</a:t>
+            </a:r>
+            <a:endParaRPr lang="en-US" sz="1500" dirty="0"/>
+          </a:p>
+          <a:p>
+            <a:pPr algn="l" indent="0" marL="0">
+              <a:lnSpc>
+                <a:spcPts val="1750"/>
+              </a:lnSpc>
+              <a:spcAft>
+                <a:spcPts val="400"/>
+              </a:spcAft>
+              <a:buNone/>
+            </a:pPr>
+            <a:r>
+              <a:rPr lang="en-US" sz="1250" dirty="0">
+                <a:solidFill>
+                  <a:srgbClr val="0F1B2D"/>
+                </a:solidFill>
+                <a:latin typeface="JetBrains Mono" pitchFamily="49" charset="0"/>
+                <a:ea typeface="JetBrains Mono" pitchFamily="49" charset="-122"/>
+                <a:cs typeface="JetBrains Mono" pitchFamily="49" charset="-120"/>
+              </a:rPr>
+              <a:t>k = [3, −4, 2, 0.5]</a:t>
+            </a:r>
+            <a:endParaRPr lang="en-US" sz="1250" dirty="0"/>
+          </a:p>
+          <a:p>
+            <a:pPr algn="l" indent="0" marL="0">
+              <a:lnSpc>
+                <a:spcPts val="1750"/>
+              </a:lnSpc>
+              <a:spcAft>
+                <a:spcPts val="400"/>
+              </a:spcAft>
+              <a:buNone/>
+            </a:pPr>
+            <a:r>
+              <a:rPr lang="en-US" sz="1250" dirty="0">
+                <a:solidFill>
+                  <a:srgbClr val="3A4556"/>
+                </a:solidFill>
+                <a:latin typeface="IBM Plex Sans" pitchFamily="34" charset="0"/>
+                <a:ea typeface="IBM Plex Sans" pitchFamily="34" charset="-122"/>
+                <a:cs typeface="IBM Plex Sans" pitchFamily="34" charset="-120"/>
+              </a:rPr>
+              <a:t>‖k‖ = √(9 + 16 + 4 + 0.25)</a:t>
+            </a:r>
+            <a:endParaRPr lang="en-US" sz="1250" dirty="0"/>
+          </a:p>
+          <a:p>
+            <a:pPr algn="l" indent="0" marL="0">
+              <a:lnSpc>
+                <a:spcPts val="1750"/>
+              </a:lnSpc>
+              <a:spcAft>
+                <a:spcPts val="400"/>
+              </a:spcAft>
+              <a:buNone/>
+            </a:pPr>
+            <a:r>
+              <a:rPr lang="en-US" sz="1250" dirty="0">
+                <a:solidFill>
+                  <a:srgbClr val="3A4556"/>
+                </a:solidFill>
+                <a:latin typeface="IBM Plex Sans" pitchFamily="34" charset="0"/>
+                <a:ea typeface="IBM Plex Sans" pitchFamily="34" charset="-122"/>
+                <a:cs typeface="IBM Plex Sans" pitchFamily="34" charset="-120"/>
+              </a:rPr>
+              <a:t>     = √29.25 = </a:t>
+            </a:r>
+            <a:r>
+              <a:rPr lang="en-US" sz="1250" b="1" dirty="0">
+                <a:solidFill>
+                  <a:srgbClr val="0F1B2D"/>
+                </a:solidFill>
+                <a:latin typeface="IBM Plex Sans" pitchFamily="34" charset="0"/>
+                <a:ea typeface="IBM Plex Sans" pitchFamily="34" charset="-122"/>
+                <a:cs typeface="IBM Plex Sans" pitchFamily="34" charset="-120"/>
+              </a:rPr>
+              <a:t>5.41</a:t>
+            </a:r>
+            <a:endParaRPr lang="en-US" sz="1250" dirty="0"/>
+          </a:p>
+          <a:p>
+            <a:pPr algn="l" indent="0" marL="0">
+              <a:lnSpc>
+                <a:spcPts val="1750"/>
+              </a:lnSpc>
+              <a:spcAft>
+                <a:spcPts val="400"/>
+              </a:spcAft>
+              <a:buNone/>
+            </a:pPr>
+            <a:r>
+              <a:rPr lang="en-US" sz="1250" dirty="0">
+                <a:solidFill>
+                  <a:srgbClr val="3A4556"/>
+                </a:solidFill>
+                <a:latin typeface="IBM Plex Sans" pitchFamily="34" charset="0"/>
+                <a:ea typeface="IBM Plex Sans" pitchFamily="34" charset="-122"/>
+                <a:cs typeface="IBM Plex Sans" pitchFamily="34" charset="-120"/>
+              </a:rPr>
+              <a:t>Stored as one float.</a:t>
+            </a:r>
+            <a:endParaRPr lang="en-US" sz="1250" dirty="0"/>
+          </a:p>
+        </p:txBody>
+      </p:sp>
+      <p:sp>
+        <p:nvSpPr>
+          <p:cNvPr id="7" name="Shape 7"/>
+          <p:cNvSpPr/>
+          <p:nvPr/>
+        </p:nvSpPr>
+        <p:spPr>
+          <a:xfrm>
+            <a:off x="3578648" y="2150000"/>
+            <a:ext cx="2585848" cy="2500000"/>
+          </a:xfrm>
+          <a:prstGeom prst="roundRect">
+            <a:avLst>
+              <a:gd name="adj" fmla="val 6060"/>
+            </a:avLst>
+          </a:prstGeom>
+          <a:solidFill>
+            <a:srgbClr val="FDFCF9"/>
+          </a:solidFill>
+          <a:ln w="6350">
+            <a:solidFill>
+              <a:srgbClr val="E2DFD6"/>
+            </a:solidFill>
+            <a:prstDash val="solid"/>
+          </a:ln>
+        </p:spPr>
+      </p:sp>
+      <p:sp>
+        <p:nvSpPr>
+          <p:cNvPr id="8" name="Text 8"/>
+          <p:cNvSpPr/>
+          <p:nvPr/>
+        </p:nvSpPr>
+        <p:spPr>
+          <a:xfrm>
+            <a:off x="3768648" y="2340000"/>
+            <a:ext cx="2205848" cy="2120000"/>
+          </a:xfrm>
+          <a:prstGeom prst="rect">
+            <a:avLst/>
+          </a:prstGeom>
+          <a:noFill/>
+          <a:ln/>
+        </p:spPr>
+        <p:txBody>
+          <a:bodyPr wrap="square" lIns="0" tIns="0" rIns="0" bIns="0" rtlCol="0" anchor="t">
+            <a:normAutofit/>
+          </a:bodyPr>
+          <a:lstStyle/>
+          <a:p>
+            <a:pPr algn="l" indent="0" marL="0">
+              <a:lnSpc>
+                <a:spcPts val="1875"/>
+              </a:lnSpc>
+              <a:spcAft>
+                <a:spcPts val="600"/>
+              </a:spcAft>
+              <a:buNone/>
+            </a:pPr>
+            <a:r>
+              <a:rPr lang="en-US" sz="1500" b="1" dirty="0">
+                <a:solidFill>
+                  <a:srgbClr val="0F1B2D"/>
+                </a:solidFill>
+                <a:latin typeface="IBM Plex Sans" pitchFamily="34" charset="0"/>
+                <a:ea typeface="IBM Plex Sans" pitchFamily="34" charset="-122"/>
+                <a:cs typeface="IBM Plex Sans" pitchFamily="34" charset="-120"/>
+              </a:rPr>
+              <a:t>2 · Project with S</a:t>
+            </a:r>
+            <a:endParaRPr lang="en-US" sz="1500" dirty="0"/>
+          </a:p>
+          <a:p>
+            <a:pPr algn="l" indent="0" marL="0">
+              <a:lnSpc>
+                <a:spcPts val="1750"/>
+              </a:lnSpc>
+              <a:spcAft>
+                <a:spcPts val="400"/>
+              </a:spcAft>
+              <a:buNone/>
+            </a:pPr>
+            <a:r>
+              <a:rPr lang="en-US" sz="1250" dirty="0">
+                <a:solidFill>
+                  <a:srgbClr val="3A4556"/>
+                </a:solidFill>
+                <a:latin typeface="IBM Plex Sans" pitchFamily="34" charset="0"/>
+                <a:ea typeface="IBM Plex Sans" pitchFamily="34" charset="-122"/>
+                <a:cs typeface="IBM Plex Sans" pitchFamily="34" charset="-120"/>
+              </a:rPr>
+              <a:t>S: 3 × 4 Gaussian, rebuilt from a seed</a:t>
+            </a:r>
+            <a:endParaRPr lang="en-US" sz="1250" dirty="0"/>
+          </a:p>
+          <a:p>
+            <a:pPr algn="l" indent="0" marL="0">
+              <a:lnSpc>
+                <a:spcPts val="1750"/>
+              </a:lnSpc>
+              <a:spcAft>
+                <a:spcPts val="400"/>
+              </a:spcAft>
+              <a:buNone/>
+            </a:pPr>
+            <a:r>
+              <a:rPr lang="en-US" sz="1250" dirty="0">
+                <a:solidFill>
+                  <a:srgbClr val="0F1B2D"/>
+                </a:solidFill>
+                <a:latin typeface="JetBrains Mono" pitchFamily="49" charset="0"/>
+                <a:ea typeface="JetBrains Mono" pitchFamily="49" charset="-122"/>
+                <a:cs typeface="JetBrains Mono" pitchFamily="49" charset="-120"/>
+              </a:rPr>
+              <a:t> 0.5 −0.2  0.8 −0.1</a:t>
+            </a:r>
+            <a:endParaRPr lang="en-US" sz="1250" dirty="0"/>
+          </a:p>
+          <a:p>
+            <a:pPr algn="l" indent="0" marL="0">
+              <a:lnSpc>
+                <a:spcPts val="1750"/>
+              </a:lnSpc>
+              <a:spcAft>
+                <a:spcPts val="400"/>
+              </a:spcAft>
+              <a:buNone/>
+            </a:pPr>
+            <a:r>
+              <a:rPr lang="en-US" sz="1250" dirty="0">
+                <a:solidFill>
+                  <a:srgbClr val="0F1B2D"/>
+                </a:solidFill>
+                <a:latin typeface="JetBrains Mono" pitchFamily="49" charset="0"/>
+                <a:ea typeface="JetBrains Mono" pitchFamily="49" charset="-122"/>
+                <a:cs typeface="JetBrains Mono" pitchFamily="49" charset="-120"/>
+              </a:rPr>
+              <a:t>−0.9  0.1  0.3  0.7</a:t>
+            </a:r>
+            <a:endParaRPr lang="en-US" sz="1250" dirty="0"/>
+          </a:p>
+          <a:p>
+            <a:pPr algn="l" indent="0" marL="0">
+              <a:lnSpc>
+                <a:spcPts val="1750"/>
+              </a:lnSpc>
+              <a:spcAft>
+                <a:spcPts val="400"/>
+              </a:spcAft>
+              <a:buNone/>
+            </a:pPr>
+            <a:r>
+              <a:rPr lang="en-US" sz="1250" dirty="0">
+                <a:solidFill>
+                  <a:srgbClr val="0F1B2D"/>
+                </a:solidFill>
+                <a:latin typeface="JetBrains Mono" pitchFamily="49" charset="0"/>
+                <a:ea typeface="JetBrains Mono" pitchFamily="49" charset="-122"/>
+                <a:cs typeface="JetBrains Mono" pitchFamily="49" charset="-120"/>
+              </a:rPr>
+              <a:t> 0.2  0.6 −0.4 −0.5</a:t>
+            </a:r>
+            <a:endParaRPr lang="en-US" sz="1250" dirty="0"/>
+          </a:p>
+          <a:p>
+            <a:pPr algn="l" indent="0" marL="0">
+              <a:lnSpc>
+                <a:spcPts val="1750"/>
+              </a:lnSpc>
+              <a:spcAft>
+                <a:spcPts val="400"/>
+              </a:spcAft>
+              <a:buNone/>
+            </a:pPr>
+            <a:r>
+              <a:rPr lang="en-US" sz="1250" dirty="0">
+                <a:solidFill>
+                  <a:srgbClr val="3A4556"/>
+                </a:solidFill>
+                <a:latin typeface="IBM Plex Sans" pitchFamily="34" charset="0"/>
+                <a:ea typeface="IBM Plex Sans" pitchFamily="34" charset="-122"/>
+                <a:cs typeface="IBM Plex Sans" pitchFamily="34" charset="-120"/>
+              </a:rPr>
+              <a:t>S·k = [3.85, −2.15, −2.85]</a:t>
+            </a:r>
+            <a:endParaRPr lang="en-US" sz="1250" dirty="0"/>
+          </a:p>
+        </p:txBody>
+      </p:sp>
+      <p:sp>
+        <p:nvSpPr>
+          <p:cNvPr id="9" name="Shape 9"/>
+          <p:cNvSpPr/>
+          <p:nvPr/>
+        </p:nvSpPr>
+        <p:spPr>
+          <a:xfrm>
+            <a:off x="6344496" y="2150000"/>
+            <a:ext cx="2585848" cy="2500000"/>
+          </a:xfrm>
+          <a:prstGeom prst="roundRect">
+            <a:avLst>
+              <a:gd name="adj" fmla="val 6060"/>
+            </a:avLst>
+          </a:prstGeom>
+          <a:solidFill>
+            <a:srgbClr val="FDFCF9"/>
+          </a:solidFill>
+          <a:ln w="6350">
+            <a:solidFill>
+              <a:srgbClr val="E2DFD6"/>
+            </a:solidFill>
+            <a:prstDash val="solid"/>
+          </a:ln>
+        </p:spPr>
+      </p:sp>
+      <p:sp>
+        <p:nvSpPr>
+          <p:cNvPr id="10" name="Text 10"/>
+          <p:cNvSpPr/>
+          <p:nvPr/>
+        </p:nvSpPr>
+        <p:spPr>
+          <a:xfrm>
+            <a:off x="6534496" y="2340000"/>
+            <a:ext cx="2205848" cy="2120000"/>
+          </a:xfrm>
+          <a:prstGeom prst="rect">
+            <a:avLst/>
+          </a:prstGeom>
+          <a:noFill/>
+          <a:ln/>
+        </p:spPr>
+        <p:txBody>
+          <a:bodyPr wrap="square" lIns="0" tIns="0" rIns="0" bIns="0" rtlCol="0" anchor="t">
+            <a:normAutofit/>
+          </a:bodyPr>
+          <a:lstStyle/>
+          <a:p>
+            <a:pPr algn="l" indent="0" marL="0">
+              <a:lnSpc>
+                <a:spcPts val="1875"/>
+              </a:lnSpc>
+              <a:spcAft>
+                <a:spcPts val="600"/>
+              </a:spcAft>
+              <a:buNone/>
+            </a:pPr>
+            <a:r>
+              <a:rPr lang="en-US" sz="1500" b="1" dirty="0">
+                <a:solidFill>
+                  <a:srgbClr val="0F1B2D"/>
+                </a:solidFill>
+                <a:latin typeface="IBM Plex Sans" pitchFamily="34" charset="0"/>
+                <a:ea typeface="IBM Plex Sans" pitchFamily="34" charset="-122"/>
+                <a:cs typeface="IBM Plex Sans" pitchFamily="34" charset="-120"/>
+              </a:rPr>
+              <a:t>3 · Keep the signs</a:t>
+            </a:r>
+            <a:endParaRPr lang="en-US" sz="1500" dirty="0"/>
+          </a:p>
+          <a:p>
+            <a:pPr algn="l" indent="0" marL="0">
+              <a:lnSpc>
+                <a:spcPts val="1750"/>
+              </a:lnSpc>
+              <a:spcAft>
+                <a:spcPts val="400"/>
+              </a:spcAft>
+              <a:buNone/>
+            </a:pPr>
+            <a:r>
+              <a:rPr lang="en-US" sz="1250" dirty="0">
+                <a:solidFill>
+                  <a:srgbClr val="3A4556"/>
+                </a:solidFill>
+                <a:latin typeface="IBM Plex Sans" pitchFamily="34" charset="0"/>
+                <a:ea typeface="IBM Plex Sans" pitchFamily="34" charset="-122"/>
+                <a:cs typeface="IBM Plex Sans" pitchFamily="34" charset="-120"/>
+              </a:rPr>
+              <a:t>sign(S·k) = [+1, −1, −1]</a:t>
+            </a:r>
+            <a:endParaRPr lang="en-US" sz="1250" dirty="0"/>
+          </a:p>
+          <a:p>
+            <a:pPr algn="l" indent="0" marL="0">
+              <a:lnSpc>
+                <a:spcPts val="1750"/>
+              </a:lnSpc>
+              <a:spcAft>
+                <a:spcPts val="400"/>
+              </a:spcAft>
+              <a:buNone/>
+            </a:pPr>
+            <a:r>
+              <a:rPr lang="en-US" sz="1250" dirty="0">
+                <a:solidFill>
+                  <a:srgbClr val="3A4556"/>
+                </a:solidFill>
+                <a:latin typeface="IBM Plex Sans" pitchFamily="34" charset="0"/>
+                <a:ea typeface="IBM Plex Sans" pitchFamily="34" charset="-122"/>
+                <a:cs typeface="IBM Plex Sans" pitchFamily="34" charset="-120"/>
+              </a:rPr>
+              <a:t>Stored as the bits </a:t>
+            </a:r>
+            <a:r>
+              <a:rPr lang="en-US" sz="1250" dirty="0">
+                <a:solidFill>
+                  <a:srgbClr val="0F1B2D"/>
+                </a:solidFill>
+                <a:latin typeface="JetBrains Mono" pitchFamily="49" charset="0"/>
+                <a:ea typeface="JetBrains Mono" pitchFamily="49" charset="-122"/>
+                <a:cs typeface="JetBrains Mono" pitchFamily="49" charset="-120"/>
+              </a:rPr>
+              <a:t>100</a:t>
+            </a:r>
+            <a:endParaRPr lang="en-US" sz="1250" dirty="0"/>
+          </a:p>
+          <a:p>
+            <a:pPr algn="l" indent="0" marL="0">
+              <a:lnSpc>
+                <a:spcPts val="1750"/>
+              </a:lnSpc>
+              <a:spcAft>
+                <a:spcPts val="400"/>
+              </a:spcAft>
+              <a:buNone/>
+            </a:pPr>
+            <a:r>
+              <a:rPr lang="en-US" sz="1250" b="1" dirty="0">
+                <a:solidFill>
+                  <a:srgbClr val="0F1B2D"/>
+                </a:solidFill>
+                <a:latin typeface="IBM Plex Sans" pitchFamily="34" charset="0"/>
+                <a:ea typeface="IBM Plex Sans" pitchFamily="34" charset="-122"/>
+                <a:cs typeface="IBM Plex Sans" pitchFamily="34" charset="-120"/>
+              </a:rPr>
+              <a:t>In memory: 3 bits + 5.41.</a:t>
+            </a:r>
+            <a:endParaRPr lang="en-US" sz="1250" dirty="0"/>
+          </a:p>
+          <a:p>
+            <a:pPr algn="l" indent="0" marL="0">
+              <a:lnSpc>
+                <a:spcPts val="1750"/>
+              </a:lnSpc>
+              <a:spcAft>
+                <a:spcPts val="400"/>
+              </a:spcAft>
+              <a:buNone/>
+            </a:pPr>
+            <a:r>
+              <a:rPr lang="en-US" sz="1250" dirty="0">
+                <a:solidFill>
+                  <a:srgbClr val="3A4556"/>
+                </a:solidFill>
+                <a:latin typeface="IBM Plex Sans" pitchFamily="34" charset="0"/>
+                <a:ea typeface="IBM Plex Sans" pitchFamily="34" charset="-122"/>
+                <a:cs typeface="IBM Plex Sans" pitchFamily="34" charset="-120"/>
+              </a:rPr>
+              <a:t>The four original floats are dropped.</a:t>
+            </a:r>
+            <a:endParaRPr lang="en-US" sz="1250" dirty="0"/>
+          </a:p>
+        </p:txBody>
+      </p:sp>
+      <p:sp>
+        <p:nvSpPr>
+          <p:cNvPr id="11" name="Shape 11"/>
+          <p:cNvSpPr/>
+          <p:nvPr/>
+        </p:nvSpPr>
+        <p:spPr>
+          <a:xfrm>
+            <a:off x="9110344" y="2150000"/>
+            <a:ext cx="2585848" cy="2500000"/>
+          </a:xfrm>
+          <a:prstGeom prst="roundRect">
+            <a:avLst>
+              <a:gd name="adj" fmla="val 6060"/>
+            </a:avLst>
+          </a:prstGeom>
+          <a:solidFill>
+            <a:srgbClr val="0F1B2D"/>
+          </a:solidFill>
+          <a:ln/>
+        </p:spPr>
+      </p:sp>
+      <p:sp>
+        <p:nvSpPr>
+          <p:cNvPr id="12" name="Text 12"/>
+          <p:cNvSpPr/>
+          <p:nvPr/>
+        </p:nvSpPr>
+        <p:spPr>
+          <a:xfrm>
+            <a:off x="9300344" y="2340000"/>
+            <a:ext cx="2205848" cy="2120000"/>
+          </a:xfrm>
+          <a:prstGeom prst="rect">
+            <a:avLst/>
+          </a:prstGeom>
+          <a:noFill/>
+          <a:ln/>
+        </p:spPr>
+        <p:txBody>
+          <a:bodyPr wrap="square" lIns="0" tIns="0" rIns="0" bIns="0" rtlCol="0" anchor="t">
+            <a:normAutofit/>
+          </a:bodyPr>
+          <a:lstStyle/>
+          <a:p>
+            <a:pPr algn="l" indent="0" marL="0">
+              <a:lnSpc>
+                <a:spcPts val="1875"/>
+              </a:lnSpc>
+              <a:spcAft>
+                <a:spcPts val="600"/>
+              </a:spcAft>
+              <a:buNone/>
+            </a:pPr>
+            <a:r>
+              <a:rPr lang="en-US" sz="1500" b="1" dirty="0">
+                <a:solidFill>
+                  <a:srgbClr val="F2A35E"/>
+                </a:solidFill>
+                <a:latin typeface="IBM Plex Sans" pitchFamily="34" charset="0"/>
+                <a:ea typeface="IBM Plex Sans" pitchFamily="34" charset="-122"/>
+                <a:cs typeface="IBM Plex Sans" pitchFamily="34" charset="-120"/>
+              </a:rPr>
+              <a:t>4 · Score a query</a:t>
+            </a:r>
+            <a:endParaRPr lang="en-US" sz="1500" dirty="0"/>
+          </a:p>
+          <a:p>
+            <a:pPr algn="l" indent="0" marL="0">
+              <a:lnSpc>
+                <a:spcPts val="1750"/>
+              </a:lnSpc>
+              <a:spcAft>
+                <a:spcPts val="400"/>
+              </a:spcAft>
+              <a:buNone/>
+            </a:pPr>
+            <a:r>
+              <a:rPr lang="en-US" sz="1250" dirty="0">
+                <a:solidFill>
+                  <a:srgbClr val="D9DEE6"/>
+                </a:solidFill>
+                <a:latin typeface="IBM Plex Sans" pitchFamily="34" charset="0"/>
+                <a:ea typeface="IBM Plex Sans" pitchFamily="34" charset="-122"/>
+                <a:cs typeface="IBM Plex Sans" pitchFamily="34" charset="-120"/>
+              </a:rPr>
+              <a:t>q = [1, −1, 1, 0], exact ⟨q, k⟩ = 9</a:t>
+            </a:r>
+            <a:endParaRPr lang="en-US" sz="1250" dirty="0"/>
+          </a:p>
+          <a:p>
+            <a:pPr algn="l" indent="0" marL="0">
+              <a:lnSpc>
+                <a:spcPts val="1750"/>
+              </a:lnSpc>
+              <a:spcAft>
+                <a:spcPts val="400"/>
+              </a:spcAft>
+              <a:buNone/>
+            </a:pPr>
+            <a:r>
+              <a:rPr lang="en-US" sz="1250" dirty="0">
+                <a:solidFill>
+                  <a:srgbClr val="D9DEE6"/>
+                </a:solidFill>
+                <a:latin typeface="IBM Plex Sans" pitchFamily="34" charset="0"/>
+                <a:ea typeface="IBM Plex Sans" pitchFamily="34" charset="-122"/>
+                <a:cs typeface="IBM Plex Sans" pitchFamily="34" charset="-120"/>
+              </a:rPr>
+              <a:t>S·q = [1.5, −0.7, −0.8], not quantized</a:t>
+            </a:r>
+            <a:endParaRPr lang="en-US" sz="1250" dirty="0"/>
+          </a:p>
+          <a:p>
+            <a:pPr algn="l" indent="0" marL="0">
+              <a:lnSpc>
+                <a:spcPts val="1750"/>
+              </a:lnSpc>
+              <a:spcAft>
+                <a:spcPts val="400"/>
+              </a:spcAft>
+              <a:buNone/>
+            </a:pPr>
+            <a:r>
+              <a:rPr lang="en-US" sz="1250" dirty="0">
+                <a:solidFill>
+                  <a:srgbClr val="D9DEE6"/>
+                </a:solidFill>
+                <a:latin typeface="IBM Plex Sans" pitchFamily="34" charset="0"/>
+                <a:ea typeface="IBM Plex Sans" pitchFamily="34" charset="-122"/>
+                <a:cs typeface="IBM Plex Sans" pitchFamily="34" charset="-120"/>
+              </a:rPr>
+              <a:t>⟨S·q, sign⟩ = 1.5 + 0.7 + 0.8 = 3.0</a:t>
+            </a:r>
+            <a:endParaRPr lang="en-US" sz="1250" dirty="0"/>
+          </a:p>
+          <a:p>
+            <a:pPr algn="l" indent="0" marL="0">
+              <a:lnSpc>
+                <a:spcPts val="1750"/>
+              </a:lnSpc>
+              <a:spcAft>
+                <a:spcPts val="400"/>
+              </a:spcAft>
+              <a:buNone/>
+            </a:pPr>
+            <a:r>
+              <a:rPr lang="en-US" sz="1250" dirty="0">
+                <a:solidFill>
+                  <a:srgbClr val="D9DEE6"/>
+                </a:solidFill>
+                <a:latin typeface="IBM Plex Sans" pitchFamily="34" charset="0"/>
+                <a:ea typeface="IBM Plex Sans" pitchFamily="34" charset="-122"/>
+                <a:cs typeface="IBM Plex Sans" pitchFamily="34" charset="-120"/>
+              </a:rPr>
+              <a:t>√(π/2)/3 · 5.41 · 3.0 =</a:t>
+            </a:r>
+            <a:endParaRPr lang="en-US" sz="1250" dirty="0"/>
+          </a:p>
+          <a:p>
+            <a:pPr algn="l" indent="0" marL="0">
+              <a:lnSpc>
+                <a:spcPts val="3919"/>
+              </a:lnSpc>
+              <a:spcAft>
+                <a:spcPts val="400"/>
+              </a:spcAft>
+              <a:buNone/>
+            </a:pPr>
+            <a:r>
+              <a:rPr lang="en-US" sz="2800" b="1" dirty="0">
+                <a:solidFill>
+                  <a:srgbClr val="F2A35E"/>
+                </a:solidFill>
+                <a:latin typeface="IBM Plex Sans" pitchFamily="34" charset="0"/>
+                <a:ea typeface="IBM Plex Sans" pitchFamily="34" charset="-122"/>
+                <a:cs typeface="IBM Plex Sans" pitchFamily="34" charset="-120"/>
+              </a:rPr>
+              <a:t>6.78</a:t>
+            </a:r>
+            <a:r>
+              <a:rPr lang="en-US" sz="1250" dirty="0">
+                <a:solidFill>
+                  <a:srgbClr val="D9DEE6"/>
+                </a:solidFill>
+                <a:latin typeface="IBM Plex Sans" pitchFamily="34" charset="0"/>
+                <a:ea typeface="IBM Plex Sans" pitchFamily="34" charset="-122"/>
+                <a:cs typeface="IBM Plex Sans" pitchFamily="34" charset="-120"/>
+              </a:rPr>
+              <a:t>  vs 9</a:t>
+            </a:r>
+            <a:endParaRPr lang="en-US" sz="2800" dirty="0"/>
+          </a:p>
+        </p:txBody>
+      </p:sp>
+      <p:sp>
+        <p:nvSpPr>
+          <p:cNvPr id="13" name="Text 13"/>
+          <p:cNvSpPr/>
+          <p:nvPr/>
+        </p:nvSpPr>
+        <p:spPr>
+          <a:xfrm>
+            <a:off x="812800" y="4900000"/>
+            <a:ext cx="5261696" cy="1000000"/>
+          </a:xfrm>
+          <a:prstGeom prst="rect">
+            <a:avLst/>
+          </a:prstGeom>
+          <a:noFill/>
+          <a:ln/>
+        </p:spPr>
+        <p:txBody>
+          <a:bodyPr wrap="square" lIns="0" tIns="0" rIns="0" bIns="0" rtlCol="0" anchor="t">
+            <a:normAutofit/>
+          </a:bodyPr>
+          <a:lstStyle/>
+          <a:p>
+            <a:pPr algn="l" indent="0" marL="0">
+              <a:lnSpc>
+                <a:spcPts val="2100"/>
+              </a:lnSpc>
+              <a:buNone/>
+            </a:pPr>
+            <a:r>
+              <a:rPr lang="en-US" sz="1500" b="1" dirty="0">
+                <a:solidFill>
+                  <a:srgbClr val="3A4556"/>
+                </a:solidFill>
+                <a:latin typeface="IBM Plex Sans" pitchFamily="34" charset="0"/>
+                <a:ea typeface="IBM Plex Sans" pitchFamily="34" charset="-122"/>
+                <a:cs typeface="IBM Plex Sans" pitchFamily="34" charset="-120"/>
+              </a:rPr>
+              <a:t>Unbiased, not exact.</a:t>
+            </a:r>
+            <a:r>
+              <a:rPr lang="en-US" sz="1500" dirty="0">
+                <a:solidFill>
+                  <a:srgbClr val="3A4556"/>
+                </a:solidFill>
+                <a:latin typeface="IBM Plex Sans" pitchFamily="34" charset="0"/>
+                <a:ea typeface="IBM Plex Sans" pitchFamily="34" charset="-122"/>
+                <a:cs typeface="IBM Plex Sans" pitchFamily="34" charset="-120"/>
+              </a:rPr>
+              <a:t> Over 2,000 draws of S the estimate averages 9.07. Its spread is 4.4 with 3 bits, 0.91 with 64 and 0.24 with 1,024: it shrinks like 1/√m.</a:t>
+            </a:r>
+            <a:endParaRPr lang="en-US" sz="1500" dirty="0"/>
+          </a:p>
+        </p:txBody>
+      </p:sp>
+      <p:sp>
+        <p:nvSpPr>
+          <p:cNvPr id="14" name="Text 14"/>
+          <p:cNvSpPr/>
+          <p:nvPr/>
+        </p:nvSpPr>
+        <p:spPr>
+          <a:xfrm>
+            <a:off x="6434496" y="4900000"/>
+            <a:ext cx="5261696" cy="1000000"/>
+          </a:xfrm>
+          <a:prstGeom prst="rect">
+            <a:avLst/>
+          </a:prstGeom>
+          <a:noFill/>
+          <a:ln/>
+        </p:spPr>
+        <p:txBody>
+          <a:bodyPr wrap="square" lIns="0" tIns="0" rIns="0" bIns="0" rtlCol="0" anchor="t">
+            <a:normAutofit/>
+          </a:bodyPr>
+          <a:lstStyle/>
+          <a:p>
+            <a:pPr algn="l" indent="0" marL="0">
+              <a:lnSpc>
+                <a:spcPts val="2100"/>
+              </a:lnSpc>
+              <a:buNone/>
+            </a:pPr>
+            <a:r>
+              <a:rPr lang="en-US" sz="1500" b="1" dirty="0">
+                <a:solidFill>
+                  <a:srgbClr val="3A4556"/>
+                </a:solidFill>
+                <a:latin typeface="IBM Plex Sans" pitchFamily="34" charset="0"/>
+                <a:ea typeface="IBM Plex Sans" pitchFamily="34" charset="-122"/>
+                <a:cs typeface="IBM Plex Sans" pitchFamily="34" charset="-120"/>
+              </a:rPr>
+              <a:t>Why √(π/2).</a:t>
+            </a:r>
+            <a:r>
+              <a:rPr lang="en-US" sz="1500" dirty="0">
+                <a:solidFill>
+                  <a:srgbClr val="3A4556"/>
+                </a:solidFill>
+                <a:latin typeface="IBM Plex Sans" pitchFamily="34" charset="0"/>
+                <a:ea typeface="IBM Plex Sans" pitchFamily="34" charset="-122"/>
+                <a:cs typeface="IBM Plex Sans" pitchFamily="34" charset="-120"/>
+              </a:rPr>
+              <a:t> Keeping signs shrinks the average by √(2/π)/‖k‖. The norm and √(π/2) undo it. The query stays full precision, so there is no XOR or popcount.</a:t>
+            </a:r>
+            <a:endParaRPr lang="en-US" sz="1500" dirty="0"/>
+          </a:p>
+        </p:txBody>
+      </p:sp>
+      <p:sp>
+        <p:nvSpPr>
+          <p:cNvPr id="15" name="Text 15"/>
+          <p:cNvSpPr/>
+          <p:nvPr/>
+        </p:nvSpPr>
+        <p:spPr>
+          <a:xfrm>
+            <a:off x="812800" y="6238280"/>
+            <a:ext cx="10883392" cy="238720"/>
+          </a:xfrm>
+          <a:prstGeom prst="rect">
+            <a:avLst/>
+          </a:prstGeom>
+          <a:noFill/>
+          <a:ln/>
+        </p:spPr>
+        <p:txBody>
+          <a:bodyPr wrap="square" lIns="0" tIns="0" rIns="0" bIns="0" rtlCol="0" anchor="t">
+            <a:normAutofit/>
+          </a:bodyPr>
+          <a:lstStyle/>
+          <a:p>
+            <a:pPr algn="l" indent="0" marL="0">
+              <a:lnSpc>
+                <a:spcPts val="1680"/>
+              </a:lnSpc>
+              <a:buNone/>
+            </a:pPr>
+            <a:r>
+              <a:rPr lang="en-US" sz="1200" dirty="0">
+                <a:solidFill>
+                  <a:srgbClr val="5F6979"/>
+                </a:solidFill>
+                <a:latin typeface="IBM Plex Sans" pitchFamily="34" charset="0"/>
+                <a:ea typeface="IBM Plex Sans" pitchFamily="34" charset="-122"/>
+                <a:cs typeface="IBM Plex Sans" pitchFamily="34" charset="-120"/>
+              </a:rPr>
+              <a:t>Section 2.1 of the guide. Every number is reproduced by docs/guide/worked_examples.py.</a:t>
+            </a:r>
+            <a:endParaRPr lang="en-US" sz="1200" dirty="0"/>
+          </a:p>
+        </p:txBody>
+      </p:sp>
+    </p:spTree>
+  </p:cSld>
+  <p:clrMapOvr>
+    <a:masterClrMapping/>
+  </p:clrMapOvr>
+</p:sld>
+</file>
+
+<file path=ppt/slides/slide26.xml><?xml version="1.0" encoding="utf-8"?>
+<p:sld xmlns:a="http://schemas.openxmlformats.org/drawingml/2006/main" xmlns:p="http://schemas.openxmlformats.org/presentationml/2006/main" xmlns:r="http://schemas.openxmlformats.org/officeDocument/2006/relationships">
+  <p:cSld>
+    <p:bg>
+      <p:bgPr>
+        <a:solidFill>
+          <a:srgbClr val="F6F5F0"/>
+        </a:solidFill>
+      </p:bgPr>
+    </p:bg>
+    <p:spTree>
+      <p:nvGrpSpPr>
+        <p:cNvPr id="1" name=""/>
+        <p:cNvGrpSpPr/>
+        <p:nvPr/>
+      </p:nvGrpSpPr>
+      <p:grpSpPr/>
+      <p:sp>
+        <p:nvSpPr>
+          <p:cNvPr id="3" name="Text 3"/>
+          <p:cNvSpPr/>
+          <p:nvPr/>
+        </p:nvSpPr>
+        <p:spPr>
+          <a:xfrm>
+            <a:off x="812800" y="812800"/>
+            <a:ext cx="10883392" cy="238720"/>
+          </a:xfrm>
+          <a:prstGeom prst="rect">
+            <a:avLst/>
+          </a:prstGeom>
+          <a:noFill/>
+          <a:ln/>
+        </p:spPr>
+        <p:txBody>
+          <a:bodyPr wrap="square" lIns="0" tIns="0" rIns="0" bIns="0" rtlCol="0" anchor="t">
+            <a:normAutofit/>
+          </a:bodyPr>
+          <a:lstStyle/>
+          <a:p>
+            <a:pPr algn="l" indent="0" marL="0">
+              <a:lnSpc>
+                <a:spcPts val="1680"/>
+              </a:lnSpc>
+              <a:buNone/>
+            </a:pPr>
+            <a:r>
+              <a:rPr lang="en-US" sz="1200" spc="100" dirty="0">
+                <a:solidFill>
+                  <a:srgbClr val="B4521A"/>
+                </a:solidFill>
+                <a:latin typeface="JetBrains Mono" pitchFamily="49" charset="0"/>
+                <a:ea typeface="JetBrains Mono" pitchFamily="49" charset="-122"/>
+                <a:cs typeface="JetBrains Mono" pitchFamily="49" charset="-120"/>
+              </a:rPr>
+              <a:t>POLARQUANT · WORKED EXAMPLE</a:t>
+            </a:r>
+            <a:endParaRPr lang="en-US" sz="1200" dirty="0"/>
+          </a:p>
+        </p:txBody>
+      </p:sp>
+      <p:sp>
+        <p:nvSpPr>
+          <p:cNvPr id="4" name="Text 4"/>
+          <p:cNvSpPr/>
+          <p:nvPr>
+            <p:ph type="title"/>
+          </p:nvPr>
+        </p:nvSpPr>
+        <p:spPr>
+          <a:xfrm>
+            <a:off x="812800" y="1381720"/>
+            <a:ext cx="11379200" cy="472380"/>
+          </a:xfrm>
+          <a:prstGeom prst="rect">
+            <a:avLst/>
+          </a:prstGeom>
+          <a:noFill/>
+          <a:ln/>
+        </p:spPr>
+        <p:txBody>
+          <a:bodyPr wrap="square" lIns="0" tIns="0" rIns="0" bIns="0" rtlCol="0" anchor="t">
+            <a:normAutofit/>
+          </a:bodyPr>
+          <a:lstStyle/>
+          <a:p>
+            <a:pPr algn="l" indent="0" marL="0">
+              <a:lnSpc>
+                <a:spcPts val="3520"/>
+              </a:lnSpc>
+              <a:buNone/>
+            </a:pPr>
+            <a:r>
+              <a:rPr lang="en-US" sz="3200" b="1" dirty="0">
+                <a:solidFill>
+                  <a:srgbClr val="0F1B2D"/>
+                </a:solidFill>
+                <a:latin typeface="IBM Plex Sans" pitchFamily="34" charset="0"/>
+                <a:ea typeface="IBM Plex Sans" pitchFamily="34" charset="-122"/>
+                <a:cs typeface="IBM Plex Sans" pitchFamily="34" charset="-120"/>
+              </a:rPr>
+              <a:t>PolarQuant by hand: pairs become radii and angles</a:t>
+            </a:r>
+            <a:endParaRPr lang="en-US" sz="3200" dirty="0"/>
+          </a:p>
+        </p:txBody>
+      </p:sp>
+      <p:sp>
+        <p:nvSpPr>
+          <p:cNvPr id="5" name="Shape 5"/>
+          <p:cNvSpPr/>
+          <p:nvPr/>
+        </p:nvSpPr>
+        <p:spPr>
+          <a:xfrm>
+            <a:off x="812800" y="2150000"/>
+            <a:ext cx="5600000" cy="3880000"/>
+          </a:xfrm>
+          <a:prstGeom prst="roundRect">
+            <a:avLst>
+              <a:gd name="adj" fmla="val 6060"/>
+            </a:avLst>
+          </a:prstGeom>
+          <a:solidFill>
+            <a:srgbClr val="FDFCF9"/>
+          </a:solidFill>
+          <a:ln w="6350">
+            <a:solidFill>
+              <a:srgbClr val="E2DFD6"/>
+            </a:solidFill>
+            <a:prstDash val="solid"/>
+          </a:ln>
+        </p:spPr>
+      </p:sp>
+      <p:cxnSp>
+        <p:nvCxnSpPr>
+          <p:cNvPr id="6" name="Line 6"/>
+          <p:cNvCxnSpPr/>
+          <p:nvPr/>
+        </p:nvCxnSpPr>
+        <p:spPr>
+          <a:xfrm>
+            <a:off x="2449050" y="4470000"/>
+            <a:ext cx="546250" cy="530000"/>
+          </a:xfrm>
+          <a:prstGeom prst="line">
+            <a:avLst/>
+          </a:prstGeom>
+          <a:ln w="12700">
+            <a:solidFill>
+              <a:srgbClr val="B8BCC4"/>
+            </a:solidFill>
+          </a:ln>
+        </p:spPr>
+      </p:cxnSp>
+      <p:cxnSp>
+        <p:nvCxnSpPr>
+          <p:cNvPr id="7" name="Line 7"/>
+          <p:cNvCxnSpPr/>
+          <p:nvPr/>
+        </p:nvCxnSpPr>
+        <p:spPr>
+          <a:xfrm flipH="1">
+            <a:off x="2995300" y="4470000"/>
+            <a:ext cx="546250" cy="530000"/>
+          </a:xfrm>
+          <a:prstGeom prst="line">
+            <a:avLst/>
+          </a:prstGeom>
+          <a:ln w="12700">
+            <a:solidFill>
+              <a:srgbClr val="B8BCC4"/>
+            </a:solidFill>
+          </a:ln>
+        </p:spPr>
+      </p:cxnSp>
+      <p:cxnSp>
+        <p:nvCxnSpPr>
+          <p:cNvPr id="8" name="Line 8"/>
+          <p:cNvCxnSpPr/>
+          <p:nvPr/>
+        </p:nvCxnSpPr>
+        <p:spPr>
+          <a:xfrm>
+            <a:off x="4634050" y="4470000"/>
+            <a:ext cx="546250" cy="530000"/>
+          </a:xfrm>
+          <a:prstGeom prst="line">
+            <a:avLst/>
+          </a:prstGeom>
+          <a:ln w="12700">
+            <a:solidFill>
+              <a:srgbClr val="B8BCC4"/>
+            </a:solidFill>
+          </a:ln>
+        </p:spPr>
+      </p:cxnSp>
+      <p:cxnSp>
+        <p:nvCxnSpPr>
+          <p:cNvPr id="9" name="Line 9"/>
+          <p:cNvCxnSpPr/>
+          <p:nvPr/>
+        </p:nvCxnSpPr>
+        <p:spPr>
+          <a:xfrm flipH="1">
+            <a:off x="5180300" y="4470000"/>
+            <a:ext cx="546250" cy="530000"/>
+          </a:xfrm>
+          <a:prstGeom prst="line">
+            <a:avLst/>
+          </a:prstGeom>
+          <a:ln w="12700">
+            <a:solidFill>
+              <a:srgbClr val="B8BCC4"/>
+            </a:solidFill>
+          </a:ln>
+        </p:spPr>
+      </p:cxnSp>
+      <p:cxnSp>
+        <p:nvCxnSpPr>
+          <p:cNvPr id="10" name="Line 10"/>
+          <p:cNvCxnSpPr/>
+          <p:nvPr/>
+        </p:nvCxnSpPr>
+        <p:spPr>
+          <a:xfrm>
+            <a:off x="2995300" y="3240000"/>
+            <a:ext cx="1092500" cy="470000"/>
+          </a:xfrm>
+          <a:prstGeom prst="line">
+            <a:avLst/>
+          </a:prstGeom>
+          <a:ln w="12700">
+            <a:solidFill>
+              <a:srgbClr val="B8BCC4"/>
+            </a:solidFill>
+          </a:ln>
+        </p:spPr>
+      </p:cxnSp>
+      <p:cxnSp>
+        <p:nvCxnSpPr>
+          <p:cNvPr id="11" name="Line 11"/>
+          <p:cNvCxnSpPr/>
+          <p:nvPr/>
+        </p:nvCxnSpPr>
+        <p:spPr>
+          <a:xfrm flipH="1">
+            <a:off x="4087800" y="3240000"/>
+            <a:ext cx="1092500" cy="470000"/>
+          </a:xfrm>
+          <a:prstGeom prst="line">
+            <a:avLst/>
+          </a:prstGeom>
+          <a:ln w="12700">
+            <a:solidFill>
+              <a:srgbClr val="B8BCC4"/>
+            </a:solidFill>
+          </a:ln>
+        </p:spPr>
+      </p:cxnSp>
+      <p:sp>
+        <p:nvSpPr>
+          <p:cNvPr id="12" name="Shape 12"/>
+          <p:cNvSpPr/>
+          <p:nvPr/>
+        </p:nvSpPr>
+        <p:spPr>
+          <a:xfrm>
+            <a:off x="2900425" y="2480000"/>
+            <a:ext cx="2374750" cy="760000"/>
+          </a:xfrm>
+          <a:prstGeom prst="roundRect">
+            <a:avLst>
+              <a:gd name="adj" fmla="val 12000"/>
+            </a:avLst>
+          </a:prstGeom>
+          <a:solidFill>
+            <a:srgbClr val="0F1B2D"/>
+          </a:solidFill>
+          <a:ln/>
+        </p:spPr>
+      </p:sp>
+      <p:sp>
+        <p:nvSpPr>
+          <p:cNvPr id="13" name="Text 13"/>
+          <p:cNvSpPr/>
+          <p:nvPr/>
+        </p:nvSpPr>
+        <p:spPr>
+          <a:xfrm>
+            <a:off x="2960425" y="2550000"/>
+            <a:ext cx="2254750" cy="660000"/>
+          </a:xfrm>
+          <a:prstGeom prst="rect">
+            <a:avLst/>
+          </a:prstGeom>
+          <a:noFill/>
+          <a:ln/>
+        </p:spPr>
+        <p:txBody>
+          <a:bodyPr wrap="square" lIns="0" tIns="0" rIns="0" bIns="0" rtlCol="0" anchor="ctr">
+            <a:normAutofit/>
+          </a:bodyPr>
+          <a:lstStyle/>
+          <a:p>
+            <a:pPr algn="ctr" indent="0" marL="0">
+              <a:lnSpc>
+                <a:spcPts val="1700"/>
+              </a:lnSpc>
+              <a:buNone/>
+            </a:pPr>
+            <a:r>
+              <a:rPr lang="en-US" sz="1300" b="1" dirty="0">
+                <a:solidFill>
+                  <a:srgbClr val="F2A35E"/>
+                </a:solidFill>
+                <a:latin typeface="IBM Plex Sans" pitchFamily="34" charset="0"/>
+                <a:ea typeface="IBM Plex Sans" pitchFamily="34" charset="-122"/>
+                <a:cs typeface="IBM Plex Sans" pitchFamily="34" charset="-120"/>
+              </a:rPr>
+              <a:t>‖v‖ = 5.41</a:t>
+            </a:r>
+            <a:endParaRPr lang="en-US" sz="1300" dirty="0"/>
+          </a:p>
+          <a:p>
+            <a:pPr algn="ctr" indent="0" marL="0">
+              <a:lnSpc>
+                <a:spcPts val="1500"/>
+              </a:lnSpc>
+              <a:buNone/>
+            </a:pPr>
+            <a:r>
+              <a:rPr lang="en-US" sz="1150" dirty="0">
+                <a:solidFill>
+                  <a:srgbClr val="D9DEE6"/>
+                </a:solidFill>
+                <a:latin typeface="IBM Plex Sans" pitchFamily="34" charset="0"/>
+                <a:ea typeface="IBM Plex Sans" pitchFamily="34" charset="-122"/>
+                <a:cs typeface="IBM Plex Sans" pitchFamily="34" charset="-120"/>
+              </a:rPr>
+              <a:t>ψ = 22.4°  (0 to 90°, 2 bits)</a:t>
+            </a:r>
+            <a:endParaRPr lang="en-US" sz="1150" dirty="0"/>
+          </a:p>
+        </p:txBody>
+      </p:sp>
+      <p:sp>
+        <p:nvSpPr>
+          <p:cNvPr id="14" name="Shape 14"/>
+          <p:cNvSpPr/>
+          <p:nvPr/>
+        </p:nvSpPr>
+        <p:spPr>
+          <a:xfrm>
+            <a:off x="1962800" y="3710000"/>
+            <a:ext cx="2065000" cy="760000"/>
+          </a:xfrm>
+          <a:prstGeom prst="roundRect">
+            <a:avLst>
+              <a:gd name="adj" fmla="val 12000"/>
+            </a:avLst>
+          </a:prstGeom>
+          <a:solidFill>
+            <a:srgbClr val="F6F5F0"/>
+          </a:solidFill>
+          <a:ln w="6350">
+            <a:solidFill>
+              <a:srgbClr val="E2DFD6"/>
+            </a:solidFill>
+            <a:prstDash val="solid"/>
+          </a:ln>
+        </p:spPr>
+      </p:sp>
+      <p:sp>
+        <p:nvSpPr>
+          <p:cNvPr id="15" name="Text 15"/>
+          <p:cNvSpPr/>
+          <p:nvPr/>
+        </p:nvSpPr>
+        <p:spPr>
+          <a:xfrm>
+            <a:off x="2022800" y="3780000"/>
+            <a:ext cx="1945000" cy="660000"/>
+          </a:xfrm>
+          <a:prstGeom prst="rect">
+            <a:avLst/>
+          </a:prstGeom>
+          <a:noFill/>
+          <a:ln/>
+        </p:spPr>
+        <p:txBody>
+          <a:bodyPr wrap="square" lIns="0" tIns="0" rIns="0" bIns="0" rtlCol="0" anchor="ctr">
+            <a:normAutofit/>
+          </a:bodyPr>
+          <a:lstStyle/>
+          <a:p>
+            <a:pPr algn="ctr" indent="0" marL="0">
+              <a:lnSpc>
+                <a:spcPts val="1700"/>
+              </a:lnSpc>
+              <a:buNone/>
+            </a:pPr>
+            <a:r>
+              <a:rPr lang="en-US" sz="1300" b="1" dirty="0">
+                <a:solidFill>
+                  <a:srgbClr val="0F1B2D"/>
+                </a:solidFill>
+                <a:latin typeface="IBM Plex Sans" pitchFamily="34" charset="0"/>
+                <a:ea typeface="IBM Plex Sans" pitchFamily="34" charset="-122"/>
+                <a:cs typeface="IBM Plex Sans" pitchFamily="34" charset="-120"/>
+              </a:rPr>
+              <a:t>R_A = 5</a:t>
+            </a:r>
+            <a:endParaRPr lang="en-US" sz="1300" dirty="0"/>
+          </a:p>
+          <a:p>
+            <a:pPr algn="ctr" indent="0" marL="0">
+              <a:lnSpc>
+                <a:spcPts val="1500"/>
+              </a:lnSpc>
+              <a:buNone/>
+            </a:pPr>
+            <a:r>
+              <a:rPr lang="en-US" sz="1150" dirty="0">
+                <a:solidFill>
+                  <a:srgbClr val="3A4556"/>
+                </a:solidFill>
+                <a:latin typeface="IBM Plex Sans" pitchFamily="34" charset="0"/>
+                <a:ea typeface="IBM Plex Sans" pitchFamily="34" charset="-122"/>
+                <a:cs typeface="IBM Plex Sans" pitchFamily="34" charset="-120"/>
+              </a:rPr>
+              <a:t>θ₁ = 306.9°  (4 bits)</a:t>
+            </a:r>
+            <a:endParaRPr lang="en-US" sz="1150" dirty="0"/>
+          </a:p>
+        </p:txBody>
+      </p:sp>
+      <p:sp>
+        <p:nvSpPr>
+          <p:cNvPr id="16" name="Shape 16"/>
+          <p:cNvSpPr/>
+          <p:nvPr/>
+        </p:nvSpPr>
+        <p:spPr>
+          <a:xfrm>
+            <a:off x="4147800" y="3710000"/>
+            <a:ext cx="2065000" cy="760000"/>
+          </a:xfrm>
+          <a:prstGeom prst="roundRect">
+            <a:avLst>
+              <a:gd name="adj" fmla="val 12000"/>
+            </a:avLst>
+          </a:prstGeom>
+          <a:solidFill>
+            <a:srgbClr val="F6F5F0"/>
+          </a:solidFill>
+          <a:ln w="6350">
+            <a:solidFill>
+              <a:srgbClr val="E2DFD6"/>
+            </a:solidFill>
+            <a:prstDash val="solid"/>
+          </a:ln>
+        </p:spPr>
+      </p:sp>
+      <p:sp>
+        <p:nvSpPr>
+          <p:cNvPr id="17" name="Text 17"/>
+          <p:cNvSpPr/>
+          <p:nvPr/>
+        </p:nvSpPr>
+        <p:spPr>
+          <a:xfrm>
+            <a:off x="4207800" y="3780000"/>
+            <a:ext cx="1945000" cy="660000"/>
+          </a:xfrm>
+          <a:prstGeom prst="rect">
+            <a:avLst/>
+          </a:prstGeom>
+          <a:noFill/>
+          <a:ln/>
+        </p:spPr>
+        <p:txBody>
+          <a:bodyPr wrap="square" lIns="0" tIns="0" rIns="0" bIns="0" rtlCol="0" anchor="ctr">
+            <a:normAutofit/>
+          </a:bodyPr>
+          <a:lstStyle/>
+          <a:p>
+            <a:pPr algn="ctr" indent="0" marL="0">
+              <a:lnSpc>
+                <a:spcPts val="1700"/>
+              </a:lnSpc>
+              <a:buNone/>
+            </a:pPr>
+            <a:r>
+              <a:rPr lang="en-US" sz="1300" b="1" dirty="0">
+                <a:solidFill>
+                  <a:srgbClr val="0F1B2D"/>
+                </a:solidFill>
+                <a:latin typeface="IBM Plex Sans" pitchFamily="34" charset="0"/>
+                <a:ea typeface="IBM Plex Sans" pitchFamily="34" charset="-122"/>
+                <a:cs typeface="IBM Plex Sans" pitchFamily="34" charset="-120"/>
+              </a:rPr>
+              <a:t>R_B = 2.06</a:t>
+            </a:r>
+            <a:endParaRPr lang="en-US" sz="1300" dirty="0"/>
+          </a:p>
+          <a:p>
+            <a:pPr algn="ctr" indent="0" marL="0">
+              <a:lnSpc>
+                <a:spcPts val="1500"/>
+              </a:lnSpc>
+              <a:buNone/>
+            </a:pPr>
+            <a:r>
+              <a:rPr lang="en-US" sz="1150" dirty="0">
+                <a:solidFill>
+                  <a:srgbClr val="3A4556"/>
+                </a:solidFill>
+                <a:latin typeface="IBM Plex Sans" pitchFamily="34" charset="0"/>
+                <a:ea typeface="IBM Plex Sans" pitchFamily="34" charset="-122"/>
+                <a:cs typeface="IBM Plex Sans" pitchFamily="34" charset="-120"/>
+              </a:rPr>
+              <a:t>θ₂ = 14.0°  (4 bits)</a:t>
+            </a:r>
+            <a:endParaRPr lang="en-US" sz="1150" dirty="0"/>
+          </a:p>
+        </p:txBody>
+      </p:sp>
+      <p:sp>
+        <p:nvSpPr>
+          <p:cNvPr id="18" name="Shape 18"/>
+          <p:cNvSpPr/>
+          <p:nvPr/>
+        </p:nvSpPr>
+        <p:spPr>
+          <a:xfrm>
+            <a:off x="1962800" y="5100000"/>
+            <a:ext cx="972500" cy="420000"/>
+          </a:xfrm>
+          <a:prstGeom prst="roundRect">
+            <a:avLst>
+              <a:gd name="adj" fmla="val 12000"/>
+            </a:avLst>
+          </a:prstGeom>
+          <a:solidFill>
+            <a:srgbClr val="F6F5F0"/>
+          </a:solidFill>
+          <a:ln w="6350">
+            <a:solidFill>
+              <a:srgbClr val="E2DFD6"/>
+            </a:solidFill>
+            <a:prstDash val="solid"/>
+          </a:ln>
+        </p:spPr>
+      </p:sp>
+      <p:sp>
+        <p:nvSpPr>
+          <p:cNvPr id="19" name="Text 19"/>
+          <p:cNvSpPr/>
+          <p:nvPr/>
+        </p:nvSpPr>
+        <p:spPr>
+          <a:xfrm>
+            <a:off x="2022800" y="5170000"/>
+            <a:ext cx="852500" cy="320000"/>
+          </a:xfrm>
+          <a:prstGeom prst="rect">
+            <a:avLst/>
+          </a:prstGeom>
+          <a:noFill/>
+          <a:ln/>
+        </p:spPr>
+        <p:txBody>
+          <a:bodyPr wrap="square" lIns="0" tIns="0" rIns="0" bIns="0" rtlCol="0" anchor="ctr">
+            <a:normAutofit/>
+          </a:bodyPr>
+          <a:lstStyle/>
+          <a:p>
+            <a:pPr algn="ctr" indent="0" marL="0">
+              <a:lnSpc>
+                <a:spcPts val="1700"/>
+              </a:lnSpc>
+              <a:buNone/>
+            </a:pPr>
+            <a:r>
+              <a:rPr lang="en-US" sz="1300" b="1" dirty="0">
+                <a:solidFill>
+                  <a:srgbClr val="0F1B2D"/>
+                </a:solidFill>
+                <a:latin typeface="IBM Plex Sans" pitchFamily="34" charset="0"/>
+                <a:ea typeface="IBM Plex Sans" pitchFamily="34" charset="-122"/>
+                <a:cs typeface="IBM Plex Sans" pitchFamily="34" charset="-120"/>
+              </a:rPr>
+              <a:t>x₁ = 3</a:t>
+            </a:r>
+            <a:endParaRPr lang="en-US" sz="1300" dirty="0"/>
+          </a:p>
+        </p:txBody>
+      </p:sp>
+      <p:sp>
+        <p:nvSpPr>
+          <p:cNvPr id="20" name="Shape 20"/>
+          <p:cNvSpPr/>
+          <p:nvPr/>
+        </p:nvSpPr>
+        <p:spPr>
+          <a:xfrm>
+            <a:off x="3055300" y="5100000"/>
+            <a:ext cx="972500" cy="420000"/>
+          </a:xfrm>
+          <a:prstGeom prst="roundRect">
+            <a:avLst>
+              <a:gd name="adj" fmla="val 12000"/>
+            </a:avLst>
+          </a:prstGeom>
+          <a:solidFill>
+            <a:srgbClr val="F6F5F0"/>
+          </a:solidFill>
+          <a:ln w="6350">
+            <a:solidFill>
+              <a:srgbClr val="E2DFD6"/>
+            </a:solidFill>
+            <a:prstDash val="solid"/>
+          </a:ln>
+        </p:spPr>
+      </p:sp>
+      <p:sp>
+        <p:nvSpPr>
+          <p:cNvPr id="21" name="Text 21"/>
+          <p:cNvSpPr/>
+          <p:nvPr/>
+        </p:nvSpPr>
+        <p:spPr>
+          <a:xfrm>
+            <a:off x="3115300" y="5170000"/>
+            <a:ext cx="852500" cy="320000"/>
+          </a:xfrm>
+          <a:prstGeom prst="rect">
+            <a:avLst/>
+          </a:prstGeom>
+          <a:noFill/>
+          <a:ln/>
+        </p:spPr>
+        <p:txBody>
+          <a:bodyPr wrap="square" lIns="0" tIns="0" rIns="0" bIns="0" rtlCol="0" anchor="ctr">
+            <a:normAutofit/>
+          </a:bodyPr>
+          <a:lstStyle/>
+          <a:p>
+            <a:pPr algn="ctr" indent="0" marL="0">
+              <a:lnSpc>
+                <a:spcPts val="1700"/>
+              </a:lnSpc>
+              <a:buNone/>
+            </a:pPr>
+            <a:r>
+              <a:rPr lang="en-US" sz="1300" b="1" dirty="0">
+                <a:solidFill>
+                  <a:srgbClr val="0F1B2D"/>
+                </a:solidFill>
+                <a:latin typeface="IBM Plex Sans" pitchFamily="34" charset="0"/>
+                <a:ea typeface="IBM Plex Sans" pitchFamily="34" charset="-122"/>
+                <a:cs typeface="IBM Plex Sans" pitchFamily="34" charset="-120"/>
+              </a:rPr>
+              <a:t>x₂ = −4</a:t>
+            </a:r>
+            <a:endParaRPr lang="en-US" sz="1300" dirty="0"/>
+          </a:p>
+        </p:txBody>
+      </p:sp>
+      <p:sp>
+        <p:nvSpPr>
+          <p:cNvPr id="22" name="Shape 22"/>
+          <p:cNvSpPr/>
+          <p:nvPr/>
+        </p:nvSpPr>
+        <p:spPr>
+          <a:xfrm>
+            <a:off x="4147800" y="5100000"/>
+            <a:ext cx="972500" cy="420000"/>
+          </a:xfrm>
+          <a:prstGeom prst="roundRect">
+            <a:avLst>
+              <a:gd name="adj" fmla="val 12000"/>
+            </a:avLst>
+          </a:prstGeom>
+          <a:solidFill>
+            <a:srgbClr val="F6F5F0"/>
+          </a:solidFill>
+          <a:ln w="6350">
+            <a:solidFill>
+              <a:srgbClr val="E2DFD6"/>
+            </a:solidFill>
+            <a:prstDash val="solid"/>
+          </a:ln>
+        </p:spPr>
+      </p:sp>
+      <p:sp>
+        <p:nvSpPr>
+          <p:cNvPr id="23" name="Text 23"/>
+          <p:cNvSpPr/>
+          <p:nvPr/>
+        </p:nvSpPr>
+        <p:spPr>
+          <a:xfrm>
+            <a:off x="4207800" y="5170000"/>
+            <a:ext cx="852500" cy="320000"/>
+          </a:xfrm>
+          <a:prstGeom prst="rect">
+            <a:avLst/>
+          </a:prstGeom>
+          <a:noFill/>
+          <a:ln/>
+        </p:spPr>
+        <p:txBody>
+          <a:bodyPr wrap="square" lIns="0" tIns="0" rIns="0" bIns="0" rtlCol="0" anchor="ctr">
+            <a:normAutofit/>
+          </a:bodyPr>
+          <a:lstStyle/>
+          <a:p>
+            <a:pPr algn="ctr" indent="0" marL="0">
+              <a:lnSpc>
+                <a:spcPts val="1700"/>
+              </a:lnSpc>
+              <a:buNone/>
+            </a:pPr>
+            <a:r>
+              <a:rPr lang="en-US" sz="1300" b="1" dirty="0">
+                <a:solidFill>
+                  <a:srgbClr val="0F1B2D"/>
+                </a:solidFill>
+                <a:latin typeface="IBM Plex Sans" pitchFamily="34" charset="0"/>
+                <a:ea typeface="IBM Plex Sans" pitchFamily="34" charset="-122"/>
+                <a:cs typeface="IBM Plex Sans" pitchFamily="34" charset="-120"/>
+              </a:rPr>
+              <a:t>x₃ = 2</a:t>
+            </a:r>
+            <a:endParaRPr lang="en-US" sz="1300" dirty="0"/>
+          </a:p>
+        </p:txBody>
+      </p:sp>
+      <p:sp>
+        <p:nvSpPr>
+          <p:cNvPr id="24" name="Shape 24"/>
+          <p:cNvSpPr/>
+          <p:nvPr/>
+        </p:nvSpPr>
+        <p:spPr>
+          <a:xfrm>
+            <a:off x="5240300" y="5100000"/>
+            <a:ext cx="972500" cy="420000"/>
+          </a:xfrm>
+          <a:prstGeom prst="roundRect">
+            <a:avLst>
+              <a:gd name="adj" fmla="val 12000"/>
+            </a:avLst>
+          </a:prstGeom>
+          <a:solidFill>
+            <a:srgbClr val="F6F5F0"/>
+          </a:solidFill>
+          <a:ln w="6350">
+            <a:solidFill>
+              <a:srgbClr val="E2DFD6"/>
+            </a:solidFill>
+            <a:prstDash val="solid"/>
+          </a:ln>
+        </p:spPr>
+      </p:sp>
+      <p:sp>
+        <p:nvSpPr>
+          <p:cNvPr id="25" name="Text 25"/>
+          <p:cNvSpPr/>
+          <p:nvPr/>
+        </p:nvSpPr>
+        <p:spPr>
+          <a:xfrm>
+            <a:off x="5300300" y="5170000"/>
+            <a:ext cx="852500" cy="320000"/>
+          </a:xfrm>
+          <a:prstGeom prst="rect">
+            <a:avLst/>
+          </a:prstGeom>
+          <a:noFill/>
+          <a:ln/>
+        </p:spPr>
+        <p:txBody>
+          <a:bodyPr wrap="square" lIns="0" tIns="0" rIns="0" bIns="0" rtlCol="0" anchor="ctr">
+            <a:normAutofit/>
+          </a:bodyPr>
+          <a:lstStyle/>
+          <a:p>
+            <a:pPr algn="ctr" indent="0" marL="0">
+              <a:lnSpc>
+                <a:spcPts val="1700"/>
+              </a:lnSpc>
+              <a:buNone/>
+            </a:pPr>
+            <a:r>
+              <a:rPr lang="en-US" sz="1300" b="1" dirty="0">
+                <a:solidFill>
+                  <a:srgbClr val="0F1B2D"/>
+                </a:solidFill>
+                <a:latin typeface="IBM Plex Sans" pitchFamily="34" charset="0"/>
+                <a:ea typeface="IBM Plex Sans" pitchFamily="34" charset="-122"/>
+                <a:cs typeface="IBM Plex Sans" pitchFamily="34" charset="-120"/>
+              </a:rPr>
+              <a:t>x₄ = 0.5</a:t>
+            </a:r>
+            <a:endParaRPr lang="en-US" sz="1300" dirty="0"/>
+          </a:p>
+        </p:txBody>
+      </p:sp>
+      <p:sp>
+        <p:nvSpPr>
+          <p:cNvPr id="26" name="Text 26"/>
+          <p:cNvSpPr/>
+          <p:nvPr/>
+        </p:nvSpPr>
+        <p:spPr>
+          <a:xfrm>
+            <a:off x="1012800" y="2750000"/>
+            <a:ext cx="1000000" cy="220000"/>
+          </a:xfrm>
+          <a:prstGeom prst="rect">
+            <a:avLst/>
+          </a:prstGeom>
+          <a:noFill/>
+          <a:ln/>
+        </p:spPr>
+        <p:txBody>
+          <a:bodyPr wrap="square" lIns="0" tIns="0" rIns="0" bIns="0" rtlCol="0" anchor="t">
+            <a:normAutofit/>
+          </a:bodyPr>
+          <a:lstStyle/>
+          <a:p>
+            <a:pPr algn="l" indent="0" marL="0">
+              <a:lnSpc>
+                <a:spcPts val="1500"/>
+              </a:lnSpc>
+              <a:buNone/>
+            </a:pPr>
+            <a:r>
+              <a:rPr lang="en-US" sz="1100" spc="100" dirty="0">
+                <a:solidFill>
+                  <a:srgbClr val="5F6979"/>
+                </a:solidFill>
+                <a:latin typeface="JetBrains Mono" pitchFamily="49" charset="0"/>
+                <a:ea typeface="JetBrains Mono" pitchFamily="49" charset="-122"/>
+                <a:cs typeface="JetBrains Mono" pitchFamily="49" charset="-120"/>
+              </a:rPr>
+              <a:t>LEVEL 2</a:t>
+            </a:r>
+            <a:endParaRPr lang="en-US" sz="1100" dirty="0"/>
+          </a:p>
+        </p:txBody>
+      </p:sp>
+      <p:sp>
+        <p:nvSpPr>
+          <p:cNvPr id="27" name="Text 27"/>
+          <p:cNvSpPr/>
+          <p:nvPr/>
+        </p:nvSpPr>
+        <p:spPr>
+          <a:xfrm>
+            <a:off x="1012800" y="3980000"/>
+            <a:ext cx="1000000" cy="220000"/>
+          </a:xfrm>
+          <a:prstGeom prst="rect">
+            <a:avLst/>
+          </a:prstGeom>
+          <a:noFill/>
+          <a:ln/>
+        </p:spPr>
+        <p:txBody>
+          <a:bodyPr wrap="square" lIns="0" tIns="0" rIns="0" bIns="0" rtlCol="0" anchor="t">
+            <a:normAutofit/>
+          </a:bodyPr>
+          <a:lstStyle/>
+          <a:p>
+            <a:pPr algn="l" indent="0" marL="0">
+              <a:lnSpc>
+                <a:spcPts val="1500"/>
+              </a:lnSpc>
+              <a:buNone/>
+            </a:pPr>
+            <a:r>
+              <a:rPr lang="en-US" sz="1100" spc="100" dirty="0">
+                <a:solidFill>
+                  <a:srgbClr val="5F6979"/>
+                </a:solidFill>
+                <a:latin typeface="JetBrains Mono" pitchFamily="49" charset="0"/>
+                <a:ea typeface="JetBrains Mono" pitchFamily="49" charset="-122"/>
+                <a:cs typeface="JetBrains Mono" pitchFamily="49" charset="-120"/>
+              </a:rPr>
+              <a:t>LEVEL 1</a:t>
+            </a:r>
+            <a:endParaRPr lang="en-US" sz="1100" dirty="0"/>
+          </a:p>
+        </p:txBody>
+      </p:sp>
+      <p:sp>
+        <p:nvSpPr>
+          <p:cNvPr id="28" name="Text 28"/>
+          <p:cNvSpPr/>
+          <p:nvPr/>
+        </p:nvSpPr>
+        <p:spPr>
+          <a:xfrm>
+            <a:off x="1012800" y="5200000"/>
+            <a:ext cx="1000000" cy="220000"/>
+          </a:xfrm>
+          <a:prstGeom prst="rect">
+            <a:avLst/>
+          </a:prstGeom>
+          <a:noFill/>
+          <a:ln/>
+        </p:spPr>
+        <p:txBody>
+          <a:bodyPr wrap="square" lIns="0" tIns="0" rIns="0" bIns="0" rtlCol="0" anchor="t">
+            <a:normAutofit/>
+          </a:bodyPr>
+          <a:lstStyle/>
+          <a:p>
+            <a:pPr algn="l" indent="0" marL="0">
+              <a:lnSpc>
+                <a:spcPts val="1500"/>
+              </a:lnSpc>
+              <a:buNone/>
+            </a:pPr>
+            <a:r>
+              <a:rPr lang="en-US" sz="1100" spc="100" dirty="0">
+                <a:solidFill>
+                  <a:srgbClr val="5F6979"/>
+                </a:solidFill>
+                <a:latin typeface="JetBrains Mono" pitchFamily="49" charset="0"/>
+                <a:ea typeface="JetBrains Mono" pitchFamily="49" charset="-122"/>
+                <a:cs typeface="JetBrains Mono" pitchFamily="49" charset="-120"/>
+              </a:rPr>
+              <a:t>INPUT</a:t>
+            </a:r>
+            <a:endParaRPr lang="en-US" sz="1100" dirty="0"/>
+          </a:p>
+        </p:txBody>
+      </p:sp>
+      <p:sp>
+        <p:nvSpPr>
+          <p:cNvPr id="29" name="Text 29"/>
+          <p:cNvSpPr/>
+          <p:nvPr/>
+        </p:nvSpPr>
+        <p:spPr>
+          <a:xfrm>
+            <a:off x="1012800" y="5700000"/>
+            <a:ext cx="5200000" cy="220000"/>
+          </a:xfrm>
+          <a:prstGeom prst="rect">
+            <a:avLst/>
+          </a:prstGeom>
+          <a:noFill/>
+          <a:ln/>
+        </p:spPr>
+        <p:txBody>
+          <a:bodyPr wrap="square" lIns="0" tIns="0" rIns="0" bIns="0" rtlCol="0" anchor="t">
+            <a:normAutofit/>
+          </a:bodyPr>
+          <a:lstStyle/>
+          <a:p>
+            <a:pPr algn="l" indent="0" marL="0">
+              <a:lnSpc>
+                <a:spcPts val="1500"/>
+              </a:lnSpc>
+              <a:buNone/>
+            </a:pPr>
+            <a:r>
+              <a:rPr lang="en-US" sz="1150" dirty="0">
+                <a:solidFill>
+                  <a:srgbClr val="5F6979"/>
+                </a:solidFill>
+                <a:latin typeface="IBM Plex Sans" pitchFamily="34" charset="0"/>
+                <a:ea typeface="IBM Plex Sans" pitchFamily="34" charset="-122"/>
+                <a:cs typeface="IBM Plex Sans" pitchFamily="34" charset="-120"/>
+              </a:rPr>
+              <a:t>v = [3, −4, 2, 0.5], already rotated. Pair, then pair the radii.</a:t>
+            </a:r>
+            <a:endParaRPr lang="en-US" sz="1150" dirty="0"/>
+          </a:p>
+        </p:txBody>
+      </p:sp>
+      <p:sp>
+        <p:nvSpPr>
+          <p:cNvPr id="30" name="Shape 30"/>
+          <p:cNvSpPr/>
+          <p:nvPr/>
+        </p:nvSpPr>
+        <p:spPr>
+          <a:xfrm>
+            <a:off x="6592800" y="2150000"/>
+            <a:ext cx="5103392" cy="1850000"/>
+          </a:xfrm>
+          <a:prstGeom prst="roundRect">
+            <a:avLst>
+              <a:gd name="adj" fmla="val 6060"/>
+            </a:avLst>
+          </a:prstGeom>
+          <a:solidFill>
+            <a:srgbClr val="FDFCF9"/>
+          </a:solidFill>
+          <a:ln w="6350">
+            <a:solidFill>
+              <a:srgbClr val="E2DFD6"/>
+            </a:solidFill>
+            <a:prstDash val="solid"/>
+          </a:ln>
+        </p:spPr>
+      </p:sp>
+      <p:sp>
+        <p:nvSpPr>
+          <p:cNvPr id="31" name="Text 31"/>
+          <p:cNvSpPr/>
+          <p:nvPr/>
+        </p:nvSpPr>
+        <p:spPr>
+          <a:xfrm>
+            <a:off x="6782800" y="2340000"/>
+            <a:ext cx="4723392" cy="1470000"/>
+          </a:xfrm>
+          <a:prstGeom prst="rect">
+            <a:avLst/>
+          </a:prstGeom>
+          <a:noFill/>
+          <a:ln/>
+        </p:spPr>
+        <p:txBody>
+          <a:bodyPr wrap="square" lIns="0" tIns="0" rIns="0" bIns="0" rtlCol="0" anchor="t">
+            <a:normAutofit/>
+          </a:bodyPr>
+          <a:lstStyle/>
+          <a:p>
+            <a:pPr algn="l" indent="0" marL="0">
+              <a:lnSpc>
+                <a:spcPts val="1875"/>
+              </a:lnSpc>
+              <a:spcAft>
+                <a:spcPts val="600"/>
+              </a:spcAft>
+              <a:buNone/>
+            </a:pPr>
+            <a:r>
+              <a:rPr lang="en-US" sz="1500" b="1" dirty="0">
+                <a:solidFill>
+                  <a:srgbClr val="0F1B2D"/>
+                </a:solidFill>
+                <a:latin typeface="IBM Plex Sans" pitchFamily="34" charset="0"/>
+                <a:ea typeface="IBM Plex Sans" pitchFamily="34" charset="-122"/>
+                <a:cs typeface="IBM Plex Sans" pitchFamily="34" charset="-120"/>
+              </a:rPr>
+              <a:t>Quantize the angles</a:t>
+            </a:r>
+            <a:endParaRPr lang="en-US" sz="1500" dirty="0"/>
+          </a:p>
+          <a:p>
+            <a:pPr algn="l" indent="0" marL="0">
+              <a:lnSpc>
+                <a:spcPts val="1750"/>
+              </a:lnSpc>
+              <a:spcAft>
+                <a:spcPts val="400"/>
+              </a:spcAft>
+              <a:buNone/>
+            </a:pPr>
+            <a:r>
+              <a:rPr lang="en-US" sz="1250" b="1" dirty="0">
+                <a:solidFill>
+                  <a:srgbClr val="0F1B2D"/>
+                </a:solidFill>
+                <a:latin typeface="IBM Plex Sans" pitchFamily="34" charset="0"/>
+                <a:ea typeface="IBM Plex Sans" pitchFamily="34" charset="-122"/>
+                <a:cs typeface="IBM Plex Sans" pitchFamily="34" charset="-120"/>
+              </a:rPr>
+              <a:t>4 bits</a:t>
+            </a:r>
+            <a:r>
+              <a:rPr lang="en-US" sz="1250" dirty="0">
+                <a:solidFill>
+                  <a:srgbClr val="3A4556"/>
+                </a:solidFill>
+                <a:latin typeface="IBM Plex Sans" pitchFamily="34" charset="0"/>
+                <a:ea typeface="IBM Plex Sans" pitchFamily="34" charset="-122"/>
+                <a:cs typeface="IBM Plex Sans" pitchFamily="34" charset="-120"/>
+              </a:rPr>
+              <a:t>, 16 buckets of 22.5°: θ₁ → bucket 13 (303.75°), θ₂ → bucket 0 (11.25°).</a:t>
+            </a:r>
+            <a:endParaRPr lang="en-US" sz="1250" dirty="0"/>
+          </a:p>
+          <a:p>
+            <a:pPr algn="l" indent="0" marL="0">
+              <a:lnSpc>
+                <a:spcPts val="1750"/>
+              </a:lnSpc>
+              <a:spcAft>
+                <a:spcPts val="400"/>
+              </a:spcAft>
+              <a:buNone/>
+            </a:pPr>
+            <a:r>
+              <a:rPr lang="en-US" sz="1250" b="1" dirty="0">
+                <a:solidFill>
+                  <a:srgbClr val="0F1B2D"/>
+                </a:solidFill>
+                <a:latin typeface="IBM Plex Sans" pitchFamily="34" charset="0"/>
+                <a:ea typeface="IBM Plex Sans" pitchFamily="34" charset="-122"/>
+                <a:cs typeface="IBM Plex Sans" pitchFamily="34" charset="-120"/>
+              </a:rPr>
+              <a:t>2 bits</a:t>
+            </a:r>
+            <a:r>
+              <a:rPr lang="en-US" sz="1250" dirty="0">
+                <a:solidFill>
+                  <a:srgbClr val="3A4556"/>
+                </a:solidFill>
+                <a:latin typeface="IBM Plex Sans" pitchFamily="34" charset="0"/>
+                <a:ea typeface="IBM Plex Sans" pitchFamily="34" charset="-122"/>
+                <a:cs typeface="IBM Plex Sans" pitchFamily="34" charset="-120"/>
+              </a:rPr>
+              <a:t>, k-means centroids 17.7°, 36.3°, 53.7°, 72.3°: ψ → 17.7° (index 0).</a:t>
+            </a:r>
+            <a:endParaRPr lang="en-US" sz="1250" dirty="0"/>
+          </a:p>
+          <a:p>
+            <a:pPr algn="l" indent="0" marL="0">
+              <a:lnSpc>
+                <a:spcPts val="1750"/>
+              </a:lnSpc>
+              <a:spcAft>
+                <a:spcPts val="400"/>
+              </a:spcAft>
+              <a:buNone/>
+            </a:pPr>
+            <a:r>
+              <a:rPr lang="en-US" sz="1250" b="1" dirty="0">
+                <a:solidFill>
+                  <a:srgbClr val="0F1B2D"/>
+                </a:solidFill>
+                <a:latin typeface="IBM Plex Sans" pitchFamily="34" charset="0"/>
+                <a:ea typeface="IBM Plex Sans" pitchFamily="34" charset="-122"/>
+                <a:cs typeface="IBM Plex Sans" pitchFamily="34" charset="-120"/>
+              </a:rPr>
+              <a:t>Stored: 4 + 4 + 2 = 10 bits + one float (5.41).</a:t>
+            </a:r>
+            <a:endParaRPr lang="en-US" sz="1250" dirty="0"/>
+          </a:p>
+        </p:txBody>
+      </p:sp>
+      <p:sp>
+        <p:nvSpPr>
+          <p:cNvPr id="32" name="Shape 32"/>
+          <p:cNvSpPr/>
+          <p:nvPr/>
+        </p:nvSpPr>
+        <p:spPr>
+          <a:xfrm>
+            <a:off x="6592800" y="4180000"/>
+            <a:ext cx="5103392" cy="1850000"/>
+          </a:xfrm>
+          <a:prstGeom prst="roundRect">
+            <a:avLst>
+              <a:gd name="adj" fmla="val 6060"/>
+            </a:avLst>
+          </a:prstGeom>
+          <a:solidFill>
+            <a:srgbClr val="0F1B2D"/>
+          </a:solidFill>
+          <a:ln/>
+        </p:spPr>
+      </p:sp>
+      <p:sp>
+        <p:nvSpPr>
+          <p:cNvPr id="33" name="Text 33"/>
+          <p:cNvSpPr/>
+          <p:nvPr/>
+        </p:nvSpPr>
+        <p:spPr>
+          <a:xfrm>
+            <a:off x="6782800" y="4370000"/>
+            <a:ext cx="4723392" cy="1470000"/>
+          </a:xfrm>
+          <a:prstGeom prst="rect">
+            <a:avLst/>
+          </a:prstGeom>
+          <a:noFill/>
+          <a:ln/>
+        </p:spPr>
+        <p:txBody>
+          <a:bodyPr wrap="square" lIns="0" tIns="0" rIns="0" bIns="0" rtlCol="0" anchor="t">
+            <a:normAutofit/>
+          </a:bodyPr>
+          <a:lstStyle/>
+          <a:p>
+            <a:pPr algn="l" indent="0" marL="0">
+              <a:lnSpc>
+                <a:spcPts val="1875"/>
+              </a:lnSpc>
+              <a:spcAft>
+                <a:spcPts val="600"/>
+              </a:spcAft>
+              <a:buNone/>
+            </a:pPr>
+            <a:r>
+              <a:rPr lang="en-US" sz="1500" b="1" dirty="0">
+                <a:solidFill>
+                  <a:srgbClr val="F2A35E"/>
+                </a:solidFill>
+                <a:latin typeface="IBM Plex Sans" pitchFamily="34" charset="0"/>
+                <a:ea typeface="IBM Plex Sans" pitchFamily="34" charset="-122"/>
+                <a:cs typeface="IBM Plex Sans" pitchFamily="34" charset="-120"/>
+              </a:rPr>
+              <a:t>Decode, top-down</a:t>
+            </a:r>
+            <a:endParaRPr lang="en-US" sz="1500" dirty="0"/>
+          </a:p>
+          <a:p>
+            <a:pPr algn="l" indent="0" marL="0">
+              <a:lnSpc>
+                <a:spcPts val="1750"/>
+              </a:lnSpc>
+              <a:spcAft>
+                <a:spcPts val="400"/>
+              </a:spcAft>
+              <a:buNone/>
+            </a:pPr>
+            <a:r>
+              <a:rPr lang="en-US" sz="1250" dirty="0">
+                <a:solidFill>
+                  <a:srgbClr val="D9DEE6"/>
+                </a:solidFill>
+                <a:latin typeface="IBM Plex Sans" pitchFamily="34" charset="0"/>
+                <a:ea typeface="IBM Plex Sans" pitchFamily="34" charset="-122"/>
+                <a:cs typeface="IBM Plex Sans" pitchFamily="34" charset="-120"/>
+              </a:rPr>
+              <a:t>R_A ≈ 5.41·cos 17.7° = 5.15,  R_B ≈ 5.41·sin 17.7° = 1.65</a:t>
+            </a:r>
+            <a:endParaRPr lang="en-US" sz="1250" dirty="0"/>
+          </a:p>
+          <a:p>
+            <a:pPr algn="l" indent="0" marL="0">
+              <a:lnSpc>
+                <a:spcPts val="1750"/>
+              </a:lnSpc>
+              <a:spcAft>
+                <a:spcPts val="400"/>
+              </a:spcAft>
+              <a:buNone/>
+            </a:pPr>
+            <a:r>
+              <a:rPr lang="en-US" sz="1250" dirty="0">
+                <a:solidFill>
+                  <a:srgbClr val="D9DEE6"/>
+                </a:solidFill>
+                <a:latin typeface="IBM Plex Sans" pitchFamily="34" charset="0"/>
+                <a:ea typeface="IBM Plex Sans" pitchFamily="34" charset="-122"/>
+                <a:cs typeface="IBM Plex Sans" pitchFamily="34" charset="-120"/>
+              </a:rPr>
+              <a:t>v̂ = [2.86, −4.28, 1.62, 0.32]</a:t>
+            </a:r>
+            <a:endParaRPr lang="en-US" sz="1250" dirty="0"/>
+          </a:p>
+          <a:p>
+            <a:pPr algn="l" indent="0" marL="0">
+              <a:lnSpc>
+                <a:spcPts val="1750"/>
+              </a:lnSpc>
+              <a:spcAft>
+                <a:spcPts val="400"/>
+              </a:spcAft>
+              <a:buNone/>
+            </a:pPr>
+            <a:r>
+              <a:rPr lang="en-US" sz="1250" dirty="0">
+                <a:solidFill>
+                  <a:srgbClr val="D9DEE6"/>
+                </a:solidFill>
+                <a:latin typeface="IBM Plex Sans" pitchFamily="34" charset="0"/>
+                <a:ea typeface="IBM Plex Sans" pitchFamily="34" charset="-122"/>
+                <a:cs typeface="IBM Plex Sans" pitchFamily="34" charset="-120"/>
+              </a:rPr>
+              <a:t>9.7% error. Score with q = [1, −1, 1, 0]: </a:t>
+            </a:r>
+            <a:r>
+              <a:rPr lang="en-US" sz="1250" b="1" dirty="0">
+                <a:solidFill>
+                  <a:srgbClr val="F6F5F0"/>
+                </a:solidFill>
+                <a:latin typeface="IBM Plex Sans" pitchFamily="34" charset="0"/>
+                <a:ea typeface="IBM Plex Sans" pitchFamily="34" charset="-122"/>
+                <a:cs typeface="IBM Plex Sans" pitchFamily="34" charset="-120"/>
+              </a:rPr>
+              <a:t>8.76</a:t>
+            </a:r>
+            <a:r>
+              <a:rPr lang="en-US" sz="1250" dirty="0">
+                <a:solidFill>
+                  <a:srgbClr val="D9DEE6"/>
+                </a:solidFill>
+                <a:latin typeface="IBM Plex Sans" pitchFamily="34" charset="0"/>
+                <a:ea typeface="IBM Plex Sans" pitchFamily="34" charset="-122"/>
+                <a:cs typeface="IBM Plex Sans" pitchFamily="34" charset="-120"/>
+              </a:rPr>
+              <a:t> vs 9.</a:t>
+            </a:r>
+            <a:endParaRPr lang="en-US" sz="1250" dirty="0"/>
+          </a:p>
+        </p:txBody>
+      </p:sp>
+      <p:sp>
+        <p:nvSpPr>
+          <p:cNvPr id="34" name="Text 34"/>
+          <p:cNvSpPr/>
+          <p:nvPr/>
+        </p:nvSpPr>
+        <p:spPr>
+          <a:xfrm>
+            <a:off x="812800" y="6238280"/>
+            <a:ext cx="10883392" cy="238720"/>
+          </a:xfrm>
+          <a:prstGeom prst="rect">
+            <a:avLst/>
+          </a:prstGeom>
+          <a:noFill/>
+          <a:ln/>
+        </p:spPr>
+        <p:txBody>
+          <a:bodyPr wrap="square" lIns="0" tIns="0" rIns="0" bIns="0" rtlCol="0" anchor="t">
+            <a:normAutofit/>
+          </a:bodyPr>
+          <a:lstStyle/>
+          <a:p>
+            <a:pPr algn="l" indent="0" marL="0">
+              <a:lnSpc>
+                <a:spcPts val="1680"/>
+              </a:lnSpc>
+              <a:buNone/>
+            </a:pPr>
+            <a:r>
+              <a:rPr lang="en-US" sz="1200" dirty="0">
+                <a:solidFill>
+                  <a:srgbClr val="5F6979"/>
+                </a:solidFill>
+                <a:latin typeface="IBM Plex Sans" pitchFamily="34" charset="0"/>
+                <a:ea typeface="IBM Plex Sans" pitchFamily="34" charset="-122"/>
+                <a:cs typeface="IBM Plex Sans" pitchFamily="34" charset="-120"/>
+              </a:rPr>
+              <a:t>Section 2.2 of the guide. In practice: 4 levels, blocks of 16 coordinates, 3.875 bits per coordinate.</a:t>
+            </a:r>
+            <a:endParaRPr lang="en-US" sz="1200" dirty="0"/>
+          </a:p>
+        </p:txBody>
+      </p:sp>
+    </p:spTree>
+  </p:cSld>
+  <p:clrMapOvr>
+    <a:masterClrMapping/>
+  </p:clrMapOvr>
+</p:sld>
+</file>
+
+<file path=ppt/slides/slide27.xml><?xml version="1.0" encoding="utf-8"?>
+<p:sld xmlns:a="http://schemas.openxmlformats.org/drawingml/2006/main" xmlns:p="http://schemas.openxmlformats.org/presentationml/2006/main" xmlns:r="http://schemas.openxmlformats.org/officeDocument/2006/relationships">
+  <p:cSld>
+    <p:bg>
+      <p:bgPr>
+        <a:solidFill>
+          <a:srgbClr val="F6F5F0"/>
+        </a:solidFill>
+      </p:bgPr>
+    </p:bg>
+    <p:spTree>
+      <p:nvGrpSpPr>
+        <p:cNvPr id="1" name=""/>
+        <p:cNvGrpSpPr/>
+        <p:nvPr/>
+      </p:nvGrpSpPr>
+      <p:grpSpPr/>
+      <p:sp>
+        <p:nvSpPr>
+          <p:cNvPr id="3" name="Text 3"/>
+          <p:cNvSpPr/>
+          <p:nvPr/>
+        </p:nvSpPr>
+        <p:spPr>
+          <a:xfrm>
+            <a:off x="812800" y="812800"/>
+            <a:ext cx="10883392" cy="238720"/>
+          </a:xfrm>
+          <a:prstGeom prst="rect">
+            <a:avLst/>
+          </a:prstGeom>
+          <a:noFill/>
+          <a:ln/>
+        </p:spPr>
+        <p:txBody>
+          <a:bodyPr wrap="square" lIns="0" tIns="0" rIns="0" bIns="0" rtlCol="0" anchor="t">
+            <a:normAutofit/>
+          </a:bodyPr>
+          <a:lstStyle/>
+          <a:p>
+            <a:pPr algn="l" indent="0" marL="0">
+              <a:lnSpc>
+                <a:spcPts val="1680"/>
+              </a:lnSpc>
+              <a:buNone/>
+            </a:pPr>
+            <a:r>
+              <a:rPr lang="en-US" sz="1200" spc="100" dirty="0">
+                <a:solidFill>
+                  <a:srgbClr val="B4521A"/>
+                </a:solidFill>
+                <a:latin typeface="JetBrains Mono" pitchFamily="49" charset="0"/>
+                <a:ea typeface="JetBrains Mono" pitchFamily="49" charset="-122"/>
+                <a:cs typeface="JetBrains Mono" pitchFamily="49" charset="-120"/>
+              </a:rPr>
+              <a:t>TURBOQUANT · WORKED EXAMPLE</a:t>
+            </a:r>
+            <a:endParaRPr lang="en-US" sz="1200" dirty="0"/>
+          </a:p>
+        </p:txBody>
+      </p:sp>
+      <p:sp>
+        <p:nvSpPr>
+          <p:cNvPr id="4" name="Text 4"/>
+          <p:cNvSpPr/>
+          <p:nvPr>
+            <p:ph type="title"/>
+          </p:nvPr>
+        </p:nvSpPr>
+        <p:spPr>
+          <a:xfrm>
+            <a:off x="812800" y="1381720"/>
+            <a:ext cx="11379200" cy="472380"/>
+          </a:xfrm>
+          <a:prstGeom prst="rect">
+            <a:avLst/>
+          </a:prstGeom>
+          <a:noFill/>
+          <a:ln/>
+        </p:spPr>
+        <p:txBody>
+          <a:bodyPr wrap="square" lIns="0" tIns="0" rIns="0" bIns="0" rtlCol="0" anchor="t">
+            <a:normAutofit/>
+          </a:bodyPr>
+          <a:lstStyle/>
+          <a:p>
+            <a:pPr algn="l" indent="0" marL="0">
+              <a:lnSpc>
+                <a:spcPts val="3520"/>
+              </a:lnSpc>
+              <a:buNone/>
+            </a:pPr>
+            <a:r>
+              <a:rPr lang="en-US" sz="3200" b="1" dirty="0">
+                <a:solidFill>
+                  <a:srgbClr val="0F1B2D"/>
+                </a:solidFill>
+                <a:latin typeface="IBM Plex Sans" pitchFamily="34" charset="0"/>
+                <a:ea typeface="IBM Plex Sans" pitchFamily="34" charset="-122"/>
+                <a:cs typeface="IBM Plex Sans" pitchFamily="34" charset="-120"/>
+              </a:rPr>
+              <a:t>TurboQuant end to end on the same four numbers</a:t>
+            </a:r>
+            <a:endParaRPr lang="en-US" sz="3200" dirty="0"/>
+          </a:p>
+        </p:txBody>
+      </p:sp>
+      <p:sp>
+        <p:nvSpPr>
+          <p:cNvPr id="5" name="Text 5"/>
+          <p:cNvSpPr/>
+          <p:nvPr/>
+        </p:nvSpPr>
+        <p:spPr>
+          <a:xfrm>
+            <a:off x="812800" y="2050000"/>
+            <a:ext cx="10883392" cy="220000"/>
+          </a:xfrm>
+          <a:prstGeom prst="rect">
+            <a:avLst/>
+          </a:prstGeom>
+          <a:noFill/>
+          <a:ln/>
+        </p:spPr>
+        <p:txBody>
+          <a:bodyPr wrap="square" lIns="0" tIns="0" rIns="0" bIns="0" rtlCol="0" anchor="t">
+            <a:normAutofit/>
+          </a:bodyPr>
+          <a:lstStyle/>
+          <a:p>
+            <a:pPr algn="l" indent="0" marL="0">
+              <a:lnSpc>
+                <a:spcPts val="1500"/>
+              </a:lnSpc>
+              <a:buNone/>
+            </a:pPr>
+            <a:r>
+              <a:rPr lang="en-US" sz="1100" spc="100" dirty="0">
+                <a:solidFill>
+                  <a:srgbClr val="5F6979"/>
+                </a:solidFill>
+                <a:latin typeface="JetBrains Mono" pitchFamily="49" charset="0"/>
+                <a:ea typeface="JetBrains Mono" pitchFamily="49" charset="-122"/>
+                <a:cs typeface="JetBrains Mono" pitchFamily="49" charset="-120"/>
+              </a:rPr>
+              <a:t>STAGE 1 · TURBOQUANT_MSE, 2 BITS PER COORDINATE</a:t>
+            </a:r>
+            <a:endParaRPr lang="en-US" sz="1100" dirty="0"/>
+          </a:p>
+        </p:txBody>
+      </p:sp>
+      <p:sp>
+        <p:nvSpPr>
+          <p:cNvPr id="6" name="Text 6"/>
+          <p:cNvSpPr/>
+          <p:nvPr/>
+        </p:nvSpPr>
+        <p:spPr>
+          <a:xfrm>
+            <a:off x="812800" y="4080000"/>
+            <a:ext cx="10883392" cy="220000"/>
+          </a:xfrm>
+          <a:prstGeom prst="rect">
+            <a:avLst/>
+          </a:prstGeom>
+          <a:noFill/>
+          <a:ln/>
+        </p:spPr>
+        <p:txBody>
+          <a:bodyPr wrap="square" lIns="0" tIns="0" rIns="0" bIns="0" rtlCol="0" anchor="t">
+            <a:normAutofit/>
+          </a:bodyPr>
+          <a:lstStyle/>
+          <a:p>
+            <a:pPr algn="l" indent="0" marL="0">
+              <a:lnSpc>
+                <a:spcPts val="1500"/>
+              </a:lnSpc>
+              <a:buNone/>
+            </a:pPr>
+            <a:r>
+              <a:rPr lang="en-US" sz="1100" spc="100" dirty="0">
+                <a:solidFill>
+                  <a:srgbClr val="5F6979"/>
+                </a:solidFill>
+                <a:latin typeface="JetBrains Mono" pitchFamily="49" charset="0"/>
+                <a:ea typeface="JetBrains Mono" pitchFamily="49" charset="-122"/>
+                <a:cs typeface="JetBrains Mono" pitchFamily="49" charset="-120"/>
+              </a:rPr>
+              <a:t>STAGE 2 · 1-BIT QJL ON THE RESIDUAL</a:t>
+            </a:r>
+            <a:endParaRPr lang="en-US" sz="1100" dirty="0"/>
+          </a:p>
+        </p:txBody>
+      </p:sp>
+      <p:sp>
+        <p:nvSpPr>
+          <p:cNvPr id="7" name="Shape 7"/>
+          <p:cNvSpPr/>
+          <p:nvPr/>
+        </p:nvSpPr>
+        <p:spPr>
+          <a:xfrm>
+            <a:off x="812800" y="2300000"/>
+            <a:ext cx="2585848" cy="1720000"/>
+          </a:xfrm>
+          <a:prstGeom prst="roundRect">
+            <a:avLst>
+              <a:gd name="adj" fmla="val 6060"/>
+            </a:avLst>
+          </a:prstGeom>
+          <a:solidFill>
+            <a:srgbClr val="FDFCF9"/>
+          </a:solidFill>
+          <a:ln w="6350">
+            <a:solidFill>
+              <a:srgbClr val="E2DFD6"/>
+            </a:solidFill>
+            <a:prstDash val="solid"/>
+          </a:ln>
+        </p:spPr>
+      </p:sp>
+      <p:sp>
+        <p:nvSpPr>
+          <p:cNvPr id="8" name="Text 8"/>
+          <p:cNvSpPr/>
+          <p:nvPr/>
+        </p:nvSpPr>
+        <p:spPr>
+          <a:xfrm>
+            <a:off x="972800" y="2460000"/>
+            <a:ext cx="2265848" cy="1400000"/>
+          </a:xfrm>
+          <a:prstGeom prst="rect">
+            <a:avLst/>
+          </a:prstGeom>
+          <a:noFill/>
+          <a:ln/>
+        </p:spPr>
+        <p:txBody>
+          <a:bodyPr wrap="square" lIns="0" tIns="0" rIns="0" bIns="0" rtlCol="0" anchor="t">
+            <a:normAutofit/>
+          </a:bodyPr>
+          <a:lstStyle/>
+          <a:p>
+            <a:pPr algn="l" indent="0" marL="0">
+              <a:lnSpc>
+                <a:spcPts val="1750"/>
+              </a:lnSpc>
+              <a:spcAft>
+                <a:spcPts val="600"/>
+              </a:spcAft>
+              <a:buNone/>
+            </a:pPr>
+            <a:r>
+              <a:rPr lang="en-US" sz="1400" b="1" dirty="0">
+                <a:solidFill>
+                  <a:srgbClr val="0F1B2D"/>
+                </a:solidFill>
+                <a:latin typeface="IBM Plex Sans" pitchFamily="34" charset="0"/>
+                <a:ea typeface="IBM Plex Sans" pitchFamily="34" charset="-122"/>
+                <a:cs typeface="IBM Plex Sans" pitchFamily="34" charset="-120"/>
+              </a:rPr>
+              <a:t>1 · Norm</a:t>
+            </a:r>
+            <a:endParaRPr lang="en-US" sz="1400" dirty="0"/>
+          </a:p>
+          <a:p>
+            <a:pPr algn="l" indent="0" marL="0">
+              <a:lnSpc>
+                <a:spcPts val="1540"/>
+              </a:lnSpc>
+              <a:spcAft>
+                <a:spcPts val="400"/>
+              </a:spcAft>
+              <a:buNone/>
+            </a:pPr>
+            <a:r>
+              <a:rPr lang="en-US" sz="1100" dirty="0">
+                <a:solidFill>
+                  <a:srgbClr val="3A4556"/>
+                </a:solidFill>
+                <a:latin typeface="IBM Plex Sans" pitchFamily="34" charset="0"/>
+                <a:ea typeface="IBM Plex Sans" pitchFamily="34" charset="-122"/>
+                <a:cs typeface="IBM Plex Sans" pitchFamily="34" charset="-120"/>
+              </a:rPr>
+              <a:t>v = [3, −4, 2, 0.5]</a:t>
+            </a:r>
+            <a:endParaRPr lang="en-US" sz="1100" dirty="0"/>
+          </a:p>
+          <a:p>
+            <a:pPr algn="l" indent="0" marL="0">
+              <a:lnSpc>
+                <a:spcPts val="1540"/>
+              </a:lnSpc>
+              <a:spcAft>
+                <a:spcPts val="400"/>
+              </a:spcAft>
+              <a:buNone/>
+            </a:pPr>
+            <a:r>
+              <a:rPr lang="en-US" sz="1100" dirty="0">
+                <a:solidFill>
+                  <a:srgbClr val="3A4556"/>
+                </a:solidFill>
+                <a:latin typeface="IBM Plex Sans" pitchFamily="34" charset="0"/>
+                <a:ea typeface="IBM Plex Sans" pitchFamily="34" charset="-122"/>
+                <a:cs typeface="IBM Plex Sans" pitchFamily="34" charset="-120"/>
+              </a:rPr>
+              <a:t>‖v‖ = </a:t>
+            </a:r>
+            <a:r>
+              <a:rPr lang="en-US" sz="1100" b="1" dirty="0">
+                <a:solidFill>
+                  <a:srgbClr val="0F1B2D"/>
+                </a:solidFill>
+                <a:latin typeface="IBM Plex Sans" pitchFamily="34" charset="0"/>
+                <a:ea typeface="IBM Plex Sans" pitchFamily="34" charset="-122"/>
+                <a:cs typeface="IBM Plex Sans" pitchFamily="34" charset="-120"/>
+              </a:rPr>
+              <a:t>5.41</a:t>
+            </a:r>
+            <a:r>
+              <a:rPr lang="en-US" sz="1100" dirty="0">
+                <a:solidFill>
+                  <a:srgbClr val="3A4556"/>
+                </a:solidFill>
+                <a:latin typeface="IBM Plex Sans" pitchFamily="34" charset="0"/>
+                <a:ea typeface="IBM Plex Sans" pitchFamily="34" charset="-122"/>
+                <a:cs typeface="IBM Plex Sans" pitchFamily="34" charset="-120"/>
+              </a:rPr>
+              <a:t>, stored in fp16</a:t>
+            </a:r>
+            <a:endParaRPr lang="en-US" sz="1100" dirty="0"/>
+          </a:p>
+          <a:p>
+            <a:pPr algn="l" indent="0" marL="0">
+              <a:lnSpc>
+                <a:spcPts val="1540"/>
+              </a:lnSpc>
+              <a:spcAft>
+                <a:spcPts val="400"/>
+              </a:spcAft>
+              <a:buNone/>
+            </a:pPr>
+            <a:r>
+              <a:rPr lang="en-US" sz="1100" dirty="0">
+                <a:solidFill>
+                  <a:srgbClr val="3A4556"/>
+                </a:solidFill>
+                <a:latin typeface="IBM Plex Sans" pitchFamily="34" charset="0"/>
+                <a:ea typeface="IBM Plex Sans" pitchFamily="34" charset="-122"/>
+                <a:cs typeface="IBM Plex Sans" pitchFamily="34" charset="-120"/>
+              </a:rPr>
+              <a:t>Continue with u = v / ‖v‖</a:t>
+            </a:r>
+            <a:endParaRPr lang="en-US" sz="1100" dirty="0"/>
+          </a:p>
+        </p:txBody>
+      </p:sp>
+      <p:sp>
+        <p:nvSpPr>
+          <p:cNvPr id="9" name="Shape 9"/>
+          <p:cNvSpPr/>
+          <p:nvPr/>
+        </p:nvSpPr>
+        <p:spPr>
+          <a:xfrm>
+            <a:off x="3578648" y="2300000"/>
+            <a:ext cx="2585848" cy="1720000"/>
+          </a:xfrm>
+          <a:prstGeom prst="roundRect">
+            <a:avLst>
+              <a:gd name="adj" fmla="val 6060"/>
+            </a:avLst>
+          </a:prstGeom>
+          <a:solidFill>
+            <a:srgbClr val="FDFCF9"/>
+          </a:solidFill>
+          <a:ln w="6350">
+            <a:solidFill>
+              <a:srgbClr val="E2DFD6"/>
+            </a:solidFill>
+            <a:prstDash val="solid"/>
+          </a:ln>
+        </p:spPr>
+      </p:sp>
+      <p:sp>
+        <p:nvSpPr>
+          <p:cNvPr id="10" name="Text 10"/>
+          <p:cNvSpPr/>
+          <p:nvPr/>
+        </p:nvSpPr>
+        <p:spPr>
+          <a:xfrm>
+            <a:off x="3738648" y="2460000"/>
+            <a:ext cx="2265848" cy="1400000"/>
+          </a:xfrm>
+          <a:prstGeom prst="rect">
+            <a:avLst/>
+          </a:prstGeom>
+          <a:noFill/>
+          <a:ln/>
+        </p:spPr>
+        <p:txBody>
+          <a:bodyPr wrap="square" lIns="0" tIns="0" rIns="0" bIns="0" rtlCol="0" anchor="t">
+            <a:normAutofit/>
+          </a:bodyPr>
+          <a:lstStyle/>
+          <a:p>
+            <a:pPr algn="l" indent="0" marL="0">
+              <a:lnSpc>
+                <a:spcPts val="1750"/>
+              </a:lnSpc>
+              <a:spcAft>
+                <a:spcPts val="600"/>
+              </a:spcAft>
+              <a:buNone/>
+            </a:pPr>
+            <a:r>
+              <a:rPr lang="en-US" sz="1400" b="1" dirty="0">
+                <a:solidFill>
+                  <a:srgbClr val="0F1B2D"/>
+                </a:solidFill>
+                <a:latin typeface="IBM Plex Sans" pitchFamily="34" charset="0"/>
+                <a:ea typeface="IBM Plex Sans" pitchFamily="34" charset="-122"/>
+                <a:cs typeface="IBM Plex Sans" pitchFamily="34" charset="-120"/>
+              </a:rPr>
+              <a:t>2 · Rotate</a:t>
+            </a:r>
+            <a:endParaRPr lang="en-US" sz="1400" dirty="0"/>
+          </a:p>
+          <a:p>
+            <a:pPr algn="l" indent="0" marL="0">
+              <a:lnSpc>
+                <a:spcPts val="1540"/>
+              </a:lnSpc>
+              <a:spcAft>
+                <a:spcPts val="400"/>
+              </a:spcAft>
+              <a:buNone/>
+            </a:pPr>
+            <a:r>
+              <a:rPr lang="en-US" sz="1100" dirty="0">
+                <a:solidFill>
+                  <a:srgbClr val="3A4556"/>
+                </a:solidFill>
+                <a:latin typeface="IBM Plex Sans" pitchFamily="34" charset="0"/>
+                <a:ea typeface="IBM Plex Sans" pitchFamily="34" charset="-122"/>
+                <a:cs typeface="IBM Plex Sans" pitchFamily="34" charset="-120"/>
+              </a:rPr>
+              <a:t>Π = ½·Hadamard, random signs</a:t>
+            </a:r>
+            <a:endParaRPr lang="en-US" sz="1100" dirty="0"/>
+          </a:p>
+          <a:p>
+            <a:pPr algn="l" indent="0" marL="0">
+              <a:lnSpc>
+                <a:spcPts val="1540"/>
+              </a:lnSpc>
+              <a:spcAft>
+                <a:spcPts val="400"/>
+              </a:spcAft>
+              <a:buNone/>
+            </a:pPr>
+            <a:r>
+              <a:rPr lang="en-US" sz="1100" dirty="0">
+                <a:solidFill>
+                  <a:srgbClr val="3A4556"/>
+                </a:solidFill>
+                <a:latin typeface="IBM Plex Sans" pitchFamily="34" charset="0"/>
+                <a:ea typeface="IBM Plex Sans" pitchFamily="34" charset="-122"/>
+                <a:cs typeface="IBM Plex Sans" pitchFamily="34" charset="-120"/>
+              </a:rPr>
+              <a:t>Π·v = [4.25, 0.75, 2.75, −1.75], same length</a:t>
+            </a:r>
+            <a:endParaRPr lang="en-US" sz="1100" dirty="0"/>
+          </a:p>
+          <a:p>
+            <a:pPr algn="l" indent="0" marL="0">
+              <a:lnSpc>
+                <a:spcPts val="1540"/>
+              </a:lnSpc>
+              <a:spcAft>
+                <a:spcPts val="400"/>
+              </a:spcAft>
+              <a:buNone/>
+            </a:pPr>
+            <a:r>
+              <a:rPr lang="en-US" sz="1100" dirty="0">
+                <a:solidFill>
+                  <a:srgbClr val="3A4556"/>
+                </a:solidFill>
+                <a:latin typeface="IBM Plex Sans" pitchFamily="34" charset="0"/>
+                <a:ea typeface="IBM Plex Sans" pitchFamily="34" charset="-122"/>
+                <a:cs typeface="IBM Plex Sans" pitchFamily="34" charset="-120"/>
+              </a:rPr>
+              <a:t>y = Π·v / ‖v‖ = [0.786, 0.139, 0.508, −0.324]</a:t>
+            </a:r>
+            <a:endParaRPr lang="en-US" sz="1100" dirty="0"/>
+          </a:p>
+        </p:txBody>
+      </p:sp>
+      <p:sp>
+        <p:nvSpPr>
+          <p:cNvPr id="11" name="Shape 11"/>
+          <p:cNvSpPr/>
+          <p:nvPr/>
+        </p:nvSpPr>
+        <p:spPr>
+          <a:xfrm>
+            <a:off x="6344496" y="2300000"/>
+            <a:ext cx="2585848" cy="1720000"/>
+          </a:xfrm>
+          <a:prstGeom prst="roundRect">
+            <a:avLst>
+              <a:gd name="adj" fmla="val 6060"/>
+            </a:avLst>
+          </a:prstGeom>
+          <a:solidFill>
+            <a:srgbClr val="FDFCF9"/>
+          </a:solidFill>
+          <a:ln w="6350">
+            <a:solidFill>
+              <a:srgbClr val="E2DFD6"/>
+            </a:solidFill>
+            <a:prstDash val="solid"/>
+          </a:ln>
+        </p:spPr>
+      </p:sp>
+      <p:sp>
+        <p:nvSpPr>
+          <p:cNvPr id="12" name="Text 12"/>
+          <p:cNvSpPr/>
+          <p:nvPr/>
+        </p:nvSpPr>
+        <p:spPr>
+          <a:xfrm>
+            <a:off x="6504496" y="2460000"/>
+            <a:ext cx="2265848" cy="1400000"/>
+          </a:xfrm>
+          <a:prstGeom prst="rect">
+            <a:avLst/>
+          </a:prstGeom>
+          <a:noFill/>
+          <a:ln/>
+        </p:spPr>
+        <p:txBody>
+          <a:bodyPr wrap="square" lIns="0" tIns="0" rIns="0" bIns="0" rtlCol="0" anchor="t">
+            <a:normAutofit/>
+          </a:bodyPr>
+          <a:lstStyle/>
+          <a:p>
+            <a:pPr algn="l" indent="0" marL="0">
+              <a:lnSpc>
+                <a:spcPts val="1750"/>
+              </a:lnSpc>
+              <a:spcAft>
+                <a:spcPts val="600"/>
+              </a:spcAft>
+              <a:buNone/>
+            </a:pPr>
+            <a:r>
+              <a:rPr lang="en-US" sz="1400" b="1" dirty="0">
+                <a:solidFill>
+                  <a:srgbClr val="0F1B2D"/>
+                </a:solidFill>
+                <a:latin typeface="IBM Plex Sans" pitchFamily="34" charset="0"/>
+                <a:ea typeface="IBM Plex Sans" pitchFamily="34" charset="-122"/>
+                <a:cs typeface="IBM Plex Sans" pitchFamily="34" charset="-120"/>
+              </a:rPr>
+              <a:t>3 · Round</a:t>
+            </a:r>
+            <a:endParaRPr lang="en-US" sz="1400" dirty="0"/>
+          </a:p>
+          <a:p>
+            <a:pPr algn="l" indent="0" marL="0">
+              <a:lnSpc>
+                <a:spcPts val="1540"/>
+              </a:lnSpc>
+              <a:spcAft>
+                <a:spcPts val="400"/>
+              </a:spcAft>
+              <a:buNone/>
+            </a:pPr>
+            <a:r>
+              <a:rPr lang="en-US" sz="1100" dirty="0">
+                <a:solidFill>
+                  <a:srgbClr val="3A4556"/>
+                </a:solidFill>
+                <a:latin typeface="IBM Plex Sans" pitchFamily="34" charset="0"/>
+                <a:ea typeface="IBM Plex Sans" pitchFamily="34" charset="-122"/>
+                <a:cs typeface="IBM Plex Sans" pitchFamily="34" charset="-120"/>
+              </a:rPr>
+              <a:t>Lloyd-Max codebook for d = 4: ±0.219, ±0.674</a:t>
+            </a:r>
+            <a:endParaRPr lang="en-US" sz="1100" dirty="0"/>
+          </a:p>
+          <a:p>
+            <a:pPr algn="l" indent="0" marL="0">
+              <a:lnSpc>
+                <a:spcPts val="1540"/>
+              </a:lnSpc>
+              <a:spcAft>
+                <a:spcPts val="400"/>
+              </a:spcAft>
+              <a:buNone/>
+            </a:pPr>
+            <a:r>
+              <a:rPr lang="en-US" sz="1100" dirty="0">
+                <a:solidFill>
+                  <a:srgbClr val="3A4556"/>
+                </a:solidFill>
+                <a:latin typeface="IBM Plex Sans" pitchFamily="34" charset="0"/>
+                <a:ea typeface="IBM Plex Sans" pitchFamily="34" charset="-122"/>
+                <a:cs typeface="IBM Plex Sans" pitchFamily="34" charset="-120"/>
+              </a:rPr>
+              <a:t>ŷ = [0.674, 0.219, 0.674, −0.219]</a:t>
+            </a:r>
+            <a:endParaRPr lang="en-US" sz="1100" dirty="0"/>
+          </a:p>
+          <a:p>
+            <a:pPr algn="l" indent="0" marL="0">
+              <a:lnSpc>
+                <a:spcPts val="1540"/>
+              </a:lnSpc>
+              <a:spcAft>
+                <a:spcPts val="400"/>
+              </a:spcAft>
+              <a:buNone/>
+            </a:pPr>
+            <a:r>
+              <a:rPr lang="en-US" sz="1100" dirty="0">
+                <a:solidFill>
+                  <a:srgbClr val="3A4556"/>
+                </a:solidFill>
+                <a:latin typeface="IBM Plex Sans" pitchFamily="34" charset="0"/>
+                <a:ea typeface="IBM Plex Sans" pitchFamily="34" charset="-122"/>
+                <a:cs typeface="IBM Plex Sans" pitchFamily="34" charset="-120"/>
+              </a:rPr>
+              <a:t>Codes </a:t>
+            </a:r>
+            <a:r>
+              <a:rPr lang="en-US" sz="1100" dirty="0">
+                <a:solidFill>
+                  <a:srgbClr val="0F1B2D"/>
+                </a:solidFill>
+                <a:latin typeface="JetBrains Mono" pitchFamily="49" charset="0"/>
+                <a:ea typeface="JetBrains Mono" pitchFamily="49" charset="-122"/>
+                <a:cs typeface="JetBrains Mono" pitchFamily="49" charset="-120"/>
+              </a:rPr>
+              <a:t>11 10 11 01</a:t>
+            </a:r>
+            <a:r>
+              <a:rPr lang="en-US" sz="1100" dirty="0">
+                <a:solidFill>
+                  <a:srgbClr val="3A4556"/>
+                </a:solidFill>
+                <a:latin typeface="IBM Plex Sans" pitchFamily="34" charset="0"/>
+                <a:ea typeface="IBM Plex Sans" pitchFamily="34" charset="-122"/>
+                <a:cs typeface="IBM Plex Sans" pitchFamily="34" charset="-120"/>
+              </a:rPr>
+              <a:t>, 8 bits</a:t>
+            </a:r>
+            <a:endParaRPr lang="en-US" sz="1100" dirty="0"/>
+          </a:p>
+        </p:txBody>
+      </p:sp>
+      <p:sp>
+        <p:nvSpPr>
+          <p:cNvPr id="13" name="Shape 13"/>
+          <p:cNvSpPr/>
+          <p:nvPr/>
+        </p:nvSpPr>
+        <p:spPr>
+          <a:xfrm>
+            <a:off x="9110344" y="2300000"/>
+            <a:ext cx="2585848" cy="1720000"/>
+          </a:xfrm>
+          <a:prstGeom prst="roundRect">
+            <a:avLst>
+              <a:gd name="adj" fmla="val 6060"/>
+            </a:avLst>
+          </a:prstGeom>
+          <a:solidFill>
+            <a:srgbClr val="FDFCF9"/>
+          </a:solidFill>
+          <a:ln w="6350">
+            <a:solidFill>
+              <a:srgbClr val="E2DFD6"/>
+            </a:solidFill>
+            <a:prstDash val="solid"/>
+          </a:ln>
+        </p:spPr>
+      </p:sp>
+      <p:sp>
+        <p:nvSpPr>
+          <p:cNvPr id="14" name="Text 14"/>
+          <p:cNvSpPr/>
+          <p:nvPr/>
+        </p:nvSpPr>
+        <p:spPr>
+          <a:xfrm>
+            <a:off x="9270344" y="2460000"/>
+            <a:ext cx="2265848" cy="1400000"/>
+          </a:xfrm>
+          <a:prstGeom prst="rect">
+            <a:avLst/>
+          </a:prstGeom>
+          <a:noFill/>
+          <a:ln/>
+        </p:spPr>
+        <p:txBody>
+          <a:bodyPr wrap="square" lIns="0" tIns="0" rIns="0" bIns="0" rtlCol="0" anchor="t">
+            <a:normAutofit/>
+          </a:bodyPr>
+          <a:lstStyle/>
+          <a:p>
+            <a:pPr algn="l" indent="0" marL="0">
+              <a:lnSpc>
+                <a:spcPts val="1750"/>
+              </a:lnSpc>
+              <a:spcAft>
+                <a:spcPts val="600"/>
+              </a:spcAft>
+              <a:buNone/>
+            </a:pPr>
+            <a:r>
+              <a:rPr lang="en-US" sz="1400" b="1" dirty="0">
+                <a:solidFill>
+                  <a:srgbClr val="0F1B2D"/>
+                </a:solidFill>
+                <a:latin typeface="IBM Plex Sans" pitchFamily="34" charset="0"/>
+                <a:ea typeface="IBM Plex Sans" pitchFamily="34" charset="-122"/>
+                <a:cs typeface="IBM Plex Sans" pitchFamily="34" charset="-120"/>
+              </a:rPr>
+              <a:t>4 · Decode</a:t>
+            </a:r>
+            <a:endParaRPr lang="en-US" sz="1400" dirty="0"/>
+          </a:p>
+          <a:p>
+            <a:pPr algn="l" indent="0" marL="0">
+              <a:lnSpc>
+                <a:spcPts val="1540"/>
+              </a:lnSpc>
+              <a:spcAft>
+                <a:spcPts val="400"/>
+              </a:spcAft>
+              <a:buNone/>
+            </a:pPr>
+            <a:r>
+              <a:rPr lang="en-US" sz="1100" dirty="0">
+                <a:solidFill>
+                  <a:srgbClr val="3A4556"/>
+                </a:solidFill>
+                <a:latin typeface="IBM Plex Sans" pitchFamily="34" charset="0"/>
+                <a:ea typeface="IBM Plex Sans" pitchFamily="34" charset="-122"/>
+                <a:cs typeface="IBM Plex Sans" pitchFamily="34" charset="-120"/>
+              </a:rPr>
+              <a:t>x̃ = ‖v‖·Πᵀ·ŷ = [3.65, −3.65, 1.19, 1.19]</a:t>
+            </a:r>
+            <a:endParaRPr lang="en-US" sz="1100" dirty="0"/>
+          </a:p>
+          <a:p>
+            <a:pPr algn="l" indent="0" marL="0">
+              <a:lnSpc>
+                <a:spcPts val="1540"/>
+              </a:lnSpc>
+              <a:spcAft>
+                <a:spcPts val="400"/>
+              </a:spcAft>
+              <a:buNone/>
+            </a:pPr>
+            <a:r>
+              <a:rPr lang="en-US" sz="1100" dirty="0">
+                <a:solidFill>
+                  <a:srgbClr val="3A4556"/>
+                </a:solidFill>
+                <a:latin typeface="IBM Plex Sans" pitchFamily="34" charset="0"/>
+                <a:ea typeface="IBM Plex Sans" pitchFamily="34" charset="-122"/>
+                <a:cs typeface="IBM Plex Sans" pitchFamily="34" charset="-120"/>
+              </a:rPr>
+              <a:t>24% error. ⟨q, x̃⟩ = </a:t>
+            </a:r>
+            <a:r>
+              <a:rPr lang="en-US" sz="1100" b="1" dirty="0">
+                <a:solidFill>
+                  <a:srgbClr val="0F1B2D"/>
+                </a:solidFill>
+                <a:latin typeface="IBM Plex Sans" pitchFamily="34" charset="0"/>
+                <a:ea typeface="IBM Plex Sans" pitchFamily="34" charset="-122"/>
+                <a:cs typeface="IBM Plex Sans" pitchFamily="34" charset="-120"/>
+              </a:rPr>
+              <a:t>8.48</a:t>
+            </a:r>
+            <a:r>
+              <a:rPr lang="en-US" sz="1100" dirty="0">
+                <a:solidFill>
+                  <a:srgbClr val="3A4556"/>
+                </a:solidFill>
+                <a:latin typeface="IBM Plex Sans" pitchFamily="34" charset="0"/>
+                <a:ea typeface="IBM Plex Sans" pitchFamily="34" charset="-122"/>
+                <a:cs typeface="IBM Plex Sans" pitchFamily="34" charset="-120"/>
+              </a:rPr>
+              <a:t> &lt; 9: the score shrinks.</a:t>
+            </a:r>
+            <a:endParaRPr lang="en-US" sz="1100" dirty="0"/>
+          </a:p>
+        </p:txBody>
+      </p:sp>
+      <p:sp>
+        <p:nvSpPr>
+          <p:cNvPr id="15" name="Shape 15"/>
+          <p:cNvSpPr/>
+          <p:nvPr/>
+        </p:nvSpPr>
+        <p:spPr>
+          <a:xfrm>
+            <a:off x="812800" y="4330000"/>
+            <a:ext cx="2585848" cy="1720000"/>
+          </a:xfrm>
+          <a:prstGeom prst="roundRect">
+            <a:avLst>
+              <a:gd name="adj" fmla="val 6060"/>
+            </a:avLst>
+          </a:prstGeom>
+          <a:solidFill>
+            <a:srgbClr val="FDFCF9"/>
+          </a:solidFill>
+          <a:ln w="6350">
+            <a:solidFill>
+              <a:srgbClr val="E2DFD6"/>
+            </a:solidFill>
+            <a:prstDash val="solid"/>
+          </a:ln>
+        </p:spPr>
+      </p:sp>
+      <p:sp>
+        <p:nvSpPr>
+          <p:cNvPr id="16" name="Text 16"/>
+          <p:cNvSpPr/>
+          <p:nvPr/>
+        </p:nvSpPr>
+        <p:spPr>
+          <a:xfrm>
+            <a:off x="972800" y="4490000"/>
+            <a:ext cx="2265848" cy="1400000"/>
+          </a:xfrm>
+          <a:prstGeom prst="rect">
+            <a:avLst/>
+          </a:prstGeom>
+          <a:noFill/>
+          <a:ln/>
+        </p:spPr>
+        <p:txBody>
+          <a:bodyPr wrap="square" lIns="0" tIns="0" rIns="0" bIns="0" rtlCol="0" anchor="t">
+            <a:normAutofit/>
+          </a:bodyPr>
+          <a:lstStyle/>
+          <a:p>
+            <a:pPr algn="l" indent="0" marL="0">
+              <a:lnSpc>
+                <a:spcPts val="1750"/>
+              </a:lnSpc>
+              <a:spcAft>
+                <a:spcPts val="600"/>
+              </a:spcAft>
+              <a:buNone/>
+            </a:pPr>
+            <a:r>
+              <a:rPr lang="en-US" sz="1400" b="1" dirty="0">
+                <a:solidFill>
+                  <a:srgbClr val="0F1B2D"/>
+                </a:solidFill>
+                <a:latin typeface="IBM Plex Sans" pitchFamily="34" charset="0"/>
+                <a:ea typeface="IBM Plex Sans" pitchFamily="34" charset="-122"/>
+                <a:cs typeface="IBM Plex Sans" pitchFamily="34" charset="-120"/>
+              </a:rPr>
+              <a:t>5 · Residual</a:t>
+            </a:r>
+            <a:endParaRPr lang="en-US" sz="1400" dirty="0"/>
+          </a:p>
+          <a:p>
+            <a:pPr algn="l" indent="0" marL="0">
+              <a:lnSpc>
+                <a:spcPts val="1540"/>
+              </a:lnSpc>
+              <a:spcAft>
+                <a:spcPts val="400"/>
+              </a:spcAft>
+              <a:buNone/>
+            </a:pPr>
+            <a:r>
+              <a:rPr lang="en-US" sz="1100" dirty="0">
+                <a:solidFill>
+                  <a:srgbClr val="3A4556"/>
+                </a:solidFill>
+                <a:latin typeface="IBM Plex Sans" pitchFamily="34" charset="0"/>
+                <a:ea typeface="IBM Plex Sans" pitchFamily="34" charset="-122"/>
+                <a:cs typeface="IBM Plex Sans" pitchFamily="34" charset="-120"/>
+              </a:rPr>
+              <a:t>r = v − x̃ = [−0.65, −0.35, 0.81, −0.69]</a:t>
+            </a:r>
+            <a:endParaRPr lang="en-US" sz="1100" dirty="0"/>
+          </a:p>
+          <a:p>
+            <a:pPr algn="l" indent="0" marL="0">
+              <a:lnSpc>
+                <a:spcPts val="1540"/>
+              </a:lnSpc>
+              <a:spcAft>
+                <a:spcPts val="400"/>
+              </a:spcAft>
+              <a:buNone/>
+            </a:pPr>
+            <a:r>
+              <a:rPr lang="en-US" sz="1100" dirty="0">
+                <a:solidFill>
+                  <a:srgbClr val="3A4556"/>
+                </a:solidFill>
+                <a:latin typeface="IBM Plex Sans" pitchFamily="34" charset="0"/>
+                <a:ea typeface="IBM Plex Sans" pitchFamily="34" charset="-122"/>
+                <a:cs typeface="IBM Plex Sans" pitchFamily="34" charset="-120"/>
+              </a:rPr>
+              <a:t>‖r‖ = </a:t>
+            </a:r>
+            <a:r>
+              <a:rPr lang="en-US" sz="1100" b="1" dirty="0">
+                <a:solidFill>
+                  <a:srgbClr val="0F1B2D"/>
+                </a:solidFill>
+                <a:latin typeface="IBM Plex Sans" pitchFamily="34" charset="0"/>
+                <a:ea typeface="IBM Plex Sans" pitchFamily="34" charset="-122"/>
+                <a:cs typeface="IBM Plex Sans" pitchFamily="34" charset="-120"/>
+              </a:rPr>
+              <a:t>1.29</a:t>
+            </a:r>
+            <a:r>
+              <a:rPr lang="en-US" sz="1100" dirty="0">
+                <a:solidFill>
+                  <a:srgbClr val="3A4556"/>
+                </a:solidFill>
+                <a:latin typeface="IBM Plex Sans" pitchFamily="34" charset="0"/>
+                <a:ea typeface="IBM Plex Sans" pitchFamily="34" charset="-122"/>
+                <a:cs typeface="IBM Plex Sans" pitchFamily="34" charset="-120"/>
+              </a:rPr>
+              <a:t>, stored in fp16</a:t>
+            </a:r>
+            <a:endParaRPr lang="en-US" sz="1100" dirty="0"/>
+          </a:p>
+          <a:p>
+            <a:pPr algn="l" indent="0" marL="0">
+              <a:lnSpc>
+                <a:spcPts val="1540"/>
+              </a:lnSpc>
+              <a:spcAft>
+                <a:spcPts val="400"/>
+              </a:spcAft>
+              <a:buNone/>
+            </a:pPr>
+            <a:r>
+              <a:rPr lang="en-US" sz="1100" dirty="0">
+                <a:solidFill>
+                  <a:srgbClr val="3A4556"/>
+                </a:solidFill>
+                <a:latin typeface="IBM Plex Sans" pitchFamily="34" charset="0"/>
+                <a:ea typeface="IBM Plex Sans" pitchFamily="34" charset="-122"/>
+                <a:cs typeface="IBM Plex Sans" pitchFamily="34" charset="-120"/>
+              </a:rPr>
+              <a:t>Missing score ⟨q, r⟩ = 0.52</a:t>
+            </a:r>
+            <a:endParaRPr lang="en-US" sz="1100" dirty="0"/>
+          </a:p>
+        </p:txBody>
+      </p:sp>
+      <p:sp>
+        <p:nvSpPr>
+          <p:cNvPr id="17" name="Shape 17"/>
+          <p:cNvSpPr/>
+          <p:nvPr/>
+        </p:nvSpPr>
+        <p:spPr>
+          <a:xfrm>
+            <a:off x="3578648" y="4330000"/>
+            <a:ext cx="2585848" cy="1720000"/>
+          </a:xfrm>
+          <a:prstGeom prst="roundRect">
+            <a:avLst>
+              <a:gd name="adj" fmla="val 6060"/>
+            </a:avLst>
+          </a:prstGeom>
+          <a:solidFill>
+            <a:srgbClr val="FDFCF9"/>
+          </a:solidFill>
+          <a:ln w="6350">
+            <a:solidFill>
+              <a:srgbClr val="E2DFD6"/>
+            </a:solidFill>
+            <a:prstDash val="solid"/>
+          </a:ln>
+        </p:spPr>
+      </p:sp>
+      <p:sp>
+        <p:nvSpPr>
+          <p:cNvPr id="18" name="Text 18"/>
+          <p:cNvSpPr/>
+          <p:nvPr/>
+        </p:nvSpPr>
+        <p:spPr>
+          <a:xfrm>
+            <a:off x="3738648" y="4490000"/>
+            <a:ext cx="2265848" cy="1400000"/>
+          </a:xfrm>
+          <a:prstGeom prst="rect">
+            <a:avLst/>
+          </a:prstGeom>
+          <a:noFill/>
+          <a:ln/>
+        </p:spPr>
+        <p:txBody>
+          <a:bodyPr wrap="square" lIns="0" tIns="0" rIns="0" bIns="0" rtlCol="0" anchor="t">
+            <a:normAutofit/>
+          </a:bodyPr>
+          <a:lstStyle/>
+          <a:p>
+            <a:pPr algn="l" indent="0" marL="0">
+              <a:lnSpc>
+                <a:spcPts val="1750"/>
+              </a:lnSpc>
+              <a:spcAft>
+                <a:spcPts val="600"/>
+              </a:spcAft>
+              <a:buNone/>
+            </a:pPr>
+            <a:r>
+              <a:rPr lang="en-US" sz="1400" b="1" dirty="0">
+                <a:solidFill>
+                  <a:srgbClr val="0F1B2D"/>
+                </a:solidFill>
+                <a:latin typeface="IBM Plex Sans" pitchFamily="34" charset="0"/>
+                <a:ea typeface="IBM Plex Sans" pitchFamily="34" charset="-122"/>
+                <a:cs typeface="IBM Plex Sans" pitchFamily="34" charset="-120"/>
+              </a:rPr>
+              <a:t>6 · Sign sketch of r</a:t>
+            </a:r>
+            <a:endParaRPr lang="en-US" sz="1400" dirty="0"/>
+          </a:p>
+          <a:p>
+            <a:pPr algn="l" indent="0" marL="0">
+              <a:lnSpc>
+                <a:spcPts val="1540"/>
+              </a:lnSpc>
+              <a:spcAft>
+                <a:spcPts val="400"/>
+              </a:spcAft>
+              <a:buNone/>
+            </a:pPr>
+            <a:r>
+              <a:rPr lang="en-US" sz="1100" dirty="0">
+                <a:solidFill>
+                  <a:srgbClr val="3A4556"/>
+                </a:solidFill>
+                <a:latin typeface="IBM Plex Sans" pitchFamily="34" charset="0"/>
+                <a:ea typeface="IBM Plex Sans" pitchFamily="34" charset="-122"/>
+                <a:cs typeface="IBM Plex Sans" pitchFamily="34" charset="-120"/>
+              </a:rPr>
+              <a:t>S = QJL's 3 rows + [0.4, −0.7, −0.3, 0.9]</a:t>
+            </a:r>
+            <a:endParaRPr lang="en-US" sz="1100" dirty="0"/>
+          </a:p>
+          <a:p>
+            <a:pPr algn="l" indent="0" marL="0">
+              <a:lnSpc>
+                <a:spcPts val="1540"/>
+              </a:lnSpc>
+              <a:spcAft>
+                <a:spcPts val="400"/>
+              </a:spcAft>
+              <a:buNone/>
+            </a:pPr>
+            <a:r>
+              <a:rPr lang="en-US" sz="1100" dirty="0">
+                <a:solidFill>
+                  <a:srgbClr val="3A4556"/>
+                </a:solidFill>
+                <a:latin typeface="IBM Plex Sans" pitchFamily="34" charset="0"/>
+                <a:ea typeface="IBM Plex Sans" pitchFamily="34" charset="-122"/>
+                <a:cs typeface="IBM Plex Sans" pitchFamily="34" charset="-120"/>
+              </a:rPr>
+              <a:t>S·r = [0.47, 0.31, −0.32, −0.87]</a:t>
+            </a:r>
+            <a:endParaRPr lang="en-US" sz="1100" dirty="0"/>
+          </a:p>
+          <a:p>
+            <a:pPr algn="l" indent="0" marL="0">
+              <a:lnSpc>
+                <a:spcPts val="1540"/>
+              </a:lnSpc>
+              <a:spcAft>
+                <a:spcPts val="400"/>
+              </a:spcAft>
+              <a:buNone/>
+            </a:pPr>
+            <a:r>
+              <a:rPr lang="en-US" sz="1100" dirty="0">
+                <a:solidFill>
+                  <a:srgbClr val="3A4556"/>
+                </a:solidFill>
+                <a:latin typeface="IBM Plex Sans" pitchFamily="34" charset="0"/>
+                <a:ea typeface="IBM Plex Sans" pitchFamily="34" charset="-122"/>
+                <a:cs typeface="IBM Plex Sans" pitchFamily="34" charset="-120"/>
+              </a:rPr>
+              <a:t>Stored as </a:t>
+            </a:r>
+            <a:r>
+              <a:rPr lang="en-US" sz="1100" dirty="0">
+                <a:solidFill>
+                  <a:srgbClr val="0F1B2D"/>
+                </a:solidFill>
+                <a:latin typeface="JetBrains Mono" pitchFamily="49" charset="0"/>
+                <a:ea typeface="JetBrains Mono" pitchFamily="49" charset="-122"/>
+                <a:cs typeface="JetBrains Mono" pitchFamily="49" charset="-120"/>
+              </a:rPr>
+              <a:t>1100</a:t>
+            </a:r>
+            <a:r>
+              <a:rPr lang="en-US" sz="1100" dirty="0">
+                <a:solidFill>
+                  <a:srgbClr val="3A4556"/>
+                </a:solidFill>
+                <a:latin typeface="IBM Plex Sans" pitchFamily="34" charset="0"/>
+                <a:ea typeface="IBM Plex Sans" pitchFamily="34" charset="-122"/>
+                <a:cs typeface="IBM Plex Sans" pitchFamily="34" charset="-120"/>
+              </a:rPr>
+              <a:t>, 4 bits</a:t>
+            </a:r>
+            <a:endParaRPr lang="en-US" sz="1100" dirty="0"/>
+          </a:p>
+        </p:txBody>
+      </p:sp>
+      <p:sp>
+        <p:nvSpPr>
+          <p:cNvPr id="19" name="Shape 19"/>
+          <p:cNvSpPr/>
+          <p:nvPr/>
+        </p:nvSpPr>
+        <p:spPr>
+          <a:xfrm>
+            <a:off x="6344496" y="4330000"/>
+            <a:ext cx="2585848" cy="1720000"/>
+          </a:xfrm>
+          <a:prstGeom prst="roundRect">
+            <a:avLst>
+              <a:gd name="adj" fmla="val 6060"/>
+            </a:avLst>
+          </a:prstGeom>
+          <a:solidFill>
+            <a:srgbClr val="FDFCF9"/>
+          </a:solidFill>
+          <a:ln w="6350">
+            <a:solidFill>
+              <a:srgbClr val="E2DFD6"/>
+            </a:solidFill>
+            <a:prstDash val="solid"/>
+          </a:ln>
+        </p:spPr>
+      </p:sp>
+      <p:sp>
+        <p:nvSpPr>
+          <p:cNvPr id="20" name="Text 20"/>
+          <p:cNvSpPr/>
+          <p:nvPr/>
+        </p:nvSpPr>
+        <p:spPr>
+          <a:xfrm>
+            <a:off x="6504496" y="4490000"/>
+            <a:ext cx="2265848" cy="1400000"/>
+          </a:xfrm>
+          <a:prstGeom prst="rect">
+            <a:avLst/>
+          </a:prstGeom>
+          <a:noFill/>
+          <a:ln/>
+        </p:spPr>
+        <p:txBody>
+          <a:bodyPr wrap="square" lIns="0" tIns="0" rIns="0" bIns="0" rtlCol="0" anchor="t">
+            <a:normAutofit/>
+          </a:bodyPr>
+          <a:lstStyle/>
+          <a:p>
+            <a:pPr algn="l" indent="0" marL="0">
+              <a:lnSpc>
+                <a:spcPts val="1750"/>
+              </a:lnSpc>
+              <a:spcAft>
+                <a:spcPts val="600"/>
+              </a:spcAft>
+              <a:buNone/>
+            </a:pPr>
+            <a:r>
+              <a:rPr lang="en-US" sz="1400" b="1" dirty="0">
+                <a:solidFill>
+                  <a:srgbClr val="0F1B2D"/>
+                </a:solidFill>
+                <a:latin typeface="IBM Plex Sans" pitchFamily="34" charset="0"/>
+                <a:ea typeface="IBM Plex Sans" pitchFamily="34" charset="-122"/>
+                <a:cs typeface="IBM Plex Sans" pitchFamily="34" charset="-120"/>
+              </a:rPr>
+              <a:t>7 · Score q = [1, −1, 1, 0]</a:t>
+            </a:r>
+            <a:endParaRPr lang="en-US" sz="1400" dirty="0"/>
+          </a:p>
+          <a:p>
+            <a:pPr algn="l" indent="0" marL="0">
+              <a:lnSpc>
+                <a:spcPts val="1540"/>
+              </a:lnSpc>
+              <a:spcAft>
+                <a:spcPts val="400"/>
+              </a:spcAft>
+              <a:buNone/>
+            </a:pPr>
+            <a:r>
+              <a:rPr lang="en-US" sz="1100" dirty="0">
+                <a:solidFill>
+                  <a:srgbClr val="3A4556"/>
+                </a:solidFill>
+                <a:latin typeface="IBM Plex Sans" pitchFamily="34" charset="0"/>
+                <a:ea typeface="IBM Plex Sans" pitchFamily="34" charset="-122"/>
+                <a:cs typeface="IBM Plex Sans" pitchFamily="34" charset="-120"/>
+              </a:rPr>
+              <a:t>S·q = [1.5, −0.7, −0.8, 0.8]</a:t>
+            </a:r>
+            <a:endParaRPr lang="en-US" sz="1100" dirty="0"/>
+          </a:p>
+          <a:p>
+            <a:pPr algn="l" indent="0" marL="0">
+              <a:lnSpc>
+                <a:spcPts val="1540"/>
+              </a:lnSpc>
+              <a:spcAft>
+                <a:spcPts val="400"/>
+              </a:spcAft>
+              <a:buNone/>
+            </a:pPr>
+            <a:r>
+              <a:rPr lang="en-US" sz="1100" dirty="0">
+                <a:solidFill>
+                  <a:srgbClr val="3A4556"/>
+                </a:solidFill>
+                <a:latin typeface="IBM Plex Sans" pitchFamily="34" charset="0"/>
+                <a:ea typeface="IBM Plex Sans" pitchFamily="34" charset="-122"/>
+                <a:cs typeface="IBM Plex Sans" pitchFamily="34" charset="-120"/>
+              </a:rPr>
+              <a:t>⟨S·q, sign(S·r)⟩ = 0.8</a:t>
+            </a:r>
+            <a:endParaRPr lang="en-US" sz="1100" dirty="0"/>
+          </a:p>
+          <a:p>
+            <a:pPr algn="l" indent="0" marL="0">
+              <a:lnSpc>
+                <a:spcPts val="1540"/>
+              </a:lnSpc>
+              <a:spcAft>
+                <a:spcPts val="400"/>
+              </a:spcAft>
+              <a:buNone/>
+            </a:pPr>
+            <a:r>
+              <a:rPr lang="en-US" sz="1100" dirty="0">
+                <a:solidFill>
+                  <a:srgbClr val="3A4556"/>
+                </a:solidFill>
+                <a:latin typeface="IBM Plex Sans" pitchFamily="34" charset="0"/>
+                <a:ea typeface="IBM Plex Sans" pitchFamily="34" charset="-122"/>
+                <a:cs typeface="IBM Plex Sans" pitchFamily="34" charset="-120"/>
+              </a:rPr>
+              <a:t>√(π/2)/4 · 1.29 · 0.8 = </a:t>
+            </a:r>
+            <a:r>
+              <a:rPr lang="en-US" sz="1100" b="1" dirty="0">
+                <a:solidFill>
+                  <a:srgbClr val="0F1B2D"/>
+                </a:solidFill>
+                <a:latin typeface="IBM Plex Sans" pitchFamily="34" charset="0"/>
+                <a:ea typeface="IBM Plex Sans" pitchFamily="34" charset="-122"/>
+                <a:cs typeface="IBM Plex Sans" pitchFamily="34" charset="-120"/>
+              </a:rPr>
+              <a:t>0.32</a:t>
+            </a:r>
+            <a:endParaRPr lang="en-US" sz="1100" dirty="0"/>
+          </a:p>
+        </p:txBody>
+      </p:sp>
+      <p:sp>
+        <p:nvSpPr>
+          <p:cNvPr id="21" name="Shape 21"/>
+          <p:cNvSpPr/>
+          <p:nvPr/>
+        </p:nvSpPr>
+        <p:spPr>
+          <a:xfrm>
+            <a:off x="9110344" y="4330000"/>
+            <a:ext cx="2585848" cy="1720000"/>
+          </a:xfrm>
+          <a:prstGeom prst="roundRect">
+            <a:avLst>
+              <a:gd name="adj" fmla="val 6060"/>
+            </a:avLst>
+          </a:prstGeom>
+          <a:solidFill>
+            <a:srgbClr val="0F1B2D"/>
+          </a:solidFill>
+          <a:ln/>
+        </p:spPr>
+      </p:sp>
+      <p:sp>
+        <p:nvSpPr>
+          <p:cNvPr id="22" name="Text 22"/>
+          <p:cNvSpPr/>
+          <p:nvPr/>
+        </p:nvSpPr>
+        <p:spPr>
+          <a:xfrm>
+            <a:off x="9270344" y="4490000"/>
+            <a:ext cx="2265848" cy="1400000"/>
+          </a:xfrm>
+          <a:prstGeom prst="rect">
+            <a:avLst/>
+          </a:prstGeom>
+          <a:noFill/>
+          <a:ln/>
+        </p:spPr>
+        <p:txBody>
+          <a:bodyPr wrap="square" lIns="0" tIns="0" rIns="0" bIns="0" rtlCol="0" anchor="t">
+            <a:normAutofit/>
+          </a:bodyPr>
+          <a:lstStyle/>
+          <a:p>
+            <a:pPr algn="l" indent="0" marL="0">
+              <a:lnSpc>
+                <a:spcPts val="1750"/>
+              </a:lnSpc>
+              <a:spcAft>
+                <a:spcPts val="600"/>
+              </a:spcAft>
+              <a:buNone/>
+            </a:pPr>
+            <a:r>
+              <a:rPr lang="en-US" sz="1400" b="1" dirty="0">
+                <a:solidFill>
+                  <a:srgbClr val="F2A35E"/>
+                </a:solidFill>
+                <a:latin typeface="IBM Plex Sans" pitchFamily="34" charset="0"/>
+                <a:ea typeface="IBM Plex Sans" pitchFamily="34" charset="-122"/>
+                <a:cs typeface="IBM Plex Sans" pitchFamily="34" charset="-120"/>
+              </a:rPr>
+              <a:t>8.48 + 0.32</a:t>
+            </a:r>
+            <a:endParaRPr lang="en-US" sz="1400" dirty="0"/>
+          </a:p>
+          <a:p>
+            <a:pPr algn="l" indent="0" marL="0">
+              <a:lnSpc>
+                <a:spcPts val="3919"/>
+              </a:lnSpc>
+              <a:spcAft>
+                <a:spcPts val="400"/>
+              </a:spcAft>
+              <a:buNone/>
+            </a:pPr>
+            <a:r>
+              <a:rPr lang="en-US" sz="2800" b="1" dirty="0">
+                <a:solidFill>
+                  <a:srgbClr val="F2A35E"/>
+                </a:solidFill>
+                <a:latin typeface="IBM Plex Sans" pitchFamily="34" charset="0"/>
+                <a:ea typeface="IBM Plex Sans" pitchFamily="34" charset="-122"/>
+                <a:cs typeface="IBM Plex Sans" pitchFamily="34" charset="-120"/>
+              </a:rPr>
+              <a:t>8.81</a:t>
+            </a:r>
+            <a:r>
+              <a:rPr lang="en-US" sz="1100" dirty="0">
+                <a:solidFill>
+                  <a:srgbClr val="D9DEE6"/>
+                </a:solidFill>
+                <a:latin typeface="IBM Plex Sans" pitchFamily="34" charset="0"/>
+                <a:ea typeface="IBM Plex Sans" pitchFamily="34" charset="-122"/>
+                <a:cs typeface="IBM Plex Sans" pitchFamily="34" charset="-120"/>
+              </a:rPr>
+              <a:t>  vs exact 9</a:t>
+            </a:r>
+            <a:endParaRPr lang="en-US" sz="2800" dirty="0"/>
+          </a:p>
+          <a:p>
+            <a:pPr algn="l" indent="0" marL="0">
+              <a:lnSpc>
+                <a:spcPts val="1540"/>
+              </a:lnSpc>
+              <a:spcAft>
+                <a:spcPts val="400"/>
+              </a:spcAft>
+              <a:buNone/>
+            </a:pPr>
+            <a:r>
+              <a:rPr lang="en-US" sz="1100" dirty="0">
+                <a:solidFill>
+                  <a:srgbClr val="D9DEE6"/>
+                </a:solidFill>
+                <a:latin typeface="IBM Plex Sans" pitchFamily="34" charset="0"/>
+                <a:ea typeface="IBM Plex Sans" pitchFamily="34" charset="-122"/>
+                <a:cs typeface="IBM Plex Sans" pitchFamily="34" charset="-120"/>
+              </a:rPr>
+              <a:t>44 bits stored instead of 64</a:t>
+            </a:r>
+            <a:endParaRPr lang="en-US" sz="1100" dirty="0"/>
+          </a:p>
+        </p:txBody>
+      </p:sp>
+      <p:sp>
+        <p:nvSpPr>
+          <p:cNvPr id="23" name="Text 23"/>
+          <p:cNvSpPr/>
+          <p:nvPr/>
+        </p:nvSpPr>
+        <p:spPr>
+          <a:xfrm>
+            <a:off x="812800" y="6238280"/>
+            <a:ext cx="10883392" cy="238720"/>
+          </a:xfrm>
+          <a:prstGeom prst="rect">
+            <a:avLst/>
+          </a:prstGeom>
+          <a:noFill/>
+          <a:ln/>
+        </p:spPr>
+        <p:txBody>
+          <a:bodyPr wrap="square" lIns="0" tIns="0" rIns="0" bIns="0" rtlCol="0" anchor="t">
+            <a:normAutofit/>
+          </a:bodyPr>
+          <a:lstStyle/>
+          <a:p>
+            <a:pPr algn="l" indent="0" marL="0">
+              <a:lnSpc>
+                <a:spcPts val="1680"/>
+              </a:lnSpc>
+              <a:buNone/>
+            </a:pPr>
+            <a:r>
+              <a:rPr lang="en-US" sz="1200" dirty="0">
+                <a:solidFill>
+                  <a:srgbClr val="5F6979"/>
+                </a:solidFill>
+                <a:latin typeface="IBM Plex Sans" pitchFamily="34" charset="0"/>
+                <a:ea typeface="IBM Plex Sans" pitchFamily="34" charset="-122"/>
+                <a:cs typeface="IBM Plex Sans" pitchFamily="34" charset="-120"/>
+              </a:rPr>
+              <a:t>Section 2.3 of the guide. Over 20,000 random rotations the MSE stage alone averages 8.32 and the full estimate 9.00.</a:t>
+            </a:r>
+            <a:endParaRPr lang="en-US" sz="1200" dirty="0"/>
           </a:p>
         </p:txBody>
       </p:sp>

</xml_diff>

<commit_message>
Use Consolas instead of JetBrains Mono in the deck and figures
JetBrains Mono is rarely installed, so PowerPoint substituted another
font and code and numbers rendered badly. The deck now uses Consolas,
which ships with Office, and the SVG figures fall back to Courier New.
</commit_message>
<xml_diff>
--- a/docs/TurboQuant.pptx
+++ b/docs/TurboQuant.pptx
@@ -3315,9 +3315,9 @@
                 <a:solidFill>
                   <a:srgbClr val="F2A35E"/>
                 </a:solidFill>
-                <a:latin typeface="JetBrains Mono" pitchFamily="49" charset="0"/>
-                <a:ea typeface="JetBrains Mono" pitchFamily="49" charset="-122"/>
-                <a:cs typeface="JetBrains Mono" pitchFamily="49" charset="-120"/>
+                <a:latin typeface="Consolas" pitchFamily="49" charset="0"/>
+                <a:ea typeface="Consolas" pitchFamily="49" charset="-122"/>
+                <a:cs typeface="Consolas" pitchFamily="49" charset="-120"/>
               </a:rPr>
               <a:t>GOOGLE RESEARCH · ARXIV 2504.19874</a:t>
             </a:r>
@@ -3669,9 +3669,9 @@
                 <a:solidFill>
                   <a:srgbClr val="B4521A"/>
                 </a:solidFill>
-                <a:latin typeface="JetBrains Mono" pitchFamily="49" charset="0"/>
-                <a:ea typeface="JetBrains Mono" pitchFamily="49" charset="-122"/>
-                <a:cs typeface="JetBrains Mono" pitchFamily="49" charset="-120"/>
+                <a:latin typeface="Consolas" pitchFamily="49" charset="0"/>
+                <a:ea typeface="Consolas" pitchFamily="49" charset="-122"/>
+                <a:cs typeface="Consolas" pitchFamily="49" charset="-120"/>
               </a:rPr>
               <a:t>STAGE 2 · TURBOQUANT_PROD</a:t>
             </a:r>
@@ -4063,9 +4063,9 @@
                 <a:solidFill>
                   <a:srgbClr val="0F1B2D"/>
                 </a:solidFill>
-                <a:latin typeface="JetBrains Mono" pitchFamily="49" charset="0"/>
-                <a:ea typeface="JetBrains Mono" pitchFamily="49" charset="-122"/>
-                <a:cs typeface="JetBrains Mono" pitchFamily="49" charset="-120"/>
+                <a:latin typeface="Consolas" pitchFamily="49" charset="0"/>
+                <a:ea typeface="Consolas" pitchFamily="49" charset="-122"/>
+                <a:cs typeface="Consolas" pitchFamily="49" charset="-120"/>
               </a:rPr>
               <a:t>idx = Q_mse(x) with b−1 bits</a:t>
             </a:r>
@@ -4083,9 +4083,9 @@
                 <a:solidFill>
                   <a:srgbClr val="0F1B2D"/>
                 </a:solidFill>
-                <a:latin typeface="JetBrains Mono" pitchFamily="49" charset="0"/>
-                <a:ea typeface="JetBrains Mono" pitchFamily="49" charset="-122"/>
-                <a:cs typeface="JetBrains Mono" pitchFamily="49" charset="-120"/>
+                <a:latin typeface="Consolas" pitchFamily="49" charset="0"/>
+                <a:ea typeface="Consolas" pitchFamily="49" charset="-122"/>
+                <a:cs typeface="Consolas" pitchFamily="49" charset="-120"/>
               </a:rPr>
               <a:t>r = x − Q_mse⁻¹(idx)</a:t>
             </a:r>
@@ -4103,9 +4103,9 @@
                 <a:solidFill>
                   <a:srgbClr val="0F1B2D"/>
                 </a:solidFill>
-                <a:latin typeface="JetBrains Mono" pitchFamily="49" charset="0"/>
-                <a:ea typeface="JetBrains Mono" pitchFamily="49" charset="-122"/>
-                <a:cs typeface="JetBrains Mono" pitchFamily="49" charset="-120"/>
+                <a:latin typeface="Consolas" pitchFamily="49" charset="0"/>
+                <a:ea typeface="Consolas" pitchFamily="49" charset="-122"/>
+                <a:cs typeface="Consolas" pitchFamily="49" charset="-120"/>
               </a:rPr>
               <a:t>store idx, sign(S·r), ‖r‖</a:t>
             </a:r>
@@ -4418,9 +4418,9 @@
                 <a:solidFill>
                   <a:srgbClr val="B4521A"/>
                 </a:solidFill>
-                <a:latin typeface="JetBrains Mono" pitchFamily="49" charset="0"/>
-                <a:ea typeface="JetBrains Mono" pitchFamily="49" charset="-122"/>
-                <a:cs typeface="JetBrains Mono" pitchFamily="49" charset="-120"/>
+                <a:latin typeface="Consolas" pitchFamily="49" charset="0"/>
+                <a:ea typeface="Consolas" pitchFamily="49" charset="-122"/>
+                <a:cs typeface="Consolas" pitchFamily="49" charset="-120"/>
               </a:rPr>
               <a:t>TURBOQUANT · WORKED EXAMPLE</a:t>
             </a:r>
@@ -4508,9 +4508,9 @@
                 <a:solidFill>
                   <a:srgbClr val="5F6979"/>
                 </a:solidFill>
-                <a:latin typeface="JetBrains Mono" pitchFamily="49" charset="0"/>
-                <a:ea typeface="JetBrains Mono" pitchFamily="49" charset="-122"/>
-                <a:cs typeface="JetBrains Mono" pitchFamily="49" charset="-120"/>
+                <a:latin typeface="Consolas" pitchFamily="49" charset="0"/>
+                <a:ea typeface="Consolas" pitchFamily="49" charset="-122"/>
+                <a:cs typeface="Consolas" pitchFamily="49" charset="-120"/>
               </a:rPr>
               <a:t>STAGE 1 · TURBOQUANT_MSE, 2 BITS PER COORDINATE</a:t>
             </a:r>
@@ -4552,9 +4552,9 @@
                 <a:solidFill>
                   <a:srgbClr val="5F6979"/>
                 </a:solidFill>
-                <a:latin typeface="JetBrains Mono" pitchFamily="49" charset="0"/>
-                <a:ea typeface="JetBrains Mono" pitchFamily="49" charset="-122"/>
-                <a:cs typeface="JetBrains Mono" pitchFamily="49" charset="-120"/>
+                <a:latin typeface="Consolas" pitchFamily="49" charset="0"/>
+                <a:ea typeface="Consolas" pitchFamily="49" charset="-122"/>
+                <a:cs typeface="Consolas" pitchFamily="49" charset="-120"/>
               </a:rPr>
               <a:t>STAGE 2 · 1-BIT QJL ON THE RESIDUAL</a:t>
             </a:r>
@@ -5026,9 +5026,9 @@
                 <a:solidFill>
                   <a:srgbClr val="0F1B2D"/>
                 </a:solidFill>
-                <a:latin typeface="JetBrains Mono" pitchFamily="49" charset="0"/>
-                <a:ea typeface="JetBrains Mono" pitchFamily="49" charset="-122"/>
-                <a:cs typeface="JetBrains Mono" pitchFamily="49" charset="-120"/>
+                <a:latin typeface="Consolas" pitchFamily="49" charset="0"/>
+                <a:ea typeface="Consolas" pitchFamily="49" charset="-122"/>
+                <a:cs typeface="Consolas" pitchFamily="49" charset="-120"/>
               </a:rPr>
               <a:t>11 10 11 01</a:t>
             </a:r>
@@ -5510,9 +5510,9 @@
                 <a:solidFill>
                   <a:srgbClr val="0F1B2D"/>
                 </a:solidFill>
-                <a:latin typeface="JetBrains Mono" pitchFamily="49" charset="0"/>
-                <a:ea typeface="JetBrains Mono" pitchFamily="49" charset="-122"/>
-                <a:cs typeface="JetBrains Mono" pitchFamily="49" charset="-120"/>
+                <a:latin typeface="Consolas" pitchFamily="49" charset="0"/>
+                <a:ea typeface="Consolas" pitchFamily="49" charset="-122"/>
+                <a:cs typeface="Consolas" pitchFamily="49" charset="-120"/>
               </a:rPr>
               <a:t>1100</a:t>
             </a:r>
@@ -5929,9 +5929,9 @@
                 <a:solidFill>
                   <a:srgbClr val="B4521A"/>
                 </a:solidFill>
-                <a:latin typeface="JetBrains Mono" pitchFamily="49" charset="0"/>
-                <a:ea typeface="JetBrains Mono" pitchFamily="49" charset="-122"/>
-                <a:cs typeface="JetBrains Mono" pitchFamily="49" charset="-120"/>
+                <a:latin typeface="Consolas" pitchFamily="49" charset="0"/>
+                <a:ea typeface="Consolas" pitchFamily="49" charset="-122"/>
+                <a:cs typeface="Consolas" pitchFamily="49" charset="-120"/>
               </a:rPr>
               <a:t>NEAR-OPTIMAL</a:t>
             </a:r>
@@ -8026,9 +8026,9 @@
                 <a:solidFill>
                   <a:srgbClr val="B4521A"/>
                 </a:solidFill>
-                <a:latin typeface="JetBrains Mono" pitchFamily="49" charset="0"/>
-                <a:ea typeface="JetBrains Mono" pitchFamily="49" charset="-122"/>
-                <a:cs typeface="JetBrains Mono" pitchFamily="49" charset="-120"/>
+                <a:latin typeface="Consolas" pitchFamily="49" charset="0"/>
+                <a:ea typeface="Consolas" pitchFamily="49" charset="-122"/>
+                <a:cs typeface="Consolas" pitchFamily="49" charset="-120"/>
               </a:rPr>
               <a:t>PAPER RESULTS · KV CACHE</a:t>
             </a:r>
@@ -10876,9 +10876,9 @@
                 <a:solidFill>
                   <a:srgbClr val="B4521A"/>
                 </a:solidFill>
-                <a:latin typeface="JetBrains Mono" pitchFamily="49" charset="0"/>
-                <a:ea typeface="JetBrains Mono" pitchFamily="49" charset="-122"/>
-                <a:cs typeface="JetBrains Mono" pitchFamily="49" charset="-120"/>
+                <a:latin typeface="Consolas" pitchFamily="49" charset="0"/>
+                <a:ea typeface="Consolas" pitchFamily="49" charset="-122"/>
+                <a:cs typeface="Consolas" pitchFamily="49" charset="-120"/>
               </a:rPr>
               <a:t>IN PRODUCTION</a:t>
             </a:r>
@@ -10997,9 +10997,9 @@
                 <a:solidFill>
                   <a:srgbClr val="5F6979"/>
                 </a:solidFill>
-                <a:latin typeface="JetBrains Mono" pitchFamily="49" charset="0"/>
-                <a:ea typeface="JetBrains Mono" pitchFamily="49" charset="-122"/>
-                <a:cs typeface="JetBrains Mono" pitchFamily="49" charset="-120"/>
+                <a:latin typeface="Consolas" pitchFamily="49" charset="0"/>
+                <a:ea typeface="Consolas" pitchFamily="49" charset="-122"/>
+                <a:cs typeface="Consolas" pitchFamily="49" charset="-120"/>
               </a:rPr>
               <a:t>GOOGLE RESEARCH BLOG</a:t>
             </a:r>
@@ -11160,9 +11160,9 @@
                 <a:solidFill>
                   <a:srgbClr val="5F6979"/>
                 </a:solidFill>
-                <a:latin typeface="JetBrains Mono" pitchFamily="49" charset="0"/>
-                <a:ea typeface="JetBrains Mono" pitchFamily="49" charset="-122"/>
-                <a:cs typeface="JetBrains Mono" pitchFamily="49" charset="-120"/>
+                <a:latin typeface="Consolas" pitchFamily="49" charset="0"/>
+                <a:ea typeface="Consolas" pitchFamily="49" charset="-122"/>
+                <a:cs typeface="Consolas" pitchFamily="49" charset="-120"/>
               </a:rPr>
               <a:t>VLLM 0.20.2+ · H100</a:t>
             </a:r>
@@ -11296,9 +11296,9 @@
                 <a:solidFill>
                   <a:srgbClr val="0F1B2D"/>
                 </a:solidFill>
-                <a:latin typeface="JetBrains Mono" pitchFamily="49" charset="0"/>
-                <a:ea typeface="JetBrains Mono" pitchFamily="49" charset="-122"/>
-                <a:cs typeface="JetBrains Mono" pitchFamily="49" charset="-120"/>
+                <a:latin typeface="Consolas" pitchFamily="49" charset="0"/>
+                <a:ea typeface="Consolas" pitchFamily="49" charset="-122"/>
+                <a:cs typeface="Consolas" pitchFamily="49" charset="-120"/>
               </a:rPr>
               <a:t>vllm serve &lt;model&gt; --kv-cache-dtype turboquant_4bit_nc # or turboquant_k8v4, turboquant_k3v4_nc, turboquant_3bit_nc</a:t>
             </a:r>
@@ -11416,9 +11416,9 @@
                 <a:solidFill>
                   <a:srgbClr val="B4521A"/>
                 </a:solidFill>
-                <a:latin typeface="JetBrains Mono" pitchFamily="49" charset="0"/>
-                <a:ea typeface="JetBrains Mono" pitchFamily="49" charset="-122"/>
-                <a:cs typeface="JetBrains Mono" pitchFamily="49" charset="-120"/>
+                <a:latin typeface="Consolas" pitchFamily="49" charset="0"/>
+                <a:ea typeface="Consolas" pitchFamily="49" charset="-122"/>
+                <a:cs typeface="Consolas" pitchFamily="49" charset="-120"/>
               </a:rPr>
               <a:t>PAPER RESULTS · VECTOR SEARCH</a:t>
             </a:r>
@@ -12892,9 +12892,9 @@
                 <a:solidFill>
                   <a:srgbClr val="F2A35E"/>
                 </a:solidFill>
-                <a:latin typeface="JetBrains Mono" pitchFamily="49" charset="0"/>
-                <a:ea typeface="JetBrains Mono" pitchFamily="49" charset="-122"/>
-                <a:cs typeface="JetBrains Mono" pitchFamily="49" charset="-120"/>
+                <a:latin typeface="Consolas" pitchFamily="49" charset="0"/>
+                <a:ea typeface="Consolas" pitchFamily="49" charset="-122"/>
+                <a:cs typeface="Consolas" pitchFamily="49" charset="-120"/>
               </a:rPr>
               <a:t>THE DEMOS</a:t>
             </a:r>
@@ -13008,9 +13008,9 @@
                 <a:solidFill>
                   <a:srgbClr val="F2A35E"/>
                 </a:solidFill>
-                <a:latin typeface="JetBrains Mono" pitchFamily="49" charset="0"/>
-                <a:ea typeface="JetBrains Mono" pitchFamily="49" charset="-122"/>
-                <a:cs typeface="JetBrains Mono" pitchFamily="49" charset="-120"/>
+                <a:latin typeface="Consolas" pitchFamily="49" charset="0"/>
+                <a:ea typeface="Consolas" pitchFamily="49" charset="-122"/>
+                <a:cs typeface="Consolas" pitchFamily="49" charset="-120"/>
               </a:rPr>
               <a:t>llm_kv_cache_demo.ipynb</a:t>
             </a:r>
@@ -13166,9 +13166,9 @@
                 <a:solidFill>
                   <a:srgbClr val="F2A35E"/>
                 </a:solidFill>
-                <a:latin typeface="JetBrains Mono" pitchFamily="49" charset="0"/>
-                <a:ea typeface="JetBrains Mono" pitchFamily="49" charset="-122"/>
-                <a:cs typeface="JetBrains Mono" pitchFamily="49" charset="-120"/>
+                <a:latin typeface="Consolas" pitchFamily="49" charset="0"/>
+                <a:ea typeface="Consolas" pitchFamily="49" charset="-122"/>
+                <a:cs typeface="Consolas" pitchFamily="49" charset="-120"/>
               </a:rPr>
               <a:t>vector_search_demo.ipynb</a:t>
             </a:r>
@@ -13374,9 +13374,9 @@
                 <a:solidFill>
                   <a:srgbClr val="B4521A"/>
                 </a:solidFill>
-                <a:latin typeface="JetBrains Mono" pitchFamily="49" charset="0"/>
-                <a:ea typeface="JetBrains Mono" pitchFamily="49" charset="-122"/>
-                <a:cs typeface="JetBrains Mono" pitchFamily="49" charset="-120"/>
+                <a:latin typeface="Consolas" pitchFamily="49" charset="0"/>
+                <a:ea typeface="Consolas" pitchFamily="49" charset="-122"/>
+                <a:cs typeface="Consolas" pitchFamily="49" charset="-120"/>
               </a:rPr>
               <a:t>DEMO 1 · LLM INFERENCE</a:t>
             </a:r>
@@ -13468,9 +13468,9 @@
                 <a:solidFill>
                   <a:srgbClr val="F6F5F0"/>
                 </a:solidFill>
-                <a:latin typeface="JetBrains Mono" pitchFamily="49" charset="0"/>
-                <a:ea typeface="JetBrains Mono" pitchFamily="49" charset="-122"/>
-                <a:cs typeface="JetBrains Mono" pitchFamily="49" charset="-120"/>
+                <a:latin typeface="Consolas" pitchFamily="49" charset="0"/>
+                <a:ea typeface="Consolas" pitchFamily="49" charset="-122"/>
+                <a:cs typeface="Consolas" pitchFamily="49" charset="-120"/>
               </a:rPr>
               <a:t>from turboquant_core import TurboQuantCache, mixed_factory</a:t>
             </a:r>
@@ -13497,9 +13497,9 @@
                 <a:solidFill>
                   <a:srgbClr val="F6F5F0"/>
                 </a:solidFill>
-                <a:latin typeface="JetBrains Mono" pitchFamily="49" charset="0"/>
-                <a:ea typeface="JetBrains Mono" pitchFamily="49" charset="-122"/>
-                <a:cs typeface="JetBrains Mono" pitchFamily="49" charset="-120"/>
+                <a:latin typeface="Consolas" pitchFamily="49" charset="0"/>
+                <a:ea typeface="Consolas" pitchFamily="49" charset="-122"/>
+                <a:cs typeface="Consolas" pitchFamily="49" charset="-120"/>
               </a:rPr>
               <a:t>cache = TurboQuantCache(</a:t>
             </a:r>
@@ -13517,9 +13517,9 @@
                 <a:solidFill>
                   <a:srgbClr val="F6F5F0"/>
                 </a:solidFill>
-                <a:latin typeface="JetBrains Mono" pitchFamily="49" charset="0"/>
-                <a:ea typeface="JetBrains Mono" pitchFamily="49" charset="-122"/>
-                <a:cs typeface="JetBrains Mono" pitchFamily="49" charset="-120"/>
+                <a:latin typeface="Consolas" pitchFamily="49" charset="0"/>
+                <a:ea typeface="Consolas" pitchFamily="49" charset="-122"/>
+                <a:cs typeface="Consolas" pitchFamily="49" charset="-120"/>
               </a:rPr>
               <a:t>model.config,</a:t>
             </a:r>
@@ -13537,9 +13537,9 @@
                 <a:solidFill>
                   <a:srgbClr val="F6F5F0"/>
                 </a:solidFill>
-                <a:latin typeface="JetBrains Mono" pitchFamily="49" charset="0"/>
-                <a:ea typeface="JetBrains Mono" pitchFamily="49" charset="-122"/>
-                <a:cs typeface="JetBrains Mono" pitchFamily="49" charset="-120"/>
+                <a:latin typeface="Consolas" pitchFamily="49" charset="0"/>
+                <a:ea typeface="Consolas" pitchFamily="49" charset="-122"/>
+                <a:cs typeface="Consolas" pitchFamily="49" charset="-120"/>
               </a:rPr>
               <a:t>make_k=mixed_factory(0.25, 3, 2), # 32 ch @3b + 96 @2b</a:t>
             </a:r>
@@ -13557,9 +13557,9 @@
                 <a:solidFill>
                   <a:srgbClr val="F6F5F0"/>
                 </a:solidFill>
-                <a:latin typeface="JetBrains Mono" pitchFamily="49" charset="0"/>
-                <a:ea typeface="JetBrains Mono" pitchFamily="49" charset="-122"/>
-                <a:cs typeface="JetBrains Mono" pitchFamily="49" charset="-120"/>
+                <a:latin typeface="Consolas" pitchFamily="49" charset="0"/>
+                <a:ea typeface="Consolas" pitchFamily="49" charset="-122"/>
+                <a:cs typeface="Consolas" pitchFamily="49" charset="-120"/>
               </a:rPr>
               <a:t>make_v=mixed_factory(0.25, 3, 2),</a:t>
             </a:r>
@@ -13577,9 +13577,9 @@
                 <a:solidFill>
                   <a:srgbClr val="F6F5F0"/>
                 </a:solidFill>
-                <a:latin typeface="JetBrains Mono" pitchFamily="49" charset="0"/>
-                <a:ea typeface="JetBrains Mono" pitchFamily="49" charset="-122"/>
-                <a:cs typeface="JetBrains Mono" pitchFamily="49" charset="-120"/>
+                <a:latin typeface="Consolas" pitchFamily="49" charset="0"/>
+                <a:ea typeface="Consolas" pitchFamily="49" charset="-122"/>
+                <a:cs typeface="Consolas" pitchFamily="49" charset="-120"/>
               </a:rPr>
               <a:t>)</a:t>
             </a:r>
@@ -13597,9 +13597,9 @@
                 <a:solidFill>
                   <a:srgbClr val="F6F5F0"/>
                 </a:solidFill>
-                <a:latin typeface="JetBrains Mono" pitchFamily="49" charset="0"/>
-                <a:ea typeface="JetBrains Mono" pitchFamily="49" charset="-122"/>
-                <a:cs typeface="JetBrains Mono" pitchFamily="49" charset="-120"/>
+                <a:latin typeface="Consolas" pitchFamily="49" charset="0"/>
+                <a:ea typeface="Consolas" pitchFamily="49" charset="-122"/>
+                <a:cs typeface="Consolas" pitchFamily="49" charset="-120"/>
               </a:rPr>
               <a:t>out = model.generate(ids, past_key_values=cache,</a:t>
             </a:r>
@@ -13617,9 +13617,9 @@
                 <a:solidFill>
                   <a:srgbClr val="F6F5F0"/>
                 </a:solidFill>
-                <a:latin typeface="JetBrains Mono" pitchFamily="49" charset="0"/>
-                <a:ea typeface="JetBrains Mono" pitchFamily="49" charset="-122"/>
-                <a:cs typeface="JetBrains Mono" pitchFamily="49" charset="-120"/>
+                <a:latin typeface="Consolas" pitchFamily="49" charset="0"/>
+                <a:ea typeface="Consolas" pitchFamily="49" charset="-122"/>
+                <a:cs typeface="Consolas" pitchFamily="49" charset="-120"/>
               </a:rPr>
               <a:t>max_new_tokens=64)</a:t>
             </a:r>
@@ -13637,9 +13637,9 @@
                 <a:solidFill>
                   <a:srgbClr val="F6F5F0"/>
                 </a:solidFill>
-                <a:latin typeface="JetBrains Mono" pitchFamily="49" charset="0"/>
-                <a:ea typeface="JetBrains Mono" pitchFamily="49" charset="-122"/>
-                <a:cs typeface="JetBrains Mono" pitchFamily="49" charset="-120"/>
+                <a:latin typeface="Consolas" pitchFamily="49" charset="0"/>
+                <a:ea typeface="Consolas" pitchFamily="49" charset="-122"/>
+                <a:cs typeface="Consolas" pitchFamily="49" charset="-120"/>
               </a:rPr>
               <a:t>print(cache.nbytes()) # measured, bit-packed</a:t>
             </a:r>
@@ -13922,9 +13922,9 @@
                 <a:solidFill>
                   <a:srgbClr val="B4521A"/>
                 </a:solidFill>
-                <a:latin typeface="JetBrains Mono" pitchFamily="49" charset="0"/>
-                <a:ea typeface="JetBrains Mono" pitchFamily="49" charset="-122"/>
-                <a:cs typeface="JetBrains Mono" pitchFamily="49" charset="-120"/>
+                <a:latin typeface="Consolas" pitchFamily="49" charset="0"/>
+                <a:ea typeface="Consolas" pitchFamily="49" charset="-122"/>
+                <a:cs typeface="Consolas" pitchFamily="49" charset="-120"/>
               </a:rPr>
               <a:t>DEMO 1 · MEMORY</a:t>
             </a:r>
@@ -15771,9 +15771,9 @@
                 <a:solidFill>
                   <a:srgbClr val="F2A35E"/>
                 </a:solidFill>
-                <a:latin typeface="JetBrains Mono" pitchFamily="49" charset="0"/>
-                <a:ea typeface="JetBrains Mono" pitchFamily="49" charset="-122"/>
-                <a:cs typeface="JetBrains Mono" pitchFamily="49" charset="-120"/>
+                <a:latin typeface="Consolas" pitchFamily="49" charset="0"/>
+                <a:ea typeface="Consolas" pitchFamily="49" charset="-122"/>
+                <a:cs typeface="Consolas" pitchFamily="49" charset="-120"/>
               </a:rPr>
               <a:t>LLAMA-3.1-8B, 8 GB OF KV</a:t>
             </a:r>
@@ -16122,9 +16122,9 @@
                 <a:solidFill>
                   <a:srgbClr val="B4521A"/>
                 </a:solidFill>
-                <a:latin typeface="JetBrains Mono" pitchFamily="49" charset="0"/>
-                <a:ea typeface="JetBrains Mono" pitchFamily="49" charset="-122"/>
-                <a:cs typeface="JetBrains Mono" pitchFamily="49" charset="-120"/>
+                <a:latin typeface="Consolas" pitchFamily="49" charset="0"/>
+                <a:ea typeface="Consolas" pitchFamily="49" charset="-122"/>
+                <a:cs typeface="Consolas" pitchFamily="49" charset="-120"/>
               </a:rPr>
               <a:t>DEMO 2 · VECTOR SEARCH, MEASURED</a:t>
             </a:r>
@@ -21201,9 +21201,9 @@
                 <a:solidFill>
                   <a:srgbClr val="B4521A"/>
                 </a:solidFill>
-                <a:latin typeface="JetBrains Mono" pitchFamily="49" charset="0"/>
-                <a:ea typeface="JetBrains Mono" pitchFamily="49" charset="-122"/>
-                <a:cs typeface="JetBrains Mono" pitchFamily="49" charset="-120"/>
+                <a:latin typeface="Consolas" pitchFamily="49" charset="0"/>
+                <a:ea typeface="Consolas" pitchFamily="49" charset="-122"/>
+                <a:cs typeface="Consolas" pitchFamily="49" charset="-120"/>
               </a:rPr>
               <a:t>BACKGROUND · THE KV CACHE</a:t>
             </a:r>
@@ -21391,9 +21391,9 @@
                 <a:solidFill>
                   <a:srgbClr val="B4521A"/>
                 </a:solidFill>
-                <a:latin typeface="JetBrains Mono" pitchFamily="49" charset="0"/>
-                <a:ea typeface="JetBrains Mono" pitchFamily="49" charset="-122"/>
-                <a:cs typeface="JetBrains Mono" pitchFamily="49" charset="-120"/>
+                <a:latin typeface="Consolas" pitchFamily="49" charset="0"/>
+                <a:ea typeface="Consolas" pitchFamily="49" charset="-122"/>
+                <a:cs typeface="Consolas" pitchFamily="49" charset="-120"/>
               </a:rPr>
               <a:t>DEMO 2 · WHAT IT MEANS</a:t>
             </a:r>
@@ -22546,9 +22546,9 @@
                 <a:solidFill>
                   <a:srgbClr val="B4521A"/>
                 </a:solidFill>
-                <a:latin typeface="JetBrains Mono" pitchFamily="49" charset="0"/>
-                <a:ea typeface="JetBrains Mono" pitchFamily="49" charset="-122"/>
-                <a:cs typeface="JetBrains Mono" pitchFamily="49" charset="-120"/>
+                <a:latin typeface="Consolas" pitchFamily="49" charset="0"/>
+                <a:ea typeface="Consolas" pitchFamily="49" charset="-122"/>
+                <a:cs typeface="Consolas" pitchFamily="49" charset="-120"/>
               </a:rPr>
               <a:t>CASE STUDIES · REAL DATA</a:t>
             </a:r>
@@ -23050,9 +23050,9 @@
                 <a:solidFill>
                   <a:srgbClr val="B4521A"/>
                 </a:solidFill>
-                <a:latin typeface="JetBrains Mono" pitchFamily="49" charset="0"/>
-                <a:ea typeface="JetBrains Mono" pitchFamily="49" charset="-122"/>
-                <a:cs typeface="JetBrains Mono" pitchFamily="49" charset="-120"/>
+                <a:latin typeface="Consolas" pitchFamily="49" charset="0"/>
+                <a:ea typeface="Consolas" pitchFamily="49" charset="-122"/>
+                <a:cs typeface="Consolas" pitchFamily="49" charset="-120"/>
               </a:rPr>
               <a:t>CASE A · SIMILAR PROVISIONS</a:t>
             </a:r>
@@ -25334,9 +25334,9 @@
                 <a:solidFill>
                   <a:srgbClr val="B4521A"/>
                 </a:solidFill>
-                <a:latin typeface="JetBrains Mono" pitchFamily="49" charset="0"/>
-                <a:ea typeface="JetBrains Mono" pitchFamily="49" charset="-122"/>
-                <a:cs typeface="JetBrains Mono" pitchFamily="49" charset="-120"/>
+                <a:latin typeface="Consolas" pitchFamily="49" charset="0"/>
+                <a:ea typeface="Consolas" pitchFamily="49" charset="-122"/>
+                <a:cs typeface="Consolas" pitchFamily="49" charset="-120"/>
               </a:rPr>
               <a:t>CASE B · MEMO SUGGESTIONS</a:t>
             </a:r>
@@ -27166,9 +27166,9 @@
                 <a:solidFill>
                   <a:srgbClr val="B4521A"/>
                 </a:solidFill>
-                <a:latin typeface="JetBrains Mono" pitchFamily="49" charset="0"/>
-                <a:ea typeface="JetBrains Mono" pitchFamily="49" charset="-122"/>
-                <a:cs typeface="JetBrains Mono" pitchFamily="49" charset="-120"/>
+                <a:latin typeface="Consolas" pitchFamily="49" charset="0"/>
+                <a:ea typeface="Consolas" pitchFamily="49" charset="-122"/>
+                <a:cs typeface="Consolas" pitchFamily="49" charset="-120"/>
               </a:rPr>
               <a:t>CASE STUDIES · LESSONS</a:t>
             </a:r>
@@ -27686,9 +27686,9 @@
                 <a:solidFill>
                   <a:srgbClr val="B4521A"/>
                 </a:solidFill>
-                <a:latin typeface="JetBrains Mono" pitchFamily="49" charset="0"/>
-                <a:ea typeface="JetBrains Mono" pitchFamily="49" charset="-122"/>
-                <a:cs typeface="JetBrains Mono" pitchFamily="49" charset="-120"/>
+                <a:latin typeface="Consolas" pitchFamily="49" charset="0"/>
+                <a:ea typeface="Consolas" pitchFamily="49" charset="-122"/>
+                <a:cs typeface="Consolas" pitchFamily="49" charset="-120"/>
               </a:rPr>
               <a:t>PRACTICAL GUIDANCE</a:t>
             </a:r>
@@ -28218,9 +28218,9 @@
                 <a:solidFill>
                   <a:srgbClr val="B4521A"/>
                 </a:solidFill>
-                <a:latin typeface="JetBrains Mono" pitchFamily="49" charset="0"/>
-                <a:ea typeface="JetBrains Mono" pitchFamily="49" charset="-122"/>
-                <a:cs typeface="JetBrains Mono" pitchFamily="49" charset="-120"/>
+                <a:latin typeface="Consolas" pitchFamily="49" charset="0"/>
+                <a:ea typeface="Consolas" pitchFamily="49" charset="-122"/>
+                <a:cs typeface="Consolas" pitchFamily="49" charset="-120"/>
               </a:rPr>
               <a:t>RUN IT YOURSELF</a:t>
             </a:r>
@@ -29329,9 +29329,9 @@
                 <a:solidFill>
                   <a:srgbClr val="F2A35E"/>
                 </a:solidFill>
-                <a:latin typeface="JetBrains Mono" pitchFamily="49" charset="0"/>
-                <a:ea typeface="JetBrains Mono" pitchFamily="49" charset="-122"/>
-                <a:cs typeface="JetBrains Mono" pitchFamily="49" charset="-120"/>
+                <a:latin typeface="Consolas" pitchFamily="49" charset="0"/>
+                <a:ea typeface="Consolas" pitchFamily="49" charset="-122"/>
+                <a:cs typeface="Consolas" pitchFamily="49" charset="-120"/>
               </a:rPr>
               <a:t>REFERENCES</a:t>
             </a:r>
@@ -29679,9 +29679,9 @@
                 <a:solidFill>
                   <a:srgbClr val="B4521A"/>
                 </a:solidFill>
-                <a:latin typeface="JetBrains Mono" pitchFamily="49" charset="0"/>
-                <a:ea typeface="JetBrains Mono" pitchFamily="49" charset="-122"/>
-                <a:cs typeface="JetBrains Mono" pitchFamily="49" charset="-120"/>
+                <a:latin typeface="Consolas" pitchFamily="49" charset="0"/>
+                <a:ea typeface="Consolas" pitchFamily="49" charset="-122"/>
+                <a:cs typeface="Consolas" pitchFamily="49" charset="-120"/>
               </a:rPr>
               <a:t>THE PROBLEM</a:t>
             </a:r>
@@ -29800,9 +29800,9 @@
                 <a:solidFill>
                   <a:srgbClr val="5F6979"/>
                 </a:solidFill>
-                <a:latin typeface="JetBrains Mono" pitchFamily="49" charset="0"/>
-                <a:ea typeface="JetBrains Mono" pitchFamily="49" charset="-122"/>
-                <a:cs typeface="JetBrains Mono" pitchFamily="49" charset="-120"/>
+                <a:latin typeface="Consolas" pitchFamily="49" charset="0"/>
+                <a:ea typeface="Consolas" pitchFamily="49" charset="-122"/>
+                <a:cs typeface="Consolas" pitchFamily="49" charset="-120"/>
               </a:rPr>
               <a:t>LLM KV CACHE · LLAMA-3.1-8B, FP16</a:t>
             </a:r>
@@ -29985,9 +29985,9 @@
                 <a:solidFill>
                   <a:srgbClr val="5F6979"/>
                 </a:solidFill>
-                <a:latin typeface="JetBrains Mono" pitchFamily="49" charset="0"/>
-                <a:ea typeface="JetBrains Mono" pitchFamily="49" charset="-122"/>
-                <a:cs typeface="JetBrains Mono" pitchFamily="49" charset="-120"/>
+                <a:latin typeface="Consolas" pitchFamily="49" charset="0"/>
+                <a:ea typeface="Consolas" pitchFamily="49" charset="-122"/>
+                <a:cs typeface="Consolas" pitchFamily="49" charset="-120"/>
               </a:rPr>
               <a:t>VECTOR INDEX · 1M × 1536-D FLOAT32</a:t>
             </a:r>
@@ -30186,9 +30186,9 @@
                 <a:solidFill>
                   <a:srgbClr val="B4521A"/>
                 </a:solidFill>
-                <a:latin typeface="JetBrains Mono" pitchFamily="49" charset="0"/>
-                <a:ea typeface="JetBrains Mono" pitchFamily="49" charset="-122"/>
-                <a:cs typeface="JetBrains Mono" pitchFamily="49" charset="-120"/>
+                <a:latin typeface="Consolas" pitchFamily="49" charset="0"/>
+                <a:ea typeface="Consolas" pitchFamily="49" charset="-122"/>
+                <a:cs typeface="Consolas" pitchFamily="49" charset="-120"/>
               </a:rPr>
               <a:t>BACKGROUND · QUANTIZATION</a:t>
             </a:r>
@@ -30376,9 +30376,9 @@
                 <a:solidFill>
                   <a:srgbClr val="B4521A"/>
                 </a:solidFill>
-                <a:latin typeface="JetBrains Mono" pitchFamily="49" charset="0"/>
-                <a:ea typeface="JetBrains Mono" pitchFamily="49" charset="-122"/>
-                <a:cs typeface="JetBrains Mono" pitchFamily="49" charset="-120"/>
+                <a:latin typeface="Consolas" pitchFamily="49" charset="0"/>
+                <a:ea typeface="Consolas" pitchFamily="49" charset="-122"/>
+                <a:cs typeface="Consolas" pitchFamily="49" charset="-120"/>
               </a:rPr>
               <a:t>THE HIDDEN TAX</a:t>
             </a:r>
@@ -32390,9 +32390,9 @@
                 <a:solidFill>
                   <a:srgbClr val="B4521A"/>
                 </a:solidFill>
-                <a:latin typeface="JetBrains Mono" pitchFamily="49" charset="0"/>
-                <a:ea typeface="JetBrains Mono" pitchFamily="49" charset="-122"/>
-                <a:cs typeface="JetBrains Mono" pitchFamily="49" charset="-120"/>
+                <a:latin typeface="Consolas" pitchFamily="49" charset="0"/>
+                <a:ea typeface="Consolas" pitchFamily="49" charset="-122"/>
+                <a:cs typeface="Consolas" pitchFamily="49" charset="-120"/>
               </a:rPr>
               <a:t>THREE PAPERS, ONE IDEA</a:t>
             </a:r>
@@ -32511,9 +32511,9 @@
                 <a:solidFill>
                   <a:srgbClr val="5F6979"/>
                 </a:solidFill>
-                <a:latin typeface="JetBrains Mono" pitchFamily="49" charset="0"/>
-                <a:ea typeface="JetBrains Mono" pitchFamily="49" charset="-122"/>
-                <a:cs typeface="JetBrains Mono" pitchFamily="49" charset="-120"/>
+                <a:latin typeface="Consolas" pitchFamily="49" charset="0"/>
+                <a:ea typeface="Consolas" pitchFamily="49" charset="-122"/>
+                <a:cs typeface="Consolas" pitchFamily="49" charset="-120"/>
               </a:rPr>
               <a:t>JUN 2024 · 2406.03482</a:t>
             </a:r>
@@ -32674,9 +32674,9 @@
                 <a:solidFill>
                   <a:srgbClr val="5F6979"/>
                 </a:solidFill>
-                <a:latin typeface="JetBrains Mono" pitchFamily="49" charset="0"/>
-                <a:ea typeface="JetBrains Mono" pitchFamily="49" charset="-122"/>
-                <a:cs typeface="JetBrains Mono" pitchFamily="49" charset="-120"/>
+                <a:latin typeface="Consolas" pitchFamily="49" charset="0"/>
+                <a:ea typeface="Consolas" pitchFamily="49" charset="-122"/>
+                <a:cs typeface="Consolas" pitchFamily="49" charset="-120"/>
               </a:rPr>
               <a:t>FEB 2025 · 2502.02617</a:t>
             </a:r>
@@ -32832,9 +32832,9 @@
                 <a:solidFill>
                   <a:srgbClr val="F2A35E"/>
                 </a:solidFill>
-                <a:latin typeface="JetBrains Mono" pitchFamily="49" charset="0"/>
-                <a:ea typeface="JetBrains Mono" pitchFamily="49" charset="-122"/>
-                <a:cs typeface="JetBrains Mono" pitchFamily="49" charset="-120"/>
+                <a:latin typeface="Consolas" pitchFamily="49" charset="0"/>
+                <a:ea typeface="Consolas" pitchFamily="49" charset="-122"/>
+                <a:cs typeface="Consolas" pitchFamily="49" charset="-120"/>
               </a:rPr>
               <a:t>APR 2025 · 2504.19874</a:t>
             </a:r>
@@ -33033,9 +33033,9 @@
                 <a:solidFill>
                   <a:srgbClr val="B4521A"/>
                 </a:solidFill>
-                <a:latin typeface="JetBrains Mono" pitchFamily="49" charset="0"/>
-                <a:ea typeface="JetBrains Mono" pitchFamily="49" charset="-122"/>
-                <a:cs typeface="JetBrains Mono" pitchFamily="49" charset="-120"/>
+                <a:latin typeface="Consolas" pitchFamily="49" charset="0"/>
+                <a:ea typeface="Consolas" pitchFamily="49" charset="-122"/>
+                <a:cs typeface="Consolas" pitchFamily="49" charset="-120"/>
               </a:rPr>
               <a:t>QJL · WORKED EXAMPLE</a:t>
             </a:r>
@@ -33180,9 +33180,9 @@
                 <a:solidFill>
                   <a:srgbClr val="0F1B2D"/>
                 </a:solidFill>
-                <a:latin typeface="JetBrains Mono" pitchFamily="49" charset="0"/>
-                <a:ea typeface="JetBrains Mono" pitchFamily="49" charset="-122"/>
-                <a:cs typeface="JetBrains Mono" pitchFamily="49" charset="-120"/>
+                <a:latin typeface="Consolas" pitchFamily="49" charset="0"/>
+                <a:ea typeface="Consolas" pitchFamily="49" charset="-122"/>
+                <a:cs typeface="Consolas" pitchFamily="49" charset="-120"/>
               </a:rPr>
               <a:t>k = [3, −4, 2, 0.5]</a:t>
             </a:r>
@@ -33384,9 +33384,9 @@
                 <a:solidFill>
                   <a:srgbClr val="0F1B2D"/>
                 </a:solidFill>
-                <a:latin typeface="JetBrains Mono" pitchFamily="49" charset="0"/>
-                <a:ea typeface="JetBrains Mono" pitchFamily="49" charset="-122"/>
-                <a:cs typeface="JetBrains Mono" pitchFamily="49" charset="-120"/>
+                <a:latin typeface="Consolas" pitchFamily="49" charset="0"/>
+                <a:ea typeface="Consolas" pitchFamily="49" charset="-122"/>
+                <a:cs typeface="Consolas" pitchFamily="49" charset="-120"/>
               </a:rPr>
               <a:t> 0.5 −0.2  0.8 −0.1</a:t>
             </a:r>
@@ -33407,9 +33407,9 @@
                 <a:solidFill>
                   <a:srgbClr val="0F1B2D"/>
                 </a:solidFill>
-                <a:latin typeface="JetBrains Mono" pitchFamily="49" charset="0"/>
-                <a:ea typeface="JetBrains Mono" pitchFamily="49" charset="-122"/>
-                <a:cs typeface="JetBrains Mono" pitchFamily="49" charset="-120"/>
+                <a:latin typeface="Consolas" pitchFamily="49" charset="0"/>
+                <a:ea typeface="Consolas" pitchFamily="49" charset="-122"/>
+                <a:cs typeface="Consolas" pitchFamily="49" charset="-120"/>
               </a:rPr>
               <a:t>−0.9  0.1  0.3  0.7</a:t>
             </a:r>
@@ -33430,9 +33430,9 @@
                 <a:solidFill>
                   <a:srgbClr val="0F1B2D"/>
                 </a:solidFill>
-                <a:latin typeface="JetBrains Mono" pitchFamily="49" charset="0"/>
-                <a:ea typeface="JetBrains Mono" pitchFamily="49" charset="-122"/>
-                <a:cs typeface="JetBrains Mono" pitchFamily="49" charset="-120"/>
+                <a:latin typeface="Consolas" pitchFamily="49" charset="0"/>
+                <a:ea typeface="Consolas" pitchFamily="49" charset="-122"/>
+                <a:cs typeface="Consolas" pitchFamily="49" charset="-120"/>
               </a:rPr>
               <a:t> 0.2  0.6 −0.4 −0.5</a:t>
             </a:r>
@@ -33588,9 +33588,9 @@
                 <a:solidFill>
                   <a:srgbClr val="0F1B2D"/>
                 </a:solidFill>
-                <a:latin typeface="JetBrains Mono" pitchFamily="49" charset="0"/>
-                <a:ea typeface="JetBrains Mono" pitchFamily="49" charset="-122"/>
-                <a:cs typeface="JetBrains Mono" pitchFamily="49" charset="-120"/>
+                <a:latin typeface="Consolas" pitchFamily="49" charset="0"/>
+                <a:ea typeface="Consolas" pitchFamily="49" charset="-122"/>
+                <a:cs typeface="Consolas" pitchFamily="49" charset="-120"/>
               </a:rPr>
               <a:t>100</a:t>
             </a:r>
@@ -34056,9 +34056,9 @@
                 <a:solidFill>
                   <a:srgbClr val="B4521A"/>
                 </a:solidFill>
-                <a:latin typeface="JetBrains Mono" pitchFamily="49" charset="0"/>
-                <a:ea typeface="JetBrains Mono" pitchFamily="49" charset="-122"/>
-                <a:cs typeface="JetBrains Mono" pitchFamily="49" charset="-120"/>
+                <a:latin typeface="Consolas" pitchFamily="49" charset="0"/>
+                <a:ea typeface="Consolas" pitchFamily="49" charset="-122"/>
+                <a:cs typeface="Consolas" pitchFamily="49" charset="-120"/>
               </a:rPr>
               <a:t>POLARQUANT · WORKED EXAMPLE</a:t>
             </a:r>
@@ -34883,9 +34883,9 @@
                 <a:solidFill>
                   <a:srgbClr val="5F6979"/>
                 </a:solidFill>
-                <a:latin typeface="JetBrains Mono" pitchFamily="49" charset="0"/>
-                <a:ea typeface="JetBrains Mono" pitchFamily="49" charset="-122"/>
-                <a:cs typeface="JetBrains Mono" pitchFamily="49" charset="-120"/>
+                <a:latin typeface="Consolas" pitchFamily="49" charset="0"/>
+                <a:ea typeface="Consolas" pitchFamily="49" charset="-122"/>
+                <a:cs typeface="Consolas" pitchFamily="49" charset="-120"/>
               </a:rPr>
               <a:t>LEVEL 2</a:t>
             </a:r>
@@ -34927,9 +34927,9 @@
                 <a:solidFill>
                   <a:srgbClr val="5F6979"/>
                 </a:solidFill>
-                <a:latin typeface="JetBrains Mono" pitchFamily="49" charset="0"/>
-                <a:ea typeface="JetBrains Mono" pitchFamily="49" charset="-122"/>
-                <a:cs typeface="JetBrains Mono" pitchFamily="49" charset="-120"/>
+                <a:latin typeface="Consolas" pitchFamily="49" charset="0"/>
+                <a:ea typeface="Consolas" pitchFamily="49" charset="-122"/>
+                <a:cs typeface="Consolas" pitchFamily="49" charset="-120"/>
               </a:rPr>
               <a:t>LEVEL 1</a:t>
             </a:r>
@@ -34971,9 +34971,9 @@
                 <a:solidFill>
                   <a:srgbClr val="5F6979"/>
                 </a:solidFill>
-                <a:latin typeface="JetBrains Mono" pitchFamily="49" charset="0"/>
-                <a:ea typeface="JetBrains Mono" pitchFamily="49" charset="-122"/>
-                <a:cs typeface="JetBrains Mono" pitchFamily="49" charset="-120"/>
+                <a:latin typeface="Consolas" pitchFamily="49" charset="0"/>
+                <a:ea typeface="Consolas" pitchFamily="49" charset="-122"/>
+                <a:cs typeface="Consolas" pitchFamily="49" charset="-120"/>
               </a:rPr>
               <a:t>INPUT</a:t>
             </a:r>
@@ -35468,9 +35468,9 @@
                 <a:solidFill>
                   <a:srgbClr val="B4521A"/>
                 </a:solidFill>
-                <a:latin typeface="JetBrains Mono" pitchFamily="49" charset="0"/>
-                <a:ea typeface="JetBrains Mono" pitchFamily="49" charset="-122"/>
-                <a:cs typeface="JetBrains Mono" pitchFamily="49" charset="-120"/>
+                <a:latin typeface="Consolas" pitchFamily="49" charset="0"/>
+                <a:ea typeface="Consolas" pitchFamily="49" charset="-122"/>
+                <a:cs typeface="Consolas" pitchFamily="49" charset="-120"/>
               </a:rPr>
               <a:t>STAGE 1 · TURBOQUANT_MSE</a:t>
             </a:r>

</xml_diff>

<commit_message>
Slide 12: compare the 44 stored bits with 128 bits of float32
</commit_message>
<xml_diff>
--- a/docs/TurboQuant.pptx
+++ b/docs/TurboQuant.pptx
@@ -2055,7 +2055,7 @@
           <a:lstStyle/>
           <a:p>
             <a:r>
-              <a:t>Now the whole of TurboQuant on the same four numbers, at 3 bits per coordinate: 2 bits for the MSE stage and 1 bit for QJL. Store the norm, 5.41, and work on the direction. Rotate: to keep the arithmetic on a slide we use a Hadamard matrix with random signs, a fast random rotation; the reference code uses a dense one. The coordinates change to 4.25, 0.75, 2.75 and minus 1.75, but the length does not. Divide by the norm and round each coordinate with the fixed Lloyd-Max codebook for d equals 4, plus or minus 0.219 and 0.674: 8 bits of codes. Decoding rotates the centroids back: 3.65, minus 3.65, 1.19, 1.19, and the score with our query drops to 8.48, the shrinkage bias. Stage two takes the residual, norm 1.29, and stores the signs of a 4 by 4 Gaussian projection of it: 1 1 0 0. At query time the correction is root pi over 2, over 4, times 1.29, times 0.8, which is 0.32, so the estimate is 8.81 against 9. Over 20,000 random rotations the MSE stage alone averages 8.32 and the full estimate 9.00: the QJL bit removes the bias.</a:t>
+              <a:t>Now the whole of TurboQuant on the same four numbers, at 3 bits per coordinate: 2 bits for the MSE stage and 1 bit for QJL. Store the norm, 5.41, and work on the direction. Rotate: to keep the arithmetic on a slide we use a Hadamard matrix with random signs, a fast random rotation; the reference code uses a dense one. The coordinates change to 4.25, 0.75, 2.75 and minus 1.75, but the length does not. Divide by the norm and round each coordinate with the fixed Lloyd-Max codebook for d equals 4, plus or minus 0.219 and 0.674: 8 bits of codes. Decoding rotates the centroids back: 3.65, minus 3.65, 1.19, 1.19, and the score with our query drops to 8.48, the shrinkage bias. Stage two takes the residual, norm 1.29, and stores the signs of a 4 by 4 Gaussian projection of it: 1 1 0 0. At query time the correction is root pi over 2, over 4, times 1.29, times 0.8, which is 0.32, so the estimate is 8.81 against 9. Over 20,000 random rotations the MSE stage alone averages 8.32 and the full estimate 9.00: the QJL bit removes the bias. What stays in memory: 8 bits of codes, 4 sign bits and two fp16 norms of 16 bits each, 44 bits in total, against 128 bits for the four numbers in float32.</a:t>
             </a:r>
           </a:p>
         </p:txBody>
@@ -7531,7 +7531,7 @@
                 <a:ea typeface="IBM Plex Sans" pitchFamily="34" charset="-122"/>
                 <a:cs typeface="IBM Plex Sans" pitchFamily="34" charset="-120"/>
               </a:rPr>
-              <a:t>44 bits stored instead of 64</a:t>
+              <a:t>44 bits stored instead of 128</a:t>
             </a:r>
             <a:endParaRPr lang="en-US" sz="1100" dirty="0"/>
           </a:p>

</xml_diff>

<commit_message>
Fix overlapping plot labels and update docs with the WikiText-2 run
- Cells 14 and 21: labels placed without overlap (leader lines for moved ones); figures regenerated from the saved results
- Needle markdown matches the real-text results
- Guides 7.1 and section 10, README, handoff and deck slides 21-22 use the real perplexity, KL, top-1 and needle numbers
</commit_message>
<xml_diff>
--- a/docs/TurboQuant.pptx
+++ b/docs/TurboQuant.pptx
@@ -15044,7 +15044,7 @@
                 </a:solidFill>
                 <a:latin typeface="IBM Plex Sans"/>
               </a:rPr>
-              <a:t>KV cache for one 8,083-token prompt, MB (effective bits per channel)</a:t>
+              <a:t>KV cache for one 8,084-token prompt, MB (effective bits per channel)</a:t>
             </a:r>
           </a:p>
         </p:txBody>
@@ -29548,7 +29548,7 @@
         <p:spPr>
           <a:xfrm>
             <a:off x="822960" y="2103120"/>
-            <a:ext cx="10552176" cy="2747536"/>
+            <a:ext cx="10552176" cy="2753896"/>
           </a:xfrm>
           <a:prstGeom prst="roundRect">
             <a:avLst>
@@ -29604,7 +29604,7 @@
         <p:spPr>
           <a:xfrm>
             <a:off x="932688" y="2212848"/>
-            <a:ext cx="10332720" cy="2528080"/>
+            <a:ext cx="10332720" cy="2534440"/>
           </a:xfrm>
           <a:prstGeom prst="rect">
             <a:avLst/>
@@ -29619,7 +29619,7 @@
         </p:nvSpPr>
         <p:spPr>
           <a:xfrm>
-            <a:off x="822960" y="5079256"/>
+            <a:off x="822960" y="5085616"/>
             <a:ext cx="3291840" cy="914400"/>
           </a:xfrm>
           <a:prstGeom prst="rect">
@@ -29663,7 +29663,7 @@
         </p:nvSpPr>
         <p:spPr>
           <a:xfrm>
-            <a:off x="4343400" y="5079256"/>
+            <a:off x="4343400" y="5085616"/>
             <a:ext cx="3291840" cy="914400"/>
           </a:xfrm>
           <a:prstGeom prst="rect">
@@ -29707,7 +29707,7 @@
         </p:nvSpPr>
         <p:spPr>
           <a:xfrm>
-            <a:off x="7863840" y="5079256"/>
+            <a:off x="7863840" y="5085616"/>
             <a:ext cx="3291840" cy="914400"/>
           </a:xfrm>
           <a:prstGeom prst="rect">
@@ -29896,7 +29896,7 @@
                 <a:ea typeface="IBM Plex Sans" pitchFamily="34" charset="-122"/>
                 <a:cs typeface="IBM Plex Sans" pitchFamily="34" charset="-120"/>
               </a:rPr>
-              <a:t>At 2 bits TurboQuant still finds the needle</a:t>
+              <a:t>TurboQuant keeps the needle; INT2 loses it</a:t>
             </a:r>
             <a:endParaRPr lang="en-US" sz="3200" dirty="0"/>
           </a:p>
@@ -29911,7 +29911,7 @@
         <p:spPr>
           <a:xfrm>
             <a:off x="822960" y="2103120"/>
-            <a:ext cx="6620256" cy="3507078"/>
+            <a:ext cx="6620256" cy="3510528"/>
           </a:xfrm>
           <a:prstGeom prst="roundRect">
             <a:avLst>
@@ -29967,7 +29967,7 @@
         <p:spPr>
           <a:xfrm>
             <a:off x="932688" y="2212848"/>
-            <a:ext cx="6400800" cy="3287622"/>
+            <a:ext cx="6400800" cy="3291072"/>
           </a:xfrm>
           <a:prstGeom prst="rect">
             <a:avLst/>
@@ -30182,7 +30182,7 @@
                 </a:solidFill>
                 <a:latin typeface="IBM Plex Sans"/>
               </a:rPr>
-              <a:t>9 of 9</a:t>
+              <a:t>7 of 9</a:t>
             </a:r>
           </a:p>
         </p:txBody>
@@ -30226,7 +30226,7 @@
                 </a:solidFill>
                 <a:latin typeface="IBM Plex Sans"/>
               </a:rPr>
-              <a:t>9 of 9</a:t>
+              <a:t>8 of 9</a:t>
             </a:r>
           </a:p>
         </p:txBody>
@@ -30270,7 +30270,7 @@
                 </a:solidFill>
                 <a:latin typeface="IBM Plex Sans"/>
               </a:rPr>
-              <a:t>7 of 9</a:t>
+              <a:t>3 of 9</a:t>
             </a:r>
           </a:p>
         </p:txBody>
@@ -30348,7 +30348,7 @@
                 <a:ea typeface="IBM Plex Sans" pitchFamily="34" charset="-122"/>
                 <a:cs typeface="IBM Plex Sans" pitchFamily="34" charset="-120"/>
               </a:rPr>
-              <a:t>Section 4 of llm_kv_cache_demo.ipynb, run on an A100 on 11 Oct 2026. In this run the filler was one sentence repeated, because WikiText-2 did not load; the notebook now loads WikiText-2, a harder haystack.</a:t>
+              <a:t>Section 4 of llm_kv_cache_demo.ipynb, run on an A100 on 11 Oct 2026. The haystack is WikiText-2 text; most misses returned part of the code (e.g. 7319 or ALPHA-42).</a:t>
             </a:r>
             <a:endParaRPr lang="en-US" sz="1200" dirty="0"/>
           </a:p>
@@ -30977,7 +30977,7 @@
                 <a:ea typeface="IBM Plex Sans" pitchFamily="34" charset="-122"/>
                 <a:cs typeface="IBM Plex Sans" pitchFamily="34" charset="-120"/>
               </a:rPr>
-              <a:t>At equal bits, TurboQuant drifts less than INT-b</a:t>
+              <a:t>At equal size, TurboQuant beats INT-b</a:t>
             </a:r>
             <a:endParaRPr lang="en-US" sz="3200" dirty="0"/>
           </a:p>
@@ -30999,19 +30999,20 @@
         </p:nvGraphicFramePr>
         <p:xfrm>
           <a:off x="822960" y="2103120"/>
-          <a:ext cx="6035040" cy="3291840"/>
+          <a:ext cx="6309360" cy="3383280"/>
         </p:xfrm>
         <a:graphic>
           <a:graphicData uri="http://schemas.openxmlformats.org/drawingml/2006/table">
             <a:tbl>
               <a:tblPr/>
               <a:tblGrid>
-                <a:gridCol w="2743200"/>
-                <a:gridCol w="1051560"/>
-                <a:gridCol w="1188720"/>
-                <a:gridCol w="1051560"/>
+                <a:gridCol w="2423160"/>
+                <a:gridCol w="914400"/>
+                <a:gridCol w="1097280"/>
+                <a:gridCol w="960120"/>
+                <a:gridCol w="914400"/>
               </a:tblGrid>
-              <a:tr h="365760">
+              <a:tr h="338328">
                 <a:tc>
                   <a:txBody>
                     <a:bodyPr/>
@@ -31174,7 +31175,78 @@
                           <a:ea typeface="IBM Plex Sans" pitchFamily="34" charset="-122"/>
                           <a:cs typeface="IBM Plex Sans" pitchFamily="34" charset="-120"/>
                         </a:rPr>
-                        <a:t>KL vs FP16</a:t>
+                        <a:t>Perplexity</a:t>
+                      </a:r>
+                      <a:endParaRPr lang="en-US" sz="1247" dirty="0">
+                        <a:latin typeface="IBM Plex Sans" charset="0"/>
+                        <a:ea typeface="IBM Plex Sans" charset="0"/>
+                        <a:cs typeface="IBM Plex Sans" charset="0"/>
+                      </a:endParaRPr>
+                    </a:p>
+                  </a:txBody>
+                  <a:tcPr marL="55437" marR="55437" marT="55437" marB="55437" anchor="t">
+                    <a:lnL w="12700" cap="flat" cmpd="sng" algn="ctr">
+                      <a:solidFill>
+                        <a:srgbClr val="B6B5B1"/>
+                      </a:solidFill>
+                      <a:prstDash val="solid"/>
+                      <a:round/>
+                      <a:headEnd type="none" w="med" len="med"/>
+                      <a:tailEnd type="none" w="med" len="med"/>
+                    </a:lnL>
+                    <a:lnR w="12700" cap="flat" cmpd="sng" algn="ctr">
+                      <a:solidFill>
+                        <a:srgbClr val="B6B5B1"/>
+                      </a:solidFill>
+                      <a:prstDash val="solid"/>
+                      <a:round/>
+                      <a:headEnd type="none" w="med" len="med"/>
+                      <a:tailEnd type="none" w="med" len="med"/>
+                    </a:lnR>
+                    <a:lnT w="12700" cap="flat" cmpd="sng" algn="ctr">
+                      <a:solidFill>
+                        <a:srgbClr val="C4C4BF"/>
+                      </a:solidFill>
+                      <a:prstDash val="solid"/>
+                      <a:round/>
+                      <a:headEnd type="none" w="med" len="med"/>
+                      <a:tailEnd type="none" w="med" len="med"/>
+                    </a:lnT>
+                    <a:lnB w="12700" cap="flat" cmpd="sng" algn="ctr">
+                      <a:solidFill>
+                        <a:srgbClr val="B6B5B1"/>
+                      </a:solidFill>
+                      <a:prstDash val="solid"/>
+                      <a:round/>
+                      <a:headEnd type="none" w="med" len="med"/>
+                      <a:tailEnd type="none" w="med" len="med"/>
+                    </a:lnB>
+                    <a:solidFill>
+                      <a:srgbClr val="E4E3DE"/>
+                    </a:solidFill>
+                  </a:tcPr>
+                </a:tc>
+                <a:tc>
+                  <a:txBody>
+                    <a:bodyPr/>
+                    <a:lstStyle/>
+                    <a:p>
+                      <a:pPr algn="r" indent="0" marL="0">
+                        <a:lnSpc>
+                          <a:spcPts val="1746"/>
+                        </a:lnSpc>
+                        <a:buNone/>
+                      </a:pPr>
+                      <a:r>
+                        <a:rPr lang="en-US" sz="1247" b="1" dirty="0">
+                          <a:solidFill>
+                            <a:srgbClr val="1B2433"/>
+                          </a:solidFill>
+                          <a:latin typeface="IBM Plex Sans" pitchFamily="34" charset="0"/>
+                          <a:ea typeface="IBM Plex Sans" pitchFamily="34" charset="-122"/>
+                          <a:cs typeface="IBM Plex Sans" pitchFamily="34" charset="-120"/>
+                        </a:rPr>
+                        <a:t>KL</a:t>
                       </a:r>
                       <a:endParaRPr lang="en-US" sz="1247" dirty="0">
                         <a:latin typeface="IBM Plex Sans" charset="0"/>
@@ -31297,7 +31369,349 @@
                   </a:tcPr>
                 </a:tc>
               </a:tr>
-              <a:tr h="365760">
+              <a:tr h="338328">
+                <a:tc>
+                  <a:txBody>
+                    <a:bodyPr/>
+                    <a:lstStyle/>
+                    <a:p>
+                      <a:pPr indent="0" marL="0">
+                        <a:lnSpc>
+                          <a:spcPts val="1746"/>
+                        </a:lnSpc>
+                        <a:buNone/>
+                      </a:pPr>
+                      <a:r>
+                        <a:rPr lang="en-US" sz="1247" dirty="0">
+                          <a:solidFill>
+                            <a:srgbClr val="1B2433"/>
+                          </a:solidFill>
+                          <a:latin typeface="IBM Plex Sans" pitchFamily="34" charset="0"/>
+                          <a:ea typeface="IBM Plex Sans" pitchFamily="34" charset="-122"/>
+                          <a:cs typeface="IBM Plex Sans" pitchFamily="34" charset="-120"/>
+                        </a:rPr>
+                        <a:t>FP16</a:t>
+                      </a:r>
+                      <a:endParaRPr lang="en-US" sz="1247" dirty="0">
+                        <a:latin typeface="IBM Plex Sans" charset="0"/>
+                        <a:ea typeface="IBM Plex Sans" charset="0"/>
+                        <a:cs typeface="IBM Plex Sans" charset="0"/>
+                      </a:endParaRPr>
+                    </a:p>
+                  </a:txBody>
+                  <a:tcPr marL="55437" marR="55437" marT="55437" marB="55437" anchor="t">
+                    <a:lnL w="12700" cap="flat" cmpd="sng" algn="ctr">
+                      <a:solidFill>
+                        <a:srgbClr val="C4C4BF"/>
+                      </a:solidFill>
+                      <a:prstDash val="solid"/>
+                      <a:round/>
+                      <a:headEnd type="none" w="med" len="med"/>
+                      <a:tailEnd type="none" w="med" len="med"/>
+                    </a:lnL>
+                    <a:lnR w="12700" cap="flat" cmpd="sng" algn="ctr">
+                      <a:solidFill>
+                        <a:srgbClr val="C4C4BF"/>
+                      </a:solidFill>
+                      <a:prstDash val="solid"/>
+                      <a:round/>
+                      <a:headEnd type="none" w="med" len="med"/>
+                      <a:tailEnd type="none" w="med" len="med"/>
+                    </a:lnR>
+                    <a:lnT w="12700" cap="flat" cmpd="sng" algn="ctr">
+                      <a:solidFill>
+                        <a:srgbClr val="C8BAB0"/>
+                      </a:solidFill>
+                      <a:prstDash val="solid"/>
+                      <a:round/>
+                      <a:headEnd type="none" w="med" len="med"/>
+                      <a:tailEnd type="none" w="med" len="med"/>
+                    </a:lnT>
+                    <a:lnB w="12700" cap="flat" cmpd="sng" algn="ctr">
+                      <a:solidFill>
+                        <a:srgbClr val="C4C4BF"/>
+                      </a:solidFill>
+                      <a:prstDash val="solid"/>
+                      <a:round/>
+                      <a:headEnd type="none" w="med" len="med"/>
+                      <a:tailEnd type="none" w="med" len="med"/>
+                    </a:lnB>
+                  </a:tcPr>
+                </a:tc>
+                <a:tc>
+                  <a:txBody>
+                    <a:bodyPr/>
+                    <a:lstStyle/>
+                    <a:p>
+                      <a:pPr algn="r" indent="0" marL="0">
+                        <a:lnSpc>
+                          <a:spcPts val="1746"/>
+                        </a:lnSpc>
+                        <a:buNone/>
+                      </a:pPr>
+                      <a:r>
+                        <a:rPr lang="en-US" sz="1247" dirty="0">
+                          <a:solidFill>
+                            <a:srgbClr val="1B2433"/>
+                          </a:solidFill>
+                          <a:latin typeface="IBM Plex Sans" pitchFamily="34" charset="0"/>
+                          <a:ea typeface="IBM Plex Sans" pitchFamily="34" charset="-122"/>
+                          <a:cs typeface="IBM Plex Sans" pitchFamily="34" charset="-120"/>
+                        </a:rPr>
+                        <a:t>16</a:t>
+                      </a:r>
+                      <a:endParaRPr lang="en-US" sz="1247" dirty="0">
+                        <a:latin typeface="IBM Plex Sans" charset="0"/>
+                        <a:ea typeface="IBM Plex Sans" charset="0"/>
+                        <a:cs typeface="IBM Plex Sans" charset="0"/>
+                      </a:endParaRPr>
+                    </a:p>
+                  </a:txBody>
+                  <a:tcPr marL="55437" marR="55437" marT="55437" marB="55437" anchor="t">
+                    <a:lnL w="12700" cap="flat" cmpd="sng" algn="ctr">
+                      <a:solidFill>
+                        <a:srgbClr val="C4C4BF"/>
+                      </a:solidFill>
+                      <a:prstDash val="solid"/>
+                      <a:round/>
+                      <a:headEnd type="none" w="med" len="med"/>
+                      <a:tailEnd type="none" w="med" len="med"/>
+                    </a:lnL>
+                    <a:lnR w="12700" cap="flat" cmpd="sng" algn="ctr">
+                      <a:solidFill>
+                        <a:srgbClr val="C4C4BF"/>
+                      </a:solidFill>
+                      <a:prstDash val="solid"/>
+                      <a:round/>
+                      <a:headEnd type="none" w="med" len="med"/>
+                      <a:tailEnd type="none" w="med" len="med"/>
+                    </a:lnR>
+                    <a:lnT w="12700" cap="flat" cmpd="sng" algn="ctr">
+                      <a:solidFill>
+                        <a:srgbClr val="C8BAB0"/>
+                      </a:solidFill>
+                      <a:prstDash val="solid"/>
+                      <a:round/>
+                      <a:headEnd type="none" w="med" len="med"/>
+                      <a:tailEnd type="none" w="med" len="med"/>
+                    </a:lnT>
+                    <a:lnB w="12700" cap="flat" cmpd="sng" algn="ctr">
+                      <a:solidFill>
+                        <a:srgbClr val="C4C4BF"/>
+                      </a:solidFill>
+                      <a:prstDash val="solid"/>
+                      <a:round/>
+                      <a:headEnd type="none" w="med" len="med"/>
+                      <a:tailEnd type="none" w="med" len="med"/>
+                    </a:lnB>
+                  </a:tcPr>
+                </a:tc>
+                <a:tc>
+                  <a:txBody>
+                    <a:bodyPr/>
+                    <a:lstStyle/>
+                    <a:p>
+                      <a:pPr algn="r" indent="0" marL="0">
+                        <a:lnSpc>
+                          <a:spcPts val="1746"/>
+                        </a:lnSpc>
+                        <a:buNone/>
+                      </a:pPr>
+                      <a:r>
+                        <a:rPr lang="en-US" sz="1247" dirty="0">
+                          <a:solidFill>
+                            <a:srgbClr val="1B2433"/>
+                          </a:solidFill>
+                          <a:latin typeface="IBM Plex Sans" pitchFamily="34" charset="0"/>
+                          <a:ea typeface="IBM Plex Sans" pitchFamily="34" charset="-122"/>
+                          <a:cs typeface="IBM Plex Sans" pitchFamily="34" charset="-120"/>
+                        </a:rPr>
+                        <a:t>5.71</a:t>
+                      </a:r>
+                      <a:endParaRPr lang="en-US" sz="1247" dirty="0">
+                        <a:latin typeface="IBM Plex Sans" charset="0"/>
+                        <a:ea typeface="IBM Plex Sans" charset="0"/>
+                        <a:cs typeface="IBM Plex Sans" charset="0"/>
+                      </a:endParaRPr>
+                    </a:p>
+                  </a:txBody>
+                  <a:tcPr marL="55437" marR="55437" marT="55437" marB="55437" anchor="t">
+                    <a:lnL w="12700" cap="flat" cmpd="sng" algn="ctr">
+                      <a:solidFill>
+                        <a:srgbClr val="C4C4BF"/>
+                      </a:solidFill>
+                      <a:prstDash val="solid"/>
+                      <a:round/>
+                      <a:headEnd type="none" w="med" len="med"/>
+                      <a:tailEnd type="none" w="med" len="med"/>
+                    </a:lnL>
+                    <a:lnR w="12700" cap="flat" cmpd="sng" algn="ctr">
+                      <a:solidFill>
+                        <a:srgbClr val="C4C4BF"/>
+                      </a:solidFill>
+                      <a:prstDash val="solid"/>
+                      <a:round/>
+                      <a:headEnd type="none" w="med" len="med"/>
+                      <a:tailEnd type="none" w="med" len="med"/>
+                    </a:lnR>
+                    <a:lnT w="12700" cap="flat" cmpd="sng" algn="ctr">
+                      <a:solidFill>
+                        <a:srgbClr val="C8BAB0"/>
+                      </a:solidFill>
+                      <a:prstDash val="solid"/>
+                      <a:round/>
+                      <a:headEnd type="none" w="med" len="med"/>
+                      <a:tailEnd type="none" w="med" len="med"/>
+                    </a:lnT>
+                    <a:lnB w="12700" cap="flat" cmpd="sng" algn="ctr">
+                      <a:solidFill>
+                        <a:srgbClr val="C4C4BF"/>
+                      </a:solidFill>
+                      <a:prstDash val="solid"/>
+                      <a:round/>
+                      <a:headEnd type="none" w="med" len="med"/>
+                      <a:tailEnd type="none" w="med" len="med"/>
+                    </a:lnB>
+                  </a:tcPr>
+                </a:tc>
+                <a:tc>
+                  <a:txBody>
+                    <a:bodyPr/>
+                    <a:lstStyle/>
+                    <a:p>
+                      <a:pPr algn="r" indent="0" marL="0">
+                        <a:lnSpc>
+                          <a:spcPts val="1746"/>
+                        </a:lnSpc>
+                        <a:buNone/>
+                      </a:pPr>
+                      <a:r>
+                        <a:rPr lang="en-US" sz="1247" dirty="0">
+                          <a:solidFill>
+                            <a:srgbClr val="1B2433"/>
+                          </a:solidFill>
+                          <a:latin typeface="IBM Plex Sans" pitchFamily="34" charset="0"/>
+                          <a:ea typeface="IBM Plex Sans" pitchFamily="34" charset="-122"/>
+                          <a:cs typeface="IBM Plex Sans" pitchFamily="34" charset="-120"/>
+                        </a:rPr>
+                        <a:t>0</a:t>
+                      </a:r>
+                      <a:endParaRPr lang="en-US" sz="1247" dirty="0">
+                        <a:latin typeface="IBM Plex Sans" charset="0"/>
+                        <a:ea typeface="IBM Plex Sans" charset="0"/>
+                        <a:cs typeface="IBM Plex Sans" charset="0"/>
+                      </a:endParaRPr>
+                    </a:p>
+                  </a:txBody>
+                  <a:tcPr marL="55437" marR="55437" marT="55437" marB="55437" anchor="t">
+                    <a:lnL w="12700" cap="flat" cmpd="sng" algn="ctr">
+                      <a:solidFill>
+                        <a:srgbClr val="C4C4BF"/>
+                      </a:solidFill>
+                      <a:prstDash val="solid"/>
+                      <a:round/>
+                      <a:headEnd type="none" w="med" len="med"/>
+                      <a:tailEnd type="none" w="med" len="med"/>
+                    </a:lnL>
+                    <a:lnR w="12700" cap="flat" cmpd="sng" algn="ctr">
+                      <a:solidFill>
+                        <a:srgbClr val="C4C4BF"/>
+                      </a:solidFill>
+                      <a:prstDash val="solid"/>
+                      <a:round/>
+                      <a:headEnd type="none" w="med" len="med"/>
+                      <a:tailEnd type="none" w="med" len="med"/>
+                    </a:lnR>
+                    <a:lnT w="12700" cap="flat" cmpd="sng" algn="ctr">
+                      <a:solidFill>
+                        <a:srgbClr val="C8BAB0"/>
+                      </a:solidFill>
+                      <a:prstDash val="solid"/>
+                      <a:round/>
+                      <a:headEnd type="none" w="med" len="med"/>
+                      <a:tailEnd type="none" w="med" len="med"/>
+                    </a:lnT>
+                    <a:lnB w="12700" cap="flat" cmpd="sng" algn="ctr">
+                      <a:solidFill>
+                        <a:srgbClr val="C4C4BF"/>
+                      </a:solidFill>
+                      <a:prstDash val="solid"/>
+                      <a:round/>
+                      <a:headEnd type="none" w="med" len="med"/>
+                      <a:tailEnd type="none" w="med" len="med"/>
+                    </a:lnB>
+                  </a:tcPr>
+                </a:tc>
+                <a:tc>
+                  <a:txBody>
+                    <a:bodyPr/>
+                    <a:lstStyle/>
+                    <a:p>
+                      <a:pPr algn="r" indent="0" marL="0">
+                        <a:lnSpc>
+                          <a:spcPts val="1746"/>
+                        </a:lnSpc>
+                        <a:buNone/>
+                      </a:pPr>
+                      <a:r>
+                        <a:rPr lang="en-US" sz="1247" dirty="0">
+                          <a:solidFill>
+                            <a:srgbClr val="1B2433"/>
+                          </a:solidFill>
+                          <a:latin typeface="IBM Plex Sans" pitchFamily="34" charset="0"/>
+                          <a:ea typeface="IBM Plex Sans" pitchFamily="34" charset="-122"/>
+                          <a:cs typeface="IBM Plex Sans" pitchFamily="34" charset="-120"/>
+                        </a:rPr>
+                        <a:t>100%</a:t>
+                      </a:r>
+                      <a:endParaRPr lang="en-US" sz="1247" dirty="0">
+                        <a:latin typeface="IBM Plex Sans" charset="0"/>
+                        <a:ea typeface="IBM Plex Sans" charset="0"/>
+                        <a:cs typeface="IBM Plex Sans" charset="0"/>
+                      </a:endParaRPr>
+                    </a:p>
+                  </a:txBody>
+                  <a:tcPr marL="55437" marR="55437" marT="55437" marB="55437" anchor="t">
+                    <a:lnL w="12700" cap="flat" cmpd="sng" algn="ctr">
+                      <a:solidFill>
+                        <a:srgbClr val="C4C4BF"/>
+                      </a:solidFill>
+                      <a:prstDash val="solid"/>
+                      <a:round/>
+                      <a:headEnd type="none" w="med" len="med"/>
+                      <a:tailEnd type="none" w="med" len="med"/>
+                    </a:lnL>
+                    <a:lnR w="12700" cap="flat" cmpd="sng" algn="ctr">
+                      <a:solidFill>
+                        <a:srgbClr val="C4C4BF"/>
+                      </a:solidFill>
+                      <a:prstDash val="solid"/>
+                      <a:round/>
+                      <a:headEnd type="none" w="med" len="med"/>
+                      <a:tailEnd type="none" w="med" len="med"/>
+                    </a:lnR>
+                    <a:lnT w="12700" cap="flat" cmpd="sng" algn="ctr">
+                      <a:solidFill>
+                        <a:srgbClr val="C8BAB0"/>
+                      </a:solidFill>
+                      <a:prstDash val="solid"/>
+                      <a:round/>
+                      <a:headEnd type="none" w="med" len="med"/>
+                      <a:tailEnd type="none" w="med" len="med"/>
+                    </a:lnT>
+                    <a:lnB w="12700" cap="flat" cmpd="sng" algn="ctr">
+                      <a:solidFill>
+                        <a:srgbClr val="C4C4BF"/>
+                      </a:solidFill>
+                      <a:prstDash val="solid"/>
+                      <a:round/>
+                      <a:headEnd type="none" w="med" len="med"/>
+                      <a:tailEnd type="none" w="med" len="med"/>
+                    </a:lnB>
+                  </a:tcPr>
+                </a:tc>
+              </a:tr>
+              <a:tr h="338328">
                 <a:tc>
                   <a:txBody>
                     <a:bodyPr/>
@@ -31460,7 +31874,7 @@
                           <a:ea typeface="IBM Plex Sans" pitchFamily="34" charset="-122"/>
                           <a:cs typeface="IBM Plex Sans" pitchFamily="34" charset="-120"/>
                         </a:rPr>
-                        <a:t>0.0006</a:t>
+                        <a:t>5.81</a:t>
                       </a:r>
                       <a:endParaRPr lang="en-US" sz="1247" dirty="0">
                         <a:latin typeface="IBM Plex Sans" charset="0"/>
@@ -31531,7 +31945,7 @@
                           <a:ea typeface="IBM Plex Sans" pitchFamily="34" charset="-122"/>
                           <a:cs typeface="IBM Plex Sans" pitchFamily="34" charset="-120"/>
                         </a:rPr>
-                        <a:t>100.0%</a:t>
+                        <a:t>0.014</a:t>
                       </a:r>
                       <a:endParaRPr lang="en-US" sz="1247" dirty="0">
                         <a:latin typeface="IBM Plex Sans" charset="0"/>
@@ -31582,8 +31996,79 @@
                     </a:solidFill>
                   </a:tcPr>
                 </a:tc>
+                <a:tc>
+                  <a:txBody>
+                    <a:bodyPr/>
+                    <a:lstStyle/>
+                    <a:p>
+                      <a:pPr algn="r" indent="0" marL="0">
+                        <a:lnSpc>
+                          <a:spcPts val="1746"/>
+                        </a:lnSpc>
+                        <a:buNone/>
+                      </a:pPr>
+                      <a:r>
+                        <a:rPr lang="en-US" sz="1247" dirty="0">
+                          <a:solidFill>
+                            <a:srgbClr val="1B2433"/>
+                          </a:solidFill>
+                          <a:latin typeface="IBM Plex Sans" pitchFamily="34" charset="0"/>
+                          <a:ea typeface="IBM Plex Sans" pitchFamily="34" charset="-122"/>
+                          <a:cs typeface="IBM Plex Sans" pitchFamily="34" charset="-120"/>
+                        </a:rPr>
+                        <a:t>95.9%</a:t>
+                      </a:r>
+                      <a:endParaRPr lang="en-US" sz="1247" dirty="0">
+                        <a:latin typeface="IBM Plex Sans" charset="0"/>
+                        <a:ea typeface="IBM Plex Sans" charset="0"/>
+                        <a:cs typeface="IBM Plex Sans" charset="0"/>
+                      </a:endParaRPr>
+                    </a:p>
+                  </a:txBody>
+                  <a:tcPr marL="55437" marR="55437" marT="55437" marB="55437" anchor="t">
+                    <a:lnL w="12700" cap="flat" cmpd="sng" algn="ctr">
+                      <a:solidFill>
+                        <a:srgbClr val="C8BAB0"/>
+                      </a:solidFill>
+                      <a:prstDash val="solid"/>
+                      <a:round/>
+                      <a:headEnd type="none" w="med" len="med"/>
+                      <a:tailEnd type="none" w="med" len="med"/>
+                    </a:lnL>
+                    <a:lnR w="12700" cap="flat" cmpd="sng" algn="ctr">
+                      <a:solidFill>
+                        <a:srgbClr val="C8BAB0"/>
+                      </a:solidFill>
+                      <a:prstDash val="solid"/>
+                      <a:round/>
+                      <a:headEnd type="none" w="med" len="med"/>
+                      <a:tailEnd type="none" w="med" len="med"/>
+                    </a:lnR>
+                    <a:lnT w="12700" cap="flat" cmpd="sng" algn="ctr">
+                      <a:solidFill>
+                        <a:srgbClr val="B6B5B1"/>
+                      </a:solidFill>
+                      <a:prstDash val="solid"/>
+                      <a:round/>
+                      <a:headEnd type="none" w="med" len="med"/>
+                      <a:tailEnd type="none" w="med" len="med"/>
+                    </a:lnT>
+                    <a:lnB w="12700" cap="flat" cmpd="sng" algn="ctr">
+                      <a:solidFill>
+                        <a:srgbClr val="C8BAB0"/>
+                      </a:solidFill>
+                      <a:prstDash val="solid"/>
+                      <a:round/>
+                      <a:headEnd type="none" w="med" len="med"/>
+                      <a:tailEnd type="none" w="med" len="med"/>
+                    </a:lnB>
+                    <a:solidFill>
+                      <a:srgbClr val="FBE9DC"/>
+                    </a:solidFill>
+                  </a:tcPr>
+                </a:tc>
               </a:tr>
-              <a:tr h="365760">
+              <a:tr h="338328">
                 <a:tc>
                   <a:txBody>
                     <a:bodyPr/>
@@ -31740,7 +32225,7 @@
                           <a:ea typeface="IBM Plex Sans" pitchFamily="34" charset="-122"/>
                           <a:cs typeface="IBM Plex Sans" pitchFamily="34" charset="-120"/>
                         </a:rPr>
-                        <a:t>0.0005</a:t>
+                        <a:t>5.78</a:t>
                       </a:r>
                       <a:endParaRPr lang="en-US" sz="1247" dirty="0">
                         <a:latin typeface="IBM Plex Sans" charset="0"/>
@@ -31808,7 +32293,7 @@
                           <a:ea typeface="IBM Plex Sans" pitchFamily="34" charset="-122"/>
                           <a:cs typeface="IBM Plex Sans" pitchFamily="34" charset="-120"/>
                         </a:rPr>
-                        <a:t>99.95%</a:t>
+                        <a:t>0.012</a:t>
                       </a:r>
                       <a:endParaRPr lang="en-US" sz="1247" dirty="0">
                         <a:latin typeface="IBM Plex Sans" charset="0"/>
@@ -31856,8 +32341,76 @@
                     </a:lnB>
                   </a:tcPr>
                 </a:tc>
+                <a:tc>
+                  <a:txBody>
+                    <a:bodyPr/>
+                    <a:lstStyle/>
+                    <a:p>
+                      <a:pPr algn="r" indent="0" marL="0">
+                        <a:lnSpc>
+                          <a:spcPts val="1746"/>
+                        </a:lnSpc>
+                        <a:buNone/>
+                      </a:pPr>
+                      <a:r>
+                        <a:rPr lang="en-US" sz="1247" dirty="0">
+                          <a:solidFill>
+                            <a:srgbClr val="1B2433"/>
+                          </a:solidFill>
+                          <a:latin typeface="IBM Plex Sans" pitchFamily="34" charset="0"/>
+                          <a:ea typeface="IBM Plex Sans" pitchFamily="34" charset="-122"/>
+                          <a:cs typeface="IBM Plex Sans" pitchFamily="34" charset="-120"/>
+                        </a:rPr>
+                        <a:t>96.2%</a:t>
+                      </a:r>
+                      <a:endParaRPr lang="en-US" sz="1247" dirty="0">
+                        <a:latin typeface="IBM Plex Sans" charset="0"/>
+                        <a:ea typeface="IBM Plex Sans" charset="0"/>
+                        <a:cs typeface="IBM Plex Sans" charset="0"/>
+                      </a:endParaRPr>
+                    </a:p>
+                  </a:txBody>
+                  <a:tcPr marL="55437" marR="55437" marT="55437" marB="55437" anchor="t">
+                    <a:lnL w="12700" cap="flat" cmpd="sng" algn="ctr">
+                      <a:solidFill>
+                        <a:srgbClr val="C4C4BF"/>
+                      </a:solidFill>
+                      <a:prstDash val="solid"/>
+                      <a:round/>
+                      <a:headEnd type="none" w="med" len="med"/>
+                      <a:tailEnd type="none" w="med" len="med"/>
+                    </a:lnL>
+                    <a:lnR w="12700" cap="flat" cmpd="sng" algn="ctr">
+                      <a:solidFill>
+                        <a:srgbClr val="C4C4BF"/>
+                      </a:solidFill>
+                      <a:prstDash val="solid"/>
+                      <a:round/>
+                      <a:headEnd type="none" w="med" len="med"/>
+                      <a:tailEnd type="none" w="med" len="med"/>
+                    </a:lnR>
+                    <a:lnT w="12700" cap="flat" cmpd="sng" algn="ctr">
+                      <a:solidFill>
+                        <a:srgbClr val="C8BAB0"/>
+                      </a:solidFill>
+                      <a:prstDash val="solid"/>
+                      <a:round/>
+                      <a:headEnd type="none" w="med" len="med"/>
+                      <a:tailEnd type="none" w="med" len="med"/>
+                    </a:lnT>
+                    <a:lnB w="12700" cap="flat" cmpd="sng" algn="ctr">
+                      <a:solidFill>
+                        <a:srgbClr val="C4C4BF"/>
+                      </a:solidFill>
+                      <a:prstDash val="solid"/>
+                      <a:round/>
+                      <a:headEnd type="none" w="med" len="med"/>
+                      <a:tailEnd type="none" w="med" len="med"/>
+                    </a:lnB>
+                  </a:tcPr>
+                </a:tc>
               </a:tr>
-              <a:tr h="365760">
+              <a:tr h="338328">
                 <a:tc>
                   <a:txBody>
                     <a:bodyPr/>
@@ -32014,7 +32567,7 @@
                           <a:ea typeface="IBM Plex Sans" pitchFamily="34" charset="-122"/>
                           <a:cs typeface="IBM Plex Sans" pitchFamily="34" charset="-120"/>
                         </a:rPr>
-                        <a:t>0.0040</a:t>
+                        <a:t>6.14</a:t>
                       </a:r>
                       <a:endParaRPr lang="en-US" sz="1247" dirty="0">
                         <a:latin typeface="IBM Plex Sans" charset="0"/>
@@ -32082,7 +32635,7 @@
                           <a:ea typeface="IBM Plex Sans" pitchFamily="34" charset="-122"/>
                           <a:cs typeface="IBM Plex Sans" pitchFamily="34" charset="-120"/>
                         </a:rPr>
-                        <a:t>99.95%</a:t>
+                        <a:t>0.069</a:t>
                       </a:r>
                       <a:endParaRPr lang="en-US" sz="1247" dirty="0">
                         <a:latin typeface="IBM Plex Sans" charset="0"/>
@@ -32130,8 +32683,76 @@
                     </a:lnB>
                   </a:tcPr>
                 </a:tc>
+                <a:tc>
+                  <a:txBody>
+                    <a:bodyPr/>
+                    <a:lstStyle/>
+                    <a:p>
+                      <a:pPr algn="r" indent="0" marL="0">
+                        <a:lnSpc>
+                          <a:spcPts val="1746"/>
+                        </a:lnSpc>
+                        <a:buNone/>
+                      </a:pPr>
+                      <a:r>
+                        <a:rPr lang="en-US" sz="1247" dirty="0">
+                          <a:solidFill>
+                            <a:srgbClr val="1B2433"/>
+                          </a:solidFill>
+                          <a:latin typeface="IBM Plex Sans" pitchFamily="34" charset="0"/>
+                          <a:ea typeface="IBM Plex Sans" pitchFamily="34" charset="-122"/>
+                          <a:cs typeface="IBM Plex Sans" pitchFamily="34" charset="-120"/>
+                        </a:rPr>
+                        <a:t>90.2%</a:t>
+                      </a:r>
+                      <a:endParaRPr lang="en-US" sz="1247" dirty="0">
+                        <a:latin typeface="IBM Plex Sans" charset="0"/>
+                        <a:ea typeface="IBM Plex Sans" charset="0"/>
+                        <a:cs typeface="IBM Plex Sans" charset="0"/>
+                      </a:endParaRPr>
+                    </a:p>
+                  </a:txBody>
+                  <a:tcPr marL="55437" marR="55437" marT="55437" marB="55437" anchor="t">
+                    <a:lnL w="12700" cap="flat" cmpd="sng" algn="ctr">
+                      <a:solidFill>
+                        <a:srgbClr val="C4C4BF"/>
+                      </a:solidFill>
+                      <a:prstDash val="solid"/>
+                      <a:round/>
+                      <a:headEnd type="none" w="med" len="med"/>
+                      <a:tailEnd type="none" w="med" len="med"/>
+                    </a:lnL>
+                    <a:lnR w="12700" cap="flat" cmpd="sng" algn="ctr">
+                      <a:solidFill>
+                        <a:srgbClr val="C4C4BF"/>
+                      </a:solidFill>
+                      <a:prstDash val="solid"/>
+                      <a:round/>
+                      <a:headEnd type="none" w="med" len="med"/>
+                      <a:tailEnd type="none" w="med" len="med"/>
+                    </a:lnR>
+                    <a:lnT w="12700" cap="flat" cmpd="sng" algn="ctr">
+                      <a:solidFill>
+                        <a:srgbClr val="C8BAB0"/>
+                      </a:solidFill>
+                      <a:prstDash val="solid"/>
+                      <a:round/>
+                      <a:headEnd type="none" w="med" len="med"/>
+                      <a:tailEnd type="none" w="med" len="med"/>
+                    </a:lnT>
+                    <a:lnB w="12700" cap="flat" cmpd="sng" algn="ctr">
+                      <a:solidFill>
+                        <a:srgbClr val="C4C4BF"/>
+                      </a:solidFill>
+                      <a:prstDash val="solid"/>
+                      <a:round/>
+                      <a:headEnd type="none" w="med" len="med"/>
+                      <a:tailEnd type="none" w="med" len="med"/>
+                    </a:lnB>
+                  </a:tcPr>
+                </a:tc>
               </a:tr>
-              <a:tr h="365760">
+              <a:tr h="338328">
                 <a:tc>
                   <a:txBody>
                     <a:bodyPr/>
@@ -32294,7 +32915,7 @@
                           <a:ea typeface="IBM Plex Sans" pitchFamily="34" charset="-122"/>
                           <a:cs typeface="IBM Plex Sans" pitchFamily="34" charset="-120"/>
                         </a:rPr>
-                        <a:t>0.0022</a:t>
+                        <a:t>5.86</a:t>
                       </a:r>
                       <a:endParaRPr lang="en-US" sz="1247" dirty="0">
                         <a:latin typeface="IBM Plex Sans" charset="0"/>
@@ -32365,7 +32986,7 @@
                           <a:ea typeface="IBM Plex Sans" pitchFamily="34" charset="-122"/>
                           <a:cs typeface="IBM Plex Sans" pitchFamily="34" charset="-120"/>
                         </a:rPr>
-                        <a:t>99.95%</a:t>
+                        <a:t>0.024</a:t>
                       </a:r>
                       <a:endParaRPr lang="en-US" sz="1247" dirty="0">
                         <a:latin typeface="IBM Plex Sans" charset="0"/>
@@ -32416,8 +33037,79 @@
                     </a:solidFill>
                   </a:tcPr>
                 </a:tc>
+                <a:tc>
+                  <a:txBody>
+                    <a:bodyPr/>
+                    <a:lstStyle/>
+                    <a:p>
+                      <a:pPr algn="r" indent="0" marL="0">
+                        <a:lnSpc>
+                          <a:spcPts val="1746"/>
+                        </a:lnSpc>
+                        <a:buNone/>
+                      </a:pPr>
+                      <a:r>
+                        <a:rPr lang="en-US" sz="1247" dirty="0">
+                          <a:solidFill>
+                            <a:srgbClr val="1B2433"/>
+                          </a:solidFill>
+                          <a:latin typeface="IBM Plex Sans" pitchFamily="34" charset="0"/>
+                          <a:ea typeface="IBM Plex Sans" pitchFamily="34" charset="-122"/>
+                          <a:cs typeface="IBM Plex Sans" pitchFamily="34" charset="-120"/>
+                        </a:rPr>
+                        <a:t>93.4%</a:t>
+                      </a:r>
+                      <a:endParaRPr lang="en-US" sz="1247" dirty="0">
+                        <a:latin typeface="IBM Plex Sans" charset="0"/>
+                        <a:ea typeface="IBM Plex Sans" charset="0"/>
+                        <a:cs typeface="IBM Plex Sans" charset="0"/>
+                      </a:endParaRPr>
+                    </a:p>
+                  </a:txBody>
+                  <a:tcPr marL="55437" marR="55437" marT="55437" marB="55437" anchor="t">
+                    <a:lnL w="12700" cap="flat" cmpd="sng" algn="ctr">
+                      <a:solidFill>
+                        <a:srgbClr val="C8BAB0"/>
+                      </a:solidFill>
+                      <a:prstDash val="solid"/>
+                      <a:round/>
+                      <a:headEnd type="none" w="med" len="med"/>
+                      <a:tailEnd type="none" w="med" len="med"/>
+                    </a:lnL>
+                    <a:lnR w="12700" cap="flat" cmpd="sng" algn="ctr">
+                      <a:solidFill>
+                        <a:srgbClr val="C8BAB0"/>
+                      </a:solidFill>
+                      <a:prstDash val="solid"/>
+                      <a:round/>
+                      <a:headEnd type="none" w="med" len="med"/>
+                      <a:tailEnd type="none" w="med" len="med"/>
+                    </a:lnR>
+                    <a:lnT w="12700" cap="flat" cmpd="sng" algn="ctr">
+                      <a:solidFill>
+                        <a:srgbClr val="B6B5B1"/>
+                      </a:solidFill>
+                      <a:prstDash val="solid"/>
+                      <a:round/>
+                      <a:headEnd type="none" w="med" len="med"/>
+                      <a:tailEnd type="none" w="med" len="med"/>
+                    </a:lnT>
+                    <a:lnB w="12700" cap="flat" cmpd="sng" algn="ctr">
+                      <a:solidFill>
+                        <a:srgbClr val="C8BAB0"/>
+                      </a:solidFill>
+                      <a:prstDash val="solid"/>
+                      <a:round/>
+                      <a:headEnd type="none" w="med" len="med"/>
+                      <a:tailEnd type="none" w="med" len="med"/>
+                    </a:lnB>
+                    <a:solidFill>
+                      <a:srgbClr val="FBE9DC"/>
+                    </a:solidFill>
+                  </a:tcPr>
+                </a:tc>
               </a:tr>
-              <a:tr h="365760">
+              <a:tr h="338328">
                 <a:tc>
                   <a:txBody>
                     <a:bodyPr/>
@@ -32580,7 +33272,7 @@
                           <a:ea typeface="IBM Plex Sans" pitchFamily="34" charset="-122"/>
                           <a:cs typeface="IBM Plex Sans" pitchFamily="34" charset="-120"/>
                         </a:rPr>
-                        <a:t>0.0060</a:t>
+                        <a:t>6.10</a:t>
                       </a:r>
                       <a:endParaRPr lang="en-US" sz="1247" dirty="0">
                         <a:latin typeface="IBM Plex Sans" charset="0"/>
@@ -32651,7 +33343,7 @@
                           <a:ea typeface="IBM Plex Sans" pitchFamily="34" charset="-122"/>
                           <a:cs typeface="IBM Plex Sans" pitchFamily="34" charset="-120"/>
                         </a:rPr>
-                        <a:t>99.90%</a:t>
+                        <a:t>0.060</a:t>
                       </a:r>
                       <a:endParaRPr lang="en-US" sz="1247" dirty="0">
                         <a:latin typeface="IBM Plex Sans" charset="0"/>
@@ -32702,8 +33394,79 @@
                     </a:solidFill>
                   </a:tcPr>
                 </a:tc>
+                <a:tc>
+                  <a:txBody>
+                    <a:bodyPr/>
+                    <a:lstStyle/>
+                    <a:p>
+                      <a:pPr algn="r" indent="0" marL="0">
+                        <a:lnSpc>
+                          <a:spcPts val="1746"/>
+                        </a:lnSpc>
+                        <a:buNone/>
+                      </a:pPr>
+                      <a:r>
+                        <a:rPr lang="en-US" sz="1247" dirty="0">
+                          <a:solidFill>
+                            <a:srgbClr val="1B2433"/>
+                          </a:solidFill>
+                          <a:latin typeface="IBM Plex Sans" pitchFamily="34" charset="0"/>
+                          <a:ea typeface="IBM Plex Sans" pitchFamily="34" charset="-122"/>
+                          <a:cs typeface="IBM Plex Sans" pitchFamily="34" charset="-120"/>
+                        </a:rPr>
+                        <a:t>90.7%</a:t>
+                      </a:r>
+                      <a:endParaRPr lang="en-US" sz="1247" dirty="0">
+                        <a:latin typeface="IBM Plex Sans" charset="0"/>
+                        <a:ea typeface="IBM Plex Sans" charset="0"/>
+                        <a:cs typeface="IBM Plex Sans" charset="0"/>
+                      </a:endParaRPr>
+                    </a:p>
+                  </a:txBody>
+                  <a:tcPr marL="55437" marR="55437" marT="55437" marB="55437" anchor="t">
+                    <a:lnL w="12700" cap="flat" cmpd="sng" algn="ctr">
+                      <a:solidFill>
+                        <a:srgbClr val="C8BAB0"/>
+                      </a:solidFill>
+                      <a:prstDash val="solid"/>
+                      <a:round/>
+                      <a:headEnd type="none" w="med" len="med"/>
+                      <a:tailEnd type="none" w="med" len="med"/>
+                    </a:lnL>
+                    <a:lnR w="12700" cap="flat" cmpd="sng" algn="ctr">
+                      <a:solidFill>
+                        <a:srgbClr val="C8BAB0"/>
+                      </a:solidFill>
+                      <a:prstDash val="solid"/>
+                      <a:round/>
+                      <a:headEnd type="none" w="med" len="med"/>
+                      <a:tailEnd type="none" w="med" len="med"/>
+                    </a:lnR>
+                    <a:lnT w="12700" cap="flat" cmpd="sng" algn="ctr">
+                      <a:solidFill>
+                        <a:srgbClr val="B6B5B1"/>
+                      </a:solidFill>
+                      <a:prstDash val="solid"/>
+                      <a:round/>
+                      <a:headEnd type="none" w="med" len="med"/>
+                      <a:tailEnd type="none" w="med" len="med"/>
+                    </a:lnT>
+                    <a:lnB w="12700" cap="flat" cmpd="sng" algn="ctr">
+                      <a:solidFill>
+                        <a:srgbClr val="C8BAB0"/>
+                      </a:solidFill>
+                      <a:prstDash val="solid"/>
+                      <a:round/>
+                      <a:headEnd type="none" w="med" len="med"/>
+                      <a:tailEnd type="none" w="med" len="med"/>
+                    </a:lnB>
+                    <a:solidFill>
+                      <a:srgbClr val="FBE9DC"/>
+                    </a:solidFill>
+                  </a:tcPr>
+                </a:tc>
               </a:tr>
-              <a:tr h="365760">
+              <a:tr h="338328">
                 <a:tc>
                   <a:txBody>
                     <a:bodyPr/>
@@ -32860,7 +33623,7 @@
                           <a:ea typeface="IBM Plex Sans" pitchFamily="34" charset="-122"/>
                           <a:cs typeface="IBM Plex Sans" pitchFamily="34" charset="-120"/>
                         </a:rPr>
-                        <a:t>0.0387</a:t>
+                        <a:t>17.20</a:t>
                       </a:r>
                       <a:endParaRPr lang="en-US" sz="1247" dirty="0">
                         <a:latin typeface="IBM Plex Sans" charset="0"/>
@@ -32928,7 +33691,7 @@
                           <a:ea typeface="IBM Plex Sans" pitchFamily="34" charset="-122"/>
                           <a:cs typeface="IBM Plex Sans" pitchFamily="34" charset="-120"/>
                         </a:rPr>
-                        <a:t>99.76%</a:t>
+                        <a:t>1.117</a:t>
                       </a:r>
                       <a:endParaRPr lang="en-US" sz="1247" dirty="0">
                         <a:latin typeface="IBM Plex Sans" charset="0"/>
@@ -32976,8 +33739,76 @@
                     </a:lnB>
                   </a:tcPr>
                 </a:tc>
+                <a:tc>
+                  <a:txBody>
+                    <a:bodyPr/>
+                    <a:lstStyle/>
+                    <a:p>
+                      <a:pPr algn="r" indent="0" marL="0">
+                        <a:lnSpc>
+                          <a:spcPts val="1746"/>
+                        </a:lnSpc>
+                        <a:buNone/>
+                      </a:pPr>
+                      <a:r>
+                        <a:rPr lang="en-US" sz="1247" dirty="0">
+                          <a:solidFill>
+                            <a:srgbClr val="1B2433"/>
+                          </a:solidFill>
+                          <a:latin typeface="IBM Plex Sans" pitchFamily="34" charset="0"/>
+                          <a:ea typeface="IBM Plex Sans" pitchFamily="34" charset="-122"/>
+                          <a:cs typeface="IBM Plex Sans" pitchFamily="34" charset="-120"/>
+                        </a:rPr>
+                        <a:t>59.8%</a:t>
+                      </a:r>
+                      <a:endParaRPr lang="en-US" sz="1247" dirty="0">
+                        <a:latin typeface="IBM Plex Sans" charset="0"/>
+                        <a:ea typeface="IBM Plex Sans" charset="0"/>
+                        <a:cs typeface="IBM Plex Sans" charset="0"/>
+                      </a:endParaRPr>
+                    </a:p>
+                  </a:txBody>
+                  <a:tcPr marL="55437" marR="55437" marT="55437" marB="55437" anchor="t">
+                    <a:lnL w="12700" cap="flat" cmpd="sng" algn="ctr">
+                      <a:solidFill>
+                        <a:srgbClr val="C4C4BF"/>
+                      </a:solidFill>
+                      <a:prstDash val="solid"/>
+                      <a:round/>
+                      <a:headEnd type="none" w="med" len="med"/>
+                      <a:tailEnd type="none" w="med" len="med"/>
+                    </a:lnL>
+                    <a:lnR w="12700" cap="flat" cmpd="sng" algn="ctr">
+                      <a:solidFill>
+                        <a:srgbClr val="C4C4BF"/>
+                      </a:solidFill>
+                      <a:prstDash val="solid"/>
+                      <a:round/>
+                      <a:headEnd type="none" w="med" len="med"/>
+                      <a:tailEnd type="none" w="med" len="med"/>
+                    </a:lnR>
+                    <a:lnT w="12700" cap="flat" cmpd="sng" algn="ctr">
+                      <a:solidFill>
+                        <a:srgbClr val="C8BAB0"/>
+                      </a:solidFill>
+                      <a:prstDash val="solid"/>
+                      <a:round/>
+                      <a:headEnd type="none" w="med" len="med"/>
+                      <a:tailEnd type="none" w="med" len="med"/>
+                    </a:lnT>
+                    <a:lnB w="12700" cap="flat" cmpd="sng" algn="ctr">
+                      <a:solidFill>
+                        <a:srgbClr val="C4C4BF"/>
+                      </a:solidFill>
+                      <a:prstDash val="solid"/>
+                      <a:round/>
+                      <a:headEnd type="none" w="med" len="med"/>
+                      <a:tailEnd type="none" w="med" len="med"/>
+                    </a:lnB>
+                  </a:tcPr>
+                </a:tc>
               </a:tr>
-              <a:tr h="365760">
+              <a:tr h="338328">
                 <a:tc>
                   <a:txBody>
                     <a:bodyPr/>
@@ -33140,7 +33971,7 @@
                           <a:ea typeface="IBM Plex Sans" pitchFamily="34" charset="-122"/>
                           <a:cs typeface="IBM Plex Sans" pitchFamily="34" charset="-120"/>
                         </a:rPr>
-                        <a:t>0.0124</a:t>
+                        <a:t>7.38</a:t>
                       </a:r>
                       <a:endParaRPr lang="en-US" sz="1247" dirty="0">
                         <a:latin typeface="IBM Plex Sans" charset="0"/>
@@ -33211,7 +34042,7 @@
                           <a:ea typeface="IBM Plex Sans" pitchFamily="34" charset="-122"/>
                           <a:cs typeface="IBM Plex Sans" pitchFamily="34" charset="-120"/>
                         </a:rPr>
-                        <a:t>99.85%</a:t>
+                        <a:t>0.246</a:t>
                       </a:r>
                       <a:endParaRPr lang="en-US" sz="1247" dirty="0">
                         <a:latin typeface="IBM Plex Sans" charset="0"/>
@@ -33262,8 +34093,79 @@
                     </a:solidFill>
                   </a:tcPr>
                 </a:tc>
+                <a:tc>
+                  <a:txBody>
+                    <a:bodyPr/>
+                    <a:lstStyle/>
+                    <a:p>
+                      <a:pPr algn="r" indent="0" marL="0">
+                        <a:lnSpc>
+                          <a:spcPts val="1746"/>
+                        </a:lnSpc>
+                        <a:buNone/>
+                      </a:pPr>
+                      <a:r>
+                        <a:rPr lang="en-US" sz="1247" dirty="0">
+                          <a:solidFill>
+                            <a:srgbClr val="1B2433"/>
+                          </a:solidFill>
+                          <a:latin typeface="IBM Plex Sans" pitchFamily="34" charset="0"/>
+                          <a:ea typeface="IBM Plex Sans" pitchFamily="34" charset="-122"/>
+                          <a:cs typeface="IBM Plex Sans" pitchFamily="34" charset="-120"/>
+                        </a:rPr>
+                        <a:t>81.3%</a:t>
+                      </a:r>
+                      <a:endParaRPr lang="en-US" sz="1247" dirty="0">
+                        <a:latin typeface="IBM Plex Sans" charset="0"/>
+                        <a:ea typeface="IBM Plex Sans" charset="0"/>
+                        <a:cs typeface="IBM Plex Sans" charset="0"/>
+                      </a:endParaRPr>
+                    </a:p>
+                  </a:txBody>
+                  <a:tcPr marL="55437" marR="55437" marT="55437" marB="55437" anchor="t">
+                    <a:lnL w="12700" cap="flat" cmpd="sng" algn="ctr">
+                      <a:solidFill>
+                        <a:srgbClr val="C8BAB0"/>
+                      </a:solidFill>
+                      <a:prstDash val="solid"/>
+                      <a:round/>
+                      <a:headEnd type="none" w="med" len="med"/>
+                      <a:tailEnd type="none" w="med" len="med"/>
+                    </a:lnL>
+                    <a:lnR w="12700" cap="flat" cmpd="sng" algn="ctr">
+                      <a:solidFill>
+                        <a:srgbClr val="C8BAB0"/>
+                      </a:solidFill>
+                      <a:prstDash val="solid"/>
+                      <a:round/>
+                      <a:headEnd type="none" w="med" len="med"/>
+                      <a:tailEnd type="none" w="med" len="med"/>
+                    </a:lnR>
+                    <a:lnT w="12700" cap="flat" cmpd="sng" algn="ctr">
+                      <a:solidFill>
+                        <a:srgbClr val="B6B5B1"/>
+                      </a:solidFill>
+                      <a:prstDash val="solid"/>
+                      <a:round/>
+                      <a:headEnd type="none" w="med" len="med"/>
+                      <a:tailEnd type="none" w="med" len="med"/>
+                    </a:lnT>
+                    <a:lnB w="12700" cap="flat" cmpd="sng" algn="ctr">
+                      <a:solidFill>
+                        <a:srgbClr val="C8BAB0"/>
+                      </a:solidFill>
+                      <a:prstDash val="solid"/>
+                      <a:round/>
+                      <a:headEnd type="none" w="med" len="med"/>
+                      <a:tailEnd type="none" w="med" len="med"/>
+                    </a:lnB>
+                    <a:solidFill>
+                      <a:srgbClr val="FBE9DC"/>
+                    </a:solidFill>
+                  </a:tcPr>
+                </a:tc>
               </a:tr>
-              <a:tr h="365760">
+              <a:tr h="338328">
                 <a:tc>
                   <a:txBody>
                     <a:bodyPr/>
@@ -33426,7 +34328,7 @@
                           <a:ea typeface="IBM Plex Sans" pitchFamily="34" charset="-122"/>
                           <a:cs typeface="IBM Plex Sans" pitchFamily="34" charset="-120"/>
                         </a:rPr>
-                        <a:t>0.0179</a:t>
+                        <a:t>9.36</a:t>
                       </a:r>
                       <a:endParaRPr lang="en-US" sz="1247" dirty="0">
                         <a:latin typeface="IBM Plex Sans" charset="0"/>
@@ -33497,7 +34399,78 @@
                           <a:ea typeface="IBM Plex Sans" pitchFamily="34" charset="-122"/>
                           <a:cs typeface="IBM Plex Sans" pitchFamily="34" charset="-120"/>
                         </a:rPr>
-                        <a:t>99.80%</a:t>
+                        <a:t>0.475</a:t>
+                      </a:r>
+                      <a:endParaRPr lang="en-US" sz="1247" dirty="0">
+                        <a:latin typeface="IBM Plex Sans" charset="0"/>
+                        <a:ea typeface="IBM Plex Sans" charset="0"/>
+                        <a:cs typeface="IBM Plex Sans" charset="0"/>
+                      </a:endParaRPr>
+                    </a:p>
+                  </a:txBody>
+                  <a:tcPr marL="55437" marR="55437" marT="55437" marB="55437" anchor="t">
+                    <a:lnL w="12700" cap="flat" cmpd="sng" algn="ctr">
+                      <a:solidFill>
+                        <a:srgbClr val="C8BAB0"/>
+                      </a:solidFill>
+                      <a:prstDash val="solid"/>
+                      <a:round/>
+                      <a:headEnd type="none" w="med" len="med"/>
+                      <a:tailEnd type="none" w="med" len="med"/>
+                    </a:lnL>
+                    <a:lnR w="12700" cap="flat" cmpd="sng" algn="ctr">
+                      <a:solidFill>
+                        <a:srgbClr val="C8BAB0"/>
+                      </a:solidFill>
+                      <a:prstDash val="solid"/>
+                      <a:round/>
+                      <a:headEnd type="none" w="med" len="med"/>
+                      <a:tailEnd type="none" w="med" len="med"/>
+                    </a:lnR>
+                    <a:lnT w="12700" cap="flat" cmpd="sng" algn="ctr">
+                      <a:solidFill>
+                        <a:srgbClr val="B6B5B1"/>
+                      </a:solidFill>
+                      <a:prstDash val="solid"/>
+                      <a:round/>
+                      <a:headEnd type="none" w="med" len="med"/>
+                      <a:tailEnd type="none" w="med" len="med"/>
+                    </a:lnT>
+                    <a:lnB w="12700" cap="flat" cmpd="sng" algn="ctr">
+                      <a:solidFill>
+                        <a:srgbClr val="C8BAB0"/>
+                      </a:solidFill>
+                      <a:prstDash val="solid"/>
+                      <a:round/>
+                      <a:headEnd type="none" w="med" len="med"/>
+                      <a:tailEnd type="none" w="med" len="med"/>
+                    </a:lnB>
+                    <a:solidFill>
+                      <a:srgbClr val="FBE9DC"/>
+                    </a:solidFill>
+                  </a:tcPr>
+                </a:tc>
+                <a:tc>
+                  <a:txBody>
+                    <a:bodyPr/>
+                    <a:lstStyle/>
+                    <a:p>
+                      <a:pPr algn="r" indent="0" marL="0">
+                        <a:lnSpc>
+                          <a:spcPts val="1746"/>
+                        </a:lnSpc>
+                        <a:buNone/>
+                      </a:pPr>
+                      <a:r>
+                        <a:rPr lang="en-US" sz="1247" dirty="0">
+                          <a:solidFill>
+                            <a:srgbClr val="1B2433"/>
+                          </a:solidFill>
+                          <a:latin typeface="IBM Plex Sans" pitchFamily="34" charset="0"/>
+                          <a:ea typeface="IBM Plex Sans" pitchFamily="34" charset="-122"/>
+                          <a:cs typeface="IBM Plex Sans" pitchFamily="34" charset="-120"/>
+                        </a:rPr>
+                        <a:t>74.1%</a:t>
                       </a:r>
                       <a:endParaRPr lang="en-US" sz="1247" dirty="0">
                         <a:latin typeface="IBM Plex Sans" charset="0"/>
@@ -33562,7 +34535,7 @@
         <p:spPr>
           <a:xfrm>
             <a:off x="7315200" y="2103120"/>
-            <a:ext cx="4069080" cy="3337560"/>
+            <a:ext cx="4069080" cy="3383280"/>
           </a:xfrm>
           <a:prstGeom prst="roundRect">
             <a:avLst>
@@ -33673,7 +34646,7 @@
                 </a:solidFill>
                 <a:latin typeface="IBM Plex Sans"/>
               </a:rPr>
-              <a:t>27.0 tok/s</a:t>
+              <a:t>26.3 tok/s</a:t>
             </a:r>
           </a:p>
         </p:txBody>
@@ -33717,7 +34690,7 @@
                 </a:solidFill>
                 <a:latin typeface="IBM Plex Sans"/>
               </a:rPr>
-              <a:t>10.3 tok/s</a:t>
+              <a:t>10.2 tok/s</a:t>
             </a:r>
           </a:p>
         </p:txBody>
@@ -33761,7 +34734,7 @@
                 </a:solidFill>
                 <a:latin typeface="IBM Plex Sans"/>
               </a:rPr>
-              <a:t>6.6 tok/s</a:t>
+              <a:t>6.5 tok/s</a:t>
             </a:r>
           </a:p>
         </p:txBody>
@@ -33809,8 +34782,8 @@
         </p:nvSpPr>
         <p:spPr>
           <a:xfrm>
-            <a:off x="822960" y="5440680"/>
-            <a:ext cx="6035040" cy="457200"/>
+            <a:off x="822960" y="5577840"/>
+            <a:ext cx="6400800" cy="457200"/>
           </a:xfrm>
           <a:prstGeom prst="rect">
             <a:avLst/>
@@ -33831,7 +34804,7 @@
                 </a:solidFill>
                 <a:latin typeface="IBM Plex Sans"/>
               </a:rPr>
-              <a:t>Compare rows of similar size: TurboQuant 3-bit against INT2 (KL 0.006 vs 0.039), TurboQuant 3.5-bit against INT3 (0.0022 vs 0.0040).</a:t>
+              <a:t>Similar size: TurboQuant 3-bit against INT2 (perplexity 6.10 vs 17.20), TurboQuant 3.5-bit against INT3 (5.86 vs 6.14). Below 3 bits TurboQuant loses quality too.</a:t>
             </a:r>
           </a:p>
         </p:txBody>
@@ -33874,7 +34847,7 @@
                 <a:ea typeface="IBM Plex Sans" pitchFamily="34" charset="-122"/>
                 <a:cs typeface="IBM Plex Sans" pitchFamily="34" charset="-120"/>
               </a:rPr>
-              <a:t>Sections 3 and 6 of llm_kv_cache_demo.ipynb, run on an A100 on 11 Oct 2026. KL and top-1 were scored on a repeated sentence because WikiText-2 did not load, so read them as a ranking; perplexity is left out. The notebook now loads WikiText-2.</a:t>
+              <a:t>Sections 3 and 6 of llm_kv_cache_demo.ipynb, run on an A100 on 11 Oct 2026. WikiText-2 test set, 2,048 tokens fed in 128-token chunks so each chunk reads the compressed cache; KL and top-1 against the FP16 cache.</a:t>
             </a:r>
             <a:endParaRPr lang="en-US" sz="1200" dirty="0"/>
           </a:p>

</xml_diff>